<commit_message>
Focus DVM 612 lecture on this hour and the Cocker case.
Drop references to other weeks, exams, and labs. Carry the vestibular Cocker Spaniel through preop, prep, and postop.

Co-authored-by: drkimvet <drkimvet@users.noreply.github.com>
</commit_message>
<xml_diff>
--- a/lectures/DVM-612_Week4_Preop_PatientPrep_Postop.pptx
+++ b/lectures/DVM-612_Week4_Preop_PatientPrep_Postop.pptx
@@ -550,7 +550,7 @@
           <a:lstStyle/>
           <a:p>
             <a:r>
-              <a:t>Welcome. This is Week 4 of DVM 612. Weeks 1–3 covered asepsis, sterilization, facilities, monitoring, communication, and surgery reports. Today we put the patient in the center: decide if they are a surgical candidate, prepare them and yourselves aseptically, and own the 24 hours after the last suture. One hour. Three acts. Keep Fossum nearby. Lab and OSCE will ask you to demonstrate the same prep and discharge skills.</a:t>
+              <a:t>Welcome. This hour is preoperative evaluation, patient and surgeon preparation, and postoperative care. We will carry one real patient through all three: a Cocker Spaniel with severe otitis who is now circling, with nystagmus and knuckling. Decide if that dog is a surgical candidate today, how you would prep, and what the next 24 hours look like.</a:t>
             </a:r>
           </a:p>
         </p:txBody>
@@ -900,7 +900,7 @@
           <a:lstStyle/>
           <a:p>
             <a:r>
-              <a:t>This is the ASA III teaching case for Exam 1. Punchline: vestibular + severe otitis is moderate/severe compensated disease. You may still anesthetize — for CT, flush, or TECA — but you do not treat the dog like a healthy spay. No Animax-style aminoglycoside in a suspect inner ear. No NSAID after DexSP.</a:t>
+              <a:t>Punchline: vestibular plus severe otitis is compensated moderate-to-severe disease — ASA III. You may still anesthetize for CT, flush, or TECA, but you do not treat this dog like a healthy spay. No aminoglycoside ointment in a suspect inner ear. No NSAID after DexSP.</a:t>
             </a:r>
           </a:p>
         </p:txBody>
@@ -1110,7 +1110,7 @@
           <a:lstStyle/>
           <a:p>
             <a:r>
-              <a:t>I teach AAHA-style 4–6 h for healthy small animals as best practice, and I tell them older exam banks may still say overnight NPO. Ruminant contrast prevents a species-blind answer on Exam 1.</a:t>
+              <a:t>Teach AAHA-style 4–6 h for healthy small animals as best practice. Older sources still say overnight NPO — explain aspiration vs hypoglycemia. Ruminants are a different physiology, not a different lecture.</a:t>
             </a:r>
           </a:p>
         </p:txBody>
@@ -1320,7 +1320,7 @@
           <a:lstStyle/>
           <a:p>
             <a:r>
-              <a:t>Read the five objectives aloud. Tell students Exam 1 (Week 6) will sample this material. OSCE/lab sign-off will include patient prep and discharge writing (LO 4 and 7).</a:t>
+              <a:t>Read the five objectives aloud. Tell them the Cocker is the patient we will keep coming back to.</a:t>
             </a:r>
           </a:p>
         </p:txBody>
@@ -1390,7 +1390,7 @@
           <a:lstStyle/>
           <a:p>
             <a:r>
-              <a:t>High-yield Exam 1 slide. Elective canine OHE is a clean procedure — do not invent a 14-day cephalexin prescription. If you give cefazolin, it is IV around induction, not a souvenir bottle home. Contrast with the vestibular Cocker: that ear is infected, so antimicrobials are therapy.</a:t>
+              <a:t>Elective canine OHE is a clean procedure — do not invent a 14-day cephalexin prescription. If you give cefazolin, it is IV around induction, not a souvenir bottle home. Contrast with the vestibular Cocker: that ear is infected, so antimicrobials are therapy.</a:t>
             </a:r>
           </a:p>
         </p:txBody>
@@ -1530,7 +1530,7 @@
           <a:lstStyle/>
           <a:p>
             <a:r>
-              <a:t>This is the skill cluster lab will watch: hair removal, skin prep, positioning, scrubbing/attire, gowning/gloving, draping. Lost asepsis that nobody names is how patients get SSI.</a:t>
+              <a:t>This is the skill cluster for this hour: hair removal, skin prep, positioning, scrubbing/attire, gowning/gloving, draping. Lost asepsis that nobody names is how patients get SSI.</a:t>
             </a:r>
           </a:p>
         </p:txBody>
@@ -1600,7 +1600,7 @@
           <a:lstStyle/>
           <a:p>
             <a:r>
-              <a:t>Read the six scored boxes. Students should be able to name them on Exam 1 without the OHE steps mixed in.</a:t>
+              <a:t>Read the six boxes. Students should be able to name them without mixing in the cutting steps.</a:t>
             </a:r>
           </a:p>
         </p:txBody>
@@ -1880,7 +1880,7 @@
           <a:lstStyle/>
           <a:p>
             <a:r>
-              <a:t>Faculty preference at LIU labs may be CHG–alcohol for trunk skin. Hammer ocular/ear contraindications — they have already seen ototoxic ear meds in other contexts.</a:t>
+              <a:t>CHG–alcohol is a common, evidence-supported choice for trunk skin when not contraindicated. Hammer ocular and middle-ear toxicity — this Cocker’s ear is exactly where CHG and aminoglycosides do harm.</a:t>
             </a:r>
           </a:p>
         </p:txBody>
@@ -2090,7 +2090,7 @@
           <a:lstStyle/>
           <a:p>
             <a:r>
-              <a:t>Keep a visible timer. If discussion runs, protect Part II (prep) — that is what lab and OSCE actually watch.</a:t>
+              <a:t>Keep a visible timer. If discussion runs, protect Part II (prep) and the Cocker case.</a:t>
             </a:r>
           </a:p>
         </p:txBody>
@@ -2230,7 +2230,7 @@
           <a:lstStyle/>
           <a:p>
             <a:r>
-              <a:t>Practice gown packs in lab until it is muscle memory. Talking through a contaminated glove replacement is an Exam 1 question.</a:t>
+              <a:t>Closed gloving after gowning is preferred. Talking through a contaminated glove replacement: both gloves off if you are unsure, then start over.</a:t>
             </a:r>
           </a:p>
         </p:txBody>
@@ -2370,7 +2370,7 @@
           <a:lstStyle/>
           <a:p>
             <a:r>
-              <a:t>Connect #1, #2, #3 to today’s lecture. Intra-op details (#4) are later weeks, but ureter injury is a positioning/exposure/identification problem that starts with a calm, well-prepped patient.</a:t>
+              <a:t>Connect hemorrhage, closure, and asepsis to this hour. Ureter injury is a calm, well-prepped, well-exposed patient problem.</a:t>
             </a:r>
           </a:p>
         </p:txBody>
@@ -2650,7 +2650,7 @@
           <a:lstStyle/>
           <a:p>
             <a:r>
-              <a:t>Course CC3. Mention they will practice scoring in skills labs. NSAIDs: not in hypovolemia, kidney injury, GI ulcer, concurrent steroids.</a:t>
+              <a:t>Score pain. NSAIDs: not in hypovolemia, kidney injury, GI ulcer, or concurrent steroids — the Cocker already got DexSP.</a:t>
             </a:r>
           </a:p>
         </p:txBody>
@@ -2930,7 +2930,7 @@
           <a:lstStyle/>
           <a:p>
             <a:r>
-              <a:t>LO 7. Lab assignment later: write a report and discharge for the model/cadaver/live lab. Show them you grade completeness, not handwriting art.</a:t>
+              <a:t>Grade completeness. For the Cocker: neuro exam, ASA III, TM status, DexSP already given, no NSAID, imaging plan.</a:t>
             </a:r>
           </a:p>
         </p:txBody>
@@ -3210,7 +3210,7 @@
           <a:lstStyle/>
           <a:p>
             <a:r>
-              <a:t>Do not lecture LA for 10 minutes. Plant the flag that Halsted travels to the barn.</a:t>
+              <a:t>One minute. Halsted travels to the barn. Then get back to the Cocker.</a:t>
             </a:r>
           </a:p>
         </p:txBody>
@@ -3280,7 +3280,7 @@
           <a:lstStyle/>
           <a:p>
             <a:r>
-              <a:t>Walk it without taking questions until the end. This is the mental movie for lab.</a:t>
+              <a:t>Walk this without questions until the end. Contrast in one sentence: a healthy Lab OHE is ASA I and gets no routine antibiotics. This Cocker is the opposite.</a:t>
             </a:r>
           </a:p>
         </p:txBody>
@@ -3350,7 +3350,7 @@
           <a:lstStyle/>
           <a:p>
             <a:r>
-              <a:t>These six are fair game for MCQ and short answer. Stop here if time is gone.</a:t>
+              <a:t>Stop here if time is gone. The Cocker is the ASA III they should be able to defend.</a:t>
             </a:r>
           </a:p>
         </p:txBody>
@@ -3490,7 +3490,7 @@
           <a:lstStyle/>
           <a:p>
             <a:r>
-              <a:t>Point to Fossum as the night-before reading.</a:t>
+              <a:t>Fossum is the text behind this hour.</a:t>
             </a:r>
           </a:p>
         </p:txBody>
@@ -3560,7 +3560,7 @@
           <a:lstStyle/>
           <a:p>
             <a:r>
-              <a:t>Take questions. If none: ‘What will you do differently on your next observed prep?’ Dismiss on time.</a:t>
+              <a:t>Take questions. If none: what would you do differently for the Cocker than for a healthy Labrador spay? Dismiss on time.</a:t>
             </a:r>
           </a:p>
         </p:txBody>
@@ -7106,7 +7106,7 @@
                 </a:solidFill>
                 <a:latin typeface="Calibri"/>
               </a:rPr>
-              <a:t>DVM 612  ·  PRINCIPLES OF SURGERY  ·  WEEK 4</a:t>
+              <a:t>DVM 612  ·  PRINCIPLES OF SURGERY</a:t>
             </a:r>
           </a:p>
         </p:txBody>
@@ -7174,7 +7174,7 @@
                 </a:solidFill>
                 <a:latin typeface="Calibri"/>
               </a:rPr>
-              <a:t>Lecture  |  60 minutes  |  Semester 3</a:t>
+              <a:t>Lecture  |  60 minutes</a:t>
             </a:r>
           </a:p>
         </p:txBody>
@@ -7207,8 +7207,8 @@
                 </a:solidFill>
                 <a:latin typeface="Calibri"/>
               </a:rPr>
-              <a:t>Mapped to DVM 612 course learning objectives 4, 7, and 8:
-asepsis and surgical preparation · postoperative plan and discharge · monitoring and recovery.</a:t>
+              <a:t>Preoperative evaluation · patient and surgeon preparation · postoperative care.
+Running case: Cocker Spaniel with severe otitis and vestibular disease.</a:t>
             </a:r>
           </a:p>
         </p:txBody>
@@ -7843,7 +7843,7 @@
                 </a:solidFill>
                 <a:latin typeface="Calibri"/>
               </a:rPr>
-              <a:t>DVM 612  |  Principles of Surgery  |  Week 4  |  Lewyt College of Veterinary Medicine</a:t>
+              <a:t>DVM 612  |  Principles of Surgery  |  Preop · prep · postop  |  Lewyt College of Veterinary Medicine</a:t>
             </a:r>
           </a:p>
         </p:txBody>
@@ -9285,7 +9285,7 @@
                 </a:solidFill>
                 <a:latin typeface="Calibri"/>
               </a:rPr>
-              <a:t>DVM 612  |  Principles of Surgery  |  Week 4  |  Lewyt College of Veterinary Medicine</a:t>
+              <a:t>DVM 612  |  Principles of Surgery  |  Preop · prep · postop  |  Lewyt College of Veterinary Medicine</a:t>
             </a:r>
           </a:p>
         </p:txBody>
@@ -10398,7 +10398,7 @@
                 </a:solidFill>
                 <a:latin typeface="Calibri"/>
               </a:rPr>
-              <a:t>DVM 612  |  Principles of Surgery  |  Week 4  |  Lewyt College of Veterinary Medicine</a:t>
+              <a:t>DVM 612  |  Principles of Surgery  |  Preop · prep · postop  |  Lewyt College of Veterinary Medicine</a:t>
             </a:r>
           </a:p>
         </p:txBody>
@@ -11303,7 +11303,7 @@
                 </a:solidFill>
                 <a:latin typeface="Calibri"/>
               </a:rPr>
-              <a:t>DVM 612  |  Principles of Surgery  |  Week 4  |  Lewyt College of Veterinary Medicine</a:t>
+              <a:t>DVM 612  |  Principles of Surgery  |  Preop · prep · postop  |  Lewyt College of Veterinary Medicine</a:t>
             </a:r>
           </a:p>
         </p:txBody>
@@ -11979,7 +11979,7 @@
                 </a:solidFill>
                 <a:latin typeface="Calibri"/>
               </a:rPr>
-              <a:t>DVM 612  |  Principles of Surgery  |  Week 4  |  Lewyt College of Veterinary Medicine</a:t>
+              <a:t>DVM 612  |  Principles of Surgery  |  Preop · prep · postop  |  Lewyt College of Veterinary Medicine</a:t>
             </a:r>
           </a:p>
         </p:txBody>
@@ -12801,7 +12801,7 @@
                 </a:solidFill>
                 <a:latin typeface="Calibri"/>
               </a:rPr>
-              <a:t>DVM 612  |  Principles of Surgery  |  Week 4  |  Lewyt College of Veterinary Medicine</a:t>
+              <a:t>DVM 612  |  Principles of Surgery  |  Preop · prep · postop  |  Lewyt College of Veterinary Medicine</a:t>
             </a:r>
           </a:p>
         </p:txBody>
@@ -13646,7 +13646,7 @@
                 </a:solidFill>
                 <a:latin typeface="Calibri"/>
               </a:rPr>
-              <a:t>DVM 612  |  Principles of Surgery  |  Week 4  |  Lewyt College of Veterinary Medicine</a:t>
+              <a:t>DVM 612  |  Principles of Surgery  |  Preop · prep · postop  |  Lewyt College of Veterinary Medicine</a:t>
             </a:r>
           </a:p>
         </p:txBody>
@@ -14389,7 +14389,7 @@
                 </a:solidFill>
                 <a:latin typeface="Calibri"/>
               </a:rPr>
-              <a:t>DVM 612  |  Principles of Surgery  |  Week 4  |  Lewyt College of Veterinary Medicine</a:t>
+              <a:t>DVM 612  |  Principles of Surgery  |  Preop · prep · postop  |  Lewyt College of Veterinary Medicine</a:t>
             </a:r>
           </a:p>
         </p:txBody>
@@ -14602,7 +14602,7 @@
                 </a:solidFill>
                 <a:latin typeface="Calibri"/>
               </a:rPr>
-              <a:t>DVM 612 / CC8  ·  WEEK 3 COMMUNICATION CONTINUES HERE</a:t>
+              <a:t>IF YOU DID NOT SAY IT, YOU DID NOT CONSENT</a:t>
             </a:r>
           </a:p>
         </p:txBody>
@@ -14985,7 +14985,7 @@
                 </a:solidFill>
                 <a:latin typeface="Calibri"/>
               </a:rPr>
-              <a:t>DVM 612  |  Principles of Surgery  |  Week 4  |  Lewyt College of Veterinary Medicine</a:t>
+              <a:t>DVM 612  |  Principles of Surgery  |  Preop · prep · postop  |  Lewyt College of Veterinary Medicine</a:t>
             </a:r>
           </a:p>
         </p:txBody>
@@ -15792,7 +15792,7 @@
                 </a:solidFill>
                 <a:latin typeface="Calibri"/>
               </a:rPr>
-              <a:t>DVM 612  |  Principles of Surgery  |  Week 4  |  Lewyt College of Veterinary Medicine</a:t>
+              <a:t>DVM 612  |  Principles of Surgery  |  Preop · prep · postop  |  Lewyt College of Veterinary Medicine</a:t>
             </a:r>
           </a:p>
         </p:txBody>
@@ -16005,7 +16005,7 @@
                 </a:solidFill>
                 <a:latin typeface="Calibri"/>
               </a:rPr>
-              <a:t>LEARNING OBJECTIVES  ·  DVM 612 LOS 4, 7, 8</a:t>
+              <a:t>LEARNING OBJECTIVES</a:t>
             </a:r>
           </a:p>
         </p:txBody>
@@ -16262,7 +16262,7 @@
                 </a:solidFill>
                 <a:latin typeface="Calibri"/>
               </a:rPr>
-              <a:t>This lecture does not teach how to cut, ligate, or close — that is Weeks 5–12. Today is judgment, asepsis, and aftercare. Poor prep cannot be rescued by elegant suture.</a:t>
+              <a:t>Today is judgment, asepsis, and aftercare. Poor prep cannot be rescued by elegant suture. We will apply every section to the vestibular Cocker.</a:t>
             </a:r>
           </a:p>
         </p:txBody>
@@ -16338,7 +16338,7 @@
                 </a:solidFill>
                 <a:latin typeface="Calibri"/>
               </a:rPr>
-              <a:t>DVM 612  |  Principles of Surgery  |  Week 4  |  Lewyt College of Veterinary Medicine</a:t>
+              <a:t>DVM 612  |  Principles of Surgery  |  Preop · prep · postop  |  Lewyt College of Veterinary Medicine</a:t>
             </a:r>
           </a:p>
         </p:txBody>
@@ -16551,7 +16551,7 @@
                 </a:solidFill>
                 <a:latin typeface="Calibri"/>
               </a:rPr>
-              <a:t>AAHA/AAFP 2022  ·  DVM 613 WILL THANK YOU</a:t>
+              <a:t>AAHA/AAFP 2022</a:t>
             </a:r>
           </a:p>
         </p:txBody>
@@ -16937,7 +16937,7 @@
                 </a:solidFill>
                 <a:latin typeface="Calibri"/>
               </a:rPr>
-              <a:t>DVM 612  |  Principles of Surgery  |  Week 4  |  Lewyt College of Veterinary Medicine</a:t>
+              <a:t>DVM 612  |  Principles of Surgery  |  Preop · prep · postop  |  Lewyt College of Veterinary Medicine</a:t>
             </a:r>
           </a:p>
         </p:txBody>
@@ -17863,7 +17863,7 @@
                 </a:solidFill>
                 <a:latin typeface="Calibri"/>
               </a:rPr>
-              <a:t>DVM 612  |  Principles of Surgery  |  Week 4  |  Lewyt College of Veterinary Medicine</a:t>
+              <a:t>DVM 612  |  Principles of Surgery  |  Preop · prep · postop  |  Lewyt College of Veterinary Medicine</a:t>
             </a:r>
           </a:p>
         </p:txBody>
@@ -18434,7 +18434,7 @@
                 </a:solidFill>
                 <a:latin typeface="Calibri"/>
               </a:rPr>
-              <a:t>DVM 612 LABORATORY AND OSCE — SAME SKILLS YOU WILL USE EVERY SURGERY DAY</a:t>
+              <a:t>THE SAME SIX BOXES EVERY TIME YOU TAKE A PATIENT TO SURGERY</a:t>
             </a:r>
           </a:p>
         </p:txBody>
@@ -18510,7 +18510,7 @@
                 </a:solidFill>
                 <a:latin typeface="Calibri"/>
               </a:rPr>
-              <a:t>What we actually score in patient and surgeon prep</a:t>
+              <a:t>What we actually check in patient and surgeon prep</a:t>
             </a:r>
           </a:p>
         </p:txBody>
@@ -19500,7 +19500,7 @@
                 </a:solidFill>
                 <a:latin typeface="Calibri"/>
               </a:rPr>
-              <a:t>Four-quadrant draping is the DVM 612 standard. Hair must not show at the drape edge. Maintain the field.</a:t>
+              <a:t>Four-quadrant draping is the standard. Hair must not show at the drape edge. Maintain the field.</a:t>
             </a:r>
           </a:p>
         </p:txBody>
@@ -19576,7 +19576,7 @@
                 </a:solidFill>
                 <a:latin typeface="Calibri"/>
               </a:rPr>
-              <a:t>DVM 612  |  Principles of Surgery  |  Week 4  |  Lewyt College of Veterinary Medicine</a:t>
+              <a:t>DVM 612  |  Principles of Surgery  |  Preop · prep · postop  |  Lewyt College of Veterinary Medicine</a:t>
             </a:r>
           </a:p>
         </p:txBody>
@@ -21173,7 +21173,7 @@
                 </a:solidFill>
                 <a:latin typeface="Calibri"/>
               </a:rPr>
-              <a:t>DVM 612  |  Principles of Surgery  |  Week 4  |  Lewyt College of Veterinary Medicine</a:t>
+              <a:t>DVM 612  |  Principles of Surgery  |  Preop · prep · postop  |  Lewyt College of Veterinary Medicine</a:t>
             </a:r>
           </a:p>
         </p:txBody>
@@ -21770,7 +21770,7 @@
                 </a:solidFill>
                 <a:latin typeface="Calibri"/>
               </a:rPr>
-              <a:t>DVM 612  |  Principles of Surgery  |  Week 4  |  Lewyt College of Veterinary Medicine</a:t>
+              <a:t>DVM 612  |  Principles of Surgery  |  Preop · prep · postop  |  Lewyt College of Veterinary Medicine</a:t>
             </a:r>
           </a:p>
         </p:txBody>
@@ -22367,7 +22367,7 @@
                 </a:solidFill>
                 <a:latin typeface="Calibri"/>
               </a:rPr>
-              <a:t>Scrotum ± prescrotal abdomen; some surgeons shave scrotum, some don’t — know lab SOP. Clip wide enough for drape.</a:t>
+              <a:t>Scrotum ± prescrotal abdomen; some surgeons shave scrotum, some don’t — follow your hospital SOP. Clip wide enough for drape.</a:t>
             </a:r>
           </a:p>
         </p:txBody>
@@ -23059,7 +23059,7 @@
                 </a:solidFill>
                 <a:latin typeface="Calibri"/>
               </a:rPr>
-              <a:t>DVM 612  |  Principles of Surgery  |  Week 4  |  Lewyt College of Veterinary Medicine</a:t>
+              <a:t>DVM 612  |  Principles of Surgery  |  Preop · prep · postop  |  Lewyt College of Veterinary Medicine</a:t>
             </a:r>
           </a:p>
         </p:txBody>
@@ -23897,7 +23897,7 @@
                 </a:solidFill>
                 <a:latin typeface="Calibri"/>
               </a:rPr>
-              <a:t>DVM 612  |  Principles of Surgery  |  Week 4  |  Lewyt College of Veterinary Medicine</a:t>
+              <a:t>DVM 612  |  Principles of Surgery  |  Preop · prep · postop  |  Lewyt College of Veterinary Medicine</a:t>
             </a:r>
           </a:p>
         </p:txBody>
@@ -24481,7 +24481,7 @@
                 </a:solidFill>
                 <a:latin typeface="Calibri"/>
               </a:rPr>
-              <a:t>DVM 612  |  Principles of Surgery  |  Week 4  |  Lewyt College of Veterinary Medicine</a:t>
+              <a:t>DVM 612  |  Principles of Surgery  |  Preop · prep · postop  |  Lewyt College of Veterinary Medicine</a:t>
             </a:r>
           </a:p>
         </p:txBody>
@@ -25462,7 +25462,7 @@
                 </a:solidFill>
                 <a:latin typeface="Calibri"/>
               </a:rPr>
-              <a:t>DVM 612  |  Principles of Surgery  |  Week 4  |  Lewyt College of Veterinary Medicine</a:t>
+              <a:t>DVM 612  |  Principles of Surgery  |  Preop · prep · postop  |  Lewyt College of Veterinary Medicine</a:t>
             </a:r>
           </a:p>
         </p:txBody>
@@ -26521,7 +26521,7 @@
                 </a:solidFill>
                 <a:latin typeface="Calibri"/>
               </a:rPr>
-              <a:t>Case wrap, exam pearls, questions</a:t>
+              <a:t>Cocker walk-through, key points, questions</a:t>
             </a:r>
           </a:p>
         </p:txBody>
@@ -26597,7 +26597,7 @@
                 </a:solidFill>
                 <a:latin typeface="Calibri"/>
               </a:rPr>
-              <a:t>DVM 612  |  Principles of Surgery  |  Week 4  |  Lewyt College of Veterinary Medicine</a:t>
+              <a:t>DVM 612  |  Principles of Surgery  |  Preop · prep · postop  |  Lewyt College of Veterinary Medicine</a:t>
             </a:r>
           </a:p>
         </p:txBody>
@@ -26810,7 +26810,7 @@
                 </a:solidFill>
                 <a:latin typeface="Calibri"/>
               </a:rPr>
-              <a:t>GOWN, GLOVE, BOX THE FIELD, THEN THE LARGE DRAPE — DVM 612 LAB STANDARD</a:t>
+              <a:t>GOWN, GLOVE, BOX THE FIELD, THEN THE LARGE DRAPE</a:t>
             </a:r>
           </a:p>
         </p:txBody>
@@ -26957,7 +26957,7 @@
                 </a:solidFill>
                 <a:latin typeface="Calibri"/>
               </a:rPr>
-              <a:t>▸  Secure (Backhaus clamps or atraumatic alternatives per lab). Do not tent the skin into the incision. Do not puncture the patient’s skin carelessly with clamps.</a:t>
+              <a:t>▸  Secure (Backhaus clamps or atraumatic alternatives). Do not tent the skin into the incision. Do not puncture the patient’s skin carelessly with clamps.</a:t>
             </a:r>
           </a:p>
           <a:p>
@@ -27124,7 +27124,7 @@
 5. Organize instruments on a sterile table
 6. Timeout
 7. Announce: ready to incise
-In lab: tell your instructor before the incision.</a:t>
+Tell your assistant before the incision.</a:t>
             </a:r>
           </a:p>
         </p:txBody>
@@ -27200,7 +27200,7 @@
                 </a:solidFill>
                 <a:latin typeface="Calibri"/>
               </a:rPr>
-              <a:t>DVM 612  |  Principles of Surgery  |  Week 4  |  Lewyt College of Veterinary Medicine</a:t>
+              <a:t>DVM 612  |  Principles of Surgery  |  Preop · prep · postop  |  Lewyt College of Veterinary Medicine</a:t>
             </a:r>
           </a:p>
         </p:txBody>
@@ -28105,7 +28105,7 @@
                 </a:solidFill>
                 <a:latin typeface="Calibri"/>
               </a:rPr>
-              <a:t>DVM 612  |  Principles of Surgery  |  Week 4  |  Lewyt College of Veterinary Medicine</a:t>
+              <a:t>DVM 612  |  Principles of Surgery  |  Preop · prep · postop  |  Lewyt College of Veterinary Medicine</a:t>
             </a:r>
           </a:p>
         </p:txBody>
@@ -28506,8 +28506,8 @@
                 <a:latin typeface="Calibri"/>
               </a:rPr>
               <a:t>If YOU contaminate yourself or the field: say it immediately and correct (re-glove, re-gown, re-drape).
-In lab we will stop you once to teach the correction if you miss it.
-A second unrecognized break means you cannot maintain an aseptic field — that lab is over.
+Name it once, fix it completely.
+A second unrecognized break means you cannot maintain an aseptic field — stop.
 This is how we protect a client-owned animal, not a game of gotcha.</a:t>
             </a:r>
           </a:p>
@@ -28698,7 +28698,7 @@
                 </a:solidFill>
                 <a:latin typeface="Calibri"/>
               </a:rPr>
-              <a:t>DVM 612  |  Principles of Surgery  |  Week 4  |  Lewyt College of Veterinary Medicine</a:t>
+              <a:t>DVM 612  |  Principles of Surgery  |  Preop · prep · postop  |  Lewyt College of Veterinary Medicine</a:t>
             </a:r>
           </a:p>
         </p:txBody>
@@ -29244,7 +29244,7 @@
                 </a:solidFill>
                 <a:latin typeface="Calibri"/>
               </a:rPr>
-              <a:t>DVM 612  |  Principles of Surgery  |  Week 4  |  Lewyt College of Veterinary Medicine</a:t>
+              <a:t>DVM 612  |  Principles of Surgery  |  Preop · prep · postop  |  Lewyt College of Veterinary Medicine</a:t>
             </a:r>
           </a:p>
         </p:txBody>
@@ -30357,7 +30357,7 @@
                 </a:solidFill>
                 <a:latin typeface="Calibri"/>
               </a:rPr>
-              <a:t>DVM 612  |  Principles of Surgery  |  Week 4  |  Lewyt College of Veterinary Medicine</a:t>
+              <a:t>DVM 612  |  Principles of Surgery  |  Preop · prep · postop  |  Lewyt College of Veterinary Medicine</a:t>
             </a:r>
           </a:p>
         </p:txBody>
@@ -32003,7 +32003,7 @@
                 </a:solidFill>
                 <a:latin typeface="Calibri"/>
               </a:rPr>
-              <a:t>DVM 612  |  Principles of Surgery  |  Week 4  |  Lewyt College of Veterinary Medicine</a:t>
+              <a:t>DVM 612  |  Principles of Surgery  |  Preop · prep · postop  |  Lewyt College of Veterinary Medicine</a:t>
             </a:r>
           </a:p>
         </p:txBody>
@@ -32730,7 +32730,7 @@
                 </a:solidFill>
                 <a:latin typeface="Calibri"/>
               </a:rPr>
-              <a:t>DVM 612  |  Principles of Surgery  |  Week 4  |  Lewyt College of Veterinary Medicine</a:t>
+              <a:t>DVM 612  |  Principles of Surgery  |  Preop · prep · postop  |  Lewyt College of Veterinary Medicine</a:t>
             </a:r>
           </a:p>
         </p:txBody>
@@ -33789,7 +33789,7 @@
                 </a:solidFill>
                 <a:latin typeface="Calibri"/>
               </a:rPr>
-              <a:t>If placed (Week 15): output, site, when to pull. Never send a drain without a written plan.</a:t>
+              <a:t>If placed: record output, site, and when to pull. Never send a drain without a written plan.</a:t>
             </a:r>
           </a:p>
         </p:txBody>
@@ -34019,7 +34019,7 @@
                 </a:solidFill>
                 <a:latin typeface="Calibri"/>
               </a:rPr>
-              <a:t>DVM 612  |  Principles of Surgery  |  Week 4  |  Lewyt College of Veterinary Medicine</a:t>
+              <a:t>DVM 612  |  Principles of Surgery  |  Preop · prep · postop  |  Lewyt College of Veterinary Medicine</a:t>
             </a:r>
           </a:p>
         </p:txBody>
@@ -35308,7 +35308,7 @@
                 </a:solidFill>
                 <a:latin typeface="Calibri"/>
               </a:rPr>
-              <a:t>DVM 612  |  Principles of Surgery  |  Week 4  |  Lewyt College of Veterinary Medicine</a:t>
+              <a:t>DVM 612  |  Principles of Surgery  |  Preop · prep · postop  |  Lewyt College of Veterinary Medicine</a:t>
             </a:r>
           </a:p>
         </p:txBody>
@@ -36284,7 +36284,7 @@
                 </a:solidFill>
                 <a:latin typeface="Calibri"/>
               </a:rPr>
-              <a:t>DVM 612  |  Principles of Surgery  |  Week 4  |  Lewyt College of Veterinary Medicine</a:t>
+              <a:t>DVM 612  |  Principles of Surgery  |  Preop · prep · postop  |  Lewyt College of Veterinary Medicine</a:t>
             </a:r>
           </a:p>
         </p:txBody>
@@ -36497,7 +36497,7 @@
                 </a:solidFill>
                 <a:latin typeface="Calibri"/>
               </a:rPr>
-              <a:t>DVM 612 LO 7  ·  WEEK 3 REPORTS, APPLIED TODAY</a:t>
+              <a:t>THE NEXT DOCTOR AT 2 A.M. IS YOUR AUDIENCE</a:t>
             </a:r>
           </a:p>
         </p:txBody>
@@ -37023,7 +37023,7 @@
                 </a:solidFill>
                 <a:latin typeface="Calibri"/>
               </a:rPr>
-              <a:t>DVM 612  |  Principles of Surgery  |  Week 4  |  Lewyt College of Veterinary Medicine</a:t>
+              <a:t>DVM 612  |  Principles of Surgery  |  Preop · prep · postop  |  Lewyt College of Veterinary Medicine</a:t>
             </a:r>
           </a:p>
         </p:txBody>
@@ -37312,7 +37312,7 @@
                 </a:solidFill>
                 <a:latin typeface="Calibri"/>
               </a:rPr>
-              <a:t>Discharge instructions — LO 7 in the client’s language</a:t>
+              <a:t>Discharge instructions — in the client’s language</a:t>
             </a:r>
           </a:p>
         </p:txBody>
@@ -38356,7 +38356,7 @@
                 </a:solidFill>
                 <a:latin typeface="Calibri"/>
               </a:rPr>
-              <a:t>DVM 612  |  Principles of Surgery  |  Week 4  |  Lewyt College of Veterinary Medicine</a:t>
+              <a:t>DVM 612  |  Principles of Surgery  |  Preop · prep · postop  |  Lewyt College of Veterinary Medicine</a:t>
             </a:r>
           </a:p>
         </p:txBody>
@@ -39183,7 +39183,7 @@
                 </a:solidFill>
                 <a:latin typeface="Calibri"/>
               </a:rPr>
-              <a:t>DVM 612  |  Principles of Surgery  |  Week 4  |  Lewyt College of Veterinary Medicine</a:t>
+              <a:t>DVM 612  |  Principles of Surgery  |  Preop · prep · postop  |  Lewyt College of Veterinary Medicine</a:t>
             </a:r>
           </a:p>
         </p:txBody>
@@ -40010,7 +40010,7 @@
                 </a:solidFill>
                 <a:latin typeface="Calibri"/>
               </a:rPr>
-              <a:t>DVM 612  |  Principles of Surgery  |  Week 4  |  Lewyt College of Veterinary Medicine</a:t>
+              <a:t>DVM 612  |  Principles of Surgery  |  Preop · prep · postop  |  Lewyt College of Veterinary Medicine</a:t>
             </a:r>
           </a:p>
         </p:txBody>
@@ -40223,7 +40223,7 @@
                 </a:solidFill>
                 <a:latin typeface="Calibri"/>
               </a:rPr>
-              <a:t>SAME PRINCIPLES; DIFFERENT DIRT, RESTRAINT, AND RECOVERY</a:t>
+              <a:t>FIELD SURGERY IS STILL HALSTED; IT IS NOT AN EXCUSE TO SKIP CLIP, GLOVES, AND A DRAPE</a:t>
             </a:r>
           </a:p>
         </p:txBody>
@@ -40299,7 +40299,7 @@
                 </a:solidFill>
                 <a:latin typeface="Calibri"/>
               </a:rPr>
-              <a:t>Large animal footnote (Week 13 will go deep)</a:t>
+              <a:t>Large animal — same principles, different dirt</a:t>
             </a:r>
           </a:p>
         </p:txBody>
@@ -40494,7 +40494,7 @@
                 </a:solidFill>
                 <a:latin typeface="Calibri"/>
               </a:rPr>
-              <a:t>DVM 612  |  Principles of Surgery  |  Week 4  |  Lewyt College of Veterinary Medicine</a:t>
+              <a:t>DVM 612  |  Principles of Surgery  |  Preop · prep · postop  |  Lewyt College of Veterinary Medicine</a:t>
             </a:r>
           </a:p>
         </p:txBody>
@@ -40707,7 +40707,7 @@
                 </a:solidFill>
                 <a:latin typeface="Calibri"/>
               </a:rPr>
-              <a:t>YOU ARE THE SURGEON. THE ANESTHESIA STUDENT HAS THE DOG READY FOR YOU.</a:t>
+              <a:t>YOU ARE THE SURGEON. CLIENT IS IN RECEPTION.</a:t>
             </a:r>
           </a:p>
         </p:txBody>
@@ -40783,7 +40783,7 @@
                 </a:solidFill>
                 <a:latin typeface="Calibri"/>
               </a:rPr>
-              <a:t>Integrated case — 8 minutes</a:t>
+              <a:t>Walk the Cocker through the whole hour</a:t>
             </a:r>
           </a:p>
         </p:txBody>
@@ -40855,13 +40855,13 @@
           <a:p>
             <a:pPr algn="l"/>
             <a:r>
-              <a:rPr sz="1600" b="0">
+              <a:rPr sz="1500" b="0">
                 <a:solidFill>
                   <a:srgbClr val="0B2C4A"/>
                 </a:solidFill>
                 <a:latin typeface="Calibri"/>
               </a:rPr>
-              <a:t>1-year-old female Labrador, 22 kg, BCS 5/9. Elective OHE. PE normal. PCV 45%, TS 6.8 g/dL. Last meal 5 hours ago. Client is in reception. Client-owned animal, going home after recovery.</a:t>
+              <a:t>Adult Cocker Spaniel. Severe otitis externa. Canal patent. TM intact. DexSP already given. Circling left, nystagmus, knuckling right. Cardiovascularly stable, walking. This is ASA III. Client-owned. Going home after recovery — if you decide recovery is in the hospital tonight.</a:t>
             </a:r>
           </a:p>
         </p:txBody>
@@ -41009,13 +41009,13 @@
           <a:p>
             <a:pPr algn="l"/>
             <a:r>
-              <a:rPr sz="1300" b="0">
+              <a:rPr sz="1200" b="0">
                 <a:solidFill>
                   <a:srgbClr val="1C1C1C"/>
                 </a:solidFill>
                 <a:latin typeface="Calibri"/>
               </a:rPr>
-              <a:t>ASA I. Consent + DNR. No routine Abx. Opioid + NSAID plan + line block. Checklist.</a:t>
+              <a:t>ASA III. Neuro exam. No NSAID (DexSP on board). No aminoglycoside in the ear. Culture. CT/MRI before TECA. Antibiotics are treatment, not clean prophylaxis. Consent: head tilt, deafness, facial nerve.</a:t>
             </a:r>
           </a:p>
         </p:txBody>
@@ -41163,13 +41163,13 @@
           <a:p>
             <a:pPr algn="l"/>
             <a:r>
-              <a:rPr sz="1300" b="0">
+              <a:rPr sz="1200" b="0">
                 <a:solidFill>
                   <a:srgbClr val="1C1C1C"/>
                 </a:solidFill>
                 <a:latin typeface="Calibri"/>
               </a:rPr>
-              <a:t>Clip xiphoid–pubis after plane is surgical. Dirty prep → OR → dorsal → sterile prep → four-quadrant drape. Closed glove.</a:t>
+              <a:t>Only after a surgical plane. Clip the intended field (ear/bulla vs TECA). Dirty then sterile prep. CHG off the canal/ear and off the eye. Position padded — this dog falls. Four-quadrant drape. Closed glove.</a:t>
             </a:r>
           </a:p>
         </p:txBody>
@@ -41317,13 +41317,13 @@
           <a:p>
             <a:pPr algn="l"/>
             <a:r>
-              <a:rPr sz="1300" b="0">
+              <a:rPr sz="1200" b="0">
                 <a:solidFill>
                   <a:srgbClr val="1C1C1C"/>
                 </a:solidFill>
                 <a:latin typeface="Calibri"/>
               </a:rPr>
-              <a:t>Announce incision. Halsted. Show pedicles before you drop them. Secure linea. Skin closure you can defend.</a:t>
+              <a:t>Timeout. Maintain asepsis. If you contaminate, say it and fix it. Do not treat this like a 20-minute spay.</a:t>
             </a:r>
           </a:p>
         </p:txBody>
@@ -41471,13 +41471,13 @@
           <a:p>
             <a:pPr algn="l"/>
             <a:r>
-              <a:rPr sz="1300" b="0">
+              <a:rPr sz="1200" b="0">
                 <a:solidFill>
                   <a:srgbClr val="1C1C1C"/>
                 </a:solidFill>
                 <a:latin typeface="Calibri"/>
               </a:rPr>
-              <a:t>Rewarm, score pain, e-collar. Watch color/HR. Written discharge + ER list. Recheck 10–14 d. You are still responsible at hour 23.</a:t>
+              <a:t>Airway, temp, pain score. No NSAID tonight. Watch for worsening vestibular signs, aspiration, incision. Written discharge + ER list. You still own hour 23.</a:t>
             </a:r>
           </a:p>
         </p:txBody>
@@ -41553,7 +41553,7 @@
                 </a:solidFill>
                 <a:latin typeface="Calibri"/>
               </a:rPr>
-              <a:t>DVM 612  |  Principles of Surgery  |  Week 4  |  Lewyt College of Veterinary Medicine</a:t>
+              <a:t>DVM 612  |  Principles of Surgery  |  Preop · prep · postop  |  Lewyt College of Veterinary Medicine</a:t>
             </a:r>
           </a:p>
         </p:txBody>
@@ -41842,7 +41842,7 @@
                 </a:solidFill>
                 <a:latin typeface="Calibri"/>
               </a:rPr>
-              <a:t>Exam 1 pearls</a:t>
+              <a:t>Key points from this hour</a:t>
             </a:r>
           </a:p>
         </p:txBody>
@@ -42842,7 +42842,7 @@
                 </a:solidFill>
                 <a:latin typeface="Calibri"/>
               </a:rPr>
-              <a:t>DVM 612  |  Principles of Surgery  |  Week 4  |  Lewyt College of Veterinary Medicine</a:t>
+              <a:t>DVM 612  |  Principles of Surgery  |  Preop · prep · postop  |  Lewyt College of Veterinary Medicine</a:t>
             </a:r>
           </a:p>
         </p:txBody>
@@ -43288,7 +43288,7 @@
                 </a:solidFill>
                 <a:latin typeface="Calibri"/>
               </a:rPr>
-              <a:t>DVM 612  |  Principles of Surgery  |  Week 4  |  Lewyt College of Veterinary Medicine</a:t>
+              <a:t>DVM 612  |  Principles of Surgery  |  Preop · prep · postop  |  Lewyt College of Veterinary Medicine</a:t>
             </a:r>
           </a:p>
         </p:txBody>
@@ -43501,7 +43501,7 @@
                 </a:solidFill>
                 <a:latin typeface="Calibri"/>
               </a:rPr>
-              <a:t>WHAT TO READ TONIGHT</a:t>
+              <a:t>SOURCES USED IN THIS LECTURE</a:t>
             </a:r>
           </a:p>
         </p:txBody>
@@ -43577,7 +43577,7 @@
                 </a:solidFill>
                 <a:latin typeface="Calibri"/>
               </a:rPr>
-              <a:t>References &amp; source map</a:t>
+              <a:t>References</a:t>
             </a:r>
           </a:p>
         </p:txBody>
@@ -43616,7 +43616,7 @@
                 </a:solidFill>
                 <a:latin typeface="Calibri"/>
               </a:rPr>
-              <a:t>▸  Fossum T.W. Small Animal Surgery. 5th ed. Elsevier; 2018. — preoperative evaluation, patient prep, postop care chapters (required).</a:t>
+              <a:t>▸  Fossum T.W. Small Animal Surgery. 5th ed. Elsevier; 2018. Preoperative evaluation, patient preparation, postoperative care.</a:t>
             </a:r>
           </a:p>
           <a:p>
@@ -43632,7 +43632,7 @@
                 </a:solidFill>
                 <a:latin typeface="Calibri"/>
               </a:rPr>
-              <a:t>▸  Hendrickson D.A., Baird A.N. Turner and McIlwraith’s Techniques in Large Animal Surgery. 4th ed. Wiley-Blackwell; 2013. (required)</a:t>
+              <a:t>▸  Hendrickson D.A., Baird A.N. Turner and McIlwraith’s Techniques in Large Animal Surgery. 4th ed. Wiley-Blackwell; 2013.</a:t>
             </a:r>
           </a:p>
           <a:p>
@@ -43683,22 +43683,6 @@
               <a:t>▸  AAHA Anesthesia and Monitoring Guidelines (current edition) — fasting, PE, monitoring, recovery.</a:t>
             </a:r>
           </a:p>
-          <a:p>
-            <a:pPr algn="l">
-              <a:spcAft>
-                <a:spcPts val="800"/>
-              </a:spcAft>
-            </a:pPr>
-            <a:r>
-              <a:rPr sz="1500" b="0">
-                <a:solidFill>
-                  <a:srgbClr val="1C1C1C"/>
-                </a:solidFill>
-                <a:latin typeface="Calibri"/>
-              </a:rPr>
-              <a:t>▸  LIU Lewyt CVM. DVM 612 Principles of Surgery course outline (Week 4 topic; LOs 4, 7, 8).</a:t>
-            </a:r>
-          </a:p>
         </p:txBody>
       </p:sp>
       <p:sp>
@@ -43772,7 +43756,7 @@
                 </a:solidFill>
                 <a:latin typeface="Calibri"/>
               </a:rPr>
-              <a:t>DVM 612  |  Principles of Surgery  |  Week 4  |  Lewyt College of Veterinary Medicine</a:t>
+              <a:t>DVM 612  |  Principles of Surgery  |  Preop · prep · postop  |  Lewyt College of Veterinary Medicine</a:t>
             </a:r>
           </a:p>
         </p:txBody>
@@ -43985,7 +43969,7 @@
                 </a:solidFill>
                 <a:latin typeface="Calibri"/>
               </a:rPr>
-              <a:t>DVM 612  ·  WEEK 4</a:t>
+              <a:t>DVM 612  ·  PRINCIPLES OF SURGERY</a:t>
             </a:r>
           </a:p>
         </p:txBody>
@@ -44051,8 +44035,8 @@
                 </a:solidFill>
                 <a:latin typeface="Calibri"/>
               </a:rPr>
-              <a:t>Next lab: practice the clip–prep–drape sequence on models until it is boring.
-Boring is the goal. Excitement belongs to the pathology, not the asepsis.</a:t>
+              <a:t>If there are no questions: what would you do differently for the Cocker
+than for a healthy Labrador spay?</a:t>
             </a:r>
           </a:p>
         </p:txBody>
@@ -44298,7 +44282,7 @@
                 </a:solidFill>
                 <a:latin typeface="Calibri"/>
               </a:rPr>
-              <a:t>WEEK 1 RECAP THAT YOU WILL APPLY, NOT RECITE</a:t>
+              <a:t>EVERY PRINCIPLE HAS A PREOP OR POSTOP ACTION, NOT ONLY AN INTRAOPERATIVE ONE</a:t>
             </a:r>
           </a:p>
         </p:txBody>
@@ -45452,7 +45436,7 @@
                 </a:solidFill>
                 <a:latin typeface="Calibri"/>
               </a:rPr>
-              <a:t>Drains and bandages (Week 15) start with today’s wound plan.</a:t>
+              <a:t>Plan dead space now: sutures, bandage, or a drain with a written pull plan.</a:t>
             </a:r>
           </a:p>
         </p:txBody>
@@ -45528,7 +45512,7 @@
                 </a:solidFill>
                 <a:latin typeface="Calibri"/>
               </a:rPr>
-              <a:t>DVM 612  |  Principles of Surgery  |  Week 4  |  Lewyt College of Veterinary Medicine</a:t>
+              <a:t>DVM 612  |  Principles of Surgery  |  Preop · prep · postop  |  Lewyt College of Veterinary Medicine</a:t>
             </a:r>
           </a:p>
         </p:txBody>
@@ -46353,8 +46337,7 @@
               </a:rPr>
               <a:t>Asepsis held
 Halsted applied
-Time, temp, pain
-(Weeks 5–12)</a:t>
+Time, temp, pain</a:t>
             </a:r>
           </a:p>
         </p:txBody>
@@ -46620,7 +46603,7 @@
                 </a:solidFill>
                 <a:latin typeface="Calibri"/>
               </a:rPr>
-              <a:t>DVM 612  |  Principles of Surgery  |  Week 4  |  Lewyt College of Veterinary Medicine</a:t>
+              <a:t>DVM 612  |  Principles of Surgery  |  Preop · prep · postop  |  Lewyt College of Veterinary Medicine</a:t>
             </a:r>
           </a:p>
         </p:txBody>
@@ -48091,7 +48074,7 @@
                 </a:solidFill>
                 <a:latin typeface="Calibri"/>
               </a:rPr>
-              <a:t>DVM 612  |  Principles of Surgery  |  Week 4  |  Lewyt College of Veterinary Medicine</a:t>
+              <a:t>DVM 612  |  Principles of Surgery  |  Preop · prep · postop  |  Lewyt College of Veterinary Medicine</a:t>
             </a:r>
           </a:p>
         </p:txBody>
@@ -48786,7 +48769,7 @@
                 </a:solidFill>
                 <a:latin typeface="Calibri"/>
               </a:rPr>
-              <a:t>DVM 612  |  Principles of Surgery  |  Week 4  |  Lewyt College of Veterinary Medicine</a:t>
+              <a:t>DVM 612  |  Principles of Surgery  |  Preop · prep · postop  |  Lewyt College of Veterinary Medicine</a:t>
             </a:r>
           </a:p>
         </p:txBody>

</xml_diff>

<commit_message>
Ground the DVM 612 lecture case in Willie’s record.
Replace the generic Cocker with the real Cavalier King Charles Spaniel: ASA III-E vestibular disease, left otitis, murmur, labs, films, and peri-op plan. Owner identifiers stay out of the slides.

Co-authored-by: drkimvet <drkimvet@users.noreply.github.com>
</commit_message>
<xml_diff>
--- a/lectures/DVM-612_Week4_Preop_PatientPrep_Postop.pptx
+++ b/lectures/DVM-612_Week4_Preop_PatientPrep_Postop.pptx
@@ -550,7 +550,7 @@
           <a:lstStyle/>
           <a:p>
             <a:r>
-              <a:t>Welcome. This hour is preoperative evaluation, patient and surgeon preparation, and postoperative care. We will carry one real patient through all three: a Cocker Spaniel with severe otitis who is now circling, with nystagmus and knuckling. Decide if that dog is a surgical candidate today, how you would prep, and what the next 24 hours look like.</a:t>
+              <a:t>Welcome. This hour is preoperative evaluation, patient and surgeon preparation, and postoperative care. We will carry one real patient through all three: Willie, a 6-year 11-month MN Cavalier, 13.7 kg, who became ataxic over about an hour, with a severe left ear infection. Assign his ASA, decide what you anesthetize him for tonight, and own the next 24 hours.</a:t>
             </a:r>
           </a:p>
         </p:txBody>
@@ -690,7 +690,7 @@
           <a:lstStyle/>
           <a:p>
             <a:r>
-              <a:t>Read ASA I and III slowly. The emergency E modifier is used clinically (ASA IV-E for GDV). An elective procedure on an ASA IV patient is a decision, not a schedule slot. Next slides: a real ASA III Cocker Spaniel.</a:t>
+              <a:t>Read ASA I and III slowly. The emergency E modifier is used clinically (ASA III-E for an acute vestibular crisis that still needs sedation tonight). Next slides: Willie.</a:t>
             </a:r>
           </a:p>
         </p:txBody>
@@ -830,7 +830,7 @@
           <a:lstStyle/>
           <a:p>
             <a:r>
-              <a:t>This is a real peri-operative patient, not a cartoon. Spend 90 seconds. Cockers plus dirty ears plus new circling is otitis media/interna until proven otherwise. Intact TM is good news for topical safety only if you are sure the middle ear is not involved — you are not sure. Knuckling vs drunk vestibular ataxia: have a student demonstrate paw placing. If placing is truly delayed, do not call this ‘just an ear’ and induce for a TECA tonight.</a:t>
+              <a:t>This is Willie. Do not skip the murmur. Right-sided knuckling with left circling is why you cannot call this just an ear flush. Mentation was quiet/dull.</a:t>
             </a:r>
           </a:p>
         </p:txBody>
@@ -900,7 +900,7 @@
           <a:lstStyle/>
           <a:p>
             <a:r>
-              <a:t>Punchline: vestibular plus severe otitis is compensated moderate-to-severe disease — ASA III. You may still anesthetize for CT, flush, or TECA, but you do not treat this dog like a healthy spay. No aminoglycoside ointment in a suspect inner ear. No NSAID after DexSP.</a:t>
+              <a:t>The drum was seen, then ointment was infused. Aminoglycosides are a risk if the middle or inner ear is involved even when the drum looks present and swollen. Cavaliers also bring mitral valve disease and Chiari-like malformation to the vestibular list. Mention both, then return to the ear as the leading infectious cause. No NSAID after DexSP.</a:t>
             </a:r>
           </a:p>
         </p:txBody>
@@ -1320,7 +1320,7 @@
           <a:lstStyle/>
           <a:p>
             <a:r>
-              <a:t>Read the five objectives aloud. Tell them the Cocker is the patient we will keep coming back to.</a:t>
+              <a:t>Read the five objectives aloud. Willie is the patient we keep coming back to.</a:t>
             </a:r>
           </a:p>
         </p:txBody>
@@ -1390,7 +1390,7 @@
           <a:lstStyle/>
           <a:p>
             <a:r>
-              <a:t>Elective canine OHE is a clean procedure — do not invent a 14-day cephalexin prescription. If you give cefazolin, it is IV around induction, not a souvenir bottle home. Contrast with the vestibular Cocker: that ear is infected, so antimicrobials are therapy.</a:t>
+              <a:t>Elective canine OHE is a clean procedure — do not invent a 14-day cephalexin prescription. Willie’s left ear is infected, so antimicrobials are treatment, not clean prophylaxis.</a:t>
             </a:r>
           </a:p>
         </p:txBody>
@@ -1880,7 +1880,7 @@
           <a:lstStyle/>
           <a:p>
             <a:r>
-              <a:t>CHG–alcohol is a common, evidence-supported choice for trunk skin when not contraindicated. Hammer ocular and middle-ear toxicity — this Cocker’s ear is exactly where CHG and aminoglycosides do harm.</a:t>
+              <a:t>CHG–alcohol is a common choice for trunk skin when not contraindicated. Willie’s left ear is exactly where CHG and aminoglycosides can harm a swollen drum and middle ear.</a:t>
             </a:r>
           </a:p>
         </p:txBody>
@@ -2090,7 +2090,7 @@
           <a:lstStyle/>
           <a:p>
             <a:r>
-              <a:t>Keep a visible timer. If discussion runs, protect Part II (prep) and the Cocker case.</a:t>
+              <a:t>Keep a visible timer. If discussion runs, protect Part II (prep) and Willie’s case.</a:t>
             </a:r>
           </a:p>
         </p:txBody>
@@ -2650,7 +2650,7 @@
           <a:lstStyle/>
           <a:p>
             <a:r>
-              <a:t>Score pain. NSAIDs: not in hypovolemia, kidney injury, GI ulcer, or concurrent steroids — the Cocker already got DexSP.</a:t>
+              <a:t>Score pain. NSAIDs: not in hypovolemia, kidney injury, GI ulcer, or concurrent steroids — Willie already received DexSP.</a:t>
             </a:r>
           </a:p>
         </p:txBody>
@@ -2930,7 +2930,7 @@
           <a:lstStyle/>
           <a:p>
             <a:r>
-              <a:t>Grade completeness. For the Cocker: neuro exam, ASA III, TM status, DexSP already given, no NSAID, imaging plan.</a:t>
+              <a:t>For Willie: neuro exam, ASA III-E, TM visible but swollen, DexSP given, no NSAID, murmur, films, MRI plan.</a:t>
             </a:r>
           </a:p>
         </p:txBody>
@@ -3210,7 +3210,7 @@
           <a:lstStyle/>
           <a:p>
             <a:r>
-              <a:t>One minute. Halsted travels to the barn. Then get back to the Cocker.</a:t>
+              <a:t>One minute. Halsted travels to the barn. Then get back to Willie.</a:t>
             </a:r>
           </a:p>
         </p:txBody>
@@ -3280,7 +3280,7 @@
           <a:lstStyle/>
           <a:p>
             <a:r>
-              <a:t>Walk this without questions until the end. Contrast in one sentence: a healthy Lab OHE is ASA I and gets no routine antibiotics. This Cocker is the opposite.</a:t>
+              <a:t>Walk Willie without questions until the end. One-sentence contrast: a healthy Lab OHE is ASA I and gets no routine antibiotics. Willie is the opposite.</a:t>
             </a:r>
           </a:p>
         </p:txBody>
@@ -3350,7 +3350,7 @@
           <a:lstStyle/>
           <a:p>
             <a:r>
-              <a:t>Stop here if time is gone. The Cocker is the ASA III they should be able to defend.</a:t>
+              <a:t>Stop here if time is gone. Willie is the ASA III-E they should be able to defend.</a:t>
             </a:r>
           </a:p>
         </p:txBody>
@@ -3560,7 +3560,7 @@
           <a:lstStyle/>
           <a:p>
             <a:r>
-              <a:t>Take questions. If none: what would you do differently for the Cocker than for a healthy Labrador spay? Dismiss on time.</a:t>
+              <a:t>Take questions. If none: what would you do differently for Willie than for a healthy Labrador spay? Dismiss on time.</a:t>
             </a:r>
           </a:p>
         </p:txBody>
@@ -7208,7 +7208,7 @@
                 <a:latin typeface="Calibri"/>
               </a:rPr>
               <a:t>Preoperative evaluation · patient and surgeon preparation · postoperative care.
-Running case: Cocker Spaniel with severe otitis and vestibular disease.</a:t>
+Running case: Willie, a Cavalier King Charles Spaniel with acute vestibular disease and left otitis.</a:t>
             </a:r>
           </a:p>
         </p:txBody>
@@ -8835,7 +8835,7 @@
                 </a:solidFill>
                 <a:latin typeface="Calibri"/>
               </a:rPr>
-              <a:t>Stable CKD; compensated heart disease; vestibular Cocker with otitis media/interna</a:t>
+              <a:t>Stable CKD; compensated murmur; Willie — vestibular + otitis, walking</a:t>
             </a:r>
           </a:p>
         </p:txBody>
@@ -10102,7 +10102,7 @@
                 </a:solidFill>
                 <a:latin typeface="Calibri"/>
               </a:rPr>
-              <a:t>Cocker Spaniel, severe otitis, circling left, nystagmus, knuckling right, TM intact, DexSP given, CV stable.</a:t>
+              <a:t>Willie: 6 y 11 mo MN Cavalier, 13.7 kg. Acute ataxia 1 h. AS otitis, TM visible/swollen. Circling left, nystagmus fast-left, right knuckling. Grade II murmur. CV stable.</a:t>
             </a:r>
           </a:p>
         </p:txBody>
@@ -10135,7 +10135,7 @@
                 </a:solidFill>
                 <a:latin typeface="Calibri"/>
               </a:rPr>
-              <a:t>ASA III  ·  not ‘just dirty ears’ — next slides</a:t>
+              <a:t>ASA III-E  ·  not ‘just dirty ears’ — next slides</a:t>
             </a:r>
           </a:p>
         </p:txBody>
@@ -10611,7 +10611,7 @@
                 </a:solidFill>
                 <a:latin typeface="Calibri"/>
               </a:rPr>
-              <a:t>SEVERE OTITIS EXTERNA PLUS INNER-EAR SIGNS  ·  NOT AN ASA I ‘EAR CLEAN’</a:t>
+              <a:t>6 Y 11 MO MN CAVALIER KING CHARLES SPANIEL  ·  13.7 KG  ·  BCS 6/9</a:t>
             </a:r>
           </a:p>
         </p:txBody>
@@ -10687,7 +10687,7 @@
                 </a:solidFill>
                 <a:latin typeface="Calibri"/>
               </a:rPr>
-              <a:t>Real ASA III case — Cocker Spaniel with vestibular disease</a:t>
+              <a:t>Real ASA III case — Willie</a:t>
             </a:r>
           </a:p>
         </p:txBody>
@@ -10701,7 +10701,7 @@
         <p:spPr>
           <a:xfrm>
             <a:off x="457200" y="1051560"/>
-            <a:ext cx="11247120" cy="1234440"/>
+            <a:ext cx="11247120" cy="1325880"/>
           </a:xfrm>
           <a:prstGeom prst="roundRect">
             <a:avLst>
@@ -10745,8 +10745,8 @@
         </p:nvSpPr>
         <p:spPr>
           <a:xfrm>
-            <a:off x="685800" y="1170432"/>
-            <a:ext cx="10789920" cy="1005840"/>
+            <a:off x="685800" y="1143000"/>
+            <a:ext cx="10789920" cy="1143000"/>
           </a:xfrm>
           <a:prstGeom prst="rect">
             <a:avLst/>
@@ -10759,13 +10759,13 @@
           <a:p>
             <a:pPr algn="l"/>
             <a:r>
-              <a:rPr sz="1500" b="0">
+              <a:rPr sz="1400" b="0">
                 <a:solidFill>
                   <a:srgbClr val="0B2C4A"/>
                 </a:solidFill>
                 <a:latin typeface="Calibri"/>
               </a:rPr>
-              <a:t>Adult Cocker Spaniel. Severe external ear infection. Canal patent. Tympanic membrane intact on otoscopy. Dexamethasone SP already given to open the canal. Now circling to the left, fast nystagmus (reported toward the left), knuckling on the right.</a:t>
+              <a:t>Acute ataxia ~1 hour. Fell off the couch twice. Abnormal paw placement. Appetite/thirst normal. Cytopoint for allergies. No prior vestibular signs. Vitals: T 100.8 °F, HR 132, RR 52, mm pink, CRT 2 s, quiet/dull.</a:t>
             </a:r>
           </a:p>
         </p:txBody>
@@ -10778,8 +10778,8 @@
         </p:nvSpPr>
         <p:spPr>
           <a:xfrm>
-            <a:off x="457200" y="2423160"/>
-            <a:ext cx="3657600" cy="3703320"/>
+            <a:off x="457200" y="2514600"/>
+            <a:ext cx="3657600" cy="3611880"/>
           </a:xfrm>
           <a:prstGeom prst="roundRect">
             <a:avLst>
@@ -10823,8 +10823,8 @@
         </p:nvSpPr>
         <p:spPr>
           <a:xfrm>
-            <a:off x="457200" y="2423160"/>
-            <a:ext cx="91440" cy="3703320"/>
+            <a:off x="457200" y="2514600"/>
+            <a:ext cx="91440" cy="3611880"/>
           </a:xfrm>
           <a:prstGeom prst="rect">
             <a:avLst/>
@@ -10866,7 +10866,7 @@
         </p:nvSpPr>
         <p:spPr>
           <a:xfrm>
-            <a:off x="713232" y="2532888"/>
+            <a:off x="713232" y="2624328"/>
             <a:ext cx="3291840" cy="347472"/>
           </a:xfrm>
           <a:prstGeom prst="rect">
@@ -10886,7 +10886,7 @@
                 </a:solidFill>
                 <a:latin typeface="Calibri"/>
               </a:rPr>
-              <a:t>Why Cockers get this</a:t>
+              <a:t>Left ear (AS)</a:t>
             </a:r>
           </a:p>
         </p:txBody>
@@ -10899,8 +10899,8 @@
         </p:nvSpPr>
         <p:spPr>
           <a:xfrm>
-            <a:off x="713232" y="2862072"/>
-            <a:ext cx="3291840" cy="3172968"/>
+            <a:off x="713232" y="2953512"/>
+            <a:ext cx="3291840" cy="3081528"/>
           </a:xfrm>
           <a:prstGeom prst="rect">
             <a:avLst/>
@@ -10919,7 +10919,7 @@
                 </a:solidFill>
                 <a:latin typeface="Calibri"/>
               </a:rPr>
-              <a:t>Pendulous, hairy canals and allergic skin disease drive chronic otitis. Stenosis hides the drum. Infection commonly extends to the middle ear even when the tympanic membrane still looks intact.</a:t>
+              <a:t>Brown and bloody discharge. Pedal reflex at the pinna base. Canal patent. Cartilage hardened. Tympanic membrane visible but swollen.</a:t>
             </a:r>
           </a:p>
         </p:txBody>
@@ -10932,8 +10932,8 @@
         </p:nvSpPr>
         <p:spPr>
           <a:xfrm>
-            <a:off x="4297680" y="2423160"/>
-            <a:ext cx="3657600" cy="3703320"/>
+            <a:off x="4297680" y="2514600"/>
+            <a:ext cx="3657600" cy="3611880"/>
           </a:xfrm>
           <a:prstGeom prst="roundRect">
             <a:avLst>
@@ -10977,8 +10977,8 @@
         </p:nvSpPr>
         <p:spPr>
           <a:xfrm>
-            <a:off x="4297680" y="2423160"/>
-            <a:ext cx="91440" cy="3703320"/>
+            <a:off x="4297680" y="2514600"/>
+            <a:ext cx="91440" cy="3611880"/>
           </a:xfrm>
           <a:prstGeom prst="rect">
             <a:avLst/>
@@ -11020,7 +11020,7 @@
         </p:nvSpPr>
         <p:spPr>
           <a:xfrm>
-            <a:off x="4553712" y="2532888"/>
+            <a:off x="4553712" y="2624328"/>
             <a:ext cx="3291840" cy="347472"/>
           </a:xfrm>
           <a:prstGeom prst="rect">
@@ -11040,7 +11040,7 @@
                 </a:solidFill>
                 <a:latin typeface="Calibri"/>
               </a:rPr>
-              <a:t>What the signs mean</a:t>
+              <a:t>Neuro exam</a:t>
             </a:r>
           </a:p>
         </p:txBody>
@@ -11053,8 +11053,8 @@
         </p:nvSpPr>
         <p:spPr>
           <a:xfrm>
-            <a:off x="4553712" y="2862072"/>
-            <a:ext cx="3291840" cy="3172968"/>
+            <a:off x="4553712" y="2953512"/>
+            <a:ext cx="3291840" cy="3081528"/>
           </a:xfrm>
           <a:prstGeom prst="rect">
             <a:avLst/>
@@ -11073,7 +11073,7 @@
                 </a:solidFill>
                 <a:latin typeface="Calibri"/>
               </a:rPr>
-              <a:t>Circling left = left-sided vestibular. Intact drum does not rule out otitis media/interna. True knuckling is not typical of simple peripheral vestibular disease — recheck placing; if real, think central involvement and image.</a:t>
+              <a:t>Circling left. Horizontal nystagmus — fast left, slow right. Right knuckling and delayed proprioception. Wheelbarrow absent on the right. That is not a simple peripheral ear.</a:t>
             </a:r>
           </a:p>
         </p:txBody>
@@ -11086,8 +11086,8 @@
         </p:nvSpPr>
         <p:spPr>
           <a:xfrm>
-            <a:off x="8138160" y="2423160"/>
-            <a:ext cx="3566160" cy="3703320"/>
+            <a:off x="8138160" y="2514600"/>
+            <a:ext cx="3566160" cy="3611880"/>
           </a:xfrm>
           <a:prstGeom prst="roundRect">
             <a:avLst>
@@ -11131,8 +11131,8 @@
         </p:nvSpPr>
         <p:spPr>
           <a:xfrm>
-            <a:off x="8138160" y="2423160"/>
-            <a:ext cx="91440" cy="3703320"/>
+            <a:off x="8138160" y="2514600"/>
+            <a:ext cx="91440" cy="3611880"/>
           </a:xfrm>
           <a:prstGeom prst="rect">
             <a:avLst/>
@@ -11174,7 +11174,7 @@
         </p:nvSpPr>
         <p:spPr>
           <a:xfrm>
-            <a:off x="8394192" y="2532888"/>
+            <a:off x="8394192" y="2624328"/>
             <a:ext cx="3200400" cy="347472"/>
           </a:xfrm>
           <a:prstGeom prst="rect">
@@ -11194,7 +11194,7 @@
                 </a:solidFill>
                 <a:latin typeface="Calibri"/>
               </a:rPr>
-              <a:t>Already on board</a:t>
+              <a:t>Also on PE</a:t>
             </a:r>
           </a:p>
         </p:txBody>
@@ -11207,8 +11207,8 @@
         </p:nvSpPr>
         <p:spPr>
           <a:xfrm>
-            <a:off x="8394192" y="2862072"/>
-            <a:ext cx="3200400" cy="3172968"/>
+            <a:off x="8394192" y="2953512"/>
+            <a:ext cx="3200400" cy="3081528"/>
           </a:xfrm>
           <a:prstGeom prst="rect">
             <a:avLst/>
@@ -11227,7 +11227,7 @@
                 </a:solidFill>
                 <a:latin typeface="Calibri"/>
               </a:rPr>
-              <a:t>DexSP reduces canal swelling so you can see the drum. Do not add an NSAID on top of a glucocorticoid. Do not put aminoglycoside ointment (e.g. neomycin) in an ear if middle/inner ear disease is possible.</a:t>
+              <a:t>Grade II/VI left systolic murmur (Cavaliers). Heavy tartar. Nasal crusts. Soft non-painful abdomen. Compensated tonight.</a:t>
             </a:r>
           </a:p>
         </p:txBody>
@@ -11516,7 +11516,7 @@
                 </a:solidFill>
                 <a:latin typeface="Calibri"/>
               </a:rPr>
-              <a:t>COMPENSATED NEUROLOGIC + INFECTIOUS DISEASE  ·  HIGHER ANESTHETIC RISK  ·  NOT A CONSTANT THREAT TO LIFE</a:t>
+              <a:t>COMPENSATED  ·  FUNCTIONAL LIMITATION  ·  ACUTE  ·  NOT A CONSTANT THREAT TO LIFE</a:t>
             </a:r>
           </a:p>
         </p:txBody>
@@ -11592,7 +11592,7 @@
                 </a:solidFill>
                 <a:latin typeface="Calibri"/>
               </a:rPr>
-              <a:t>Why this dog is ASA III — and what changes today</a:t>
+              <a:t>Why Willie is ASA III-E — and what we actually did</a:t>
             </a:r>
           </a:p>
         </p:txBody>
@@ -11664,13 +11664,13 @@
           <a:p>
             <a:pPr algn="l"/>
             <a:r>
-              <a:rPr sz="1600" b="1">
+              <a:rPr sz="1800" b="1">
                 <a:solidFill>
                   <a:srgbClr val="2E6B4F"/>
                 </a:solidFill>
                 <a:latin typeface="Calibri"/>
               </a:rPr>
-              <a:t>ASA III, not II or IV</a:t>
+              <a:t>ASA III-E</a:t>
             </a:r>
           </a:p>
         </p:txBody>
@@ -11703,10 +11703,10 @@
                 </a:solidFill>
                 <a:latin typeface="Calibri"/>
               </a:rPr>
-              <a:t>II would be dirty ears without neurologic signs.
-III: ongoing infection plus vestibular dysfunction, still cardiovascularly stable and walking.
-IV if recumbent, dull, septic, or in respiratory distress.
-Add E only if this is a true emergency cut tonight — most of these dogs need imaging and medical control first.</a:t>
+              <a:t>II = murmur alone, or dirty ears without neuro signs.
+III = acute vestibular disease plus severe AS otitis, still pink, walking, kidneys normal.
+E = started an hour ago; sedation tonight.
+IV = recumbent, seizing, septic, or in heart failure. He was not.</a:t>
             </a:r>
           </a:p>
         </p:txBody>
@@ -11784,7 +11784,7 @@
                 </a:solidFill>
                 <a:latin typeface="Calibri"/>
               </a:rPr>
-              <a:t>Preoperative plan for this patient</a:t>
+              <a:t>Work-up and peri-op plan (this patient)</a:t>
             </a:r>
           </a:p>
         </p:txBody>
@@ -11797,8 +11797,8 @@
         </p:nvSpPr>
         <p:spPr>
           <a:xfrm>
-            <a:off x="4480560" y="1691640"/>
-            <a:ext cx="6949440" cy="4114800"/>
+            <a:off x="4480560" y="1645920"/>
+            <a:ext cx="6949440" cy="4206240"/>
           </a:xfrm>
           <a:prstGeom prst="rect">
             <a:avLst/>
@@ -11813,97 +11813,97 @@
           <a:p>
             <a:pPr algn="l">
               <a:spcAft>
-                <a:spcPts val="600"/>
+                <a:spcPts val="500"/>
               </a:spcAft>
             </a:pPr>
             <a:r>
-              <a:rPr sz="1400" b="0">
+              <a:rPr sz="1300" b="0">
                 <a:solidFill>
                   <a:srgbClr val="1C1C1C"/>
                 </a:solidFill>
                 <a:latin typeface="Calibri"/>
               </a:rPr>
-              <a:t>▸  Full neuro exam: mentation, head tilt, nystagmus (fast phase), facial nerve, Horner’s, paw placing on all four limbs.</a:t>
+              <a:t>▸  CBC WNL. Phosphorus 6.0 (high), glucose 130 (stress). Kidneys, liver, electrolytes normal.</a:t>
             </a:r>
           </a:p>
           <a:p>
             <a:pPr algn="l">
               <a:spcAft>
-                <a:spcPts val="600"/>
+                <a:spcPts val="500"/>
               </a:spcAft>
             </a:pPr>
             <a:r>
-              <a:rPr sz="1400" b="0">
+              <a:rPr sz="1300" b="0">
                 <a:solidFill>
                   <a:srgbClr val="1C1C1C"/>
                 </a:solidFill>
                 <a:latin typeface="Calibri"/>
               </a:rPr>
-              <a:t>▸  CBC/chemistry ± culture of the canal. CT of the bullae (or MRI if knuckling is real) before TECA or deep flush under anesthesia.</a:t>
+              <a:t>▸  IV fluids, Cerenia IV, DexSP 0.68 mL SQ. No NSAID after the steroid.</a:t>
             </a:r>
           </a:p>
           <a:p>
             <a:pPr algn="l">
               <a:spcAft>
-                <a:spcPts val="600"/>
+                <a:spcPts val="500"/>
               </a:spcAft>
             </a:pPr>
             <a:r>
-              <a:rPr sz="1400" b="0">
+              <a:rPr sz="1300" b="0">
                 <a:solidFill>
                   <a:srgbClr val="1C1C1C"/>
                 </a:solidFill>
                 <a:latin typeface="Calibri"/>
               </a:rPr>
-              <a:t>▸  This is infected tissue — antimicrobials are treatment, not clean-surgery prophylaxis.</a:t>
+              <a:t>▸  Alfaxalone sedation: deep left-ear clean, cytology/culture, 3-view skull/spine films.</a:t>
             </a:r>
           </a:p>
           <a:p>
             <a:pPr algn="l">
               <a:spcAft>
-                <a:spcPts val="600"/>
+                <a:spcPts val="500"/>
               </a:spcAft>
             </a:pPr>
             <a:r>
-              <a:rPr sz="1400" b="0">
+              <a:rPr sz="1300" b="0">
                 <a:solidFill>
                   <a:srgbClr val="1C1C1C"/>
                 </a:solidFill>
                 <a:latin typeface="Calibri"/>
               </a:rPr>
-              <a:t>▸  Protect the airway; vestibular dogs regurgitate. Fast as for any anesthetic. Pad well; they fall.</a:t>
+              <a:t>▸  Films: bullae radiographically intact, skull intact, L7–S1 discospondylosis — that does not explain acute circling.</a:t>
             </a:r>
           </a:p>
           <a:p>
             <a:pPr algn="l">
               <a:spcAft>
-                <a:spcPts val="600"/>
+                <a:spcPts val="500"/>
               </a:spcAft>
             </a:pPr>
             <a:r>
-              <a:rPr sz="1400" b="0">
+              <a:rPr sz="1300" b="0">
                 <a:solidFill>
                   <a:srgbClr val="1C1C1C"/>
                 </a:solidFill>
                 <a:latin typeface="Calibri"/>
               </a:rPr>
-              <a:t>▸  Consent: persistent head tilt, deafness, facial paralysis, Horner’s, need for TECA if medical therapy fails.</a:t>
+              <a:t>▸  Left circling + left-fast nystagmus + right proprioceptive deficit → central until MRI says otherwise.</a:t>
             </a:r>
           </a:p>
           <a:p>
             <a:pPr algn="l">
               <a:spcAft>
-                <a:spcPts val="600"/>
+                <a:spcPts val="500"/>
               </a:spcAft>
             </a:pPr>
             <a:r>
-              <a:rPr sz="1400" b="0">
+              <a:rPr sz="1300" b="0">
                 <a:solidFill>
                   <a:srgbClr val="1C1C1C"/>
                 </a:solidFill>
                 <a:latin typeface="Calibri"/>
               </a:rPr>
-              <a:t>▸  Delay any unrelated elective procedure until the dog can walk a straight line and eat.</a:t>
+              <a:t>▸  Home: meclizine 25 mg PO BID × 5 d, Cerenia 60 mg PO SID × 4 d, confine, no stairs. MRI recommended. TECA-LBO if culture-guided medical therapy fails.</a:t>
             </a:r>
           </a:p>
         </p:txBody>
@@ -16262,7 +16262,7 @@
                 </a:solidFill>
                 <a:latin typeface="Calibri"/>
               </a:rPr>
-              <a:t>Today is judgment, asepsis, and aftercare. Poor prep cannot be rescued by elegant suture. We will apply every section to the vestibular Cocker.</a:t>
+              <a:t>Today is judgment, asepsis, and aftercare. Poor prep cannot be rescued by elegant suture. We will apply every section to Willie.</a:t>
             </a:r>
           </a:p>
         </p:txBody>
@@ -26521,7 +26521,7 @@
                 </a:solidFill>
                 <a:latin typeface="Calibri"/>
               </a:rPr>
-              <a:t>Cocker walk-through, key points, questions</a:t>
+              <a:t>Willie walk-through, key points, questions</a:t>
             </a:r>
           </a:p>
         </p:txBody>
@@ -40707,7 +40707,7 @@
                 </a:solidFill>
                 <a:latin typeface="Calibri"/>
               </a:rPr>
-              <a:t>YOU ARE THE SURGEON. CLIENT IS IN RECEPTION.</a:t>
+              <a:t>YOU ARE THE SURGEON. THE OWNER IS IN RECEPTION.</a:t>
             </a:r>
           </a:p>
         </p:txBody>
@@ -40783,7 +40783,7 @@
                 </a:solidFill>
                 <a:latin typeface="Calibri"/>
               </a:rPr>
-              <a:t>Walk the Cocker through the whole hour</a:t>
+              <a:t>Walk Willie through the whole hour</a:t>
             </a:r>
           </a:p>
         </p:txBody>
@@ -40861,7 +40861,7 @@
                 </a:solidFill>
                 <a:latin typeface="Calibri"/>
               </a:rPr>
-              <a:t>Adult Cocker Spaniel. Severe otitis externa. Canal patent. TM intact. DexSP already given. Circling left, nystagmus, knuckling right. Cardiovascularly stable, walking. This is ASA III. Client-owned. Going home after recovery — if you decide recovery is in the hospital tonight.</a:t>
+              <a:t>Willie, 6 y 11 mo MN Cavalier, 13.7 kg. Acute vestibular crisis. Severe AS otitis, TM visible/swollen. Circling left, nystagmus fast-left, right knuckling. Grade II murmur. CBC WNL. This is ASA III-E. Client-owned.</a:t>
             </a:r>
           </a:p>
         </p:txBody>
@@ -41015,7 +41015,7 @@
                 </a:solidFill>
                 <a:latin typeface="Calibri"/>
               </a:rPr>
-              <a:t>ASA III. Neuro exam. No NSAID (DexSP on board). No aminoglycoside in the ear. Culture. CT/MRI before TECA. Antibiotics are treatment, not clean prophylaxis. Consent: head tilt, deafness, facial nerve.</a:t>
+              <a:t>ASA III-E. Neuro exam. No NSAID (DexSP). IVF, Cerenia, meclizine. Culture the ear. Radiographs ≠ MRI. Central until proven otherwise.</a:t>
             </a:r>
           </a:p>
         </p:txBody>
@@ -41169,7 +41169,7 @@
                 </a:solidFill>
                 <a:latin typeface="Calibri"/>
               </a:rPr>
-              <a:t>Only after a surgical plane. Clip the intended field (ear/bulla vs TECA). Dirty then sterile prep. CHG off the canal/ear and off the eye. Position padded — this dog falls. Four-quadrant drape. Closed glove.</a:t>
+              <a:t>Alfaxalone only after a surgical plane. Clip/prep the ear if you flush. CHG off the eye and drum. Pad him — he falls. Maintain the airway.</a:t>
             </a:r>
           </a:p>
         </p:txBody>
@@ -41323,7 +41323,7 @@
                 </a:solidFill>
                 <a:latin typeface="Calibri"/>
               </a:rPr>
-              <a:t>Timeout. Maintain asepsis. If you contaminate, say it and fix it. Do not treat this like a 20-minute spay.</a:t>
+              <a:t>Deep clean + cytology. Timeout. If you contaminate, say it. Do not treat this like a 20-minute spay.</a:t>
             </a:r>
           </a:p>
         </p:txBody>
@@ -41477,7 +41477,7 @@
                 </a:solidFill>
                 <a:latin typeface="Calibri"/>
               </a:rPr>
-              <a:t>Airway, temp, pain score. No NSAID tonight. Watch for worsening vestibular signs, aspiration, incision. Written discharge + ER list. You still own hour 23.</a:t>
+              <a:t>Confine, no stairs. Watch neuro signs, vomiting, seizures. MRI next. TECA-LBO only after culture if medical therapy fails. You own hour 23.</a:t>
             </a:r>
           </a:p>
         </p:txBody>
@@ -41996,7 +41996,7 @@
                 </a:solidFill>
                 <a:latin typeface="Calibri"/>
               </a:rPr>
-              <a:t>ASA is assigned after today’s PE and labs. Vestibular Cocker + severe otitis = ASA III, not a healthy ear flush.</a:t>
+              <a:t>ASA is assigned after today’s PE and labs. Willie (vestibular Cavalier + AS otitis + murmur) is ASA III-E, not a healthy ear flush.</a:t>
             </a:r>
           </a:p>
         </p:txBody>
@@ -44035,7 +44035,7 @@
                 </a:solidFill>
                 <a:latin typeface="Calibri"/>
               </a:rPr>
-              <a:t>If there are no questions: what would you do differently for the Cocker
+              <a:t>If there are no questions: what would you do differently for Willie
 than for a healthy Labrador spay?</a:t>
             </a:r>
           </a:p>

</xml_diff>

<commit_message>
Use the ASA Status 1–5 wording on the memorize slide.
Match the American Society of Anesthesiologists classification language for this lecture: Status 1–5 definitions, E modifier, and Willie as 3-E / MoMo as 4-E.

Co-authored-by: drkimvet <drkimvet@users.noreply.github.com>
</commit_message>
<xml_diff>
--- a/lectures/DVM-612_Week4_Preop_PatientPrep_Postop.pptx
+++ b/lectures/DVM-612_Week4_Preop_PatientPrep_Postop.pptx
@@ -697,7 +697,7 @@
           <a:lstStyle/>
           <a:p>
             <a:r>
-              <a:t>Read statuses 1 and 3 slowly, then 4. This is the wording to memorize. E means emergency. Next: four 60-second cases, then the two real records — Willie (3-E, we sedated) and MoMo (4-E, we did not cut).</a:t>
+              <a:t>Read Status 1, then 3, then 4 slowly. This is the wording to memorize. E means emergency. Next: four 60-second cases, then Willie (3-E, we sedated) and MoMo (4-E, we did not cut).</a:t>
             </a:r>
           </a:p>
         </p:txBody>
@@ -8642,8 +8642,8 @@
         </p:nvSpPr>
         <p:spPr>
           <a:xfrm>
-            <a:off x="457200" y="1078992"/>
-            <a:ext cx="11247120" cy="411480"/>
+            <a:off x="411480" y="1024128"/>
+            <a:ext cx="11338560" cy="365760"/>
           </a:xfrm>
           <a:prstGeom prst="rect">
             <a:avLst/>
@@ -8685,8 +8685,8 @@
         </p:nvSpPr>
         <p:spPr>
           <a:xfrm>
-            <a:off x="594360" y="1078992"/>
-            <a:ext cx="1097280" cy="411480"/>
+            <a:off x="502920" y="1024128"/>
+            <a:ext cx="2194560" cy="365760"/>
           </a:xfrm>
           <a:prstGeom prst="rect">
             <a:avLst/>
@@ -8699,13 +8699,13 @@
           <a:p>
             <a:pPr algn="l"/>
             <a:r>
-              <a:rPr sz="1400" b="1">
+              <a:rPr sz="1300" b="1">
                 <a:solidFill>
                   <a:srgbClr val="C5A35A"/>
                 </a:solidFill>
                 <a:latin typeface="Calibri"/>
               </a:rPr>
-              <a:t>ASA</a:t>
+              <a:t>ASA status</a:t>
             </a:r>
           </a:p>
         </p:txBody>
@@ -8718,8 +8718,8 @@
         </p:nvSpPr>
         <p:spPr>
           <a:xfrm>
-            <a:off x="1737360" y="1078992"/>
-            <a:ext cx="5120640" cy="411480"/>
+            <a:off x="2743200" y="1024128"/>
+            <a:ext cx="5852160" cy="365760"/>
           </a:xfrm>
           <a:prstGeom prst="rect">
             <a:avLst/>
@@ -8732,13 +8732,13 @@
           <a:p>
             <a:pPr algn="l"/>
             <a:r>
-              <a:rPr sz="1400" b="1">
+              <a:rPr sz="1300" b="1">
                 <a:solidFill>
                   <a:srgbClr val="FFFFFF"/>
                 </a:solidFill>
                 <a:latin typeface="Calibri"/>
               </a:rPr>
-              <a:t>Definition</a:t>
+              <a:t>Definition — this is the wording to memorize</a:t>
             </a:r>
           </a:p>
         </p:txBody>
@@ -8751,8 +8751,8 @@
         </p:nvSpPr>
         <p:spPr>
           <a:xfrm>
-            <a:off x="6949440" y="1078992"/>
-            <a:ext cx="4572000" cy="411480"/>
+            <a:off x="8595360" y="1024128"/>
+            <a:ext cx="3017520" cy="365760"/>
           </a:xfrm>
           <a:prstGeom prst="rect">
             <a:avLst/>
@@ -8765,13 +8765,13 @@
           <a:p>
             <a:pPr algn="l"/>
             <a:r>
-              <a:rPr sz="1400" b="1">
+              <a:rPr sz="1300" b="1">
                 <a:solidFill>
                   <a:srgbClr val="FFFFFF"/>
                 </a:solidFill>
                 <a:latin typeface="Calibri"/>
               </a:rPr>
-              <a:t>Typical example</a:t>
+              <a:t>Example</a:t>
             </a:r>
           </a:p>
         </p:txBody>
@@ -8784,8 +8784,8 @@
         </p:nvSpPr>
         <p:spPr>
           <a:xfrm>
-            <a:off x="457200" y="1490472"/>
-            <a:ext cx="11247120" cy="749808"/>
+            <a:off x="411480" y="1426464"/>
+            <a:ext cx="11338560" cy="768096"/>
           </a:xfrm>
           <a:prstGeom prst="roundRect">
             <a:avLst>
@@ -8829,8 +8829,8 @@
         </p:nvSpPr>
         <p:spPr>
           <a:xfrm>
-            <a:off x="457200" y="1490472"/>
-            <a:ext cx="1097280" cy="749808"/>
+            <a:off x="411480" y="1426464"/>
+            <a:ext cx="2148840" cy="768096"/>
           </a:xfrm>
           <a:prstGeom prst="rect">
             <a:avLst/>
@@ -8872,8 +8872,8 @@
         </p:nvSpPr>
         <p:spPr>
           <a:xfrm>
-            <a:off x="457200" y="1490472"/>
-            <a:ext cx="1097280" cy="749808"/>
+            <a:off x="411480" y="1426464"/>
+            <a:ext cx="2148840" cy="768096"/>
           </a:xfrm>
           <a:prstGeom prst="rect">
             <a:avLst/>
@@ -8886,13 +8886,13 @@
           <a:p>
             <a:pPr algn="ctr"/>
             <a:r>
-              <a:rPr sz="2200" b="1">
+              <a:rPr sz="1800" b="1">
                 <a:solidFill>
                   <a:srgbClr val="FFFFFF"/>
                 </a:solidFill>
                 <a:latin typeface="Calibri"/>
               </a:rPr>
-              <a:t>1</a:t>
+              <a:t>Status 1</a:t>
             </a:r>
           </a:p>
         </p:txBody>
@@ -8905,8 +8905,8 @@
         </p:nvSpPr>
         <p:spPr>
           <a:xfrm>
-            <a:off x="1737360" y="1545336"/>
-            <a:ext cx="5029200" cy="640080"/>
+            <a:off x="2697480" y="1481328"/>
+            <a:ext cx="5806440" cy="658368"/>
           </a:xfrm>
           <a:prstGeom prst="rect">
             <a:avLst/>
@@ -8919,46 +8919,46 @@
           <a:p>
             <a:pPr algn="l"/>
             <a:r>
+              <a:rPr sz="1300" b="0">
+                <a:solidFill>
+                  <a:srgbClr val="1C1C1C"/>
+                </a:solidFill>
+                <a:latin typeface="Calibri"/>
+              </a:rPr>
+              <a:t>Normal, healthy patient</a:t>
+            </a:r>
+          </a:p>
+        </p:txBody>
+      </p:sp>
+      <p:sp>
+        <p:nvSpPr>
+          <p:cNvPr id="16" name="TextBox 15"/>
+          <p:cNvSpPr txBox="1"/>
+          <p:nvPr/>
+        </p:nvSpPr>
+        <p:spPr>
+          <a:xfrm>
+            <a:off x="8595360" y="1481328"/>
+            <a:ext cx="2971800" cy="658368"/>
+          </a:xfrm>
+          <a:prstGeom prst="rect">
+            <a:avLst/>
+          </a:prstGeom>
+          <a:noFill/>
+        </p:spPr>
+        <p:txBody>
+          <a:bodyPr wrap="square" anchor="ctr"/>
+          <a:lstStyle/>
+          <a:p>
+            <a:pPr algn="l"/>
+            <a:r>
               <a:rPr sz="1200" b="0">
                 <a:solidFill>
-                  <a:srgbClr val="1C1C1C"/>
-                </a:solidFill>
-                <a:latin typeface="Calibri"/>
-              </a:rPr>
-              <a:t>Normal, healthy patient</a:t>
-            </a:r>
-          </a:p>
-        </p:txBody>
-      </p:sp>
-      <p:sp>
-        <p:nvSpPr>
-          <p:cNvPr id="16" name="TextBox 15"/>
-          <p:cNvSpPr txBox="1"/>
-          <p:nvPr/>
-        </p:nvSpPr>
-        <p:spPr>
-          <a:xfrm>
-            <a:off x="6949440" y="1545336"/>
-            <a:ext cx="4572000" cy="640080"/>
-          </a:xfrm>
-          <a:prstGeom prst="rect">
-            <a:avLst/>
-          </a:prstGeom>
-          <a:noFill/>
-        </p:spPr>
-        <p:txBody>
-          <a:bodyPr wrap="square" anchor="ctr"/>
-          <a:lstStyle/>
-          <a:p>
-            <a:pPr algn="l"/>
-            <a:r>
-              <a:rPr sz="1200" b="0">
-                <a:solidFill>
                   <a:srgbClr val="3D4A57"/>
                 </a:solidFill>
                 <a:latin typeface="Calibri"/>
               </a:rPr>
-              <a:t>Elective OHE in a well 1-year-old</a:t>
+              <a:t>Healthy 1-year-old OHE</a:t>
             </a:r>
           </a:p>
         </p:txBody>
@@ -8971,8 +8971,8 @@
         </p:nvSpPr>
         <p:spPr>
           <a:xfrm>
-            <a:off x="457200" y="2295144"/>
-            <a:ext cx="11247120" cy="749808"/>
+            <a:off x="411480" y="2249424"/>
+            <a:ext cx="11338560" cy="768096"/>
           </a:xfrm>
           <a:prstGeom prst="roundRect">
             <a:avLst>
@@ -9016,8 +9016,8 @@
         </p:nvSpPr>
         <p:spPr>
           <a:xfrm>
-            <a:off x="457200" y="2295144"/>
-            <a:ext cx="1097280" cy="749808"/>
+            <a:off x="411480" y="2249424"/>
+            <a:ext cx="2148840" cy="768096"/>
           </a:xfrm>
           <a:prstGeom prst="rect">
             <a:avLst/>
@@ -9059,8 +9059,8 @@
         </p:nvSpPr>
         <p:spPr>
           <a:xfrm>
-            <a:off x="457200" y="2295144"/>
-            <a:ext cx="1097280" cy="749808"/>
+            <a:off x="411480" y="2249424"/>
+            <a:ext cx="2148840" cy="768096"/>
           </a:xfrm>
           <a:prstGeom prst="rect">
             <a:avLst/>
@@ -9073,13 +9073,13 @@
           <a:p>
             <a:pPr algn="ctr"/>
             <a:r>
-              <a:rPr sz="2200" b="1">
+              <a:rPr sz="1800" b="1">
                 <a:solidFill>
                   <a:srgbClr val="FFFFFF"/>
                 </a:solidFill>
                 <a:latin typeface="Calibri"/>
               </a:rPr>
-              <a:t>2</a:t>
+              <a:t>Status 2</a:t>
             </a:r>
           </a:p>
         </p:txBody>
@@ -9092,8 +9092,8 @@
         </p:nvSpPr>
         <p:spPr>
           <a:xfrm>
-            <a:off x="1737360" y="2350008"/>
-            <a:ext cx="5029200" cy="640080"/>
+            <a:off x="2697480" y="2304288"/>
+            <a:ext cx="5806440" cy="658368"/>
           </a:xfrm>
           <a:prstGeom prst="rect">
             <a:avLst/>
@@ -9106,46 +9106,46 @@
           <a:p>
             <a:pPr algn="l"/>
             <a:r>
+              <a:rPr sz="1300" b="0">
+                <a:solidFill>
+                  <a:srgbClr val="1C1C1C"/>
+                </a:solidFill>
+                <a:latin typeface="Calibri"/>
+              </a:rPr>
+              <a:t>Mild systemic disease, well compensated</a:t>
+            </a:r>
+          </a:p>
+        </p:txBody>
+      </p:sp>
+      <p:sp>
+        <p:nvSpPr>
+          <p:cNvPr id="21" name="TextBox 20"/>
+          <p:cNvSpPr txBox="1"/>
+          <p:nvPr/>
+        </p:nvSpPr>
+        <p:spPr>
+          <a:xfrm>
+            <a:off x="8595360" y="2304288"/>
+            <a:ext cx="2971800" cy="658368"/>
+          </a:xfrm>
+          <a:prstGeom prst="rect">
+            <a:avLst/>
+          </a:prstGeom>
+          <a:noFill/>
+        </p:spPr>
+        <p:txBody>
+          <a:bodyPr wrap="square" anchor="ctr"/>
+          <a:lstStyle/>
+          <a:p>
+            <a:pPr algn="l"/>
+            <a:r>
               <a:rPr sz="1200" b="0">
                 <a:solidFill>
-                  <a:srgbClr val="1C1C1C"/>
-                </a:solidFill>
-                <a:latin typeface="Calibri"/>
-              </a:rPr>
-              <a:t>Mild systemic disease, well compensated</a:t>
-            </a:r>
-          </a:p>
-        </p:txBody>
-      </p:sp>
-      <p:sp>
-        <p:nvSpPr>
-          <p:cNvPr id="21" name="TextBox 20"/>
-          <p:cNvSpPr txBox="1"/>
-          <p:nvPr/>
-        </p:nvSpPr>
-        <p:spPr>
-          <a:xfrm>
-            <a:off x="6949440" y="2350008"/>
-            <a:ext cx="4572000" cy="640080"/>
-          </a:xfrm>
-          <a:prstGeom prst="rect">
-            <a:avLst/>
-          </a:prstGeom>
-          <a:noFill/>
-        </p:spPr>
-        <p:txBody>
-          <a:bodyPr wrap="square" anchor="ctr"/>
-          <a:lstStyle/>
-          <a:p>
-            <a:pPr algn="l"/>
-            <a:r>
-              <a:rPr sz="1200" b="0">
-                <a:solidFill>
                   <a:srgbClr val="3D4A57"/>
                 </a:solidFill>
                 <a:latin typeface="Calibri"/>
               </a:rPr>
-              <a:t>Controlled diabetes; obese but stable; asymptomatic murmur</a:t>
+              <a:t>Obesity; asymptomatic murmur; controlled diabetes</a:t>
             </a:r>
           </a:p>
         </p:txBody>
@@ -9158,8 +9158,8 @@
         </p:nvSpPr>
         <p:spPr>
           <a:xfrm>
-            <a:off x="457200" y="3099816"/>
-            <a:ext cx="11247120" cy="749808"/>
+            <a:off x="411480" y="3072384"/>
+            <a:ext cx="11338560" cy="768096"/>
           </a:xfrm>
           <a:prstGeom prst="roundRect">
             <a:avLst>
@@ -9203,8 +9203,8 @@
         </p:nvSpPr>
         <p:spPr>
           <a:xfrm>
-            <a:off x="457200" y="3099816"/>
-            <a:ext cx="1097280" cy="749808"/>
+            <a:off x="411480" y="3072384"/>
+            <a:ext cx="2148840" cy="768096"/>
           </a:xfrm>
           <a:prstGeom prst="rect">
             <a:avLst/>
@@ -9246,8 +9246,8 @@
         </p:nvSpPr>
         <p:spPr>
           <a:xfrm>
-            <a:off x="457200" y="3099816"/>
-            <a:ext cx="1097280" cy="749808"/>
+            <a:off x="411480" y="3072384"/>
+            <a:ext cx="2148840" cy="768096"/>
           </a:xfrm>
           <a:prstGeom prst="rect">
             <a:avLst/>
@@ -9260,13 +9260,13 @@
           <a:p>
             <a:pPr algn="ctr"/>
             <a:r>
-              <a:rPr sz="2200" b="1">
+              <a:rPr sz="1800" b="1">
                 <a:solidFill>
                   <a:srgbClr val="FFFFFF"/>
                 </a:solidFill>
                 <a:latin typeface="Calibri"/>
               </a:rPr>
-              <a:t>3</a:t>
+              <a:t>Status 3</a:t>
             </a:r>
           </a:p>
         </p:txBody>
@@ -9279,8 +9279,8 @@
         </p:nvSpPr>
         <p:spPr>
           <a:xfrm>
-            <a:off x="1737360" y="3154680"/>
-            <a:ext cx="5029200" cy="640080"/>
+            <a:off x="2697480" y="3127248"/>
+            <a:ext cx="5806440" cy="658368"/>
           </a:xfrm>
           <a:prstGeom prst="rect">
             <a:avLst/>
@@ -9293,46 +9293,46 @@
           <a:p>
             <a:pPr algn="l"/>
             <a:r>
+              <a:rPr sz="1300" b="0">
+                <a:solidFill>
+                  <a:srgbClr val="1C1C1C"/>
+                </a:solidFill>
+                <a:latin typeface="Calibri"/>
+              </a:rPr>
+              <a:t>Moderate systemic disease that is ongoing but compensated; some functional limitations exist that increase the risk of anesthesia</a:t>
+            </a:r>
+          </a:p>
+        </p:txBody>
+      </p:sp>
+      <p:sp>
+        <p:nvSpPr>
+          <p:cNvPr id="26" name="TextBox 25"/>
+          <p:cNvSpPr txBox="1"/>
+          <p:nvPr/>
+        </p:nvSpPr>
+        <p:spPr>
+          <a:xfrm>
+            <a:off x="8595360" y="3127248"/>
+            <a:ext cx="2971800" cy="658368"/>
+          </a:xfrm>
+          <a:prstGeom prst="rect">
+            <a:avLst/>
+          </a:prstGeom>
+          <a:noFill/>
+        </p:spPr>
+        <p:txBody>
+          <a:bodyPr wrap="square" anchor="ctr"/>
+          <a:lstStyle/>
+          <a:p>
+            <a:pPr algn="l"/>
+            <a:r>
               <a:rPr sz="1200" b="0">
                 <a:solidFill>
-                  <a:srgbClr val="1C1C1C"/>
-                </a:solidFill>
-                <a:latin typeface="Calibri"/>
-              </a:rPr>
-              <a:t>Moderate systemic disease that is ongoing but compensated; some functional limitations exist that increase the risk of anesthesia</a:t>
-            </a:r>
-          </a:p>
-        </p:txBody>
-      </p:sp>
-      <p:sp>
-        <p:nvSpPr>
-          <p:cNvPr id="26" name="TextBox 25"/>
-          <p:cNvSpPr txBox="1"/>
-          <p:nvPr/>
-        </p:nvSpPr>
-        <p:spPr>
-          <a:xfrm>
-            <a:off x="6949440" y="3154680"/>
-            <a:ext cx="4572000" cy="640080"/>
-          </a:xfrm>
-          <a:prstGeom prst="rect">
-            <a:avLst/>
-          </a:prstGeom>
-          <a:noFill/>
-        </p:spPr>
-        <p:txBody>
-          <a:bodyPr wrap="square" anchor="ctr"/>
-          <a:lstStyle/>
-          <a:p>
-            <a:pPr algn="l"/>
-            <a:r>
-              <a:rPr sz="1200" b="0">
-                <a:solidFill>
                   <a:srgbClr val="3D4A57"/>
                 </a:solidFill>
                 <a:latin typeface="Calibri"/>
               </a:rPr>
-              <a:t>Stable CKD; compensated murmur; Willie — vestibular + otitis, walking</a:t>
+              <a:t>Willie — vestibular + otitis, walking, compensated murmur</a:t>
             </a:r>
           </a:p>
         </p:txBody>
@@ -9345,8 +9345,8 @@
         </p:nvSpPr>
         <p:spPr>
           <a:xfrm>
-            <a:off x="457200" y="3904488"/>
-            <a:ext cx="11247120" cy="749808"/>
+            <a:off x="411480" y="3895344"/>
+            <a:ext cx="11338560" cy="768096"/>
           </a:xfrm>
           <a:prstGeom prst="roundRect">
             <a:avLst>
@@ -9390,8 +9390,8 @@
         </p:nvSpPr>
         <p:spPr>
           <a:xfrm>
-            <a:off x="457200" y="3904488"/>
-            <a:ext cx="1097280" cy="749808"/>
+            <a:off x="411480" y="3895344"/>
+            <a:ext cx="2148840" cy="768096"/>
           </a:xfrm>
           <a:prstGeom prst="rect">
             <a:avLst/>
@@ -9433,8 +9433,8 @@
         </p:nvSpPr>
         <p:spPr>
           <a:xfrm>
-            <a:off x="457200" y="3904488"/>
-            <a:ext cx="1097280" cy="749808"/>
+            <a:off x="411480" y="3895344"/>
+            <a:ext cx="2148840" cy="768096"/>
           </a:xfrm>
           <a:prstGeom prst="rect">
             <a:avLst/>
@@ -9447,13 +9447,13 @@
           <a:p>
             <a:pPr algn="ctr"/>
             <a:r>
-              <a:rPr sz="2200" b="1">
+              <a:rPr sz="1800" b="1">
                 <a:solidFill>
                   <a:srgbClr val="FFFFFF"/>
                 </a:solidFill>
                 <a:latin typeface="Calibri"/>
               </a:rPr>
-              <a:t>4</a:t>
+              <a:t>Status 4</a:t>
             </a:r>
           </a:p>
         </p:txBody>
@@ -9466,8 +9466,8 @@
         </p:nvSpPr>
         <p:spPr>
           <a:xfrm>
-            <a:off x="1737360" y="3959352"/>
-            <a:ext cx="5029200" cy="640080"/>
+            <a:off x="2697480" y="3950208"/>
+            <a:ext cx="5806440" cy="658368"/>
           </a:xfrm>
           <a:prstGeom prst="rect">
             <a:avLst/>
@@ -9480,46 +9480,46 @@
           <a:p>
             <a:pPr algn="l"/>
             <a:r>
+              <a:rPr sz="1300" b="0">
+                <a:solidFill>
+                  <a:srgbClr val="1C1C1C"/>
+                </a:solidFill>
+                <a:latin typeface="Calibri"/>
+              </a:rPr>
+              <a:t>Severe systemic disease that is a constant threat to life, uncompensated disease, high anesthetic risk because vital body systems involved</a:t>
+            </a:r>
+          </a:p>
+        </p:txBody>
+      </p:sp>
+      <p:sp>
+        <p:nvSpPr>
+          <p:cNvPr id="31" name="TextBox 30"/>
+          <p:cNvSpPr txBox="1"/>
+          <p:nvPr/>
+        </p:nvSpPr>
+        <p:spPr>
+          <a:xfrm>
+            <a:off x="8595360" y="3950208"/>
+            <a:ext cx="2971800" cy="658368"/>
+          </a:xfrm>
+          <a:prstGeom prst="rect">
+            <a:avLst/>
+          </a:prstGeom>
+          <a:noFill/>
+        </p:spPr>
+        <p:txBody>
+          <a:bodyPr wrap="square" anchor="ctr"/>
+          <a:lstStyle/>
+          <a:p>
+            <a:pPr algn="l"/>
+            <a:r>
               <a:rPr sz="1200" b="0">
                 <a:solidFill>
-                  <a:srgbClr val="1C1C1C"/>
-                </a:solidFill>
-                <a:latin typeface="Calibri"/>
-              </a:rPr>
-              <a:t>Severe systemic disease that is a constant threat to life; uncompensated disease; high anesthetic risk because vital body systems are involved</a:t>
-            </a:r>
-          </a:p>
-        </p:txBody>
-      </p:sp>
-      <p:sp>
-        <p:nvSpPr>
-          <p:cNvPr id="31" name="TextBox 30"/>
-          <p:cNvSpPr txBox="1"/>
-          <p:nvPr/>
-        </p:nvSpPr>
-        <p:spPr>
-          <a:xfrm>
-            <a:off x="6949440" y="3959352"/>
-            <a:ext cx="4572000" cy="640080"/>
-          </a:xfrm>
-          <a:prstGeom prst="rect">
-            <a:avLst/>
-          </a:prstGeom>
-          <a:noFill/>
-        </p:spPr>
-        <p:txBody>
-          <a:bodyPr wrap="square" anchor="ctr"/>
-          <a:lstStyle/>
-          <a:p>
-            <a:pPr algn="l"/>
-            <a:r>
-              <a:rPr sz="1200" b="0">
-                <a:solidFill>
                   <a:srgbClr val="3D4A57"/>
                 </a:solidFill>
                 <a:latin typeface="Calibri"/>
               </a:rPr>
-              <a:t>MoMo — rising azotemia, one kidney non-functional; GDV; septic abdomen</a:t>
+              <a:t>MoMo — rising azotemia, non-functional kidney; GDV; septic abdomen</a:t>
             </a:r>
           </a:p>
         </p:txBody>
@@ -9532,8 +9532,8 @@
         </p:nvSpPr>
         <p:spPr>
           <a:xfrm>
-            <a:off x="457200" y="4709160"/>
-            <a:ext cx="11247120" cy="749808"/>
+            <a:off x="411480" y="4718304"/>
+            <a:ext cx="11338560" cy="768096"/>
           </a:xfrm>
           <a:prstGeom prst="roundRect">
             <a:avLst>
@@ -9577,8 +9577,8 @@
         </p:nvSpPr>
         <p:spPr>
           <a:xfrm>
-            <a:off x="457200" y="4709160"/>
-            <a:ext cx="1097280" cy="749808"/>
+            <a:off x="411480" y="4718304"/>
+            <a:ext cx="2148840" cy="768096"/>
           </a:xfrm>
           <a:prstGeom prst="rect">
             <a:avLst/>
@@ -9620,8 +9620,8 @@
         </p:nvSpPr>
         <p:spPr>
           <a:xfrm>
-            <a:off x="457200" y="4709160"/>
-            <a:ext cx="1097280" cy="749808"/>
+            <a:off x="411480" y="4718304"/>
+            <a:ext cx="2148840" cy="768096"/>
           </a:xfrm>
           <a:prstGeom prst="rect">
             <a:avLst/>
@@ -9634,13 +9634,13 @@
           <a:p>
             <a:pPr algn="ctr"/>
             <a:r>
-              <a:rPr sz="2200" b="1">
+              <a:rPr sz="1800" b="1">
                 <a:solidFill>
                   <a:srgbClr val="FFFFFF"/>
                 </a:solidFill>
                 <a:latin typeface="Calibri"/>
               </a:rPr>
-              <a:t>5</a:t>
+              <a:t>Status 5</a:t>
             </a:r>
           </a:p>
         </p:txBody>
@@ -9653,8 +9653,8 @@
         </p:nvSpPr>
         <p:spPr>
           <a:xfrm>
-            <a:off x="1737360" y="4764024"/>
-            <a:ext cx="5029200" cy="640080"/>
+            <a:off x="2697480" y="4773168"/>
+            <a:ext cx="5806440" cy="658368"/>
           </a:xfrm>
           <a:prstGeom prst="rect">
             <a:avLst/>
@@ -9667,46 +9667,46 @@
           <a:p>
             <a:pPr algn="l"/>
             <a:r>
+              <a:rPr sz="1300" b="0">
+                <a:solidFill>
+                  <a:srgbClr val="1C1C1C"/>
+                </a:solidFill>
+                <a:latin typeface="Calibri"/>
+              </a:rPr>
+              <a:t>Moribund patient not expected to live more than 24 hours with or without surgery</a:t>
+            </a:r>
+          </a:p>
+        </p:txBody>
+      </p:sp>
+      <p:sp>
+        <p:nvSpPr>
+          <p:cNvPr id="36" name="TextBox 35"/>
+          <p:cNvSpPr txBox="1"/>
+          <p:nvPr/>
+        </p:nvSpPr>
+        <p:spPr>
+          <a:xfrm>
+            <a:off x="8595360" y="4773168"/>
+            <a:ext cx="2971800" cy="658368"/>
+          </a:xfrm>
+          <a:prstGeom prst="rect">
+            <a:avLst/>
+          </a:prstGeom>
+          <a:noFill/>
+        </p:spPr>
+        <p:txBody>
+          <a:bodyPr wrap="square" anchor="ctr"/>
+          <a:lstStyle/>
+          <a:p>
+            <a:pPr algn="l"/>
+            <a:r>
               <a:rPr sz="1200" b="0">
                 <a:solidFill>
-                  <a:srgbClr val="1C1C1C"/>
-                </a:solidFill>
-                <a:latin typeface="Calibri"/>
-              </a:rPr>
-              <a:t>Moribund patient not expected to live more than 24 hours with or without surgery</a:t>
-            </a:r>
-          </a:p>
-        </p:txBody>
-      </p:sp>
-      <p:sp>
-        <p:nvSpPr>
-          <p:cNvPr id="36" name="TextBox 35"/>
-          <p:cNvSpPr txBox="1"/>
-          <p:nvPr/>
-        </p:nvSpPr>
-        <p:spPr>
-          <a:xfrm>
-            <a:off x="6949440" y="4764024"/>
-            <a:ext cx="4572000" cy="640080"/>
-          </a:xfrm>
-          <a:prstGeom prst="rect">
-            <a:avLst/>
-          </a:prstGeom>
-          <a:noFill/>
-        </p:spPr>
-        <p:txBody>
-          <a:bodyPr wrap="square" anchor="ctr"/>
-          <a:lstStyle/>
-          <a:p>
-            <a:pPr algn="l"/>
-            <a:r>
-              <a:rPr sz="1200" b="0">
-                <a:solidFill>
                   <a:srgbClr val="3D4A57"/>
                 </a:solidFill>
                 <a:latin typeface="Calibri"/>
               </a:rPr>
-              <a:t>Gastric rupture, catastrophic trauma, end-stage disease</a:t>
+              <a:t>Gastric rupture; catastrophic trauma; end-stage disease</a:t>
             </a:r>
           </a:p>
         </p:txBody>
@@ -9719,8 +9719,8 @@
         </p:nvSpPr>
         <p:spPr>
           <a:xfrm>
-            <a:off x="457200" y="5623560"/>
-            <a:ext cx="11247120" cy="822960"/>
+            <a:off x="411480" y="5596128"/>
+            <a:ext cx="11338560" cy="868680"/>
           </a:xfrm>
           <a:prstGeom prst="roundRect">
             <a:avLst>
@@ -9764,8 +9764,8 @@
         </p:nvSpPr>
         <p:spPr>
           <a:xfrm>
-            <a:off x="640080" y="5742432"/>
-            <a:ext cx="10881360" cy="594360"/>
+            <a:off x="594360" y="5687568"/>
+            <a:ext cx="11018520" cy="685800"/>
           </a:xfrm>
           <a:prstGeom prst="rect">
             <a:avLst/>
@@ -9778,13 +9778,13 @@
           <a:p>
             <a:pPr algn="l"/>
             <a:r>
-              <a:rPr sz="1300" b="0">
+              <a:rPr sz="1400" b="0">
                 <a:solidFill>
                   <a:srgbClr val="0B2C4A"/>
                 </a:solidFill>
                 <a:latin typeface="Calibri"/>
               </a:rPr>
-              <a:t>E = emergency. Written as 3-E or 4-E. Willie is 3-E (acute, still compensated). MoMo is 4-E (acute, uncompensated vital-system disease). Assign the number after today’s PE and labs, not from the appointment book.</a:t>
+              <a:t>E = emergency (written Status 3-E or 4-E). Willie is Status 3-E: acute, still compensated. MoMo is Status 4-E: acute, uncompensated, vital systems involved. Assign the number after today’s PE and labs, not from the appointment book.</a:t>
             </a:r>
           </a:p>
         </p:txBody>
@@ -10336,7 +10336,7 @@
                 </a:solidFill>
                 <a:latin typeface="Calibri"/>
               </a:rPr>
-              <a:t>ASA I  ·  proceed</a:t>
+              <a:t>ASA Status 1  ·  proceed</a:t>
             </a:r>
           </a:p>
         </p:txBody>
@@ -10523,7 +10523,7 @@
                 </a:solidFill>
                 <a:latin typeface="Calibri"/>
               </a:rPr>
-              <a:t>ASA II  ·  proceed with monitoring plan</a:t>
+              <a:t>ASA Status 2  ·  proceed with monitoring plan</a:t>
             </a:r>
           </a:p>
         </p:txBody>
@@ -10710,7 +10710,7 @@
                 </a:solidFill>
                 <a:latin typeface="Calibri"/>
               </a:rPr>
-              <a:t>ASA III-E  ·  not ‘just dirty ears’ — next slides</a:t>
+              <a:t>ASA Status 3-E  ·  not ‘just dirty ears’ — next slides</a:t>
             </a:r>
           </a:p>
         </p:txBody>
@@ -10897,7 +10897,7 @@
                 </a:solidFill>
                 <a:latin typeface="Calibri"/>
               </a:rPr>
-              <a:t>Do not cut yet. Imaging + labs first  ·  this became ASA IV-E, not a surgical abdomen</a:t>
+              <a:t>Do not cut yet. Imaging + labs first  ·  this became ASA Status 4-E, not a surgical abdomen</a:t>
             </a:r>
           </a:p>
         </p:txBody>

</xml_diff>

<commit_message>
Show Dr. Yujin Kim, D.V.M., Ph.D., FFCP on the lecture.
Put the instructor credential on the title slide, the closing slide, every content footer, and the instructor script.

Co-authored-by: drkimvet <drkimvet@users.noreply.github.com>
</commit_message>
<xml_diff>
--- a/lectures/DVM-612_Week4_Preop_PatientPrep_Postop.pptx
+++ b/lectures/DVM-612_Week4_Preop_PatientPrep_Postop.pptx
@@ -7864,8 +7864,8 @@
         </p:nvSpPr>
         <p:spPr>
           <a:xfrm>
-            <a:off x="685800" y="4709160"/>
-            <a:ext cx="10972800" cy="365760"/>
+            <a:off x="685800" y="4617720"/>
+            <a:ext cx="10972800" cy="411480"/>
           </a:xfrm>
           <a:prstGeom prst="rect">
             <a:avLst/>
@@ -7878,26 +7878,59 @@
           <a:p>
             <a:pPr algn="l"/>
             <a:r>
+              <a:rPr sz="2200" b="1">
+                <a:solidFill>
+                  <a:srgbClr val="C5A35A"/>
+                </a:solidFill>
+                <a:latin typeface="Calibri"/>
+              </a:rPr>
+              <a:t>Dr. Yujin Kim, D.V.M., Ph.D., FFCP</a:t>
+            </a:r>
+          </a:p>
+        </p:txBody>
+      </p:sp>
+      <p:sp>
+        <p:nvSpPr>
+          <p:cNvPr id="9" name="TextBox 8"/>
+          <p:cNvSpPr txBox="1"/>
+          <p:nvPr/>
+        </p:nvSpPr>
+        <p:spPr>
+          <a:xfrm>
+            <a:off x="685800" y="5029200"/>
+            <a:ext cx="10972800" cy="320040"/>
+          </a:xfrm>
+          <a:prstGeom prst="rect">
+            <a:avLst/>
+          </a:prstGeom>
+          <a:noFill/>
+        </p:spPr>
+        <p:txBody>
+          <a:bodyPr wrap="square" anchor="t"/>
+          <a:lstStyle/>
+          <a:p>
+            <a:pPr algn="l"/>
+            <a:r>
               <a:rPr sz="1600" b="0">
                 <a:solidFill>
                   <a:srgbClr val="F4EBD3"/>
                 </a:solidFill>
                 <a:latin typeface="Calibri"/>
               </a:rPr>
-              <a:t>Dr. Yujin Kim, D.V.M., Ph.D., FFCP  ·  Lecture  |  60 minutes</a:t>
-            </a:r>
-          </a:p>
-        </p:txBody>
-      </p:sp>
-      <p:sp>
-        <p:nvSpPr>
-          <p:cNvPr id="9" name="TextBox 8"/>
-          <p:cNvSpPr txBox="1"/>
-          <p:nvPr/>
-        </p:nvSpPr>
-        <p:spPr>
-          <a:xfrm>
-            <a:off x="685800" y="5120640"/>
+              <a:t>Lecture  |  60 minutes</a:t>
+            </a:r>
+          </a:p>
+        </p:txBody>
+      </p:sp>
+      <p:sp>
+        <p:nvSpPr>
+          <p:cNvPr id="10" name="TextBox 9"/>
+          <p:cNvSpPr txBox="1"/>
+          <p:nvPr/>
+        </p:nvSpPr>
+        <p:spPr>
+          <a:xfrm>
+            <a:off x="685800" y="5394960"/>
             <a:ext cx="10972800" cy="640080"/>
           </a:xfrm>
           <a:prstGeom prst="rect">
@@ -7925,14 +7958,14 @@
       </p:sp>
       <p:sp>
         <p:nvSpPr>
-          <p:cNvPr id="10" name="TextBox 9"/>
-          <p:cNvSpPr txBox="1"/>
-          <p:nvPr/>
-        </p:nvSpPr>
-        <p:spPr>
-          <a:xfrm>
-            <a:off x="685800" y="5989320"/>
-            <a:ext cx="10972800" cy="320040"/>
+          <p:cNvPr id="11" name="TextBox 10"/>
+          <p:cNvSpPr txBox="1"/>
+          <p:nvPr/>
+        </p:nvSpPr>
+        <p:spPr>
+          <a:xfrm>
+            <a:off x="685800" y="6053328"/>
+            <a:ext cx="10972800" cy="292608"/>
           </a:xfrm>
           <a:prstGeom prst="rect">
             <a:avLst/>
@@ -7958,7 +7991,7 @@
       </p:sp>
       <p:sp>
         <p:nvSpPr>
-          <p:cNvPr id="11" name="TextBox 10"/>
+          <p:cNvPr id="12" name="TextBox 11"/>
           <p:cNvSpPr txBox="1"/>
           <p:nvPr/>
         </p:nvSpPr>
@@ -8553,7 +8586,7 @@
                 </a:solidFill>
                 <a:latin typeface="Calibri"/>
               </a:rPr>
-              <a:t>DVM 612  |  Principles of Surgery  |  Preop · prep · postop  |  Lewyt College of Veterinary Medicine</a:t>
+              <a:t>DVM 612  |  Dr. Yujin Kim, D.V.M., Ph.D., FFCP  |  Preop · prep · postop  |  Lewyt CVM</a:t>
             </a:r>
           </a:p>
         </p:txBody>
@@ -10073,7 +10106,7 @@
                 </a:solidFill>
                 <a:latin typeface="Calibri"/>
               </a:rPr>
-              <a:t>DVM 612  |  Principles of Surgery  |  Preop · prep · postop  |  Lewyt College of Veterinary Medicine</a:t>
+              <a:t>DVM 612  |  Dr. Yujin Kim, D.V.M., Ph.D., FFCP  |  Preop · prep · postop  |  Lewyt CVM</a:t>
             </a:r>
           </a:p>
         </p:txBody>
@@ -11186,7 +11219,7 @@
                 </a:solidFill>
                 <a:latin typeface="Calibri"/>
               </a:rPr>
-              <a:t>DVM 612  |  Principles of Surgery  |  Preop · prep · postop  |  Lewyt College of Veterinary Medicine</a:t>
+              <a:t>DVM 612  |  Dr. Yujin Kim, D.V.M., Ph.D., FFCP  |  Preop · prep · postop  |  Lewyt CVM</a:t>
             </a:r>
           </a:p>
         </p:txBody>
@@ -12091,7 +12124,7 @@
                 </a:solidFill>
                 <a:latin typeface="Calibri"/>
               </a:rPr>
-              <a:t>DVM 612  |  Principles of Surgery  |  Preop · prep · postop  |  Lewyt College of Veterinary Medicine</a:t>
+              <a:t>DVM 612  |  Dr. Yujin Kim, D.V.M., Ph.D., FFCP  |  Preop · prep · postop  |  Lewyt CVM</a:t>
             </a:r>
           </a:p>
         </p:txBody>
@@ -12767,7 +12800,7 @@
                 </a:solidFill>
                 <a:latin typeface="Calibri"/>
               </a:rPr>
-              <a:t>DVM 612  |  Principles of Surgery  |  Preop · prep · postop  |  Lewyt College of Veterinary Medicine</a:t>
+              <a:t>DVM 612  |  Dr. Yujin Kim, D.V.M., Ph.D., FFCP  |  Preop · prep · postop  |  Lewyt CVM</a:t>
             </a:r>
           </a:p>
         </p:txBody>
@@ -13672,7 +13705,7 @@
                 </a:solidFill>
                 <a:latin typeface="Calibri"/>
               </a:rPr>
-              <a:t>DVM 612  |  Principles of Surgery  |  Preop · prep · postop  |  Lewyt College of Veterinary Medicine</a:t>
+              <a:t>DVM 612  |  Dr. Yujin Kim, D.V.M., Ph.D., FFCP  |  Preop · prep · postop  |  Lewyt CVM</a:t>
             </a:r>
           </a:p>
         </p:txBody>
@@ -14349,7 +14382,7 @@
                 </a:solidFill>
                 <a:latin typeface="Calibri"/>
               </a:rPr>
-              <a:t>DVM 612  |  Principles of Surgery  |  Preop · prep · postop  |  Lewyt College of Veterinary Medicine</a:t>
+              <a:t>DVM 612  |  Dr. Yujin Kim, D.V.M., Ph.D., FFCP  |  Preop · prep · postop  |  Lewyt CVM</a:t>
             </a:r>
           </a:p>
         </p:txBody>
@@ -15171,7 +15204,7 @@
                 </a:solidFill>
                 <a:latin typeface="Calibri"/>
               </a:rPr>
-              <a:t>DVM 612  |  Principles of Surgery  |  Preop · prep · postop  |  Lewyt College of Veterinary Medicine</a:t>
+              <a:t>DVM 612  |  Dr. Yujin Kim, D.V.M., Ph.D., FFCP  |  Preop · prep · postop  |  Lewyt CVM</a:t>
             </a:r>
           </a:p>
         </p:txBody>
@@ -15560,7 +15593,7 @@
                 </a:solidFill>
                 <a:latin typeface="Calibri"/>
               </a:rPr>
-              <a:t>DVM 612  |  Principles of Surgery  |  Preop · prep · postop  |  Lewyt College of Veterinary Medicine</a:t>
+              <a:t>DVM 612  |  Dr. Yujin Kim, D.V.M., Ph.D., FFCP  |  Preop · prep · postop  |  Lewyt CVM</a:t>
             </a:r>
           </a:p>
         </p:txBody>
@@ -15949,7 +15982,7 @@
                 </a:solidFill>
                 <a:latin typeface="Calibri"/>
               </a:rPr>
-              <a:t>DVM 612  |  Principles of Surgery  |  Preop · prep · postop  |  Lewyt College of Veterinary Medicine</a:t>
+              <a:t>DVM 612  |  Dr. Yujin Kim, D.V.M., Ph.D., FFCP  |  Preop · prep · postop  |  Lewyt CVM</a:t>
             </a:r>
           </a:p>
         </p:txBody>
@@ -16495,7 +16528,7 @@
                 </a:solidFill>
                 <a:latin typeface="Calibri"/>
               </a:rPr>
-              <a:t>DVM 612  |  Principles of Surgery  |  Preop · prep · postop  |  Lewyt College of Veterinary Medicine</a:t>
+              <a:t>DVM 612  |  Dr. Yujin Kim, D.V.M., Ph.D., FFCP  |  Preop · prep · postop  |  Lewyt CVM</a:t>
             </a:r>
           </a:p>
         </p:txBody>
@@ -17179,7 +17212,7 @@
                 </a:solidFill>
                 <a:latin typeface="Calibri"/>
               </a:rPr>
-              <a:t>DVM 612  |  Principles of Surgery  |  Preop · prep · postop  |  Lewyt College of Veterinary Medicine</a:t>
+              <a:t>DVM 612  |  Dr. Yujin Kim, D.V.M., Ph.D., FFCP  |  Preop · prep · postop  |  Lewyt CVM</a:t>
             </a:r>
           </a:p>
         </p:txBody>
@@ -18024,7 +18057,7 @@
                 </a:solidFill>
                 <a:latin typeface="Calibri"/>
               </a:rPr>
-              <a:t>DVM 612  |  Principles of Surgery  |  Preop · prep · postop  |  Lewyt College of Veterinary Medicine</a:t>
+              <a:t>DVM 612  |  Dr. Yujin Kim, D.V.M., Ph.D., FFCP  |  Preop · prep · postop  |  Lewyt CVM</a:t>
             </a:r>
           </a:p>
         </p:txBody>
@@ -18767,7 +18800,7 @@
                 </a:solidFill>
                 <a:latin typeface="Calibri"/>
               </a:rPr>
-              <a:t>DVM 612  |  Principles of Surgery  |  Preop · prep · postop  |  Lewyt College of Veterinary Medicine</a:t>
+              <a:t>DVM 612  |  Dr. Yujin Kim, D.V.M., Ph.D., FFCP  |  Preop · prep · postop  |  Lewyt CVM</a:t>
             </a:r>
           </a:p>
         </p:txBody>
@@ -19363,7 +19396,7 @@
                 </a:solidFill>
                 <a:latin typeface="Calibri"/>
               </a:rPr>
-              <a:t>DVM 612  |  Principles of Surgery  |  Preop · prep · postop  |  Lewyt College of Veterinary Medicine</a:t>
+              <a:t>DVM 612  |  Dr. Yujin Kim, D.V.M., Ph.D., FFCP  |  Preop · prep · postop  |  Lewyt CVM</a:t>
             </a:r>
           </a:p>
         </p:txBody>
@@ -20170,7 +20203,7 @@
                 </a:solidFill>
                 <a:latin typeface="Calibri"/>
               </a:rPr>
-              <a:t>DVM 612  |  Principles of Surgery  |  Preop · prep · postop  |  Lewyt College of Veterinary Medicine</a:t>
+              <a:t>DVM 612  |  Dr. Yujin Kim, D.V.M., Ph.D., FFCP  |  Preop · prep · postop  |  Lewyt CVM</a:t>
             </a:r>
           </a:p>
         </p:txBody>
@@ -20559,7 +20592,7 @@
                 </a:solidFill>
                 <a:latin typeface="Calibri"/>
               </a:rPr>
-              <a:t>DVM 612  |  Principles of Surgery  |  Preop · prep · postop  |  Lewyt College of Veterinary Medicine</a:t>
+              <a:t>DVM 612  |  Dr. Yujin Kim, D.V.M., Ph.D., FFCP  |  Preop · prep · postop  |  Lewyt CVM</a:t>
             </a:r>
           </a:p>
         </p:txBody>
@@ -20948,7 +20981,7 @@
                 </a:solidFill>
                 <a:latin typeface="Calibri"/>
               </a:rPr>
-              <a:t>DVM 612  |  Principles of Surgery  |  Preop · prep · postop  |  Lewyt College of Veterinary Medicine</a:t>
+              <a:t>DVM 612  |  Dr. Yujin Kim, D.V.M., Ph.D., FFCP  |  Preop · prep · postop  |  Lewyt CVM</a:t>
             </a:r>
           </a:p>
         </p:txBody>
@@ -21337,7 +21370,7 @@
                 </a:solidFill>
                 <a:latin typeface="Calibri"/>
               </a:rPr>
-              <a:t>DVM 612  |  Principles of Surgery  |  Preop · prep · postop  |  Lewyt College of Veterinary Medicine</a:t>
+              <a:t>DVM 612  |  Dr. Yujin Kim, D.V.M., Ph.D., FFCP  |  Preop · prep · postop  |  Lewyt CVM</a:t>
             </a:r>
           </a:p>
         </p:txBody>
@@ -21936,7 +21969,7 @@
                 </a:solidFill>
                 <a:latin typeface="Calibri"/>
               </a:rPr>
-              <a:t>DVM 612  |  Principles of Surgery  |  Preop · prep · postop  |  Lewyt College of Veterinary Medicine</a:t>
+              <a:t>DVM 612  |  Dr. Yujin Kim, D.V.M., Ph.D., FFCP  |  Preop · prep · postop  |  Lewyt CVM</a:t>
             </a:r>
           </a:p>
         </p:txBody>
@@ -22862,7 +22895,7 @@
                 </a:solidFill>
                 <a:latin typeface="Calibri"/>
               </a:rPr>
-              <a:t>DVM 612  |  Principles of Surgery  |  Preop · prep · postop  |  Lewyt College of Veterinary Medicine</a:t>
+              <a:t>DVM 612  |  Dr. Yujin Kim, D.V.M., Ph.D., FFCP  |  Preop · prep · postop  |  Lewyt CVM</a:t>
             </a:r>
           </a:p>
         </p:txBody>
@@ -23997,7 +24030,7 @@
                 </a:solidFill>
                 <a:latin typeface="Calibri"/>
               </a:rPr>
-              <a:t>DVM 612  |  Principles of Surgery  |  Preop · prep · postop  |  Lewyt College of Veterinary Medicine</a:t>
+              <a:t>DVM 612  |  Dr. Yujin Kim, D.V.M., Ph.D., FFCP  |  Preop · prep · postop  |  Lewyt CVM</a:t>
             </a:r>
           </a:p>
         </p:txBody>
@@ -25710,7 +25743,7 @@
                 </a:solidFill>
                 <a:latin typeface="Calibri"/>
               </a:rPr>
-              <a:t>DVM 612  |  Principles of Surgery  |  Preop · prep · postop  |  Lewyt College of Veterinary Medicine</a:t>
+              <a:t>DVM 612  |  Dr. Yujin Kim, D.V.M., Ph.D., FFCP  |  Preop · prep · postop  |  Lewyt CVM</a:t>
             </a:r>
           </a:p>
         </p:txBody>
@@ -27307,7 +27340,7 @@
                 </a:solidFill>
                 <a:latin typeface="Calibri"/>
               </a:rPr>
-              <a:t>DVM 612  |  Principles of Surgery  |  Preop · prep · postop  |  Lewyt College of Veterinary Medicine</a:t>
+              <a:t>DVM 612  |  Dr. Yujin Kim, D.V.M., Ph.D., FFCP  |  Preop · prep · postop  |  Lewyt CVM</a:t>
             </a:r>
           </a:p>
         </p:txBody>
@@ -27893,7 +27926,7 @@
                 </a:solidFill>
                 <a:latin typeface="Calibri"/>
               </a:rPr>
-              <a:t>DVM 612  |  Principles of Surgery  |  Preop · prep · postop  |  Lewyt College of Veterinary Medicine</a:t>
+              <a:t>DVM 612  |  Dr. Yujin Kim, D.V.M., Ph.D., FFCP  |  Preop · prep · postop  |  Lewyt CVM</a:t>
             </a:r>
           </a:p>
         </p:txBody>
@@ -29182,7 +29215,7 @@
                 </a:solidFill>
                 <a:latin typeface="Calibri"/>
               </a:rPr>
-              <a:t>DVM 612  |  Principles of Surgery  |  Preop · prep · postop  |  Lewyt College of Veterinary Medicine</a:t>
+              <a:t>DVM 612  |  Dr. Yujin Kim, D.V.M., Ph.D., FFCP  |  Preop · prep · postop  |  Lewyt CVM</a:t>
             </a:r>
           </a:p>
         </p:txBody>
@@ -30020,7 +30053,7 @@
                 </a:solidFill>
                 <a:latin typeface="Calibri"/>
               </a:rPr>
-              <a:t>DVM 612  |  Principles of Surgery  |  Preop · prep · postop  |  Lewyt College of Veterinary Medicine</a:t>
+              <a:t>DVM 612  |  Dr. Yujin Kim, D.V.M., Ph.D., FFCP  |  Preop · prep · postop  |  Lewyt CVM</a:t>
             </a:r>
           </a:p>
         </p:txBody>
@@ -30606,7 +30639,7 @@
                 </a:solidFill>
                 <a:latin typeface="Calibri"/>
               </a:rPr>
-              <a:t>DVM 612  |  Principles of Surgery  |  Preop · prep · postop  |  Lewyt College of Veterinary Medicine</a:t>
+              <a:t>DVM 612  |  Dr. Yujin Kim, D.V.M., Ph.D., FFCP  |  Preop · prep · postop  |  Lewyt CVM</a:t>
             </a:r>
           </a:p>
         </p:txBody>
@@ -31587,7 +31620,7 @@
                 </a:solidFill>
                 <a:latin typeface="Calibri"/>
               </a:rPr>
-              <a:t>DVM 612  |  Principles of Surgery  |  Preop · prep · postop  |  Lewyt College of Veterinary Medicine</a:t>
+              <a:t>DVM 612  |  Dr. Yujin Kim, D.V.M., Ph.D., FFCP  |  Preop · prep · postop  |  Lewyt CVM</a:t>
             </a:r>
           </a:p>
         </p:txBody>
@@ -32234,7 +32267,7 @@
                 </a:solidFill>
                 <a:latin typeface="Calibri"/>
               </a:rPr>
-              <a:t>DVM 612  |  Principles of Surgery  |  Preop · prep · postop  |  Lewyt College of Veterinary Medicine</a:t>
+              <a:t>DVM 612  |  Dr. Yujin Kim, D.V.M., Ph.D., FFCP  |  Preop · prep · postop  |  Lewyt CVM</a:t>
             </a:r>
           </a:p>
         </p:txBody>
@@ -32725,7 +32758,7 @@
                 </a:solidFill>
                 <a:latin typeface="Calibri"/>
               </a:rPr>
-              <a:t>DVM 612  |  Principles of Surgery  |  Preop · prep · postop  |  Lewyt College of Veterinary Medicine</a:t>
+              <a:t>DVM 612  |  Dr. Yujin Kim, D.V.M., Ph.D., FFCP  |  Preop · prep · postop  |  Lewyt CVM</a:t>
             </a:r>
           </a:p>
         </p:txBody>
@@ -33701,7 +33734,7 @@
                 </a:solidFill>
                 <a:latin typeface="Calibri"/>
               </a:rPr>
-              <a:t>DVM 612  |  Principles of Surgery  |  Preop · prep · postop  |  Lewyt College of Veterinary Medicine</a:t>
+              <a:t>DVM 612  |  Dr. Yujin Kim, D.V.M., Ph.D., FFCP  |  Preop · prep · postop  |  Lewyt CVM</a:t>
             </a:r>
           </a:p>
         </p:txBody>
@@ -34294,7 +34327,7 @@
                 </a:solidFill>
                 <a:latin typeface="Calibri"/>
               </a:rPr>
-              <a:t>DVM 612  |  Principles of Surgery  |  Preop · prep · postop  |  Lewyt College of Veterinary Medicine</a:t>
+              <a:t>DVM 612  |  Dr. Yujin Kim, D.V.M., Ph.D., FFCP  |  Preop · prep · postop  |  Lewyt CVM</a:t>
             </a:r>
           </a:p>
         </p:txBody>
@@ -34840,7 +34873,7 @@
                 </a:solidFill>
                 <a:latin typeface="Calibri"/>
               </a:rPr>
-              <a:t>DVM 612  |  Principles of Surgery  |  Preop · prep · postop  |  Lewyt College of Veterinary Medicine</a:t>
+              <a:t>DVM 612  |  Dr. Yujin Kim, D.V.M., Ph.D., FFCP  |  Preop · prep · postop  |  Lewyt CVM</a:t>
             </a:r>
           </a:p>
         </p:txBody>
@@ -35953,7 +35986,7 @@
                 </a:solidFill>
                 <a:latin typeface="Calibri"/>
               </a:rPr>
-              <a:t>DVM 612  |  Principles of Surgery  |  Preop · prep · postop  |  Lewyt College of Veterinary Medicine</a:t>
+              <a:t>DVM 612  |  Dr. Yujin Kim, D.V.M., Ph.D., FFCP  |  Preop · prep · postop  |  Lewyt CVM</a:t>
             </a:r>
           </a:p>
         </p:txBody>
@@ -36896,7 +36929,7 @@
                 </a:solidFill>
                 <a:latin typeface="Calibri"/>
               </a:rPr>
-              <a:t>DVM 612  |  Principles of Surgery  |  Preop · prep · postop  |  Lewyt College of Veterinary Medicine</a:t>
+              <a:t>DVM 612  |  Dr. Yujin Kim, D.V.M., Ph.D., FFCP  |  Preop · prep · postop  |  Lewyt CVM</a:t>
             </a:r>
           </a:p>
         </p:txBody>
@@ -37285,7 +37318,7 @@
                 </a:solidFill>
                 <a:latin typeface="Calibri"/>
               </a:rPr>
-              <a:t>DVM 612  |  Principles of Surgery  |  Preop · prep · postop  |  Lewyt College of Veterinary Medicine</a:t>
+              <a:t>DVM 612  |  Dr. Yujin Kim, D.V.M., Ph.D., FFCP  |  Preop · prep · postop  |  Lewyt CVM</a:t>
             </a:r>
           </a:p>
         </p:txBody>
@@ -38012,7 +38045,7 @@
                 </a:solidFill>
                 <a:latin typeface="Calibri"/>
               </a:rPr>
-              <a:t>DVM 612  |  Principles of Surgery  |  Preop · prep · postop  |  Lewyt College of Veterinary Medicine</a:t>
+              <a:t>DVM 612  |  Dr. Yujin Kim, D.V.M., Ph.D., FFCP  |  Preop · prep · postop  |  Lewyt CVM</a:t>
             </a:r>
           </a:p>
         </p:txBody>
@@ -39301,7 +39334,7 @@
                 </a:solidFill>
                 <a:latin typeface="Calibri"/>
               </a:rPr>
-              <a:t>DVM 612  |  Principles of Surgery  |  Preop · prep · postop  |  Lewyt College of Veterinary Medicine</a:t>
+              <a:t>DVM 612  |  Dr. Yujin Kim, D.V.M., Ph.D., FFCP  |  Preop · prep · postop  |  Lewyt CVM</a:t>
             </a:r>
           </a:p>
         </p:txBody>
@@ -40590,7 +40623,7 @@
                 </a:solidFill>
                 <a:latin typeface="Calibri"/>
               </a:rPr>
-              <a:t>DVM 612  |  Principles of Surgery  |  Preop · prep · postop  |  Lewyt College of Veterinary Medicine</a:t>
+              <a:t>DVM 612  |  Dr. Yujin Kim, D.V.M., Ph.D., FFCP  |  Preop · prep · postop  |  Lewyt CVM</a:t>
             </a:r>
           </a:p>
         </p:txBody>
@@ -41329,7 +41362,7 @@
                 </a:solidFill>
                 <a:latin typeface="Calibri"/>
               </a:rPr>
-              <a:t>DVM 612  |  Principles of Surgery  |  Preop · prep · postop  |  Lewyt College of Veterinary Medicine</a:t>
+              <a:t>DVM 612  |  Dr. Yujin Kim, D.V.M., Ph.D., FFCP  |  Preop · prep · postop  |  Lewyt CVM</a:t>
             </a:r>
           </a:p>
         </p:txBody>
@@ -42772,7 +42805,7 @@
                 </a:solidFill>
                 <a:latin typeface="Calibri"/>
               </a:rPr>
-              <a:t>DVM 612  |  Principles of Surgery  |  Preop · prep · postop  |  Lewyt College of Veterinary Medicine</a:t>
+              <a:t>DVM 612  |  Dr. Yujin Kim, D.V.M., Ph.D., FFCP  |  Preop · prep · postop  |  Lewyt CVM</a:t>
             </a:r>
           </a:p>
         </p:txBody>
@@ -44105,7 +44138,7 @@
                 </a:solidFill>
                 <a:latin typeface="Calibri"/>
               </a:rPr>
-              <a:t>DVM 612  |  Principles of Surgery  |  Preop · prep · postop  |  Lewyt College of Veterinary Medicine</a:t>
+              <a:t>DVM 612  |  Dr. Yujin Kim, D.V.M., Ph.D., FFCP  |  Preop · prep · postop  |  Lewyt CVM</a:t>
             </a:r>
           </a:p>
         </p:txBody>
@@ -44932,7 +44965,7 @@
                 </a:solidFill>
                 <a:latin typeface="Calibri"/>
               </a:rPr>
-              <a:t>DVM 612  |  Principles of Surgery  |  Preop · prep · postop  |  Lewyt College of Veterinary Medicine</a:t>
+              <a:t>DVM 612  |  Dr. Yujin Kim, D.V.M., Ph.D., FFCP  |  Preop · prep · postop  |  Lewyt CVM</a:t>
             </a:r>
           </a:p>
         </p:txBody>
@@ -45759,7 +45792,7 @@
                 </a:solidFill>
                 <a:latin typeface="Calibri"/>
               </a:rPr>
-              <a:t>DVM 612  |  Principles of Surgery  |  Preop · prep · postop  |  Lewyt College of Veterinary Medicine</a:t>
+              <a:t>DVM 612  |  Dr. Yujin Kim, D.V.M., Ph.D., FFCP  |  Preop · prep · postop  |  Lewyt CVM</a:t>
             </a:r>
           </a:p>
         </p:txBody>
@@ -46243,7 +46276,7 @@
                 </a:solidFill>
                 <a:latin typeface="Calibri"/>
               </a:rPr>
-              <a:t>DVM 612  |  Principles of Surgery  |  Preop · prep · postop  |  Lewyt College of Veterinary Medicine</a:t>
+              <a:t>DVM 612  |  Dr. Yujin Kim, D.V.M., Ph.D., FFCP  |  Preop · prep · postop  |  Lewyt CVM</a:t>
             </a:r>
           </a:p>
         </p:txBody>
@@ -47302,7 +47335,7 @@
                 </a:solidFill>
                 <a:latin typeface="Calibri"/>
               </a:rPr>
-              <a:t>DVM 612  |  Principles of Surgery  |  Preop · prep · postop  |  Lewyt College of Veterinary Medicine</a:t>
+              <a:t>DVM 612  |  Dr. Yujin Kim, D.V.M., Ph.D., FFCP  |  Preop · prep · postop  |  Lewyt CVM</a:t>
             </a:r>
           </a:p>
         </p:txBody>
@@ -47975,7 +48008,7 @@
                 </a:solidFill>
                 <a:latin typeface="Calibri"/>
               </a:rPr>
-              <a:t>DVM 612  |  Principles of Surgery  |  Preop · prep · postop  |  Lewyt College of Veterinary Medicine</a:t>
+              <a:t>DVM 612  |  Dr. Yujin Kim, D.V.M., Ph.D., FFCP  |  Preop · prep · postop  |  Lewyt CVM</a:t>
             </a:r>
           </a:p>
         </p:txBody>
@@ -49264,7 +49297,7 @@
                 </a:solidFill>
                 <a:latin typeface="Calibri"/>
               </a:rPr>
-              <a:t>DVM 612  |  Principles of Surgery  |  Preop · prep · postop  |  Lewyt College of Veterinary Medicine</a:t>
+              <a:t>DVM 612  |  Dr. Yujin Kim, D.V.M., Ph.D., FFCP  |  Preop · prep · postop  |  Lewyt CVM</a:t>
             </a:r>
           </a:p>
         </p:txBody>
@@ -49710,7 +49743,7 @@
                 </a:solidFill>
                 <a:latin typeface="Calibri"/>
               </a:rPr>
-              <a:t>DVM 612  |  Principles of Surgery  |  Preop · prep · postop  |  Lewyt College of Veterinary Medicine</a:t>
+              <a:t>DVM 612  |  Dr. Yujin Kim, D.V.M., Ph.D., FFCP  |  Preop · prep · postop  |  Lewyt CVM</a:t>
             </a:r>
           </a:p>
         </p:txBody>
@@ -50178,7 +50211,7 @@
                 </a:solidFill>
                 <a:latin typeface="Calibri"/>
               </a:rPr>
-              <a:t>DVM 612  |  Principles of Surgery  |  Preop · prep · postop  |  Lewyt College of Veterinary Medicine</a:t>
+              <a:t>DVM 612  |  Dr. Yujin Kim, D.V.M., Ph.D., FFCP  |  Preop · prep · postop  |  Lewyt CVM</a:t>
             </a:r>
           </a:p>
         </p:txBody>
@@ -51582,7 +51615,7 @@
                 </a:solidFill>
                 <a:latin typeface="Calibri"/>
               </a:rPr>
-              <a:t>DVM 612  |  Principles of Surgery  |  Preop · prep · postop  |  Lewyt College of Veterinary Medicine</a:t>
+              <a:t>DVM 612  |  Dr. Yujin Kim, D.V.M., Ph.D., FFCP  |  Preop · prep · postop  |  Lewyt CVM</a:t>
             </a:r>
           </a:p>
         </p:txBody>
@@ -53053,7 +53086,7 @@
                 </a:solidFill>
                 <a:latin typeface="Calibri"/>
               </a:rPr>
-              <a:t>DVM 612  |  Principles of Surgery  |  Preop · prep · postop  |  Lewyt College of Veterinary Medicine</a:t>
+              <a:t>DVM 612  |  Dr. Yujin Kim, D.V.M., Ph.D., FFCP  |  Preop · prep · postop  |  Lewyt CVM</a:t>
             </a:r>
           </a:p>
         </p:txBody>
@@ -53748,7 +53781,7 @@
                 </a:solidFill>
                 <a:latin typeface="Calibri"/>
               </a:rPr>
-              <a:t>DVM 612  |  Principles of Surgery  |  Preop · prep · postop  |  Lewyt College of Veterinary Medicine</a:t>
+              <a:t>DVM 612  |  Dr. Yujin Kim, D.V.M., Ph.D., FFCP  |  Preop · prep · postop  |  Lewyt CVM</a:t>
             </a:r>
           </a:p>
         </p:txBody>

</xml_diff>

<commit_message>
Replace generated clinic scenes with real surgical photographs.
Use openly licensed and U.S. government clinical photos for clipping, positioning, draping, anesthesia, recovery, and the 24-hour OHE incision. Keep the spiral-prep and closed-gloving figures as technique diagrams. Credit sources on the slides.

Co-authored-by: drkimvet <drkimvet@users.noreply.github.com>
</commit_message>
<xml_diff>
--- a/lectures/DVM-612_Week4_Preop_PatientPrep_Postop.pptx
+++ b/lectures/DVM-612_Week4_Preop_PatientPrep_Postop.pptx
@@ -2380,7 +2380,7 @@
           <a:lstStyle/>
           <a:p>
             <a:r>
-              <a:t>The yellow box is the field. If the drape later shows hair, the clip failed. Willie: if you only flush an ear you still clip what you will contaminate; a TECA field is the whole pinna and lateral skull, not this abdomen. MoMo never reached this slide.</a:t>
+              <a:t>Left photo is a real clip in progress and still too narrow — that is the teaching point. Right photo is a real 24-hour OHE: the clip is the field you needed yesterday. Willie: TECA field is pinna and skull, not abdomen. MoMo never reached clippers.</a:t>
             </a:r>
           </a:p>
         </p:txBody>
@@ -2590,7 +2590,7 @@
           <a:lstStyle/>
           <a:p>
             <a:r>
-              <a:t>Mime the spiral. The picture is abdomen; the rule is the same on an ear or a limb. CHG in Willie’s ear is a real harm.</a:t>
+              <a:t>Mime the spiral. No open-license spiral-prep photograph was available; this stays a diagram. Real clip, drape, anesthesia, and recovery photos are adjacent.</a:t>
             </a:r>
           </a:p>
         </p:txBody>
@@ -2660,7 +2660,7 @@
           <a:lstStyle/>
           <a:p>
             <a:r>
-              <a:t>Canine OHE is dorsal recumbency. Over-splitting femurs of a large dog is a student habit. Mention GDV: even positioning can worsen caval compression — communicate with anesthesia.</a:t>
+              <a:t>This is a real dog in dorsal recumbency. Point: airway and monitoring are on before the clip. Over-splitting femurs is a student habit. GDV positioning can worsen caval compression.</a:t>
             </a:r>
           </a:p>
         </p:txBody>
@@ -2730,7 +2730,7 @@
           <a:lstStyle/>
           <a:p>
             <a:r>
-              <a:t>Spend 90 seconds on the two pictures. Students remember the hairy window. Then: gown/glove before you drape, timeout before you cut.</a:t>
+              <a:t>Left is a real spay: gown/mask/drape are present, but hair is still at the window — that is the fail. Right is a real sterile field. Then timeout before you cut.</a:t>
             </a:r>
           </a:p>
         </p:txBody>
@@ -2800,7 +2800,7 @@
           <a:lstStyle/>
           <a:p>
             <a:r>
-              <a:t>Call out the inset as the correct closed-glove mechanic. The workstation picture is the minimum monitoring set. Students should name SpO2, ETCO2, ECG, temp, fluids without looking.</a:t>
+              <a:t>Call out the inset as closed gloving. Students name SpO2, ETCO2, ECG, temp, fluids off the real workstation photo.</a:t>
             </a:r>
           </a:p>
         </p:txBody>
@@ -3220,7 +3220,7 @@
           <a:lstStyle/>
           <a:p>
             <a:r>
-              <a:t>The picture is a Cavalier in recovery — that is Willie. Pulse ox on the tongue is correct in recovery. Do not send a pale OHE to the kennel because she looks groggy.</a:t>
+              <a:t>Real recovery: e-collar, IV, clipped abdomen. Do not send a pale OHE to the kennel because she looks groggy.</a:t>
             </a:r>
           </a:p>
         </p:txBody>
@@ -3430,7 +3430,7 @@
           <a:lstStyle/>
           <a:p>
             <a:r>
-              <a:t>Licking and basketball-with-the-dog are the two discharge failures. Be concrete: ‘no off-leash for 14 days.’</a:t>
+              <a:t>Real 24-hour OHE. Licking and basketball-with-the-dog are the two discharge failures. Be concrete: no off-leash for 14 days.</a:t>
             </a:r>
           </a:p>
         </p:txBody>
@@ -27553,7 +27553,7 @@
                 </a:solidFill>
                 <a:latin typeface="Calibri"/>
               </a:rPr>
-              <a:t>#40 BLADE  ·  CLIPPER, NOT RAZOR  ·  FIELD WIDE ENOUGH TO EXTEND THE INCISION</a:t>
+              <a:t>REAL CLINIC PHOTOGRAPHS  ·  #40 CLIPPER, NOT RAZOR  ·  FIELD WIDE ENOUGH TO EXTEND</a:t>
             </a:r>
           </a:p>
         </p:txBody>
@@ -27634,9 +27634,87 @@
           </a:p>
         </p:txBody>
       </p:sp>
+      <p:sp>
+        <p:nvSpPr>
+          <p:cNvPr id="8" name="Rounded Rectangle 7"/>
+          <p:cNvSpPr/>
+          <p:nvPr/>
+        </p:nvSpPr>
+        <p:spPr>
+          <a:xfrm>
+            <a:off x="365760" y="1005840"/>
+            <a:ext cx="5669280" cy="347472"/>
+          </a:xfrm>
+          <a:prstGeom prst="roundRect">
+            <a:avLst>
+              <a:gd name="adj" fmla="val 8000"/>
+            </a:avLst>
+          </a:prstGeom>
+          <a:solidFill>
+            <a:srgbClr val="8B2E2E"/>
+          </a:solidFill>
+          <a:ln>
+            <a:noFill/>
+          </a:ln>
+        </p:spPr>
+        <p:style>
+          <a:lnRef idx="1">
+            <a:schemeClr val="accent1"/>
+          </a:lnRef>
+          <a:fillRef idx="3">
+            <a:schemeClr val="accent1"/>
+          </a:fillRef>
+          <a:effectRef idx="2">
+            <a:schemeClr val="accent1"/>
+          </a:effectRef>
+          <a:fontRef idx="minor">
+            <a:schemeClr val="lt1"/>
+          </a:fontRef>
+        </p:style>
+        <p:txBody>
+          <a:bodyPr rtlCol="0" anchor="ctr"/>
+          <a:lstStyle/>
+          <a:p>
+            <a:pPr algn="ctr"/>
+          </a:p>
+        </p:txBody>
+      </p:sp>
+      <p:sp>
+        <p:nvSpPr>
+          <p:cNvPr id="9" name="TextBox 8"/>
+          <p:cNvSpPr txBox="1"/>
+          <p:nvPr/>
+        </p:nvSpPr>
+        <p:spPr>
+          <a:xfrm>
+            <a:off x="365760" y="1005840"/>
+            <a:ext cx="5669280" cy="347472"/>
+          </a:xfrm>
+          <a:prstGeom prst="rect">
+            <a:avLst/>
+          </a:prstGeom>
+          <a:noFill/>
+        </p:spPr>
+        <p:txBody>
+          <a:bodyPr wrap="square" anchor="ctr"/>
+          <a:lstStyle/>
+          <a:p>
+            <a:pPr algn="ctr"/>
+            <a:r>
+              <a:rPr sz="1300" b="1">
+                <a:solidFill>
+                  <a:srgbClr val="FFFFFF"/>
+                </a:solidFill>
+                <a:latin typeface="Calibri"/>
+              </a:rPr>
+              <a:t>Too narrow — hair still at the margin</a:t>
+            </a:r>
+          </a:p>
+        </p:txBody>
+      </p:sp>
       <p:pic>
         <p:nvPicPr>
-          <p:cNvPr id="8" name="Picture 7" descr="prep_ohe_clip_wide.png"/>
+          <p:cNvPr id="10" name="Picture 9" descr="clip_cat.jpg"/>
           <p:cNvPicPr>
             <a:picLocks noChangeAspect="1"/>
           </p:cNvPicPr>
@@ -27650,8 +27728,8 @@
         </p:blipFill>
         <p:spPr>
           <a:xfrm>
-            <a:off x="365760" y="1051560"/>
-            <a:ext cx="6675120" cy="5394960"/>
+            <a:off x="365760" y="1371600"/>
+            <a:ext cx="5669280" cy="3246120"/>
           </a:xfrm>
           <a:prstGeom prst="rect">
             <a:avLst/>
@@ -27660,14 +27738,14 @@
       </p:pic>
       <p:sp>
         <p:nvSpPr>
-          <p:cNvPr id="9" name="Rounded Rectangle 8"/>
-          <p:cNvSpPr/>
-          <p:nvPr/>
-        </p:nvSpPr>
-        <p:spPr>
-          <a:xfrm>
-            <a:off x="7178040" y="1051560"/>
-            <a:ext cx="4572000" cy="5394960"/>
+          <p:cNvPr id="11" name="Rounded Rectangle 10"/>
+          <p:cNvSpPr/>
+          <p:nvPr/>
+        </p:nvSpPr>
+        <p:spPr>
+          <a:xfrm>
+            <a:off x="6172200" y="1005840"/>
+            <a:ext cx="5669280" cy="347472"/>
           </a:xfrm>
           <a:prstGeom prst="roundRect">
             <a:avLst>
@@ -27675,6 +27753,108 @@
             </a:avLst>
           </a:prstGeom>
           <a:solidFill>
+            <a:srgbClr val="2E6B4F"/>
+          </a:solidFill>
+          <a:ln>
+            <a:noFill/>
+          </a:ln>
+        </p:spPr>
+        <p:style>
+          <a:lnRef idx="1">
+            <a:schemeClr val="accent1"/>
+          </a:lnRef>
+          <a:fillRef idx="3">
+            <a:schemeClr val="accent1"/>
+          </a:fillRef>
+          <a:effectRef idx="2">
+            <a:schemeClr val="accent1"/>
+          </a:effectRef>
+          <a:fontRef idx="minor">
+            <a:schemeClr val="lt1"/>
+          </a:fontRef>
+        </p:style>
+        <p:txBody>
+          <a:bodyPr rtlCol="0" anchor="ctr"/>
+          <a:lstStyle/>
+          <a:p>
+            <a:pPr algn="ctr"/>
+          </a:p>
+        </p:txBody>
+      </p:sp>
+      <p:sp>
+        <p:nvSpPr>
+          <p:cNvPr id="12" name="TextBox 11"/>
+          <p:cNvSpPr txBox="1"/>
+          <p:nvPr/>
+        </p:nvSpPr>
+        <p:spPr>
+          <a:xfrm>
+            <a:off x="6172200" y="1005840"/>
+            <a:ext cx="5669280" cy="347472"/>
+          </a:xfrm>
+          <a:prstGeom prst="rect">
+            <a:avLst/>
+          </a:prstGeom>
+          <a:noFill/>
+        </p:spPr>
+        <p:txBody>
+          <a:bodyPr wrap="square" anchor="ctr"/>
+          <a:lstStyle/>
+          <a:p>
+            <a:pPr algn="ctr"/>
+            <a:r>
+              <a:rPr sz="1300" b="1">
+                <a:solidFill>
+                  <a:srgbClr val="FFFFFF"/>
+                </a:solidFill>
+                <a:latin typeface="Calibri"/>
+              </a:rPr>
+              <a:t>24 h after OHE — this is the clip you needed</a:t>
+            </a:r>
+          </a:p>
+        </p:txBody>
+      </p:sp>
+      <p:pic>
+        <p:nvPicPr>
+          <p:cNvPr id="13" name="Picture 12" descr="spay_incision.jpg"/>
+          <p:cNvPicPr>
+            <a:picLocks noChangeAspect="1"/>
+          </p:cNvPicPr>
+          <p:nvPr/>
+        </p:nvPicPr>
+        <p:blipFill>
+          <a:blip r:embed="rId3"/>
+          <a:stretch>
+            <a:fillRect/>
+          </a:stretch>
+        </p:blipFill>
+        <p:spPr>
+          <a:xfrm>
+            <a:off x="6172200" y="1371600"/>
+            <a:ext cx="5669280" cy="3246120"/>
+          </a:xfrm>
+          <a:prstGeom prst="rect">
+            <a:avLst/>
+          </a:prstGeom>
+        </p:spPr>
+      </p:pic>
+      <p:sp>
+        <p:nvSpPr>
+          <p:cNvPr id="14" name="Rounded Rectangle 13"/>
+          <p:cNvSpPr/>
+          <p:nvPr/>
+        </p:nvSpPr>
+        <p:spPr>
+          <a:xfrm>
+            <a:off x="365760" y="4736592"/>
+            <a:ext cx="11475720" cy="1737360"/>
+          </a:xfrm>
+          <a:prstGeom prst="roundRect">
+            <a:avLst>
+              <a:gd name="adj" fmla="val 8000"/>
+            </a:avLst>
+          </a:prstGeom>
+          <a:solidFill>
             <a:srgbClr val="FFFFFF"/>
           </a:solidFill>
           <a:ln>
@@ -27705,14 +27885,14 @@
       </p:sp>
       <p:sp>
         <p:nvSpPr>
-          <p:cNvPr id="10" name="TextBox 9"/>
-          <p:cNvSpPr txBox="1"/>
-          <p:nvPr/>
-        </p:nvSpPr>
-        <p:spPr>
-          <a:xfrm>
-            <a:off x="7406640" y="1188720"/>
-            <a:ext cx="4160520" cy="365760"/>
+          <p:cNvPr id="15" name="TextBox 14"/>
+          <p:cNvSpPr txBox="1"/>
+          <p:nvPr/>
+        </p:nvSpPr>
+        <p:spPr>
+          <a:xfrm>
+            <a:off x="548640" y="4864608"/>
+            <a:ext cx="11155680" cy="1463040"/>
           </a:xfrm>
           <a:prstGeom prst="rect">
             <a:avLst/>
@@ -27725,139 +27905,21 @@
           <a:p>
             <a:pPr algn="l"/>
             <a:r>
-              <a:rPr sz="1600" b="1">
-                <a:solidFill>
-                  <a:srgbClr val="0B2C4A"/>
-                </a:solidFill>
-                <a:latin typeface="Calibri"/>
-              </a:rPr>
-              <a:t>OHE / celiotomy field</a:t>
-            </a:r>
-          </a:p>
-        </p:txBody>
-      </p:sp>
-      <p:sp>
-        <p:nvSpPr>
-          <p:cNvPr id="11" name="TextBox 10"/>
-          <p:cNvSpPr txBox="1"/>
-          <p:nvPr/>
-        </p:nvSpPr>
-        <p:spPr>
-          <a:xfrm>
-            <a:off x="7360920" y="1600200"/>
-            <a:ext cx="4206240" cy="4572000"/>
-          </a:xfrm>
-          <a:prstGeom prst="rect">
-            <a:avLst/>
-          </a:prstGeom>
-          <a:noFill/>
-        </p:spPr>
-        <p:txBody>
-          <a:bodyPr wrap="square">
-            <a:spAutoFit/>
-          </a:bodyPr>
-          <a:lstStyle/>
-          <a:p>
-            <a:pPr algn="l">
-              <a:spcAft>
-                <a:spcPts val="600"/>
-              </a:spcAft>
-            </a:pPr>
-            <a:r>
-              <a:rPr sz="1300" b="0">
+              <a:rPr sz="1400" b="0">
                 <a:solidFill>
                   <a:srgbClr val="1C1C1C"/>
                 </a:solidFill>
                 <a:latin typeface="Calibri"/>
               </a:rPr>
-              <a:t>▸  Xiphoid (or slightly cranial) to pubis, widely lateral past the nipples — a rectangle, not a bikini strip.</a:t>
-            </a:r>
-          </a:p>
-          <a:p>
-            <a:pPr algn="l">
-              <a:spcAft>
-                <a:spcPts val="600"/>
-              </a:spcAft>
-            </a:pPr>
-            <a:r>
-              <a:rPr sz="1300" b="0">
-                <a:solidFill>
-                  <a:srgbClr val="1C1C1C"/>
-                </a:solidFill>
-                <a:latin typeface="Calibri"/>
-              </a:rPr>
-              <a:t>▸  Clip with the grain, then against, to the skin. Vacuum the hair.</a:t>
-            </a:r>
-          </a:p>
-          <a:p>
-            <a:pPr algn="l">
-              <a:spcAft>
-                <a:spcPts val="600"/>
-              </a:spcAft>
-            </a:pPr>
-            <a:r>
-              <a:rPr sz="1300" b="0">
-                <a:solidFill>
-                  <a:srgbClr val="1C1C1C"/>
-                </a:solidFill>
-                <a:latin typeface="Calibri"/>
-              </a:rPr>
-              <a:t>▸  ~20 cm beyond the planned incision is a Fossum-style working rule.</a:t>
-            </a:r>
-          </a:p>
-          <a:p>
-            <a:pPr algn="l">
-              <a:spcAft>
-                <a:spcPts val="600"/>
-              </a:spcAft>
-            </a:pPr>
-            <a:r>
-              <a:rPr sz="1300" b="0">
-                <a:solidFill>
-                  <a:srgbClr val="1C1C1C"/>
-                </a:solidFill>
-                <a:latin typeface="Calibri"/>
-              </a:rPr>
-              <a:t>▸  Do not clip the night before: bacterial load rises.</a:t>
-            </a:r>
-          </a:p>
-          <a:p>
-            <a:pPr algn="l">
-              <a:spcAft>
-                <a:spcPts val="600"/>
-              </a:spcAft>
-            </a:pPr>
-            <a:r>
-              <a:rPr sz="1300" b="0">
-                <a:solidFill>
-                  <a:srgbClr val="1C1C1C"/>
-                </a:solidFill>
-                <a:latin typeface="Calibri"/>
-              </a:rPr>
-              <a:t>▸  Razor = micro-nicks = higher SSI. Clipper burn is a wound.</a:t>
-            </a:r>
-          </a:p>
-          <a:p>
-            <a:pPr algn="l">
-              <a:spcAft>
-                <a:spcPts val="600"/>
-              </a:spcAft>
-            </a:pPr>
-            <a:r>
-              <a:rPr sz="1300" b="0">
-                <a:solidFill>
-                  <a:srgbClr val="1C1C1C"/>
-                </a:solidFill>
-                <a:latin typeface="Calibri"/>
-              </a:rPr>
-              <a:t>▸  Airway in and depth adequate BEFORE the clippers start.</a:t>
-            </a:r>
-          </a:p>
-        </p:txBody>
-      </p:sp>
-      <p:sp>
-        <p:nvSpPr>
-          <p:cNvPr id="12" name="Rectangle 11"/>
+              <a:t>Xiphoid (or slightly cranial) to pubis, widely lateral past the nipples — a rectangle, not a bikini strip. Clip with the grain, then against, to the skin. Vacuum. ~20 cm beyond the planned incision. Do not clip the night before. Razor = micro-nicks = higher SSI. Airway in and depth adequate BEFORE the clippers start.
+Photos: Uwe Gille, CC0 (cat clip); Liannadavis, CC BY-SA 4.0 (OHE incision).</a:t>
+            </a:r>
+          </a:p>
+        </p:txBody>
+      </p:sp>
+      <p:sp>
+        <p:nvSpPr>
+          <p:cNvPr id="16" name="Rectangle 15"/>
           <p:cNvSpPr/>
           <p:nvPr/>
         </p:nvSpPr>
@@ -27900,7 +27962,7 @@
       </p:sp>
       <p:sp>
         <p:nvSpPr>
-          <p:cNvPr id="13" name="TextBox 12"/>
+          <p:cNvPr id="17" name="TextBox 16"/>
           <p:cNvSpPr txBox="1"/>
           <p:nvPr/>
         </p:nvSpPr>
@@ -27933,7 +27995,7 @@
       </p:sp>
       <p:sp>
         <p:nvSpPr>
-          <p:cNvPr id="14" name="TextBox 13"/>
+          <p:cNvPr id="18" name="TextBox 17"/>
           <p:cNvSpPr txBox="1"/>
           <p:nvPr/>
         </p:nvSpPr>
@@ -30266,7 +30328,7 @@
                 </a:solidFill>
                 <a:latin typeface="Calibri"/>
               </a:rPr>
-              <a:t>CENTER → PERIPHERY  ·  NEW SPONGE EVERY TIME YOU LEAVE THE INCISION  ·  HONOR CONTACT TIME</a:t>
+              <a:t>TECHNIQUE DIAGRAM  ·  CENTER → PERIPHERY  ·  REAL PHOTOS ARE ON THE CLIP AND DRAPE SLIDES</a:t>
             </a:r>
           </a:p>
         </p:txBody>
@@ -30515,7 +30577,7 @@
                 </a:solidFill>
                 <a:latin typeface="Calibri"/>
               </a:rPr>
-              <a:t>▸  Typical teaching: timed 3–5 min or product cycles, then a final paint. Follow the bottle in your lab.</a:t>
+              <a:t>▸  Typical teaching: timed 3–5 min or product cycles, then a final paint.</a:t>
             </a:r>
           </a:p>
           <a:p>
@@ -30531,7 +30593,7 @@
                 </a:solidFill>
                 <a:latin typeface="Calibri"/>
               </a:rPr>
-              <a:t>▸  Damp-to-dry, not a lake. Puddles wick bacteria and soak the patient cold.</a:t>
+              <a:t>▸  Damp-to-dry, not a lake.</a:t>
             </a:r>
           </a:p>
           <a:p>
@@ -30563,7 +30625,7 @@
                 </a:solidFill>
                 <a:latin typeface="Calibri"/>
               </a:rPr>
-              <a:t>▸  Hanging limb: prep from incision toward the dirty foot, never reverse.</a:t>
+              <a:t>▸  This spiral is a diagram. The clip and drape slides are real clinic photographs.</a:t>
             </a:r>
           </a:p>
         </p:txBody>
@@ -30852,7 +30914,7 @@
                 </a:solidFill>
                 <a:latin typeface="Calibri"/>
               </a:rPr>
-              <a:t>PRESSURE, STRETCH, AND ASPIRATION LIVE HERE</a:t>
+              <a:t>REAL OR PHOTOGRAPH  ·  DORSAL RECUMBENCY, AIRWAY, IV, MONITORING, V-TROUGH</a:t>
             </a:r>
           </a:p>
         </p:txBody>
@@ -30933,16 +30995,40 @@
           </a:p>
         </p:txBody>
       </p:sp>
-      <p:sp>
-        <p:nvSpPr>
-          <p:cNvPr id="8" name="Rounded Rectangle 7"/>
-          <p:cNvSpPr/>
-          <p:nvPr/>
-        </p:nvSpPr>
-        <p:spPr>
-          <a:xfrm>
-            <a:off x="411480" y="1097280"/>
-            <a:ext cx="5715000" cy="2331720"/>
+      <p:pic>
+        <p:nvPicPr>
+          <p:cNvPr id="8" name="Picture 7" descr="dog_or.jpg"/>
+          <p:cNvPicPr>
+            <a:picLocks noChangeAspect="1"/>
+          </p:cNvPicPr>
+          <p:nvPr/>
+        </p:nvPicPr>
+        <p:blipFill>
+          <a:blip r:embed="rId2"/>
+          <a:stretch>
+            <a:fillRect/>
+          </a:stretch>
+        </p:blipFill>
+        <p:spPr>
+          <a:xfrm>
+            <a:off x="320040" y="1024128"/>
+            <a:ext cx="7635240" cy="5440680"/>
+          </a:xfrm>
+          <a:prstGeom prst="rect">
+            <a:avLst/>
+          </a:prstGeom>
+        </p:spPr>
+      </p:pic>
+      <p:sp>
+        <p:nvSpPr>
+          <p:cNvPr id="9" name="Rounded Rectangle 8"/>
+          <p:cNvSpPr/>
+          <p:nvPr/>
+        </p:nvSpPr>
+        <p:spPr>
+          <a:xfrm>
+            <a:off x="8092440" y="1024128"/>
+            <a:ext cx="3749039" cy="5440680"/>
           </a:xfrm>
           <a:prstGeom prst="roundRect">
             <a:avLst>
@@ -30980,57 +31066,14 @@
       </p:sp>
       <p:sp>
         <p:nvSpPr>
-          <p:cNvPr id="9" name="Rectangle 8"/>
-          <p:cNvSpPr/>
-          <p:nvPr/>
-        </p:nvSpPr>
-        <p:spPr>
-          <a:xfrm>
-            <a:off x="411480" y="1097280"/>
-            <a:ext cx="91440" cy="2331720"/>
-          </a:xfrm>
-          <a:prstGeom prst="rect">
-            <a:avLst/>
-          </a:prstGeom>
-          <a:solidFill>
-            <a:srgbClr val="0B2C4A"/>
-          </a:solidFill>
-          <a:ln>
-            <a:noFill/>
-          </a:ln>
-        </p:spPr>
-        <p:style>
-          <a:lnRef idx="1">
-            <a:schemeClr val="accent1"/>
-          </a:lnRef>
-          <a:fillRef idx="3">
-            <a:schemeClr val="accent1"/>
-          </a:fillRef>
-          <a:effectRef idx="2">
-            <a:schemeClr val="accent1"/>
-          </a:effectRef>
-          <a:fontRef idx="minor">
-            <a:schemeClr val="lt1"/>
-          </a:fontRef>
-        </p:style>
-        <p:txBody>
-          <a:bodyPr rtlCol="0" anchor="ctr"/>
-          <a:lstStyle/>
-          <a:p>
-            <a:pPr algn="ctr"/>
-          </a:p>
-        </p:txBody>
-      </p:sp>
-      <p:sp>
-        <p:nvSpPr>
           <p:cNvPr id="10" name="TextBox 9"/>
           <p:cNvSpPr txBox="1"/>
           <p:nvPr/>
         </p:nvSpPr>
         <p:spPr>
           <a:xfrm>
-            <a:off x="667512" y="1207008"/>
-            <a:ext cx="5349240" cy="347472"/>
+            <a:off x="8275320" y="1170432"/>
+            <a:ext cx="3429000" cy="411480"/>
           </a:xfrm>
           <a:prstGeom prst="rect">
             <a:avLst/>
@@ -31043,13 +31086,13 @@
           <a:p>
             <a:pPr algn="l"/>
             <a:r>
-              <a:rPr sz="1500" b="1">
+              <a:rPr sz="1600" b="1">
                 <a:solidFill>
                   <a:srgbClr val="0B2C4A"/>
                 </a:solidFill>
                 <a:latin typeface="Calibri"/>
               </a:rPr>
-              <a:t>Dorsal recumbency</a:t>
+              <a:t>Name what you see</a:t>
             </a:r>
           </a:p>
         </p:txBody>
@@ -31062,8 +31105,8 @@
         </p:nvSpPr>
         <p:spPr>
           <a:xfrm>
-            <a:off x="667512" y="1536192"/>
-            <a:ext cx="5349240" cy="1801368"/>
+            <a:off x="8275320" y="1645920"/>
+            <a:ext cx="3429000" cy="4572000"/>
           </a:xfrm>
           <a:prstGeom prst="rect">
             <a:avLst/>
@@ -31076,482 +31119,28 @@
           <a:p>
             <a:pPr algn="l"/>
             <a:r>
-              <a:rPr sz="1300" b="0">
-                <a:solidFill>
-                  <a:srgbClr val="3D4A57"/>
-                </a:solidFill>
-                <a:latin typeface="Calibri"/>
-              </a:rPr>
-              <a:t>OHE, most celiotomies. Straight spine, hind limbs caudal not forced into a split that strains the hips of a dysplastic dog. V-trough or sandbags. Head/neck neutral for the airway.</a:t>
-            </a:r>
-          </a:p>
-        </p:txBody>
-      </p:sp>
-      <p:sp>
-        <p:nvSpPr>
-          <p:cNvPr id="12" name="Rounded Rectangle 11"/>
-          <p:cNvSpPr/>
-          <p:nvPr/>
-        </p:nvSpPr>
-        <p:spPr>
-          <a:xfrm>
-            <a:off x="6309360" y="1097280"/>
-            <a:ext cx="5715000" cy="2331720"/>
-          </a:xfrm>
-          <a:prstGeom prst="roundRect">
-            <a:avLst>
-              <a:gd name="adj" fmla="val 8000"/>
-            </a:avLst>
-          </a:prstGeom>
-          <a:solidFill>
-            <a:srgbClr val="FFFFFF"/>
-          </a:solidFill>
-          <a:ln>
-            <a:noFill/>
-          </a:ln>
-        </p:spPr>
-        <p:style>
-          <a:lnRef idx="1">
-            <a:schemeClr val="accent1"/>
-          </a:lnRef>
-          <a:fillRef idx="3">
-            <a:schemeClr val="accent1"/>
-          </a:fillRef>
-          <a:effectRef idx="2">
-            <a:schemeClr val="accent1"/>
-          </a:effectRef>
-          <a:fontRef idx="minor">
-            <a:schemeClr val="lt1"/>
-          </a:fontRef>
-        </p:style>
-        <p:txBody>
-          <a:bodyPr rtlCol="0" anchor="ctr"/>
-          <a:lstStyle/>
-          <a:p>
-            <a:pPr algn="ctr"/>
-          </a:p>
-        </p:txBody>
-      </p:sp>
-      <p:sp>
-        <p:nvSpPr>
-          <p:cNvPr id="13" name="Rectangle 12"/>
-          <p:cNvSpPr/>
-          <p:nvPr/>
-        </p:nvSpPr>
-        <p:spPr>
-          <a:xfrm>
-            <a:off x="6309360" y="1097280"/>
-            <a:ext cx="91440" cy="2331720"/>
-          </a:xfrm>
-          <a:prstGeom prst="rect">
-            <a:avLst/>
-          </a:prstGeom>
-          <a:solidFill>
-            <a:srgbClr val="0B2C4A"/>
-          </a:solidFill>
-          <a:ln>
-            <a:noFill/>
-          </a:ln>
-        </p:spPr>
-        <p:style>
-          <a:lnRef idx="1">
-            <a:schemeClr val="accent1"/>
-          </a:lnRef>
-          <a:fillRef idx="3">
-            <a:schemeClr val="accent1"/>
-          </a:fillRef>
-          <a:effectRef idx="2">
-            <a:schemeClr val="accent1"/>
-          </a:effectRef>
-          <a:fontRef idx="minor">
-            <a:schemeClr val="lt1"/>
-          </a:fontRef>
-        </p:style>
-        <p:txBody>
-          <a:bodyPr rtlCol="0" anchor="ctr"/>
-          <a:lstStyle/>
-          <a:p>
-            <a:pPr algn="ctr"/>
-          </a:p>
-        </p:txBody>
-      </p:sp>
-      <p:sp>
-        <p:nvSpPr>
-          <p:cNvPr id="14" name="TextBox 13"/>
-          <p:cNvSpPr txBox="1"/>
-          <p:nvPr/>
-        </p:nvSpPr>
-        <p:spPr>
-          <a:xfrm>
-            <a:off x="6565392" y="1207008"/>
-            <a:ext cx="5349240" cy="347472"/>
-          </a:xfrm>
-          <a:prstGeom prst="rect">
-            <a:avLst/>
-          </a:prstGeom>
-          <a:noFill/>
-        </p:spPr>
-        <p:txBody>
-          <a:bodyPr wrap="square" anchor="t"/>
-          <a:lstStyle/>
-          <a:p>
-            <a:pPr algn="l"/>
-            <a:r>
-              <a:rPr sz="1500" b="1">
-                <a:solidFill>
-                  <a:srgbClr val="0B2C4A"/>
-                </a:solidFill>
-                <a:latin typeface="Calibri"/>
-              </a:rPr>
-              <a:t>Lateral</a:t>
-            </a:r>
-          </a:p>
-        </p:txBody>
-      </p:sp>
-      <p:sp>
-        <p:nvSpPr>
-          <p:cNvPr id="15" name="TextBox 14"/>
-          <p:cNvSpPr txBox="1"/>
-          <p:nvPr/>
-        </p:nvSpPr>
-        <p:spPr>
-          <a:xfrm>
-            <a:off x="6565392" y="1536192"/>
-            <a:ext cx="5349240" cy="1801368"/>
-          </a:xfrm>
-          <a:prstGeom prst="rect">
-            <a:avLst/>
-          </a:prstGeom>
-          <a:noFill/>
-        </p:spPr>
-        <p:txBody>
-          <a:bodyPr wrap="square" anchor="t"/>
-          <a:lstStyle/>
-          <a:p>
-            <a:pPr algn="l"/>
-            <a:r>
-              <a:rPr sz="1300" b="0">
-                <a:solidFill>
-                  <a:srgbClr val="3D4A57"/>
-                </a:solidFill>
-                <a:latin typeface="Calibri"/>
-              </a:rPr>
-              <a:t>Thoracotomy, some mass removals, GDV sometimes after decompression. Down lung, down vessels, down muscles — pad the elbow, greater trochanter, acromion.</a:t>
-            </a:r>
-          </a:p>
-        </p:txBody>
-      </p:sp>
-      <p:sp>
-        <p:nvSpPr>
-          <p:cNvPr id="16" name="Rounded Rectangle 15"/>
-          <p:cNvSpPr/>
-          <p:nvPr/>
-        </p:nvSpPr>
-        <p:spPr>
-          <a:xfrm>
-            <a:off x="411480" y="3611880"/>
-            <a:ext cx="5715000" cy="2331720"/>
-          </a:xfrm>
-          <a:prstGeom prst="roundRect">
-            <a:avLst>
-              <a:gd name="adj" fmla="val 8000"/>
-            </a:avLst>
-          </a:prstGeom>
-          <a:solidFill>
-            <a:srgbClr val="FFFFFF"/>
-          </a:solidFill>
-          <a:ln>
-            <a:noFill/>
-          </a:ln>
-        </p:spPr>
-        <p:style>
-          <a:lnRef idx="1">
-            <a:schemeClr val="accent1"/>
-          </a:lnRef>
-          <a:fillRef idx="3">
-            <a:schemeClr val="accent1"/>
-          </a:fillRef>
-          <a:effectRef idx="2">
-            <a:schemeClr val="accent1"/>
-          </a:effectRef>
-          <a:fontRef idx="minor">
-            <a:schemeClr val="lt1"/>
-          </a:fontRef>
-        </p:style>
-        <p:txBody>
-          <a:bodyPr rtlCol="0" anchor="ctr"/>
-          <a:lstStyle/>
-          <a:p>
-            <a:pPr algn="ctr"/>
-          </a:p>
-        </p:txBody>
-      </p:sp>
-      <p:sp>
-        <p:nvSpPr>
-          <p:cNvPr id="17" name="Rectangle 16"/>
-          <p:cNvSpPr/>
-          <p:nvPr/>
-        </p:nvSpPr>
-        <p:spPr>
-          <a:xfrm>
-            <a:off x="411480" y="3611880"/>
-            <a:ext cx="91440" cy="2331720"/>
-          </a:xfrm>
-          <a:prstGeom prst="rect">
-            <a:avLst/>
-          </a:prstGeom>
-          <a:solidFill>
-            <a:srgbClr val="1B6B7A"/>
-          </a:solidFill>
-          <a:ln>
-            <a:noFill/>
-          </a:ln>
-        </p:spPr>
-        <p:style>
-          <a:lnRef idx="1">
-            <a:schemeClr val="accent1"/>
-          </a:lnRef>
-          <a:fillRef idx="3">
-            <a:schemeClr val="accent1"/>
-          </a:fillRef>
-          <a:effectRef idx="2">
-            <a:schemeClr val="accent1"/>
-          </a:effectRef>
-          <a:fontRef idx="minor">
-            <a:schemeClr val="lt1"/>
-          </a:fontRef>
-        </p:style>
-        <p:txBody>
-          <a:bodyPr rtlCol="0" anchor="ctr"/>
-          <a:lstStyle/>
-          <a:p>
-            <a:pPr algn="ctr"/>
-          </a:p>
-        </p:txBody>
-      </p:sp>
-      <p:sp>
-        <p:nvSpPr>
-          <p:cNvPr id="18" name="TextBox 17"/>
-          <p:cNvSpPr txBox="1"/>
-          <p:nvPr/>
-        </p:nvSpPr>
-        <p:spPr>
-          <a:xfrm>
-            <a:off x="667512" y="3721608"/>
-            <a:ext cx="5349240" cy="347472"/>
-          </a:xfrm>
-          <a:prstGeom prst="rect">
-            <a:avLst/>
-          </a:prstGeom>
-          <a:noFill/>
-        </p:spPr>
-        <p:txBody>
-          <a:bodyPr wrap="square" anchor="t"/>
-          <a:lstStyle/>
-          <a:p>
-            <a:pPr algn="l"/>
-            <a:r>
-              <a:rPr sz="1500" b="1">
-                <a:solidFill>
-                  <a:srgbClr val="0B2C4A"/>
-                </a:solidFill>
-                <a:latin typeface="Calibri"/>
-              </a:rPr>
-              <a:t>Sternal / perineal</a:t>
-            </a:r>
-          </a:p>
-        </p:txBody>
-      </p:sp>
-      <p:sp>
-        <p:nvSpPr>
-          <p:cNvPr id="19" name="TextBox 18"/>
-          <p:cNvSpPr txBox="1"/>
-          <p:nvPr/>
-        </p:nvSpPr>
-        <p:spPr>
-          <a:xfrm>
-            <a:off x="667512" y="4050792"/>
-            <a:ext cx="5349240" cy="1801368"/>
-          </a:xfrm>
-          <a:prstGeom prst="rect">
-            <a:avLst/>
-          </a:prstGeom>
-          <a:noFill/>
-        </p:spPr>
-        <p:txBody>
-          <a:bodyPr wrap="square" anchor="t"/>
-          <a:lstStyle/>
-          <a:p>
-            <a:pPr algn="l"/>
-            <a:r>
-              <a:rPr sz="1300" b="0">
-                <a:solidFill>
-                  <a:srgbClr val="3D4A57"/>
-                </a:solidFill>
-                <a:latin typeface="Calibri"/>
-              </a:rPr>
-              <a:t>Anal sac, some urinary, dorsal spinal. Do not over-flex the neck of brachycephalics. Purse-string the anus when indicated — and remove it at the end.</a:t>
-            </a:r>
-          </a:p>
-        </p:txBody>
-      </p:sp>
-      <p:sp>
-        <p:nvSpPr>
-          <p:cNvPr id="20" name="Rounded Rectangle 19"/>
-          <p:cNvSpPr/>
-          <p:nvPr/>
-        </p:nvSpPr>
-        <p:spPr>
-          <a:xfrm>
-            <a:off x="6309360" y="3611880"/>
-            <a:ext cx="5715000" cy="2331720"/>
-          </a:xfrm>
-          <a:prstGeom prst="roundRect">
-            <a:avLst>
-              <a:gd name="adj" fmla="val 8000"/>
-            </a:avLst>
-          </a:prstGeom>
-          <a:solidFill>
-            <a:srgbClr val="FFFFFF"/>
-          </a:solidFill>
-          <a:ln>
-            <a:noFill/>
-          </a:ln>
-        </p:spPr>
-        <p:style>
-          <a:lnRef idx="1">
-            <a:schemeClr val="accent1"/>
-          </a:lnRef>
-          <a:fillRef idx="3">
-            <a:schemeClr val="accent1"/>
-          </a:fillRef>
-          <a:effectRef idx="2">
-            <a:schemeClr val="accent1"/>
-          </a:effectRef>
-          <a:fontRef idx="minor">
-            <a:schemeClr val="lt1"/>
-          </a:fontRef>
-        </p:style>
-        <p:txBody>
-          <a:bodyPr rtlCol="0" anchor="ctr"/>
-          <a:lstStyle/>
-          <a:p>
-            <a:pPr algn="ctr"/>
-          </a:p>
-        </p:txBody>
-      </p:sp>
-      <p:sp>
-        <p:nvSpPr>
-          <p:cNvPr id="21" name="Rectangle 20"/>
-          <p:cNvSpPr/>
-          <p:nvPr/>
-        </p:nvSpPr>
-        <p:spPr>
-          <a:xfrm>
-            <a:off x="6309360" y="3611880"/>
-            <a:ext cx="91440" cy="2331720"/>
-          </a:xfrm>
-          <a:prstGeom prst="rect">
-            <a:avLst/>
-          </a:prstGeom>
-          <a:solidFill>
-            <a:srgbClr val="1B6B7A"/>
-          </a:solidFill>
-          <a:ln>
-            <a:noFill/>
-          </a:ln>
-        </p:spPr>
-        <p:style>
-          <a:lnRef idx="1">
-            <a:schemeClr val="accent1"/>
-          </a:lnRef>
-          <a:fillRef idx="3">
-            <a:schemeClr val="accent1"/>
-          </a:fillRef>
-          <a:effectRef idx="2">
-            <a:schemeClr val="accent1"/>
-          </a:effectRef>
-          <a:fontRef idx="minor">
-            <a:schemeClr val="lt1"/>
-          </a:fontRef>
-        </p:style>
-        <p:txBody>
-          <a:bodyPr rtlCol="0" anchor="ctr"/>
-          <a:lstStyle/>
-          <a:p>
-            <a:pPr algn="ctr"/>
-          </a:p>
-        </p:txBody>
-      </p:sp>
-      <p:sp>
-        <p:nvSpPr>
-          <p:cNvPr id="22" name="TextBox 21"/>
-          <p:cNvSpPr txBox="1"/>
-          <p:nvPr/>
-        </p:nvSpPr>
-        <p:spPr>
-          <a:xfrm>
-            <a:off x="6565392" y="3721608"/>
-            <a:ext cx="5349240" cy="347472"/>
-          </a:xfrm>
-          <a:prstGeom prst="rect">
-            <a:avLst/>
-          </a:prstGeom>
-          <a:noFill/>
-        </p:spPr>
-        <p:txBody>
-          <a:bodyPr wrap="square" anchor="t"/>
-          <a:lstStyle/>
-          <a:p>
-            <a:pPr algn="l"/>
-            <a:r>
-              <a:rPr sz="1500" b="1">
-                <a:solidFill>
-                  <a:srgbClr val="0B2C4A"/>
-                </a:solidFill>
-                <a:latin typeface="Calibri"/>
-              </a:rPr>
-              <a:t>Padding &amp; safety</a:t>
-            </a:r>
-          </a:p>
-        </p:txBody>
-      </p:sp>
-      <p:sp>
-        <p:nvSpPr>
-          <p:cNvPr id="23" name="TextBox 22"/>
-          <p:cNvSpPr txBox="1"/>
-          <p:nvPr/>
-        </p:nvSpPr>
-        <p:spPr>
-          <a:xfrm>
-            <a:off x="6565392" y="4050792"/>
-            <a:ext cx="5349240" cy="1801368"/>
-          </a:xfrm>
-          <a:prstGeom prst="rect">
-            <a:avLst/>
-          </a:prstGeom>
-          <a:noFill/>
-        </p:spPr>
-        <p:txBody>
-          <a:bodyPr wrap="square" anchor="t"/>
-          <a:lstStyle/>
-          <a:p>
-            <a:pPr algn="l"/>
-            <a:r>
-              <a:rPr sz="1300" b="0">
-                <a:solidFill>
-                  <a:srgbClr val="3D4A57"/>
-                </a:solidFill>
-                <a:latin typeface="Calibri"/>
-              </a:rPr>
-              <a:t>Hypothermia: warming devices that cannot burn. Eyes lubricated. Endotracheal tube not kinked. Electrosurgery pad contact. Ties not tourniquets.</a:t>
-            </a:r>
-          </a:p>
-        </p:txBody>
-      </p:sp>
-      <p:sp>
-        <p:nvSpPr>
-          <p:cNvPr id="24" name="Rectangle 23"/>
+              <a:rPr sz="1400" b="0">
+                <a:solidFill>
+                  <a:srgbClr val="1C1C1C"/>
+                </a:solidFill>
+                <a:latin typeface="Calibri"/>
+              </a:rPr>
+              <a:t>• ET tube + pulse ox
+• IV catheter + fluids
+• Anesthesia machine
+• V-trough / padding
+• Ties that are not tourniquets
+• Abdomen not yet clipped — that is next, after a surgical plane
+Do not over-split the hips.
+Eyes lubricated. Tube not kinked.
+Photo: Anja, CC BY-SA 4.0.</a:t>
+            </a:r>
+          </a:p>
+        </p:txBody>
+      </p:sp>
+      <p:sp>
+        <p:nvSpPr>
+          <p:cNvPr id="12" name="Rectangle 11"/>
           <p:cNvSpPr/>
           <p:nvPr/>
         </p:nvSpPr>
@@ -31594,7 +31183,7 @@
       </p:sp>
       <p:sp>
         <p:nvSpPr>
-          <p:cNvPr id="25" name="TextBox 24"/>
+          <p:cNvPr id="13" name="TextBox 12"/>
           <p:cNvSpPr txBox="1"/>
           <p:nvPr/>
         </p:nvSpPr>
@@ -31627,7 +31216,7 @@
       </p:sp>
       <p:sp>
         <p:nvSpPr>
-          <p:cNvPr id="26" name="TextBox 25"/>
+          <p:cNvPr id="14" name="TextBox 13"/>
           <p:cNvSpPr txBox="1"/>
           <p:nvPr/>
         </p:nvSpPr>
@@ -31833,7 +31422,7 @@
                 </a:solidFill>
                 <a:latin typeface="Calibri"/>
               </a:rPr>
-              <a:t>LEFT PICTURE IS WRONG  ·  RIGHT PICTURE IS THE FIELD YOU ACTUALLY WANT</a:t>
+              <a:t>REAL CLINIC PHOTOGRAPHS  ·  GOWN, GLOVE, BOX THE FIELD, THEN THE LARGE DRAPE</a:t>
             </a:r>
           </a:p>
         </p:txBody>
@@ -31909,7 +31498,7 @@
                 </a:solidFill>
                 <a:latin typeface="Calibri"/>
               </a:rPr>
-              <a:t>Four-quadrant draping — hair in the window fails the prep</a:t>
+              <a:t>Draping — hair at the edge fails the prep</a:t>
             </a:r>
           </a:p>
         </p:txBody>
@@ -31922,8 +31511,8 @@
         </p:nvSpPr>
         <p:spPr>
           <a:xfrm>
-            <a:off x="365760" y="1024128"/>
-            <a:ext cx="5669280" cy="384048"/>
+            <a:off x="365760" y="1005840"/>
+            <a:ext cx="5669280" cy="347472"/>
           </a:xfrm>
           <a:prstGeom prst="roundRect">
             <a:avLst>
@@ -31967,8 +31556,8 @@
         </p:nvSpPr>
         <p:spPr>
           <a:xfrm>
-            <a:off x="365760" y="1024128"/>
-            <a:ext cx="5669280" cy="384048"/>
+            <a:off x="365760" y="1005840"/>
+            <a:ext cx="5669280" cy="347472"/>
           </a:xfrm>
           <a:prstGeom prst="rect">
             <a:avLst/>
@@ -31981,20 +31570,20 @@
           <a:p>
             <a:pPr algn="ctr"/>
             <a:r>
-              <a:rPr sz="1400" b="1">
+              <a:rPr sz="1300" b="1">
                 <a:solidFill>
                   <a:srgbClr val="FFFFFF"/>
                 </a:solidFill>
                 <a:latin typeface="Calibri"/>
               </a:rPr>
-              <a:t>WRONG — hair in the field</a:t>
+              <a:t>Real OHE — hair still at the drape</a:t>
             </a:r>
           </a:p>
         </p:txBody>
       </p:sp>
       <p:pic>
         <p:nvPicPr>
-          <p:cNvPr id="10" name="Picture 9" descr="prep_four_quadrant_drape.png"/>
+          <p:cNvPr id="10" name="Picture 9" descr="cherry_point_spay.jpg"/>
           <p:cNvPicPr>
             <a:picLocks noChangeAspect="1"/>
           </p:cNvPicPr>
@@ -32008,7 +31597,7 @@
         </p:blipFill>
         <p:spPr>
           <a:xfrm>
-            <a:off x="365760" y="1444752"/>
+            <a:off x="365760" y="1371600"/>
             <a:ext cx="5669280" cy="3246120"/>
           </a:xfrm>
           <a:prstGeom prst="rect">
@@ -32024,8 +31613,8 @@
         </p:nvSpPr>
         <p:spPr>
           <a:xfrm>
-            <a:off x="6172200" y="1024128"/>
-            <a:ext cx="5669280" cy="384048"/>
+            <a:off x="6172200" y="1005840"/>
+            <a:ext cx="5669280" cy="347472"/>
           </a:xfrm>
           <a:prstGeom prst="roundRect">
             <a:avLst>
@@ -32069,8 +31658,8 @@
         </p:nvSpPr>
         <p:spPr>
           <a:xfrm>
-            <a:off x="6172200" y="1024128"/>
-            <a:ext cx="5669280" cy="384048"/>
+            <a:off x="6172200" y="1005840"/>
+            <a:ext cx="5669280" cy="347472"/>
           </a:xfrm>
           <a:prstGeom prst="rect">
             <a:avLst/>
@@ -32083,20 +31672,20 @@
           <a:p>
             <a:pPr algn="ctr"/>
             <a:r>
-              <a:rPr sz="1400" b="1">
+              <a:rPr sz="1300" b="1">
                 <a:solidFill>
                   <a:srgbClr val="FFFFFF"/>
                 </a:solidFill>
                 <a:latin typeface="Calibri"/>
               </a:rPr>
-              <a:t>CORRECT — clipped skin, hair covered</a:t>
+              <a:t>Real sterile field — gown, glove, drape</a:t>
             </a:r>
           </a:p>
         </p:txBody>
       </p:sp>
       <p:pic>
         <p:nvPicPr>
-          <p:cNvPr id="13" name="Picture 12" descr="prep_four_quadrant_drape_correct.png"/>
+          <p:cNvPr id="13" name="Picture 12" descr="hektor_drape.jpg"/>
           <p:cNvPicPr>
             <a:picLocks noChangeAspect="1"/>
           </p:cNvPicPr>
@@ -32110,7 +31699,7 @@
         </p:blipFill>
         <p:spPr>
           <a:xfrm>
-            <a:off x="6172200" y="1444752"/>
+            <a:off x="6172200" y="1371600"/>
             <a:ext cx="5669280" cy="3246120"/>
           </a:xfrm>
           <a:prstGeom prst="rect">
@@ -32126,8 +31715,8 @@
         </p:nvSpPr>
         <p:spPr>
           <a:xfrm>
-            <a:off x="365760" y="4828032"/>
-            <a:ext cx="11475720" cy="1645920"/>
+            <a:off x="365760" y="4736592"/>
+            <a:ext cx="11475720" cy="1737360"/>
           </a:xfrm>
           <a:prstGeom prst="roundRect">
             <a:avLst>
@@ -32171,8 +31760,8 @@
         </p:nvSpPr>
         <p:spPr>
           <a:xfrm>
-            <a:off x="548640" y="4956048"/>
-            <a:ext cx="11155680" cy="1371600"/>
+            <a:off x="548640" y="4864608"/>
+            <a:ext cx="11155680" cy="1463040"/>
           </a:xfrm>
           <a:prstGeom prst="rect">
             <a:avLst/>
@@ -32185,13 +31774,14 @@
           <a:p>
             <a:pPr algn="l"/>
             <a:r>
-              <a:rPr sz="1500" b="0">
+              <a:rPr sz="1400" b="0">
                 <a:solidFill>
                   <a:srgbClr val="1C1C1C"/>
                 </a:solidFill>
                 <a:latin typeface="Calibri"/>
               </a:rPr>
-              <a:t>Four towels box the field (near towel first). Hair must not show at any edge — re-clip or re-drape. Clamp without tenting skin. Large drape over towels; cuff your hands; never shake a drape over the field. Wet-through (strikethrough) is contaminated. Hands stay on the field; below table height is not sterile.</a:t>
+              <a:t>Four towels box the field (near towel first). Hair must not show at any edge — re-clip or re-drape. Large drape over towels; cuff your hands. Wet-through is contaminated. Hands stay on the field.
+Photos: Cpl. Samuel A. Nasso, U.S. Marine Corps, public domain (left); MSgt Carlotta Holley, U.S. Air Force, public domain (right).</a:t>
             </a:r>
           </a:p>
         </p:txBody>
@@ -32480,7 +32070,7 @@
                 </a:solidFill>
                 <a:latin typeface="Calibri"/>
               </a:rPr>
-              <a:t>YOU ARE A FOMITE UNTIL YOU ARE NOT  ·  MONITORING IS ON BEFORE THE FIRST DRUG</a:t>
+              <a:t>DIAGRAM FOR THE GLOVE  ·  PHOTOGRAPH FOR THE MACHINE</a:t>
             </a:r>
           </a:p>
         </p:txBody>
@@ -32556,7 +32146,7 @@
                 </a:solidFill>
                 <a:latin typeface="Calibri"/>
               </a:rPr>
-              <a:t>Closed gloving and the anesthesia workstation</a:t>
+              <a:t>Closed gloving and a real anesthesia workstation</a:t>
             </a:r>
           </a:p>
         </p:txBody>
@@ -32587,7 +32177,7 @@
       </p:pic>
       <p:pic>
         <p:nvPicPr>
-          <p:cNvPr id="9" name="Picture 8" descr="prep_gown_glove_anesthesia.png"/>
+          <p:cNvPr id="9" name="Picture 8" descr="hektor_or.jpg"/>
           <p:cNvPicPr>
             <a:picLocks noChangeAspect="1"/>
           </p:cNvPicPr>
@@ -32682,7 +32272,8 @@
                 </a:solidFill>
                 <a:latin typeface="Calibri"/>
               </a:rPr>
-              <a:t>Closed gloving: hands stay inside the gown cuffs while the glove is pulled on (use the inset, not a bare-hand pull). Open gloving is for replacing a contaminated glove. Cap, mask, short nails, no jewelry. Timed or brushless scrub, fingertips-up. Anesthesia: SpO2, capnograph, ECG, temperature, IV fluids, airway — on before induction. Willie needed this for an ear clean. MoMo never reached induction.</a:t>
+              <a:t>Left: closed-gloving technique diagram (hands stay inside the gown cuffs). Right: real K9 anesthesia — cap, mask, ECG/SpO2/ETCO2 monitors, circle system, IV fluids, airway. Monitoring is on before the first drug. Willie needed this for an ear clean. MoMo never reached induction.
+Photo: MSgt Carlotta Holley, U.S. Air Force, public domain.</a:t>
             </a:r>
           </a:p>
         </p:txBody>
@@ -36556,7 +36147,7 @@
                 </a:solidFill>
                 <a:latin typeface="Calibri"/>
               </a:rPr>
-              <a:t>AIRWAY, BREATHING, CIRCULATION, TEMPERATURE, PAIN — THEN THE KENNEL</a:t>
+              <a:t>REAL CLINIC PHOTOGRAPH  ·  E-COLLAR, IV, CLIPPED ABDOMEN, NOT LEFT ALONE</a:t>
             </a:r>
           </a:p>
         </p:txBody>
@@ -36639,7 +36230,7 @@
       </p:sp>
       <p:pic>
         <p:nvPicPr>
-          <p:cNvPr id="8" name="Picture 7" descr="postop_recovery_monitoring.png"/>
+          <p:cNvPr id="8" name="Picture 7" descr="remus_recovery.jpg"/>
           <p:cNvPicPr>
             <a:picLocks noChangeAspect="1"/>
           </p:cNvPicPr>
@@ -36748,7 +36339,7 @@
         <p:spPr>
           <a:xfrm>
             <a:off x="8001000" y="1600200"/>
-            <a:ext cx="3703320" cy="4617720"/>
+            <a:ext cx="3703320" cy="4023360"/>
           </a:xfrm>
           <a:prstGeom prst="rect">
             <a:avLst/>
@@ -36821,7 +36412,7 @@
                 </a:solidFill>
                 <a:latin typeface="Calibri"/>
               </a:rPr>
-              <a:t>▸  Score pain. Give the analgesic you planned. Willie: no NSAID after DexSP.</a:t>
+              <a:t>▸  E-collar on before they can lick.</a:t>
             </a:r>
           </a:p>
           <a:p>
@@ -36837,30 +36428,47 @@
                 </a:solidFill>
                 <a:latin typeface="Calibri"/>
               </a:rPr>
-              <a:t>▸  E-collar on before they can lick.</a:t>
-            </a:r>
-          </a:p>
-          <a:p>
-            <a:pPr algn="l">
-              <a:spcAft>
-                <a:spcPts val="600"/>
-              </a:spcAft>
-            </a:pPr>
-            <a:r>
-              <a:rPr sz="1300" b="0">
-                <a:solidFill>
-                  <a:srgbClr val="1C1C1C"/>
-                </a:solidFill>
-                <a:latin typeface="Calibri"/>
-              </a:rPr>
-              <a:t>▸  A ‘quiet’ animal may be cold, hypotensive, or painful.</a:t>
-            </a:r>
-          </a:p>
-        </p:txBody>
-      </p:sp>
-      <p:sp>
-        <p:nvSpPr>
-          <p:cNvPr id="12" name="Rectangle 11"/>
+              <a:t>▸  Willie: no NSAID after DexSP.</a:t>
+            </a:r>
+          </a:p>
+        </p:txBody>
+      </p:sp>
+      <p:sp>
+        <p:nvSpPr>
+          <p:cNvPr id="12" name="TextBox 11"/>
+          <p:cNvSpPr txBox="1"/>
+          <p:nvPr/>
+        </p:nvSpPr>
+        <p:spPr>
+          <a:xfrm>
+            <a:off x="8046720" y="5806440"/>
+            <a:ext cx="3657600" cy="502920"/>
+          </a:xfrm>
+          <a:prstGeom prst="rect">
+            <a:avLst/>
+          </a:prstGeom>
+          <a:noFill/>
+        </p:spPr>
+        <p:txBody>
+          <a:bodyPr wrap="square" anchor="t"/>
+          <a:lstStyle/>
+          <a:p>
+            <a:pPr algn="l"/>
+            <a:r>
+              <a:rPr sz="1100" b="0">
+                <a:solidFill>
+                  <a:srgbClr val="5B646E"/>
+                </a:solidFill>
+                <a:latin typeface="Calibri"/>
+              </a:rPr>
+              <a:t>Photo: Anja, CC BY-SA 4.0.</a:t>
+            </a:r>
+          </a:p>
+        </p:txBody>
+      </p:sp>
+      <p:sp>
+        <p:nvSpPr>
+          <p:cNvPr id="13" name="Rectangle 12"/>
           <p:cNvSpPr/>
           <p:nvPr/>
         </p:nvSpPr>
@@ -36903,7 +36511,7 @@
       </p:sp>
       <p:sp>
         <p:nvSpPr>
-          <p:cNvPr id="13" name="TextBox 12"/>
+          <p:cNvPr id="14" name="TextBox 13"/>
           <p:cNvSpPr txBox="1"/>
           <p:nvPr/>
         </p:nvSpPr>
@@ -36936,7 +36544,7 @@
       </p:sp>
       <p:sp>
         <p:nvSpPr>
-          <p:cNvPr id="14" name="TextBox 13"/>
+          <p:cNvPr id="15" name="TextBox 14"/>
           <p:cNvSpPr txBox="1"/>
           <p:nvPr/>
         </p:nvSpPr>
@@ -38258,7 +37866,7 @@
                 </a:solidFill>
                 <a:latin typeface="Calibri"/>
               </a:rPr>
-              <a:t>PROTECT THE APPOSITION YOU JUST CREATED</a:t>
+              <a:t>REAL 24-HOUR OHE PHOTOGRAPH  ·  PROTECT THE APPOSITION YOU JUST CREATED</a:t>
             </a:r>
           </a:p>
         </p:txBody>
@@ -38339,16 +37947,40 @@
           </a:p>
         </p:txBody>
       </p:sp>
-      <p:sp>
-        <p:nvSpPr>
-          <p:cNvPr id="8" name="Rounded Rectangle 7"/>
-          <p:cNvSpPr/>
-          <p:nvPr/>
-        </p:nvSpPr>
-        <p:spPr>
-          <a:xfrm>
-            <a:off x="411480" y="1097280"/>
-            <a:ext cx="3703320" cy="2331720"/>
+      <p:pic>
+        <p:nvPicPr>
+          <p:cNvPr id="8" name="Picture 7" descr="spay_incision.jpg"/>
+          <p:cNvPicPr>
+            <a:picLocks noChangeAspect="1"/>
+          </p:cNvPicPr>
+          <p:nvPr/>
+        </p:nvPicPr>
+        <p:blipFill>
+          <a:blip r:embed="rId2"/>
+          <a:stretch>
+            <a:fillRect/>
+          </a:stretch>
+        </p:blipFill>
+        <p:spPr>
+          <a:xfrm>
+            <a:off x="365760" y="1024128"/>
+            <a:ext cx="5852160" cy="5440680"/>
+          </a:xfrm>
+          <a:prstGeom prst="rect">
+            <a:avLst/>
+          </a:prstGeom>
+        </p:spPr>
+      </p:pic>
+      <p:sp>
+        <p:nvSpPr>
+          <p:cNvPr id="9" name="Rounded Rectangle 8"/>
+          <p:cNvSpPr/>
+          <p:nvPr/>
+        </p:nvSpPr>
+        <p:spPr>
+          <a:xfrm>
+            <a:off x="6355080" y="1024128"/>
+            <a:ext cx="5440680" cy="5440680"/>
           </a:xfrm>
           <a:prstGeom prst="roundRect">
             <a:avLst>
@@ -38386,57 +38018,14 @@
       </p:sp>
       <p:sp>
         <p:nvSpPr>
-          <p:cNvPr id="9" name="Rectangle 8"/>
-          <p:cNvSpPr/>
-          <p:nvPr/>
-        </p:nvSpPr>
-        <p:spPr>
-          <a:xfrm>
-            <a:off x="411480" y="1097280"/>
-            <a:ext cx="91440" cy="2331720"/>
-          </a:xfrm>
-          <a:prstGeom prst="rect">
-            <a:avLst/>
-          </a:prstGeom>
-          <a:solidFill>
-            <a:srgbClr val="2E6B4F"/>
-          </a:solidFill>
-          <a:ln>
-            <a:noFill/>
-          </a:ln>
-        </p:spPr>
-        <p:style>
-          <a:lnRef idx="1">
-            <a:schemeClr val="accent1"/>
-          </a:lnRef>
-          <a:fillRef idx="3">
-            <a:schemeClr val="accent1"/>
-          </a:fillRef>
-          <a:effectRef idx="2">
-            <a:schemeClr val="accent1"/>
-          </a:effectRef>
-          <a:fontRef idx="minor">
-            <a:schemeClr val="lt1"/>
-          </a:fontRef>
-        </p:style>
-        <p:txBody>
-          <a:bodyPr rtlCol="0" anchor="ctr"/>
-          <a:lstStyle/>
-          <a:p>
-            <a:pPr algn="ctr"/>
-          </a:p>
-        </p:txBody>
-      </p:sp>
-      <p:sp>
-        <p:nvSpPr>
           <p:cNvPr id="10" name="TextBox 9"/>
           <p:cNvSpPr txBox="1"/>
           <p:nvPr/>
         </p:nvSpPr>
         <p:spPr>
           <a:xfrm>
-            <a:off x="667512" y="1207008"/>
-            <a:ext cx="3337560" cy="347472"/>
+            <a:off x="6537960" y="1170432"/>
+            <a:ext cx="5074920" cy="365760"/>
           </a:xfrm>
           <a:prstGeom prst="rect">
             <a:avLst/>
@@ -38449,13 +38038,13 @@
           <a:p>
             <a:pPr algn="l"/>
             <a:r>
-              <a:rPr sz="1500" b="1">
+              <a:rPr sz="1600" b="1">
                 <a:solidFill>
                   <a:srgbClr val="0B2C4A"/>
                 </a:solidFill>
                 <a:latin typeface="Calibri"/>
               </a:rPr>
-              <a:t>Look</a:t>
+              <a:t>Protect it</a:t>
             </a:r>
           </a:p>
         </p:txBody>
@@ -38468,804 +38057,120 @@
         </p:nvSpPr>
         <p:spPr>
           <a:xfrm>
-            <a:off x="667512" y="1536192"/>
-            <a:ext cx="3337560" cy="1801368"/>
-          </a:xfrm>
-          <a:prstGeom prst="rect">
-            <a:avLst/>
-          </a:prstGeom>
-          <a:noFill/>
-        </p:spPr>
-        <p:txBody>
-          <a:bodyPr wrap="square" anchor="t"/>
-          <a:lstStyle/>
-          <a:p>
-            <a:pPr algn="l"/>
-            <a:r>
-              <a:rPr sz="1300" b="0">
-                <a:solidFill>
-                  <a:srgbClr val="3D4A57"/>
-                </a:solidFill>
-                <a:latin typeface="Calibri"/>
-              </a:rPr>
-              <a:t>Twice daily: swelling, discharge, gapping, smell, heat, bruise vs. hematoma. Photograph if the client is anxious.</a:t>
-            </a:r>
-          </a:p>
-        </p:txBody>
-      </p:sp>
-      <p:sp>
-        <p:nvSpPr>
-          <p:cNvPr id="12" name="Rounded Rectangle 11"/>
-          <p:cNvSpPr/>
-          <p:nvPr/>
-        </p:nvSpPr>
-        <p:spPr>
-          <a:xfrm>
-            <a:off x="4297680" y="1097280"/>
-            <a:ext cx="3703320" cy="2331720"/>
-          </a:xfrm>
-          <a:prstGeom prst="roundRect">
-            <a:avLst>
-              <a:gd name="adj" fmla="val 8000"/>
-            </a:avLst>
-          </a:prstGeom>
-          <a:solidFill>
-            <a:srgbClr val="FFFFFF"/>
-          </a:solidFill>
-          <a:ln>
-            <a:noFill/>
-          </a:ln>
-        </p:spPr>
-        <p:style>
-          <a:lnRef idx="1">
-            <a:schemeClr val="accent1"/>
-          </a:lnRef>
-          <a:fillRef idx="3">
-            <a:schemeClr val="accent1"/>
-          </a:fillRef>
-          <a:effectRef idx="2">
-            <a:schemeClr val="accent1"/>
-          </a:effectRef>
-          <a:fontRef idx="minor">
-            <a:schemeClr val="lt1"/>
-          </a:fontRef>
-        </p:style>
-        <p:txBody>
-          <a:bodyPr rtlCol="0" anchor="ctr"/>
-          <a:lstStyle/>
-          <a:p>
-            <a:pPr algn="ctr"/>
-          </a:p>
-        </p:txBody>
-      </p:sp>
-      <p:sp>
-        <p:nvSpPr>
-          <p:cNvPr id="13" name="Rectangle 12"/>
-          <p:cNvSpPr/>
-          <p:nvPr/>
-        </p:nvSpPr>
-        <p:spPr>
-          <a:xfrm>
-            <a:off x="4297680" y="1097280"/>
-            <a:ext cx="91440" cy="2331720"/>
-          </a:xfrm>
-          <a:prstGeom prst="rect">
-            <a:avLst/>
-          </a:prstGeom>
-          <a:solidFill>
-            <a:srgbClr val="2E6B4F"/>
-          </a:solidFill>
-          <a:ln>
-            <a:noFill/>
-          </a:ln>
-        </p:spPr>
-        <p:style>
-          <a:lnRef idx="1">
-            <a:schemeClr val="accent1"/>
-          </a:lnRef>
-          <a:fillRef idx="3">
-            <a:schemeClr val="accent1"/>
-          </a:fillRef>
-          <a:effectRef idx="2">
-            <a:schemeClr val="accent1"/>
-          </a:effectRef>
-          <a:fontRef idx="minor">
-            <a:schemeClr val="lt1"/>
-          </a:fontRef>
-        </p:style>
-        <p:txBody>
-          <a:bodyPr rtlCol="0" anchor="ctr"/>
-          <a:lstStyle/>
-          <a:p>
-            <a:pPr algn="ctr"/>
-          </a:p>
-        </p:txBody>
-      </p:sp>
-      <p:sp>
-        <p:nvSpPr>
-          <p:cNvPr id="14" name="TextBox 13"/>
-          <p:cNvSpPr txBox="1"/>
-          <p:nvPr/>
-        </p:nvSpPr>
-        <p:spPr>
-          <a:xfrm>
-            <a:off x="4553712" y="1207008"/>
-            <a:ext cx="3337560" cy="347472"/>
-          </a:xfrm>
-          <a:prstGeom prst="rect">
-            <a:avLst/>
-          </a:prstGeom>
-          <a:noFill/>
-        </p:spPr>
-        <p:txBody>
-          <a:bodyPr wrap="square" anchor="t"/>
-          <a:lstStyle/>
-          <a:p>
-            <a:pPr algn="l"/>
-            <a:r>
-              <a:rPr sz="1500" b="1">
-                <a:solidFill>
-                  <a:srgbClr val="0B2C4A"/>
-                </a:solidFill>
-                <a:latin typeface="Calibri"/>
-              </a:rPr>
-              <a:t>Lick</a:t>
-            </a:r>
-          </a:p>
-        </p:txBody>
-      </p:sp>
-      <p:sp>
-        <p:nvSpPr>
-          <p:cNvPr id="15" name="TextBox 14"/>
-          <p:cNvSpPr txBox="1"/>
-          <p:nvPr/>
-        </p:nvSpPr>
-        <p:spPr>
-          <a:xfrm>
-            <a:off x="4553712" y="1536192"/>
-            <a:ext cx="3337560" cy="1801368"/>
-          </a:xfrm>
-          <a:prstGeom prst="rect">
-            <a:avLst/>
-          </a:prstGeom>
-          <a:noFill/>
-        </p:spPr>
-        <p:txBody>
-          <a:bodyPr wrap="square" anchor="t"/>
-          <a:lstStyle/>
-          <a:p>
-            <a:pPr algn="l"/>
-            <a:r>
-              <a:rPr sz="1300" b="0">
-                <a:solidFill>
-                  <a:srgbClr val="3D4A57"/>
-                </a:solidFill>
-                <a:latin typeface="Calibri"/>
-              </a:rPr>
-              <a:t>E-collar, suit, or inflatable — whatever actually stays on. Licking is the leading cause of dehiscence in student surgeries.</a:t>
-            </a:r>
-          </a:p>
-        </p:txBody>
-      </p:sp>
-      <p:sp>
-        <p:nvSpPr>
-          <p:cNvPr id="16" name="Rounded Rectangle 15"/>
-          <p:cNvSpPr/>
-          <p:nvPr/>
-        </p:nvSpPr>
-        <p:spPr>
-          <a:xfrm>
-            <a:off x="8183880" y="1097280"/>
-            <a:ext cx="3703320" cy="2331720"/>
-          </a:xfrm>
-          <a:prstGeom prst="roundRect">
-            <a:avLst>
-              <a:gd name="adj" fmla="val 8000"/>
-            </a:avLst>
-          </a:prstGeom>
-          <a:solidFill>
-            <a:srgbClr val="FFFFFF"/>
-          </a:solidFill>
-          <a:ln>
-            <a:noFill/>
-          </a:ln>
-        </p:spPr>
-        <p:style>
-          <a:lnRef idx="1">
-            <a:schemeClr val="accent1"/>
-          </a:lnRef>
-          <a:fillRef idx="3">
-            <a:schemeClr val="accent1"/>
-          </a:fillRef>
-          <a:effectRef idx="2">
-            <a:schemeClr val="accent1"/>
-          </a:effectRef>
-          <a:fontRef idx="minor">
-            <a:schemeClr val="lt1"/>
-          </a:fontRef>
-        </p:style>
-        <p:txBody>
-          <a:bodyPr rtlCol="0" anchor="ctr"/>
-          <a:lstStyle/>
-          <a:p>
-            <a:pPr algn="ctr"/>
-          </a:p>
-        </p:txBody>
-      </p:sp>
-      <p:sp>
-        <p:nvSpPr>
-          <p:cNvPr id="17" name="Rectangle 16"/>
-          <p:cNvSpPr/>
-          <p:nvPr/>
-        </p:nvSpPr>
-        <p:spPr>
-          <a:xfrm>
-            <a:off x="8183880" y="1097280"/>
-            <a:ext cx="91440" cy="2331720"/>
-          </a:xfrm>
-          <a:prstGeom prst="rect">
-            <a:avLst/>
-          </a:prstGeom>
-          <a:solidFill>
-            <a:srgbClr val="2E6B4F"/>
-          </a:solidFill>
-          <a:ln>
-            <a:noFill/>
-          </a:ln>
-        </p:spPr>
-        <p:style>
-          <a:lnRef idx="1">
-            <a:schemeClr val="accent1"/>
-          </a:lnRef>
-          <a:fillRef idx="3">
-            <a:schemeClr val="accent1"/>
-          </a:fillRef>
-          <a:effectRef idx="2">
-            <a:schemeClr val="accent1"/>
-          </a:effectRef>
-          <a:fontRef idx="minor">
-            <a:schemeClr val="lt1"/>
-          </a:fontRef>
-        </p:style>
-        <p:txBody>
-          <a:bodyPr rtlCol="0" anchor="ctr"/>
-          <a:lstStyle/>
-          <a:p>
-            <a:pPr algn="ctr"/>
-          </a:p>
-        </p:txBody>
-      </p:sp>
-      <p:sp>
-        <p:nvSpPr>
-          <p:cNvPr id="18" name="TextBox 17"/>
-          <p:cNvSpPr txBox="1"/>
-          <p:nvPr/>
-        </p:nvSpPr>
-        <p:spPr>
-          <a:xfrm>
-            <a:off x="8439912" y="1207008"/>
-            <a:ext cx="3337560" cy="347472"/>
-          </a:xfrm>
-          <a:prstGeom prst="rect">
-            <a:avLst/>
-          </a:prstGeom>
-          <a:noFill/>
-        </p:spPr>
-        <p:txBody>
-          <a:bodyPr wrap="square" anchor="t"/>
-          <a:lstStyle/>
-          <a:p>
-            <a:pPr algn="l"/>
-            <a:r>
-              <a:rPr sz="1500" b="1">
-                <a:solidFill>
-                  <a:srgbClr val="0B2C4A"/>
-                </a:solidFill>
-                <a:latin typeface="Calibri"/>
-              </a:rPr>
-              <a:t>Motion</a:t>
-            </a:r>
-          </a:p>
-        </p:txBody>
-      </p:sp>
-      <p:sp>
-        <p:nvSpPr>
-          <p:cNvPr id="19" name="TextBox 18"/>
-          <p:cNvSpPr txBox="1"/>
-          <p:nvPr/>
-        </p:nvSpPr>
-        <p:spPr>
-          <a:xfrm>
-            <a:off x="8439912" y="1536192"/>
-            <a:ext cx="3337560" cy="1801368"/>
-          </a:xfrm>
-          <a:prstGeom prst="rect">
-            <a:avLst/>
-          </a:prstGeom>
-          <a:noFill/>
-        </p:spPr>
-        <p:txBody>
-          <a:bodyPr wrap="square" anchor="t"/>
-          <a:lstStyle/>
-          <a:p>
-            <a:pPr algn="l"/>
-            <a:r>
-              <a:rPr sz="1300" b="0">
-                <a:solidFill>
-                  <a:srgbClr val="3D4A57"/>
-                </a:solidFill>
-                <a:latin typeface="Calibri"/>
-              </a:rPr>
-              <a:t>Leash only. No running, jumping, wrestling, stairs unsupervised. Exercise restriction is a prescription, not a suggestion.</a:t>
-            </a:r>
-          </a:p>
-        </p:txBody>
-      </p:sp>
-      <p:sp>
-        <p:nvSpPr>
-          <p:cNvPr id="20" name="Rounded Rectangle 19"/>
-          <p:cNvSpPr/>
-          <p:nvPr/>
-        </p:nvSpPr>
-        <p:spPr>
-          <a:xfrm>
-            <a:off x="411480" y="3611880"/>
-            <a:ext cx="3703320" cy="2331720"/>
-          </a:xfrm>
-          <a:prstGeom prst="roundRect">
-            <a:avLst>
-              <a:gd name="adj" fmla="val 8000"/>
-            </a:avLst>
-          </a:prstGeom>
-          <a:solidFill>
-            <a:srgbClr val="FFFFFF"/>
-          </a:solidFill>
-          <a:ln>
-            <a:noFill/>
-          </a:ln>
-        </p:spPr>
-        <p:style>
-          <a:lnRef idx="1">
-            <a:schemeClr val="accent1"/>
-          </a:lnRef>
-          <a:fillRef idx="3">
-            <a:schemeClr val="accent1"/>
-          </a:fillRef>
-          <a:effectRef idx="2">
-            <a:schemeClr val="accent1"/>
-          </a:effectRef>
-          <a:fontRef idx="minor">
-            <a:schemeClr val="lt1"/>
-          </a:fontRef>
-        </p:style>
-        <p:txBody>
-          <a:bodyPr rtlCol="0" anchor="ctr"/>
-          <a:lstStyle/>
-          <a:p>
-            <a:pPr algn="ctr"/>
-          </a:p>
-        </p:txBody>
-      </p:sp>
-      <p:sp>
-        <p:nvSpPr>
-          <p:cNvPr id="21" name="Rectangle 20"/>
-          <p:cNvSpPr/>
-          <p:nvPr/>
-        </p:nvSpPr>
-        <p:spPr>
-          <a:xfrm>
-            <a:off x="411480" y="3611880"/>
-            <a:ext cx="91440" cy="2331720"/>
-          </a:xfrm>
-          <a:prstGeom prst="rect">
-            <a:avLst/>
-          </a:prstGeom>
-          <a:solidFill>
-            <a:srgbClr val="2E6B4F"/>
-          </a:solidFill>
-          <a:ln>
-            <a:noFill/>
-          </a:ln>
-        </p:spPr>
-        <p:style>
-          <a:lnRef idx="1">
-            <a:schemeClr val="accent1"/>
-          </a:lnRef>
-          <a:fillRef idx="3">
-            <a:schemeClr val="accent1"/>
-          </a:fillRef>
-          <a:effectRef idx="2">
-            <a:schemeClr val="accent1"/>
-          </a:effectRef>
-          <a:fontRef idx="minor">
-            <a:schemeClr val="lt1"/>
-          </a:fontRef>
-        </p:style>
-        <p:txBody>
-          <a:bodyPr rtlCol="0" anchor="ctr"/>
-          <a:lstStyle/>
-          <a:p>
-            <a:pPr algn="ctr"/>
-          </a:p>
-        </p:txBody>
-      </p:sp>
-      <p:sp>
-        <p:nvSpPr>
-          <p:cNvPr id="22" name="TextBox 21"/>
-          <p:cNvSpPr txBox="1"/>
-          <p:nvPr/>
-        </p:nvSpPr>
-        <p:spPr>
-          <a:xfrm>
-            <a:off x="667512" y="3721608"/>
-            <a:ext cx="3337560" cy="347472"/>
-          </a:xfrm>
-          <a:prstGeom prst="rect">
-            <a:avLst/>
-          </a:prstGeom>
-          <a:noFill/>
-        </p:spPr>
-        <p:txBody>
-          <a:bodyPr wrap="square" anchor="t"/>
-          <a:lstStyle/>
-          <a:p>
-            <a:pPr algn="l"/>
-            <a:r>
-              <a:rPr sz="1500" b="1">
-                <a:solidFill>
-                  <a:srgbClr val="0B2C4A"/>
-                </a:solidFill>
-                <a:latin typeface="Calibri"/>
-              </a:rPr>
-              <a:t>Clean</a:t>
-            </a:r>
-          </a:p>
-        </p:txBody>
-      </p:sp>
-      <p:sp>
-        <p:nvSpPr>
-          <p:cNvPr id="23" name="TextBox 22"/>
-          <p:cNvSpPr txBox="1"/>
-          <p:nvPr/>
-        </p:nvSpPr>
-        <p:spPr>
-          <a:xfrm>
-            <a:off x="667512" y="4050792"/>
-            <a:ext cx="3337560" cy="1801368"/>
-          </a:xfrm>
-          <a:prstGeom prst="rect">
-            <a:avLst/>
-          </a:prstGeom>
-          <a:noFill/>
-        </p:spPr>
-        <p:txBody>
-          <a:bodyPr wrap="square" anchor="t"/>
-          <a:lstStyle/>
-          <a:p>
-            <a:pPr algn="l"/>
-            <a:r>
-              <a:rPr sz="1300" b="0">
-                <a:solidFill>
-                  <a:srgbClr val="3D4A57"/>
-                </a:solidFill>
-                <a:latin typeface="Calibri"/>
-              </a:rPr>
-              <a:t>Usually no topical ointment unless directed. Do not scrub with CHG daily. Clean dirt with saline if needed.</a:t>
-            </a:r>
-          </a:p>
-        </p:txBody>
-      </p:sp>
-      <p:sp>
-        <p:nvSpPr>
-          <p:cNvPr id="24" name="Rounded Rectangle 23"/>
-          <p:cNvSpPr/>
-          <p:nvPr/>
-        </p:nvSpPr>
-        <p:spPr>
-          <a:xfrm>
-            <a:off x="4297680" y="3611880"/>
-            <a:ext cx="3703320" cy="2331720"/>
-          </a:xfrm>
-          <a:prstGeom prst="roundRect">
-            <a:avLst>
-              <a:gd name="adj" fmla="val 8000"/>
-            </a:avLst>
-          </a:prstGeom>
-          <a:solidFill>
-            <a:srgbClr val="FFFFFF"/>
-          </a:solidFill>
-          <a:ln>
-            <a:noFill/>
-          </a:ln>
-        </p:spPr>
-        <p:style>
-          <a:lnRef idx="1">
-            <a:schemeClr val="accent1"/>
-          </a:lnRef>
-          <a:fillRef idx="3">
-            <a:schemeClr val="accent1"/>
-          </a:fillRef>
-          <a:effectRef idx="2">
-            <a:schemeClr val="accent1"/>
-          </a:effectRef>
-          <a:fontRef idx="minor">
-            <a:schemeClr val="lt1"/>
-          </a:fontRef>
-        </p:style>
-        <p:txBody>
-          <a:bodyPr rtlCol="0" anchor="ctr"/>
-          <a:lstStyle/>
-          <a:p>
-            <a:pPr algn="ctr"/>
-          </a:p>
-        </p:txBody>
-      </p:sp>
-      <p:sp>
-        <p:nvSpPr>
-          <p:cNvPr id="25" name="Rectangle 24"/>
-          <p:cNvSpPr/>
-          <p:nvPr/>
-        </p:nvSpPr>
-        <p:spPr>
-          <a:xfrm>
-            <a:off x="4297680" y="3611880"/>
-            <a:ext cx="91440" cy="2331720"/>
-          </a:xfrm>
-          <a:prstGeom prst="rect">
-            <a:avLst/>
-          </a:prstGeom>
-          <a:solidFill>
-            <a:srgbClr val="2E6B4F"/>
-          </a:solidFill>
-          <a:ln>
-            <a:noFill/>
-          </a:ln>
-        </p:spPr>
-        <p:style>
-          <a:lnRef idx="1">
-            <a:schemeClr val="accent1"/>
-          </a:lnRef>
-          <a:fillRef idx="3">
-            <a:schemeClr val="accent1"/>
-          </a:fillRef>
-          <a:effectRef idx="2">
-            <a:schemeClr val="accent1"/>
-          </a:effectRef>
-          <a:fontRef idx="minor">
-            <a:schemeClr val="lt1"/>
-          </a:fontRef>
-        </p:style>
-        <p:txBody>
-          <a:bodyPr rtlCol="0" anchor="ctr"/>
-          <a:lstStyle/>
-          <a:p>
-            <a:pPr algn="ctr"/>
-          </a:p>
-        </p:txBody>
-      </p:sp>
-      <p:sp>
-        <p:nvSpPr>
-          <p:cNvPr id="26" name="TextBox 25"/>
-          <p:cNvSpPr txBox="1"/>
-          <p:nvPr/>
-        </p:nvSpPr>
-        <p:spPr>
-          <a:xfrm>
-            <a:off x="4553712" y="3721608"/>
-            <a:ext cx="3337560" cy="347472"/>
-          </a:xfrm>
-          <a:prstGeom prst="rect">
-            <a:avLst/>
-          </a:prstGeom>
-          <a:noFill/>
-        </p:spPr>
-        <p:txBody>
-          <a:bodyPr wrap="square" anchor="t"/>
-          <a:lstStyle/>
-          <a:p>
-            <a:pPr algn="l"/>
-            <a:r>
-              <a:rPr sz="1500" b="1">
-                <a:solidFill>
-                  <a:srgbClr val="0B2C4A"/>
-                </a:solidFill>
-                <a:latin typeface="Calibri"/>
-              </a:rPr>
-              <a:t>Drain</a:t>
-            </a:r>
-          </a:p>
-        </p:txBody>
-      </p:sp>
-      <p:sp>
-        <p:nvSpPr>
-          <p:cNvPr id="27" name="TextBox 26"/>
-          <p:cNvSpPr txBox="1"/>
-          <p:nvPr/>
-        </p:nvSpPr>
-        <p:spPr>
-          <a:xfrm>
-            <a:off x="4553712" y="4050792"/>
-            <a:ext cx="3337560" cy="1801368"/>
-          </a:xfrm>
-          <a:prstGeom prst="rect">
-            <a:avLst/>
-          </a:prstGeom>
-          <a:noFill/>
-        </p:spPr>
-        <p:txBody>
-          <a:bodyPr wrap="square" anchor="t"/>
-          <a:lstStyle/>
-          <a:p>
-            <a:pPr algn="l"/>
-            <a:r>
-              <a:rPr sz="1300" b="0">
-                <a:solidFill>
-                  <a:srgbClr val="3D4A57"/>
-                </a:solidFill>
-                <a:latin typeface="Calibri"/>
-              </a:rPr>
-              <a:t>If placed: record output, site, and when to pull. Never send a drain without a written plan.</a:t>
-            </a:r>
-          </a:p>
-        </p:txBody>
-      </p:sp>
-      <p:sp>
-        <p:nvSpPr>
-          <p:cNvPr id="28" name="Rounded Rectangle 27"/>
-          <p:cNvSpPr/>
-          <p:nvPr/>
-        </p:nvSpPr>
-        <p:spPr>
-          <a:xfrm>
-            <a:off x="8183880" y="3611880"/>
-            <a:ext cx="3703320" cy="2331720"/>
-          </a:xfrm>
-          <a:prstGeom prst="roundRect">
-            <a:avLst>
-              <a:gd name="adj" fmla="val 8000"/>
-            </a:avLst>
-          </a:prstGeom>
-          <a:solidFill>
-            <a:srgbClr val="FFFFFF"/>
-          </a:solidFill>
-          <a:ln>
-            <a:noFill/>
-          </a:ln>
-        </p:spPr>
-        <p:style>
-          <a:lnRef idx="1">
-            <a:schemeClr val="accent1"/>
-          </a:lnRef>
-          <a:fillRef idx="3">
-            <a:schemeClr val="accent1"/>
-          </a:fillRef>
-          <a:effectRef idx="2">
-            <a:schemeClr val="accent1"/>
-          </a:effectRef>
-          <a:fontRef idx="minor">
-            <a:schemeClr val="lt1"/>
-          </a:fontRef>
-        </p:style>
-        <p:txBody>
-          <a:bodyPr rtlCol="0" anchor="ctr"/>
-          <a:lstStyle/>
-          <a:p>
-            <a:pPr algn="ctr"/>
-          </a:p>
-        </p:txBody>
-      </p:sp>
-      <p:sp>
-        <p:nvSpPr>
-          <p:cNvPr id="29" name="Rectangle 28"/>
-          <p:cNvSpPr/>
-          <p:nvPr/>
-        </p:nvSpPr>
-        <p:spPr>
-          <a:xfrm>
-            <a:off x="8183880" y="3611880"/>
-            <a:ext cx="91440" cy="2331720"/>
-          </a:xfrm>
-          <a:prstGeom prst="rect">
-            <a:avLst/>
-          </a:prstGeom>
-          <a:solidFill>
-            <a:srgbClr val="2E6B4F"/>
-          </a:solidFill>
-          <a:ln>
-            <a:noFill/>
-          </a:ln>
-        </p:spPr>
-        <p:style>
-          <a:lnRef idx="1">
-            <a:schemeClr val="accent1"/>
-          </a:lnRef>
-          <a:fillRef idx="3">
-            <a:schemeClr val="accent1"/>
-          </a:fillRef>
-          <a:effectRef idx="2">
-            <a:schemeClr val="accent1"/>
-          </a:effectRef>
-          <a:fontRef idx="minor">
-            <a:schemeClr val="lt1"/>
-          </a:fontRef>
-        </p:style>
-        <p:txBody>
-          <a:bodyPr rtlCol="0" anchor="ctr"/>
-          <a:lstStyle/>
-          <a:p>
-            <a:pPr algn="ctr"/>
-          </a:p>
-        </p:txBody>
-      </p:sp>
-      <p:sp>
-        <p:nvSpPr>
-          <p:cNvPr id="30" name="TextBox 29"/>
-          <p:cNvSpPr txBox="1"/>
-          <p:nvPr/>
-        </p:nvSpPr>
-        <p:spPr>
-          <a:xfrm>
-            <a:off x="8439912" y="3721608"/>
-            <a:ext cx="3337560" cy="347472"/>
-          </a:xfrm>
-          <a:prstGeom prst="rect">
-            <a:avLst/>
-          </a:prstGeom>
-          <a:noFill/>
-        </p:spPr>
-        <p:txBody>
-          <a:bodyPr wrap="square" anchor="t"/>
-          <a:lstStyle/>
-          <a:p>
-            <a:pPr algn="l"/>
-            <a:r>
-              <a:rPr sz="1500" b="1">
-                <a:solidFill>
-                  <a:srgbClr val="0B2C4A"/>
-                </a:solidFill>
-                <a:latin typeface="Calibri"/>
-              </a:rPr>
-              <a:t>Suture/staple</a:t>
-            </a:r>
-          </a:p>
-        </p:txBody>
-      </p:sp>
-      <p:sp>
-        <p:nvSpPr>
-          <p:cNvPr id="31" name="TextBox 30"/>
-          <p:cNvSpPr txBox="1"/>
-          <p:nvPr/>
-        </p:nvSpPr>
-        <p:spPr>
-          <a:xfrm>
-            <a:off x="8439912" y="4050792"/>
-            <a:ext cx="3337560" cy="1801368"/>
-          </a:xfrm>
-          <a:prstGeom prst="rect">
-            <a:avLst/>
-          </a:prstGeom>
-          <a:noFill/>
-        </p:spPr>
-        <p:txBody>
-          <a:bodyPr wrap="square" anchor="t"/>
-          <a:lstStyle/>
-          <a:p>
-            <a:pPr algn="l"/>
-            <a:r>
-              <a:rPr sz="1300" b="0">
-                <a:solidFill>
-                  <a:srgbClr val="3D4A57"/>
-                </a:solidFill>
-                <a:latin typeface="Calibri"/>
-              </a:rPr>
-              <a:t>Typically 10–14 days for skin in small animals if healing is routine. Absorbable intradermal: still recheck.</a:t>
-            </a:r>
-          </a:p>
-        </p:txBody>
-      </p:sp>
-      <p:sp>
-        <p:nvSpPr>
-          <p:cNvPr id="32" name="Rectangle 31"/>
+            <a:off x="6492240" y="1600200"/>
+            <a:ext cx="5120640" cy="4297680"/>
+          </a:xfrm>
+          <a:prstGeom prst="rect">
+            <a:avLst/>
+          </a:prstGeom>
+          <a:noFill/>
+        </p:spPr>
+        <p:txBody>
+          <a:bodyPr wrap="square">
+            <a:spAutoFit/>
+          </a:bodyPr>
+          <a:lstStyle/>
+          <a:p>
+            <a:pPr algn="l">
+              <a:spcAft>
+                <a:spcPts val="700"/>
+              </a:spcAft>
+            </a:pPr>
+            <a:r>
+              <a:rPr sz="1400" b="0">
+                <a:solidFill>
+                  <a:srgbClr val="1C1C1C"/>
+                </a:solidFill>
+                <a:latin typeface="Calibri"/>
+              </a:rPr>
+              <a:t>▸  Look twice daily: swelling, discharge, gapping, smell, heat.</a:t>
+            </a:r>
+          </a:p>
+          <a:p>
+            <a:pPr algn="l">
+              <a:spcAft>
+                <a:spcPts val="700"/>
+              </a:spcAft>
+            </a:pPr>
+            <a:r>
+              <a:rPr sz="1400" b="0">
+                <a:solidFill>
+                  <a:srgbClr val="1C1C1C"/>
+                </a:solidFill>
+                <a:latin typeface="Calibri"/>
+              </a:rPr>
+              <a:t>▸  E-collar that actually stays on. Licking is the leading student dehiscence.</a:t>
+            </a:r>
+          </a:p>
+          <a:p>
+            <a:pPr algn="l">
+              <a:spcAft>
+                <a:spcPts val="700"/>
+              </a:spcAft>
+            </a:pPr>
+            <a:r>
+              <a:rPr sz="1400" b="0">
+                <a:solidFill>
+                  <a:srgbClr val="1C1C1C"/>
+                </a:solidFill>
+                <a:latin typeface="Calibri"/>
+              </a:rPr>
+              <a:t>▸  Leash only. No running, jumping, wrestling, unsupervised stairs.</a:t>
+            </a:r>
+          </a:p>
+          <a:p>
+            <a:pPr algn="l">
+              <a:spcAft>
+                <a:spcPts val="700"/>
+              </a:spcAft>
+            </a:pPr>
+            <a:r>
+              <a:rPr sz="1400" b="0">
+                <a:solidFill>
+                  <a:srgbClr val="1C1C1C"/>
+                </a:solidFill>
+                <a:latin typeface="Calibri"/>
+              </a:rPr>
+              <a:t>▸  Usually no daily CHG scrub. Saline if dirty.</a:t>
+            </a:r>
+          </a:p>
+          <a:p>
+            <a:pPr algn="l">
+              <a:spcAft>
+                <a:spcPts val="700"/>
+              </a:spcAft>
+            </a:pPr>
+            <a:r>
+              <a:rPr sz="1400" b="0">
+                <a:solidFill>
+                  <a:srgbClr val="1C1C1C"/>
+                </a:solidFill>
+                <a:latin typeface="Calibri"/>
+              </a:rPr>
+              <a:t>▸  Skin sutures typically 10–14 days if healing is routine.</a:t>
+            </a:r>
+          </a:p>
+          <a:p>
+            <a:pPr algn="l">
+              <a:spcAft>
+                <a:spcPts val="700"/>
+              </a:spcAft>
+            </a:pPr>
+            <a:r>
+              <a:rPr sz="1400" b="0">
+                <a:solidFill>
+                  <a:srgbClr val="1C1C1C"/>
+                </a:solidFill>
+                <a:latin typeface="Calibri"/>
+              </a:rPr>
+              <a:t>▸  Photo: Liannadavis, CC BY-SA 4.0.</a:t>
+            </a:r>
+          </a:p>
+        </p:txBody>
+      </p:sp>
+      <p:sp>
+        <p:nvSpPr>
+          <p:cNvPr id="12" name="Rectangle 11"/>
           <p:cNvSpPr/>
           <p:nvPr/>
         </p:nvSpPr>
@@ -39308,7 +38213,7 @@
       </p:sp>
       <p:sp>
         <p:nvSpPr>
-          <p:cNvPr id="33" name="TextBox 32"/>
+          <p:cNvPr id="13" name="TextBox 12"/>
           <p:cNvSpPr txBox="1"/>
           <p:nvPr/>
         </p:nvSpPr>
@@ -39341,7 +38246,7 @@
       </p:sp>
       <p:sp>
         <p:nvSpPr>
-          <p:cNvPr id="34" name="TextBox 33"/>
+          <p:cNvPr id="14" name="TextBox 13"/>
           <p:cNvSpPr txBox="1"/>
           <p:nvPr/>
         </p:nvSpPr>
@@ -50061,11 +48966,11 @@
           <a:p>
             <a:pPr algn="l">
               <a:spcAft>
-                <a:spcPts val="800"/>
+                <a:spcPts val="700"/>
               </a:spcAft>
             </a:pPr>
             <a:r>
-              <a:rPr sz="1500" b="0">
+              <a:rPr sz="1400" b="0">
                 <a:solidFill>
                   <a:srgbClr val="1C1C1C"/>
                 </a:solidFill>
@@ -50077,11 +48982,11 @@
           <a:p>
             <a:pPr algn="l">
               <a:spcAft>
-                <a:spcPts val="800"/>
+                <a:spcPts val="700"/>
               </a:spcAft>
             </a:pPr>
             <a:r>
-              <a:rPr sz="1500" b="0">
+              <a:rPr sz="1400" b="0">
                 <a:solidFill>
                   <a:srgbClr val="1C1C1C"/>
                 </a:solidFill>
@@ -50093,11 +48998,11 @@
           <a:p>
             <a:pPr algn="l">
               <a:spcAft>
-                <a:spcPts val="800"/>
+                <a:spcPts val="700"/>
               </a:spcAft>
             </a:pPr>
             <a:r>
-              <a:rPr sz="1500" b="0">
+              <a:rPr sz="1400" b="0">
                 <a:solidFill>
                   <a:srgbClr val="1C1C1C"/>
                 </a:solidFill>
@@ -50109,11 +49014,11 @@
           <a:p>
             <a:pPr algn="l">
               <a:spcAft>
-                <a:spcPts val="800"/>
+                <a:spcPts val="700"/>
               </a:spcAft>
             </a:pPr>
             <a:r>
-              <a:rPr sz="1500" b="0">
+              <a:rPr sz="1400" b="0">
                 <a:solidFill>
                   <a:srgbClr val="1C1C1C"/>
                 </a:solidFill>
@@ -50125,17 +49030,33 @@
           <a:p>
             <a:pPr algn="l">
               <a:spcAft>
-                <a:spcPts val="800"/>
+                <a:spcPts val="700"/>
               </a:spcAft>
             </a:pPr>
             <a:r>
-              <a:rPr sz="1500" b="0">
+              <a:rPr sz="1400" b="0">
                 <a:solidFill>
                   <a:srgbClr val="1C1C1C"/>
                 </a:solidFill>
                 <a:latin typeface="Calibri"/>
               </a:rPr>
               <a:t>▸  AAHA Anesthesia and Monitoring Guidelines (current edition) — fasting, PE, monitoring, recovery.</a:t>
+            </a:r>
+          </a:p>
+          <a:p>
+            <a:pPr algn="l">
+              <a:spcAft>
+                <a:spcPts val="700"/>
+              </a:spcAft>
+            </a:pPr>
+            <a:r>
+              <a:rPr sz="1400" b="0">
+                <a:solidFill>
+                  <a:srgbClr val="1C1C1C"/>
+                </a:solidFill>
+                <a:latin typeface="Calibri"/>
+              </a:rPr>
+              <a:t>▸  Clinical photographs (open license or U.S. government work): Uwe Gille (CC0); Anja (CC BY-SA 4.0); Liannadavis (CC BY-SA 4.0); Cpl. Samuel A. Nasso, USMC (public domain); MSgt Carlotta Holley, USAF (public domain). Closed-gloving and spiral-prep figures are technique diagrams, not clinic photographs.</a:t>
             </a:r>
           </a:p>
         </p:txBody>

</xml_diff>

<commit_message>
Replace client-handout iodine language with 1:20–1:50 PVP-I teaching.
DVM students mix 10% povidone-iodine themselves: mucosa, conjunctiva, and prepuce are 1 to 20 to 1 to 50 in sterile saline, not "dilute as directed." Fact-check the rest of the hour into professor voice.

Co-authored-by: drkimvet <drkimvet@users.noreply.github.com>
</commit_message>
<xml_diff>
--- a/lectures/DVM-612_Week4_Preop_PatientPrep_Postop.pptx
+++ b/lectures/DVM-612_Week4_Preop_PatientPrep_Postop.pptx
@@ -2310,7 +2310,7 @@
           <a:lstStyle/>
           <a:p>
             <a:r>
-              <a:t>Classic fail: clipping in the OR, or sterile prep in the prep room then dragging a wet dog across a dirty corridor without a clean transfer. Another fail: starting the clip before a surgical plane — patient wakes, contaminates, gets clipper lacerations.</a:t>
+              <a:t>Classic fail: clipping in the OR, or sterile prep in the prep room then dragging a wet dog across a dirty corridor without a clean transfer. Another fail: starting the clip before adequate anesthetic depth — the patient wakes, contaminates, and is lacerated. Step 5: they will mix 10% PVP-I 1 to 20 to 1 to 50 for mucosa and eye. That is not a client instruction; it is their job.</a:t>
             </a:r>
           </a:p>
         </p:txBody>
@@ -2520,7 +2520,7 @@
           <a:lstStyle/>
           <a:p>
             <a:r>
-              <a:t>CHG–alcohol is a common choice for trunk skin when not contraindicated. Willie’s left ear is exactly where CHG and aminoglycosides can harm a swollen drum and middle ear.</a:t>
+              <a:t>Stop and have them write the arithmetic. You are not teaching a client handout. Stock is 10% povidone-iodine solution. For mucosa, conjunctiva, and prepuce they dilute that solution — never the 7.5% detergent scrub — one part in twenty to one part in fifty with sterile saline. 1 mL + 19 mL = 1:20 = 0.5%. 1 mL + 49 mL = 1:50 = 0.2%, the classic canine ocular dilution (Roberts, AJVR 1986). Intact skin is labeled 10% solution or 7.5% scrub; do not invent a skin dilution. Chlorhexidine 2–4% with alcohol is the default for intact trunk skin and destroys cornea and middle ear. Willie has a swollen tympanum — that is not a chlorhexidine ear, and aminoglycoside ointment is not a casual choice if the middle ear is involved. Do not mix CHG and iodine. Do not call PVP-I sporicidal at surgical contact times. Organic matter inactivates iodine; dirty prep first, then sterile prep with contact time.</a:t>
             </a:r>
           </a:p>
         </p:txBody>
@@ -2590,7 +2590,7 @@
           <a:lstStyle/>
           <a:p>
             <a:r>
-              <a:t>Mime the spiral. No open-license spiral-prep photograph was available; this stays a diagram. Real clip, drape, anesthesia, and recovery photos are adjacent.</a:t>
+              <a:t>Mime the spiral. Have one student recite the iodine arithmetic before you leave this slide. No open-license spiral-prep photograph was available; this stays a diagram. Real clip, drape, anesthesia, and recovery photos are adjacent.</a:t>
             </a:r>
           </a:p>
         </p:txBody>
@@ -3080,7 +3080,7 @@
           <a:lstStyle/>
           <a:p>
             <a:r>
-              <a:t>C is the safety slide. D is the nuanced yes.</a:t>
+              <a:t>C is the safety slide. D is the arithmetic they must leave with. Hair at the drape edge is still a fail on the draping photographs — salvage with a sterile towel is not the standard; an adequate clip is.</a:t>
             </a:r>
           </a:p>
         </p:txBody>
@@ -3430,7 +3430,7 @@
           <a:lstStyle/>
           <a:p>
             <a:r>
-              <a:t>Real 24-hour OHE. Licking and basketball-with-the-dog are the two discharge failures. Be concrete: no off-leash for 14 days.</a:t>
+              <a:t>Real 24-hour OHE. Licking and unsupervised running are the two discharge failures I see after otherwise adequate closure. Be concrete: no off-leash activity for 14 days.</a:t>
             </a:r>
           </a:p>
         </p:txBody>
@@ -4340,7 +4340,7 @@
           <a:lstStyle/>
           <a:p>
             <a:r>
-              <a:t>Take questions. If none: Willie vs MoMo ASA and why only Willie was anesthetized. Dismiss on time.</a:t>
+              <a:t>Take questions. If none: Willie vs MoMo ASA, then the iodine arithmetic — 1 to 20 to 1 to 50. Dismiss on time.</a:t>
             </a:r>
           </a:p>
         </p:txBody>
@@ -4620,7 +4620,7 @@
           <a:lstStyle/>
           <a:p>
             <a:r>
-              <a:t>Spend 2 minutes. Highlight Doberman/vWD, brachycephalics, and last meal as exam favorites. Never premedicate before you have examined the patient.</a:t>
+              <a:t>Spend 2 minutes. Highlight Doberman/vWD, brachycephalics, and last meal. Never premedicate before you have examined the patient.</a:t>
             </a:r>
           </a:p>
         </p:txBody>
@@ -8392,7 +8392,7 @@
                 </a:solidFill>
                 <a:latin typeface="Calibri"/>
               </a:rPr>
-              <a:t>▸  Record it. If it is not written, the next person (and the exam) will assume you skipped it.</a:t>
+              <a:t>▸  Record it. If it is not written, the next clinician will assume you skipped it.</a:t>
             </a:r>
           </a:p>
         </p:txBody>
@@ -16342,7 +16342,7 @@
                 </a:solidFill>
                 <a:latin typeface="Calibri"/>
               </a:rPr>
-              <a:t>▸  Prepare the patient and surgeon for aseptic surgery (clip, antiseptic prep, four-quadrant drape, gown, closed glove).</a:t>
+              <a:t>▸  Prepare the patient and surgeon for aseptic surgery: clip, correct antiseptic concentrations (including povidone-iodine 1 to 20 to 1 to 50), four-quadrant drape, gown, closed glove.</a:t>
             </a:r>
           </a:p>
           <a:p>
@@ -16976,7 +16976,7 @@
 Glucose 130 — stress (Status 2 band).
 Kidneys, liver, electrolytes normal.
 No EPOC indicated for this ear clean.
-ASA Status 3-E anyway: acute vestibular disease, severe AS otitis, murmur. Do not down-stage him because the chemistry is pretty.</a:t>
+ASA Status 3-E anyway: acute vestibular disease, severe AS otitis, murmur. An unremarkable chemistry does not down-stage a neurologic patient.</a:t>
             </a:r>
           </a:p>
         </p:txBody>
@@ -18479,7 +18479,7 @@
                 </a:solidFill>
                 <a:latin typeface="Calibri"/>
               </a:rPr>
-              <a:t>▸  Traditional/Fossum-era: often 8–12 h NPO — still appears on some exams; be able to discuss aspiration vs. hypoglycemia.</a:t>
+              <a:t>▸  Traditional/Fossum-era: often 8–12 h NPO — still used in some hospitals; be able to discuss aspiration versus hypoglycemia.</a:t>
             </a:r>
           </a:p>
           <a:p>
@@ -19160,7 +19160,7 @@
                 </a:solidFill>
                 <a:latin typeface="Calibri"/>
               </a:rPr>
-              <a:t>▸  Material risks: anesthesia death (rare but real), hemorrhage, infection, dehiscence, incomplete excision, recurrence, incontinence (OHE myth vs. data — be honest).</a:t>
+              <a:t>▸  Material risks: anesthesia death (rare but real), hemorrhage, infection, dehiscence, incomplete excision, recurrence. Urinary incontinence after OHE is a real risk in some bitches, especially large-breed — quote it; do not omit it and do not inflate it.</a:t>
             </a:r>
           </a:p>
           <a:p>
@@ -25018,7 +25018,7 @@
                 </a:solidFill>
                 <a:latin typeface="Calibri"/>
               </a:rPr>
-              <a:t>Dirty prep then sterile prep. Contact time. Center → periphery. No pooling / wicking.</a:t>
+              <a:t>Dirty then sterile prep. Contact time. Intact skin: labeled CHG or 10% PVP-I. Mucosa/eye: 1 to 20 to 1 to 50.</a:t>
             </a:r>
           </a:p>
         </p:txBody>
@@ -26802,7 +26802,7 @@
                 </a:solidFill>
                 <a:latin typeface="Calibri"/>
               </a:rPr>
-              <a:t>Sterile prep (gloved), contact time honored</a:t>
+              <a:t>Sterile prep (gloved), contact time. Mucosa/eye: PVP-I 1 to 20 – 1 to 50</a:t>
             </a:r>
           </a:p>
         </p:txBody>
@@ -27911,7 +27911,7 @@
                 </a:solidFill>
                 <a:latin typeface="Calibri"/>
               </a:rPr>
-              <a:t>Xiphoid (or slightly cranial) to pubis, widely lateral past the nipples — a rectangle, not a bikini strip. Clip with the grain, then against, to the skin. Vacuum. ~20 cm beyond the planned incision. Do not clip the night before. Razor = micro-nicks = higher SSI. Airway in and depth adequate BEFORE the clippers start.
+              <a:t>Xiphoid, or slightly cranial to it, to the pubis, and widely lateral past the nipples — a rectangle, not a narrow strip of hair. Clip with the grain, then against, to the skin. Vacuum. Approximately 20 cm beyond the planned incision. Do not clip the night before. Razors create micro-nicks and raise SSI risk. Airway in and a surgical plane before the clippers start.
 Photos: Uwe Gille, CC0 (cat clip); Liannadavis, CC BY-SA 4.0 (OHE incision).</a:t>
             </a:r>
           </a:p>
@@ -29490,7 +29490,7 @@
                 </a:solidFill>
                 <a:latin typeface="Calibri"/>
               </a:rPr>
-              <a:t>NO SINGLE AGENT IS PERFECT; TECHNIQUE AND CONTACT TIME BEAT BRAND</a:t>
+              <a:t>THIS IS DVM 612, NOT A CLIENT HANDOUT. YOU ARE THE VETERINARIAN AT THE TABLE.</a:t>
             </a:r>
           </a:p>
         </p:txBody>
@@ -29566,7 +29566,7 @@
                 </a:solidFill>
                 <a:latin typeface="Calibri"/>
               </a:rPr>
-              <a:t>Skin antiseptics — choose with anatomy, not loyalty</a:t>
+              <a:t>Skin antiseptics — you mix the iodine. Memorize the ratio.</a:t>
             </a:r>
           </a:p>
         </p:txBody>
@@ -29579,8 +29579,8 @@
         </p:nvSpPr>
         <p:spPr>
           <a:xfrm>
-            <a:off x="411480" y="1097280"/>
-            <a:ext cx="3703320" cy="5029200"/>
+            <a:off x="365760" y="987552"/>
+            <a:ext cx="11448288" cy="1298448"/>
           </a:xfrm>
           <a:prstGeom prst="roundRect">
             <a:avLst>
@@ -29588,74 +29588,64 @@
             </a:avLst>
           </a:prstGeom>
           <a:solidFill>
-            <a:srgbClr val="FFFFFF"/>
-          </a:solidFill>
-          <a:ln>
-            <a:noFill/>
-          </a:ln>
-        </p:spPr>
-        <p:style>
-          <a:lnRef idx="1">
-            <a:schemeClr val="accent1"/>
-          </a:lnRef>
-          <a:fillRef idx="3">
-            <a:schemeClr val="accent1"/>
-          </a:fillRef>
-          <a:effectRef idx="2">
-            <a:schemeClr val="accent1"/>
-          </a:effectRef>
-          <a:fontRef idx="minor">
-            <a:schemeClr val="lt1"/>
-          </a:fontRef>
-        </p:style>
-        <p:txBody>
-          <a:bodyPr rtlCol="0" anchor="ctr"/>
-          <a:lstStyle/>
-          <a:p>
-            <a:pPr algn="ctr"/>
-          </a:p>
-        </p:txBody>
-      </p:sp>
-      <p:sp>
-        <p:nvSpPr>
-          <p:cNvPr id="9" name="Rectangle 8"/>
-          <p:cNvSpPr/>
-          <p:nvPr/>
-        </p:nvSpPr>
-        <p:spPr>
-          <a:xfrm>
-            <a:off x="411480" y="1097280"/>
-            <a:ext cx="3703320" cy="640080"/>
-          </a:xfrm>
-          <a:prstGeom prst="rect">
-            <a:avLst/>
-          </a:prstGeom>
-          <a:solidFill>
-            <a:srgbClr val="1B6B7A"/>
-          </a:solidFill>
-          <a:ln>
-            <a:noFill/>
-          </a:ln>
-        </p:spPr>
-        <p:style>
-          <a:lnRef idx="1">
-            <a:schemeClr val="accent1"/>
-          </a:lnRef>
-          <a:fillRef idx="3">
-            <a:schemeClr val="accent1"/>
-          </a:fillRef>
-          <a:effectRef idx="2">
-            <a:schemeClr val="accent1"/>
-          </a:effectRef>
-          <a:fontRef idx="minor">
-            <a:schemeClr val="lt1"/>
-          </a:fontRef>
-        </p:style>
-        <p:txBody>
-          <a:bodyPr rtlCol="0" anchor="ctr"/>
-          <a:lstStyle/>
-          <a:p>
-            <a:pPr algn="ctr"/>
+            <a:srgbClr val="F4EBD3"/>
+          </a:solidFill>
+          <a:ln>
+            <a:noFill/>
+          </a:ln>
+        </p:spPr>
+        <p:style>
+          <a:lnRef idx="1">
+            <a:schemeClr val="accent1"/>
+          </a:lnRef>
+          <a:fillRef idx="3">
+            <a:schemeClr val="accent1"/>
+          </a:fillRef>
+          <a:effectRef idx="2">
+            <a:schemeClr val="accent1"/>
+          </a:effectRef>
+          <a:fontRef idx="minor">
+            <a:schemeClr val="lt1"/>
+          </a:fontRef>
+        </p:style>
+        <p:txBody>
+          <a:bodyPr rtlCol="0" anchor="ctr"/>
+          <a:lstStyle/>
+          <a:p>
+            <a:pPr algn="ctr"/>
+          </a:p>
+        </p:txBody>
+      </p:sp>
+      <p:sp>
+        <p:nvSpPr>
+          <p:cNvPr id="9" name="TextBox 8"/>
+          <p:cNvSpPr txBox="1"/>
+          <p:nvPr/>
+        </p:nvSpPr>
+        <p:spPr>
+          <a:xfrm>
+            <a:off x="502920" y="1024128"/>
+            <a:ext cx="11155680" cy="384048"/>
+          </a:xfrm>
+          <a:prstGeom prst="rect">
+            <a:avLst/>
+          </a:prstGeom>
+          <a:noFill/>
+        </p:spPr>
+        <p:txBody>
+          <a:bodyPr wrap="square" anchor="ctr"/>
+          <a:lstStyle/>
+          <a:p>
+            <a:pPr algn="ctr"/>
+            <a:r>
+              <a:rPr sz="1600" b="1">
+                <a:solidFill>
+                  <a:srgbClr val="0B2C4A"/>
+                </a:solidFill>
+                <a:latin typeface="Calibri"/>
+              </a:rPr>
+              <a:t>10% povidone-iodine SOLUTION  ·  mucosa, conjunctiva, prepuce  ·  dilute  1 to 20  through  1 to 50  in sterile saline</a:t>
+            </a:r>
           </a:p>
         </p:txBody>
       </p:sp>
@@ -29667,41 +29657,8 @@
         </p:nvSpPr>
         <p:spPr>
           <a:xfrm>
-            <a:off x="411480" y="1097280"/>
-            <a:ext cx="3703320" cy="640080"/>
-          </a:xfrm>
-          <a:prstGeom prst="rect">
-            <a:avLst/>
-          </a:prstGeom>
-          <a:noFill/>
-        </p:spPr>
-        <p:txBody>
-          <a:bodyPr wrap="square" anchor="ctr"/>
-          <a:lstStyle/>
-          <a:p>
-            <a:pPr algn="ctr"/>
-            <a:r>
-              <a:rPr sz="1800" b="1">
-                <a:solidFill>
-                  <a:srgbClr val="FFFFFF"/>
-                </a:solidFill>
-                <a:latin typeface="Calibri"/>
-              </a:rPr>
-              <a:t>Chlorhexidine</a:t>
-            </a:r>
-          </a:p>
-        </p:txBody>
-      </p:sp>
-      <p:sp>
-        <p:nvSpPr>
-          <p:cNvPr id="11" name="TextBox 10"/>
-          <p:cNvSpPr txBox="1"/>
-          <p:nvPr/>
-        </p:nvSpPr>
-        <p:spPr>
-          <a:xfrm>
-            <a:off x="640080" y="1874519"/>
-            <a:ext cx="3291840" cy="4023360"/>
+            <a:off x="502920" y="1389888"/>
+            <a:ext cx="11155680" cy="804672"/>
           </a:xfrm>
           <a:prstGeom prst="rect">
             <a:avLst/>
@@ -29712,7 +29669,7 @@
           <a:bodyPr wrap="square" anchor="t"/>
           <a:lstStyle/>
           <a:p>
-            <a:pPr algn="l"/>
+            <a:pPr algn="ctr"/>
             <a:r>
               <a:rPr sz="1400" b="0">
                 <a:solidFill>
@@ -29720,25 +29677,22 @@
                 </a:solidFill>
                 <a:latin typeface="Calibri"/>
               </a:rPr>
-              <a:t>Broad Gram+ / Gram−, residual 24 h on skin.
-Best with alcohol (CHG–alcohol).
-Inactivated by organic debris if too dilute.
-TOXIC to cornea. Ototoxic in the middle ear. Not for peritoneum, bladder, joints, meninges.
-Do not store homemade dilute jugs.</a:t>
-            </a:r>
-          </a:p>
-        </p:txBody>
-      </p:sp>
-      <p:sp>
-        <p:nvSpPr>
-          <p:cNvPr id="12" name="Rounded Rectangle 11"/>
-          <p:cNvSpPr/>
-          <p:nvPr/>
-        </p:nvSpPr>
-        <p:spPr>
-          <a:xfrm>
-            <a:off x="4251960" y="1097280"/>
-            <a:ext cx="3703320" cy="5029200"/>
+              <a:t>1 mL stock + 19 mL saline = 1:20 = 0.5% PVP-I        ·        1 mL stock + 49 mL saline = 1:50 = 0.2% PVP-I
+1:50 is the evidence-based canine ocular dilution. Do not use 1:2 (5%) on cornea. Never put the 7.5% detergent scrub in an eye.</a:t>
+            </a:r>
+          </a:p>
+        </p:txBody>
+      </p:sp>
+      <p:sp>
+        <p:nvSpPr>
+          <p:cNvPr id="11" name="Rounded Rectangle 10"/>
+          <p:cNvSpPr/>
+          <p:nvPr/>
+        </p:nvSpPr>
+        <p:spPr>
+          <a:xfrm>
+            <a:off x="365760" y="2395728"/>
+            <a:ext cx="3749039" cy="4041648"/>
           </a:xfrm>
           <a:prstGeom prst="roundRect">
             <a:avLst>
@@ -29776,44 +29730,77 @@
       </p:sp>
       <p:sp>
         <p:nvSpPr>
-          <p:cNvPr id="13" name="Rectangle 12"/>
-          <p:cNvSpPr/>
-          <p:nvPr/>
-        </p:nvSpPr>
-        <p:spPr>
-          <a:xfrm>
-            <a:off x="4251960" y="1097280"/>
-            <a:ext cx="3703320" cy="640080"/>
-          </a:xfrm>
-          <a:prstGeom prst="rect">
-            <a:avLst/>
-          </a:prstGeom>
-          <a:solidFill>
-            <a:srgbClr val="C5A35A"/>
-          </a:solidFill>
-          <a:ln>
-            <a:noFill/>
-          </a:ln>
-        </p:spPr>
-        <p:style>
-          <a:lnRef idx="1">
-            <a:schemeClr val="accent1"/>
-          </a:lnRef>
-          <a:fillRef idx="3">
-            <a:schemeClr val="accent1"/>
-          </a:fillRef>
-          <a:effectRef idx="2">
-            <a:schemeClr val="accent1"/>
-          </a:effectRef>
-          <a:fontRef idx="minor">
-            <a:schemeClr val="lt1"/>
-          </a:fontRef>
-        </p:style>
-        <p:txBody>
-          <a:bodyPr rtlCol="0" anchor="ctr"/>
-          <a:lstStyle/>
-          <a:p>
-            <a:pPr algn="ctr"/>
+          <p:cNvPr id="12" name="Rectangle 11"/>
+          <p:cNvSpPr/>
+          <p:nvPr/>
+        </p:nvSpPr>
+        <p:spPr>
+          <a:xfrm>
+            <a:off x="365760" y="2395728"/>
+            <a:ext cx="3749039" cy="457200"/>
+          </a:xfrm>
+          <a:prstGeom prst="rect">
+            <a:avLst/>
+          </a:prstGeom>
+          <a:solidFill>
+            <a:srgbClr val="1B6B7A"/>
+          </a:solidFill>
+          <a:ln>
+            <a:noFill/>
+          </a:ln>
+        </p:spPr>
+        <p:style>
+          <a:lnRef idx="1">
+            <a:schemeClr val="accent1"/>
+          </a:lnRef>
+          <a:fillRef idx="3">
+            <a:schemeClr val="accent1"/>
+          </a:fillRef>
+          <a:effectRef idx="2">
+            <a:schemeClr val="accent1"/>
+          </a:effectRef>
+          <a:fontRef idx="minor">
+            <a:schemeClr val="lt1"/>
+          </a:fontRef>
+        </p:style>
+        <p:txBody>
+          <a:bodyPr rtlCol="0" anchor="ctr"/>
+          <a:lstStyle/>
+          <a:p>
+            <a:pPr algn="ctr"/>
+          </a:p>
+        </p:txBody>
+      </p:sp>
+      <p:sp>
+        <p:nvSpPr>
+          <p:cNvPr id="13" name="TextBox 12"/>
+          <p:cNvSpPr txBox="1"/>
+          <p:nvPr/>
+        </p:nvSpPr>
+        <p:spPr>
+          <a:xfrm>
+            <a:off x="365760" y="2395728"/>
+            <a:ext cx="3749039" cy="457200"/>
+          </a:xfrm>
+          <a:prstGeom prst="rect">
+            <a:avLst/>
+          </a:prstGeom>
+          <a:noFill/>
+        </p:spPr>
+        <p:txBody>
+          <a:bodyPr wrap="square" anchor="ctr"/>
+          <a:lstStyle/>
+          <a:p>
+            <a:pPr algn="ctr"/>
+            <a:r>
+              <a:rPr sz="1600" b="1">
+                <a:solidFill>
+                  <a:srgbClr val="FFFFFF"/>
+                </a:solidFill>
+                <a:latin typeface="Calibri"/>
+              </a:rPr>
+              <a:t>Chlorhexidine</a:t>
+            </a:r>
           </a:p>
         </p:txBody>
       </p:sp>
@@ -29825,41 +29812,8 @@
         </p:nvSpPr>
         <p:spPr>
           <a:xfrm>
-            <a:off x="4251960" y="1097280"/>
-            <a:ext cx="3703320" cy="640080"/>
-          </a:xfrm>
-          <a:prstGeom prst="rect">
-            <a:avLst/>
-          </a:prstGeom>
-          <a:noFill/>
-        </p:spPr>
-        <p:txBody>
-          <a:bodyPr wrap="square" anchor="ctr"/>
-          <a:lstStyle/>
-          <a:p>
-            <a:pPr algn="ctr"/>
-            <a:r>
-              <a:rPr sz="1800" b="1">
-                <a:solidFill>
-                  <a:srgbClr val="0B2C4A"/>
-                </a:solidFill>
-                <a:latin typeface="Calibri"/>
-              </a:rPr>
-              <a:t>Povidone-iodine</a:t>
-            </a:r>
-          </a:p>
-        </p:txBody>
-      </p:sp>
-      <p:sp>
-        <p:nvSpPr>
-          <p:cNvPr id="15" name="TextBox 14"/>
-          <p:cNvSpPr txBox="1"/>
-          <p:nvPr/>
-        </p:nvSpPr>
-        <p:spPr>
-          <a:xfrm>
-            <a:off x="4480560" y="1874519"/>
-            <a:ext cx="3291840" cy="4023360"/>
+            <a:off x="502920" y="2944368"/>
+            <a:ext cx="3474720" cy="3337560"/>
           </a:xfrm>
           <a:prstGeom prst="rect">
             <a:avLst/>
@@ -29872,31 +29826,31 @@
           <a:p>
             <a:pPr algn="l"/>
             <a:r>
-              <a:rPr sz="1400" b="0">
+              <a:rPr sz="1300" b="0">
                 <a:solidFill>
                   <a:srgbClr val="1C1C1C"/>
                 </a:solidFill>
                 <a:latin typeface="Calibri"/>
               </a:rPr>
-              <a:t>Broad spectrum including spores at right conc./time.
-Better near mucous membranes / some ocular protocols (dilute, veterinarian-directed).
-Inactivated by organic matter and alcohol in some sequences.
-Skin/thyroid/iodine sensitivity. Stains.
-Must dry / contact time to work.</a:t>
-            </a:r>
-          </a:p>
-        </p:txBody>
-      </p:sp>
-      <p:sp>
-        <p:nvSpPr>
-          <p:cNvPr id="16" name="Rounded Rectangle 15"/>
-          <p:cNvSpPr/>
-          <p:nvPr/>
-        </p:nvSpPr>
-        <p:spPr>
-          <a:xfrm>
-            <a:off x="8092440" y="1097280"/>
-            <a:ext cx="3657600" cy="5029200"/>
+              <a:t>Default for intact haired skin: 2–4% CHG, usually with 70% alcohol. Hours of residual activity.
+Rinse gross debris first. Anionic soaps reduce activity.
+Destroys cornea. Ototoxic in the middle ear. Not for meninges, synovium, or open viscera.
+Do not mix with povidone-iodine on the same field.
+Do not store homemade dilute jugs (outbreak risk).</a:t>
+            </a:r>
+          </a:p>
+        </p:txBody>
+      </p:sp>
+      <p:sp>
+        <p:nvSpPr>
+          <p:cNvPr id="15" name="Rounded Rectangle 14"/>
+          <p:cNvSpPr/>
+          <p:nvPr/>
+        </p:nvSpPr>
+        <p:spPr>
+          <a:xfrm>
+            <a:off x="4224528" y="2395728"/>
+            <a:ext cx="3749039" cy="4041648"/>
           </a:xfrm>
           <a:prstGeom prst="roundRect">
             <a:avLst>
@@ -29934,14 +29888,172 @@
       </p:sp>
       <p:sp>
         <p:nvSpPr>
-          <p:cNvPr id="17" name="Rectangle 16"/>
-          <p:cNvSpPr/>
-          <p:nvPr/>
-        </p:nvSpPr>
-        <p:spPr>
-          <a:xfrm>
-            <a:off x="8092440" y="1097280"/>
-            <a:ext cx="3657600" cy="640080"/>
+          <p:cNvPr id="16" name="Rectangle 15"/>
+          <p:cNvSpPr/>
+          <p:nvPr/>
+        </p:nvSpPr>
+        <p:spPr>
+          <a:xfrm>
+            <a:off x="4224528" y="2395728"/>
+            <a:ext cx="3749039" cy="457200"/>
+          </a:xfrm>
+          <a:prstGeom prst="rect">
+            <a:avLst/>
+          </a:prstGeom>
+          <a:solidFill>
+            <a:srgbClr val="C5A35A"/>
+          </a:solidFill>
+          <a:ln>
+            <a:noFill/>
+          </a:ln>
+        </p:spPr>
+        <p:style>
+          <a:lnRef idx="1">
+            <a:schemeClr val="accent1"/>
+          </a:lnRef>
+          <a:fillRef idx="3">
+            <a:schemeClr val="accent1"/>
+          </a:fillRef>
+          <a:effectRef idx="2">
+            <a:schemeClr val="accent1"/>
+          </a:effectRef>
+          <a:fontRef idx="minor">
+            <a:schemeClr val="lt1"/>
+          </a:fontRef>
+        </p:style>
+        <p:txBody>
+          <a:bodyPr rtlCol="0" anchor="ctr"/>
+          <a:lstStyle/>
+          <a:p>
+            <a:pPr algn="ctr"/>
+          </a:p>
+        </p:txBody>
+      </p:sp>
+      <p:sp>
+        <p:nvSpPr>
+          <p:cNvPr id="17" name="TextBox 16"/>
+          <p:cNvSpPr txBox="1"/>
+          <p:nvPr/>
+        </p:nvSpPr>
+        <p:spPr>
+          <a:xfrm>
+            <a:off x="4224528" y="2395728"/>
+            <a:ext cx="3749039" cy="457200"/>
+          </a:xfrm>
+          <a:prstGeom prst="rect">
+            <a:avLst/>
+          </a:prstGeom>
+          <a:noFill/>
+        </p:spPr>
+        <p:txBody>
+          <a:bodyPr wrap="square" anchor="ctr"/>
+          <a:lstStyle/>
+          <a:p>
+            <a:pPr algn="ctr"/>
+            <a:r>
+              <a:rPr sz="1600" b="1">
+                <a:solidFill>
+                  <a:srgbClr val="0B2C4A"/>
+                </a:solidFill>
+                <a:latin typeface="Calibri"/>
+              </a:rPr>
+              <a:t>Povidone-iodine</a:t>
+            </a:r>
+          </a:p>
+        </p:txBody>
+      </p:sp>
+      <p:sp>
+        <p:nvSpPr>
+          <p:cNvPr id="18" name="TextBox 17"/>
+          <p:cNvSpPr txBox="1"/>
+          <p:nvPr/>
+        </p:nvSpPr>
+        <p:spPr>
+          <a:xfrm>
+            <a:off x="4361688" y="2944368"/>
+            <a:ext cx="3474720" cy="3337560"/>
+          </a:xfrm>
+          <a:prstGeom prst="rect">
+            <a:avLst/>
+          </a:prstGeom>
+          <a:noFill/>
+        </p:spPr>
+        <p:txBody>
+          <a:bodyPr wrap="square" anchor="t"/>
+          <a:lstStyle/>
+          <a:p>
+            <a:pPr algn="l"/>
+            <a:r>
+              <a:rPr sz="1300" b="0">
+                <a:solidFill>
+                  <a:srgbClr val="1C1C1C"/>
+                </a:solidFill>
+                <a:latin typeface="Calibri"/>
+              </a:rPr>
+              <a:t>Intact skin: 10% solution or 7.5% scrub, used as labeled. Do not invent a skin dilution.
+Mucosa / eye / prepuce: 10% SOLUTION only, 1 to 20 to 1 to 50, as above.
+Organic matter inactivates it — that is why the dirty prep comes first.
+Contact time 2–5 minutes; allow to dry.
+Not sporicidal at surgical contact times. Iodine hypersensitivity. Stains.</a:t>
+            </a:r>
+          </a:p>
+        </p:txBody>
+      </p:sp>
+      <p:sp>
+        <p:nvSpPr>
+          <p:cNvPr id="19" name="Rounded Rectangle 18"/>
+          <p:cNvSpPr/>
+          <p:nvPr/>
+        </p:nvSpPr>
+        <p:spPr>
+          <a:xfrm>
+            <a:off x="8083296" y="2395728"/>
+            <a:ext cx="3730752" cy="4041648"/>
+          </a:xfrm>
+          <a:prstGeom prst="roundRect">
+            <a:avLst>
+              <a:gd name="adj" fmla="val 8000"/>
+            </a:avLst>
+          </a:prstGeom>
+          <a:solidFill>
+            <a:srgbClr val="FFFFFF"/>
+          </a:solidFill>
+          <a:ln>
+            <a:noFill/>
+          </a:ln>
+        </p:spPr>
+        <p:style>
+          <a:lnRef idx="1">
+            <a:schemeClr val="accent1"/>
+          </a:lnRef>
+          <a:fillRef idx="3">
+            <a:schemeClr val="accent1"/>
+          </a:fillRef>
+          <a:effectRef idx="2">
+            <a:schemeClr val="accent1"/>
+          </a:effectRef>
+          <a:fontRef idx="minor">
+            <a:schemeClr val="lt1"/>
+          </a:fontRef>
+        </p:style>
+        <p:txBody>
+          <a:bodyPr rtlCol="0" anchor="ctr"/>
+          <a:lstStyle/>
+          <a:p>
+            <a:pPr algn="ctr"/>
+          </a:p>
+        </p:txBody>
+      </p:sp>
+      <p:sp>
+        <p:nvSpPr>
+          <p:cNvPr id="20" name="Rectangle 19"/>
+          <p:cNvSpPr/>
+          <p:nvPr/>
+        </p:nvSpPr>
+        <p:spPr>
+          <a:xfrm>
+            <a:off x="8083296" y="2395728"/>
+            <a:ext cx="3730752" cy="457200"/>
           </a:xfrm>
           <a:prstGeom prst="rect">
             <a:avLst/>
@@ -29977,14 +30089,14 @@
       </p:sp>
       <p:sp>
         <p:nvSpPr>
-          <p:cNvPr id="18" name="TextBox 17"/>
-          <p:cNvSpPr txBox="1"/>
-          <p:nvPr/>
-        </p:nvSpPr>
-        <p:spPr>
-          <a:xfrm>
-            <a:off x="8092440" y="1097280"/>
-            <a:ext cx="3657600" cy="640080"/>
+          <p:cNvPr id="21" name="TextBox 20"/>
+          <p:cNvSpPr txBox="1"/>
+          <p:nvPr/>
+        </p:nvSpPr>
+        <p:spPr>
+          <a:xfrm>
+            <a:off x="8083296" y="2395728"/>
+            <a:ext cx="3730752" cy="457200"/>
           </a:xfrm>
           <a:prstGeom prst="rect">
             <a:avLst/>
@@ -29997,7 +30109,7 @@
           <a:p>
             <a:pPr algn="ctr"/>
             <a:r>
-              <a:rPr sz="1800" b="1">
+              <a:rPr sz="1600" b="1">
                 <a:solidFill>
                   <a:srgbClr val="C5A35A"/>
                 </a:solidFill>
@@ -30010,14 +30122,14 @@
       </p:sp>
       <p:sp>
         <p:nvSpPr>
-          <p:cNvPr id="19" name="TextBox 18"/>
-          <p:cNvSpPr txBox="1"/>
-          <p:nvPr/>
-        </p:nvSpPr>
-        <p:spPr>
-          <a:xfrm>
-            <a:off x="8321040" y="1874519"/>
-            <a:ext cx="3246120" cy="4023360"/>
+          <p:cNvPr id="22" name="TextBox 21"/>
+          <p:cNvSpPr txBox="1"/>
+          <p:nvPr/>
+        </p:nvSpPr>
+        <p:spPr>
+          <a:xfrm>
+            <a:off x="8220456" y="2944368"/>
+            <a:ext cx="3456432" cy="3337560"/>
           </a:xfrm>
           <a:prstGeom prst="rect">
             <a:avLst/>
@@ -30030,23 +30142,24 @@
           <a:p>
             <a:pPr algn="l"/>
             <a:r>
-              <a:rPr sz="1400" b="0">
+              <a:rPr sz="1300" b="0">
                 <a:solidFill>
                   <a:srgbClr val="1C1C1C"/>
                 </a:solidFill>
                 <a:latin typeface="Calibri"/>
               </a:rPr>
-              <a:t>Isopropyl/ethyl alcohol: rapid, no residual, flammable — no pooling near cautery.
-Often the ‘paint’ between CHG scrubs.
-Do not use alcohol on open wounds, mucous membranes, or laser/cautery pools.
-Hydrogen peroxide is not a surgical prep.</a:t>
-            </a:r>
-          </a:p>
-        </p:txBody>
-      </p:sp>
-      <p:sp>
-        <p:nvSpPr>
-          <p:cNvPr id="20" name="Rectangle 19"/>
+              <a:t>70% isopropyl or ethyl: rapid kill, no residual. Flammable — no pooling near cautery.
+Rinse or paint between CHG cycles on intact skin.
+Not for open wounds, mucous membranes, or the eye.
+Hydrogen peroxide is not a surgical antiseptic.
+Contact time is part of the prep. Follow the labeled product in your hospital.</a:t>
+            </a:r>
+          </a:p>
+        </p:txBody>
+      </p:sp>
+      <p:sp>
+        <p:nvSpPr>
+          <p:cNvPr id="23" name="Rectangle 22"/>
           <p:cNvSpPr/>
           <p:nvPr/>
         </p:nvSpPr>
@@ -30089,7 +30202,7 @@
       </p:sp>
       <p:sp>
         <p:nvSpPr>
-          <p:cNvPr id="21" name="TextBox 20"/>
+          <p:cNvPr id="24" name="TextBox 23"/>
           <p:cNvSpPr txBox="1"/>
           <p:nvPr/>
         </p:nvSpPr>
@@ -30122,7 +30235,7 @@
       </p:sp>
       <p:sp>
         <p:nvSpPr>
-          <p:cNvPr id="22" name="TextBox 21"/>
+          <p:cNvPr id="25" name="TextBox 24"/>
           <p:cNvSpPr txBox="1"/>
           <p:nvPr/>
         </p:nvSpPr>
@@ -30577,7 +30690,7 @@
                 </a:solidFill>
                 <a:latin typeface="Calibri"/>
               </a:rPr>
-              <a:t>▸  Typical teaching: timed 3–5 min or product cycles, then a final paint.</a:t>
+              <a:t>▸  Timed 3–5 min or labeled product cycles, then a final paint. Damp-to-dry, not a lake.</a:t>
             </a:r>
           </a:p>
           <a:p>
@@ -30593,7 +30706,7 @@
                 </a:solidFill>
                 <a:latin typeface="Calibri"/>
               </a:rPr>
-              <a:t>▸  Damp-to-dry, not a lake.</a:t>
+              <a:t>▸  Intact skin: 2–4% CHG–alcohol or labeled 10% PVP-I.</a:t>
             </a:r>
           </a:p>
           <a:p>
@@ -30609,23 +30722,7 @@
                 </a:solidFill>
                 <a:latin typeface="Calibri"/>
               </a:rPr>
-              <a:t>▸  CHG off the cornea and out of the middle ear — Willie’s swollen drum.</a:t>
-            </a:r>
-          </a:p>
-          <a:p>
-            <a:pPr algn="l">
-              <a:spcAft>
-                <a:spcPts val="600"/>
-              </a:spcAft>
-            </a:pPr>
-            <a:r>
-              <a:rPr sz="1300" b="0">
-                <a:solidFill>
-                  <a:srgbClr val="1C1C1C"/>
-                </a:solidFill>
-                <a:latin typeface="Calibri"/>
-              </a:rPr>
-              <a:t>▸  This spiral is a diagram. The clip and drape slides are real clinic photographs.</a:t>
+              <a:t>▸  Mucosa, conjunctiva, prepuce: 10% PVP-I solution, 1 to 20 to 1 to 50. Never CHG in the eye or middle ear — Willie’s swollen drum.</a:t>
             </a:r>
           </a:p>
         </p:txBody>
@@ -33725,10 +33822,10 @@
                 </a:solidFill>
                 <a:latin typeface="Calibri"/>
               </a:rPr>
-              <a:t>If YOU contaminate yourself or the field: say it immediately and correct (re-glove, re-gown, re-drape).
-Name it once, fix it completely.
-A second unrecognized break means you cannot maintain an aseptic field — stop.
-This is how we protect a client-owned animal, not a game of gotcha.</a:t>
+              <a:t>If you contaminate yourself or the field: say it immediately and correct it — re-glove, re-gown, or re-drape.
+Name the break once. Fix it completely.
+A second unrecognized break means you cannot maintain an aseptic field. Stop.
+This is how we protect a client-owned animal.</a:t>
             </a:r>
           </a:p>
         </p:txBody>
@@ -35314,7 +35411,7 @@
                 </a:solidFill>
                 <a:latin typeface="Calibri"/>
               </a:rPr>
-              <a:t>Emergency for the eye. CHG is corneal-toxic. Irrigate immediately; do not ‘continue.’</a:t>
+              <a:t>Emergency for the eye. CHG is corneal-toxic. Irrigate with sterile saline immediately. Do not continue the prep over a burned cornea.</a:t>
             </a:r>
           </a:p>
         </p:txBody>
@@ -35468,7 +35565,7 @@
                 </a:solidFill>
                 <a:latin typeface="Calibri"/>
               </a:rPr>
-              <a:t>Hair visible at the drape edge; you add another towel to cover it.</a:t>
+              <a:t>For conjunctiva or prepuce, dilute 10% povidone-iodine SOLUTION 1 to 20 to 1 to 50 in sterile saline.</a:t>
             </a:r>
           </a:p>
         </p:txBody>
@@ -35501,7 +35598,7 @@
                 </a:solidFill>
                 <a:latin typeface="Calibri"/>
               </a:rPr>
-              <a:t>Yes — if the added drape is sterile and the field is truly covered. Best is an adequate clip.</a:t>
+              <a:t>Yes. 1 mL + 19 mL = 1:20 (0.5%). 1 mL + 49 mL = 1:50 (0.2%). Never the 7.5% detergent scrub in an eye.</a:t>
             </a:r>
           </a:p>
         </p:txBody>
@@ -38099,7 +38196,7 @@
                 </a:solidFill>
                 <a:latin typeface="Calibri"/>
               </a:rPr>
-              <a:t>▸  E-collar that actually stays on. Licking is the leading student dehiscence.</a:t>
+              <a:t>▸  E-collar that actually stays on. Licking is the most common cause of dehiscence after otherwise adequate closure.</a:t>
             </a:r>
           </a:p>
           <a:p>
@@ -45856,7 +45953,7 @@
                 </a:solidFill>
                 <a:latin typeface="Calibri"/>
               </a:rPr>
-              <a:t>Alfaxalone only after a surgical plane. Clip/prep the ear if you flush. CHG off the eye and drum. Pad him — he falls. Maintain the airway.</a:t>
+              <a:t>Airway protected, monitors on, then alfaxalone to a depth that is safe to clip and flush. CHG off the eye and drum. Mucosa/periocular: 10% PVP-I 1 to 20 to 1 to 50. Pad him — he falls.</a:t>
             </a:r>
           </a:p>
         </p:txBody>
@@ -47972,7 +48069,7 @@
                 </a:solidFill>
                 <a:latin typeface="Calibri"/>
               </a:rPr>
-              <a:t>Closed glove; CHG off the cornea and out of the middle ear; announce contamination.</a:t>
+              <a:t>Intact skin: 2–4% CHG or labeled 10% PVP-I. Mucosa, conjunctiva, prepuce: 10% PVP-I solution 1 to 20 to 1 to 50. CHG never on cornea or in the middle ear.</a:t>
             </a:r>
           </a:p>
         </p:txBody>
@@ -48992,7 +49089,7 @@
                 </a:solidFill>
                 <a:latin typeface="Calibri"/>
               </a:rPr>
-              <a:t>▸  Hendrickson D.A., Baird A.N. Turner and McIlwraith’s Techniques in Large Animal Surgery. 4th ed. Wiley-Blackwell; 2013.</a:t>
+              <a:t>▸  Johnston S.A., Tobias K.M. Veterinary Surgery: Small Animal. 2nd ed. Elsevier; 2017.</a:t>
             </a:r>
           </a:p>
           <a:p>
@@ -49008,7 +49105,7 @@
                 </a:solidFill>
                 <a:latin typeface="Calibri"/>
               </a:rPr>
-              <a:t>▸  Johnston S.A., Tobias K.M. Veterinary Surgery: Small Animal. 2nd ed. Elsevier; 2017.</a:t>
+              <a:t>▸  Hendrickson D.A., Baird A.N. Turner and McIlwraith’s Techniques in Large Animal Surgery. 4th ed. Wiley-Blackwell; 2013.</a:t>
             </a:r>
           </a:p>
           <a:p>
@@ -49024,7 +49121,7 @@
                 </a:solidFill>
                 <a:latin typeface="Calibri"/>
               </a:rPr>
-              <a:t>▸  AAHA/AAFP Antimicrobial Stewardship Guidelines, 2022 — surgical prophylaxis.</a:t>
+              <a:t>▸  Roberts S.M., Severin G.A., Lavach J.D. Antibacterial activity of dilute povidone-iodine solutions used for ocular surface disinfection in dogs. Am J Vet Res. 1986;47(6):1207–1210. — 10% PVP-I (1% available iodine) diluted 1:50 (0.2%) is the classic canine ocular recommendation; 1:2 (5%) caused corneal edema.</a:t>
             </a:r>
           </a:p>
           <a:p>
@@ -49040,7 +49137,7 @@
                 </a:solidFill>
                 <a:latin typeface="Calibri"/>
               </a:rPr>
-              <a:t>▸  AAHA Anesthesia and Monitoring Guidelines (current edition) — fasting, PE, monitoring, recovery.</a:t>
+              <a:t>▸  AAHA/AAFP Antimicrobial Stewardship Guidelines, 2022 — surgical prophylaxis.  ·  AAHA Anesthesia and Monitoring Guidelines — fasting, PE, monitoring, recovery.</a:t>
             </a:r>
           </a:p>
           <a:p>
@@ -49412,7 +49509,7 @@
                 <a:latin typeface="Calibri"/>
               </a:rPr>
               <a:t>If there are no questions: why was Willie ASA III-E and MoMo ASA IV-E —
-and why did only one of them get anesthetized?</a:t>
+and how do you dilute 10% povidone-iodine for conjunctiva or prepuce?</a:t>
             </a:r>
           </a:p>
         </p:txBody>

</xml_diff>

<commit_message>
State exact PVP-I times: 5 minutes on skin, 2 plus 2 on the eye.
Replace vague contact-time language with the veterinary Betadine 5-minute wet scrub and the Roberts 2-minute scrub plus 2-minute soak for 1:50 ocular prep.

Co-authored-by: drkimvet <drkimvet@users.noreply.github.com>
</commit_message>
<xml_diff>
--- a/lectures/DVM-612_Week4_Preop_PatientPrep_Postop.pptx
+++ b/lectures/DVM-612_Week4_Preop_PatientPrep_Postop.pptx
@@ -2310,7 +2310,7 @@
           <a:lstStyle/>
           <a:p>
             <a:r>
-              <a:t>Classic fail: clipping in the OR, or sterile prep in the prep room then dragging a wet dog across a dirty corridor without a clean transfer. Another fail: starting the clip before adequate anesthetic depth — the patient wakes, contaminates, and is lacerated. Step 5: they will mix 10% PVP-I 1 to 20 to 1 to 50 for mucosa and eye. That is not a client instruction; it is their job.</a:t>
+              <a:t>Classic fail: clipping in the OR, or sterile prep in the prep room then dragging a wet dog across a dirty corridor without a clean transfer. Another fail: starting the clip before adequate anesthetic depth — the patient wakes, contaminates, and is lacerated. Step 5: 10% PVP-I on intact skin is 5 minutes of wet contact — lather the 7.5% scrub for 5 minutes, rinse, paint 10% solution, dry before you drape. Mucosa and eye: 1 to 20 to 1 to 50. Eye at 1:50 is a 2-minute scrub plus a 2-minute soak.</a:t>
             </a:r>
           </a:p>
         </p:txBody>
@@ -2520,7 +2520,7 @@
           <a:lstStyle/>
           <a:p>
             <a:r>
-              <a:t>Stop and have them write the arithmetic. You are not teaching a client handout. Stock is 10% povidone-iodine solution. For mucosa, conjunctiva, and prepuce they dilute that solution — never the 7.5% detergent scrub — one part in twenty to one part in fifty with sterile saline. 1 mL + 19 mL = 1:20 = 0.5%. 1 mL + 49 mL = 1:50 = 0.2%, the classic canine ocular dilution (Roberts, AJVR 1986). Intact skin is labeled 10% solution or 7.5% scrub; do not invent a skin dilution. Chlorhexidine 2–4% with alcohol is the default for intact trunk skin and destroys cornea and middle ear. Willie has a swollen tympanum — that is not a chlorhexidine ear, and aminoglycoside ointment is not a casual choice if the middle ear is involved. Do not mix CHG and iodine. Do not call PVP-I sporicidal at surgical contact times. Organic matter inactivates iodine; dirty prep first, then sterile prep with contact time.</a:t>
+              <a:t>Write the numbers on the board. Intact skin, 7.5% povidone-iodine scrub: lather 5 minutes, rinse, paint 10% solution, dry before draping — that is the veterinary Betadine label. Mucosa, conjunctiva, prepuce: 10% SOLUTION diluted 1 to 20 to 1 to 50. Eye at 1:50: 2-minute scrub plus 2-minute soak (Roberts, AJVR 1986). 1:2 (5%) caused corneal edema; do not use it on cornea. Aqueous chlorhexidine: 3 minutes wet contact; residual 6 hours. CHG–alcohol 2%/70%: 30 seconds dry skin, 2 minutes moist skin. Alcohol 70%: 30 seconds, then dry. PVP-I is not sporicidal at 5 minutes. Willie: swollen tympanum — not a chlorhexidine ear.</a:t>
             </a:r>
           </a:p>
         </p:txBody>
@@ -2590,7 +2590,7 @@
           <a:lstStyle/>
           <a:p>
             <a:r>
-              <a:t>Mime the spiral. Have one student recite the iodine arithmetic before you leave this slide. No open-license spiral-prep photograph was available; this stays a diagram. Real clip, drape, anesthesia, and recovery photos are adjacent.</a:t>
+              <a:t>Mime the spiral. Clock 5 minutes for povidone-iodine on intact skin. Recite the 1 to 20 to 1 to 50 arithmetic. Eye: 2 minutes plus 2 minutes. No open-license spiral-prep photograph was available; this stays a diagram.</a:t>
             </a:r>
           </a:p>
         </p:txBody>
@@ -3080,7 +3080,7 @@
           <a:lstStyle/>
           <a:p>
             <a:r>
-              <a:t>C is the safety slide. D is the arithmetic they must leave with. Hair at the drape edge is still a fail on the draping photographs — salvage with a sterile towel is not the standard; an adequate clip is.</a:t>
+              <a:t>C is the safety slide. D: 1 to 20 to 1 to 50, 5 minutes wet on intact skin, 2 minutes plus 2 minutes on the eye. Hair at the drape edge is still a fail — an adequate clip, not a salvage towel.</a:t>
             </a:r>
           </a:p>
         </p:txBody>
@@ -4340,7 +4340,7 @@
           <a:lstStyle/>
           <a:p>
             <a:r>
-              <a:t>Take questions. If none: Willie vs MoMo ASA, then the iodine arithmetic — 1 to 20 to 1 to 50. Dismiss on time.</a:t>
+              <a:t>Take questions. If none: Willie vs MoMo ASA, then iodine — 1 to 20 to 1 to 50, 5 minutes wet on intact skin, 2 minutes plus 2 minutes on the eye. Dismiss on time.</a:t>
             </a:r>
           </a:p>
         </p:txBody>
@@ -19882,7 +19882,7 @@
                 </a:solidFill>
                 <a:latin typeface="Calibri"/>
               </a:rPr>
-              <a:t>▸  Antibiotics given (if indicated) 30–60 min before incision.</a:t>
+              <a:t>▸  Antibiotics given (if indicated) 30 minutes before incision.</a:t>
             </a:r>
           </a:p>
           <a:p>
@@ -21886,12 +21886,12 @@
                 </a:solidFill>
                 <a:latin typeface="Calibri"/>
               </a:rPr>
-              <a:t>Give 30–60 min before incision; redose (e.g. cefazolin ~q90 min) if surgery is long or blood loss is large.
+              <a:t>Give IV cefazolin 22 mg/kg 30 minutes before incision; redose every 90 minutes if the surgery is still open or blood loss is large.
 Consider if:
 • Clean-contaminated / contaminated / dirty
 • Implant (orthopedic, mesh)
 • Hollow viscus entry
-• Prolonged surgery or known break in asepsis
+• Surgery &gt;90 minutes or a known break in asepsis
 • Patient immunocompromised
 • Infection would be catastrophic (some neuro/implant cases — still think, don’t reflex)</a:t>
             </a:r>
@@ -25018,7 +25018,7 @@
                 </a:solidFill>
                 <a:latin typeface="Calibri"/>
               </a:rPr>
-              <a:t>Dirty then sterile prep. Contact time. Intact skin: labeled CHG or 10% PVP-I. Mucosa/eye: 1 to 20 to 1 to 50.</a:t>
+              <a:t>Dirty then sterile. PVP-I: 5 minutes wet contact. Mucosa/eye: 1 to 20 to 1 to 50.</a:t>
             </a:r>
           </a:p>
         </p:txBody>
@@ -26802,7 +26802,7 @@
                 </a:solidFill>
                 <a:latin typeface="Calibri"/>
               </a:rPr>
-              <a:t>Sterile prep (gloved), contact time. Mucosa/eye: PVP-I 1 to 20 – 1 to 50</a:t>
+              <a:t>Sterile prep (gloved). PVP-I 5 min wet contact. Mucosa/eye: 1 to 20 – 1 to 50</a:t>
             </a:r>
           </a:p>
         </p:txBody>
@@ -27911,7 +27911,7 @@
                 </a:solidFill>
                 <a:latin typeface="Calibri"/>
               </a:rPr>
-              <a:t>Xiphoid, or slightly cranial to it, to the pubis, and widely lateral past the nipples — a rectangle, not a narrow strip of hair. Clip with the grain, then against, to the skin. Vacuum. Approximately 20 cm beyond the planned incision. Do not clip the night before. Razors create micro-nicks and raise SSI risk. Airway in and a surgical plane before the clippers start.
+              <a:t>Xiphoid, or slightly cranial to it, to the pubis, and widely lateral past the nipples — a rectangle, not a narrow strip of hair. Clip with the grain, then against, to the skin. Vacuum. 20 cm beyond the planned incision. Do not clip the night before. Razors create micro-nicks and raise SSI risk. Airway in and a surgical plane before the clippers start.
 Photos: Uwe Gille, CC0 (cat clip); Liannadavis, CC BY-SA 4.0 (OHE incision).</a:t>
             </a:r>
           </a:p>
@@ -29678,7 +29678,7 @@
                 <a:latin typeface="Calibri"/>
               </a:rPr>
               <a:t>1 mL stock + 19 mL saline = 1:20 = 0.5% PVP-I        ·        1 mL stock + 49 mL saline = 1:50 = 0.2% PVP-I
-1:50 is the evidence-based canine ocular dilution. Do not use 1:2 (5%) on cornea. Never put the 7.5% detergent scrub in an eye.</a:t>
+Intact skin: 5 minutes wet contact.  Eye at 1:50: 2-minute scrub + 2-minute soak.  Never the 7.5% detergent scrub in an eye.</a:t>
             </a:r>
           </a:p>
         </p:txBody>
@@ -29793,13 +29793,13 @@
           <a:p>
             <a:pPr algn="ctr"/>
             <a:r>
-              <a:rPr sz="1600" b="1">
+              <a:rPr sz="1500" b="1">
                 <a:solidFill>
                   <a:srgbClr val="FFFFFF"/>
                 </a:solidFill>
                 <a:latin typeface="Calibri"/>
               </a:rPr>
-              <a:t>Chlorhexidine</a:t>
+              <a:t>Chlorhexidine — 3 minutes</a:t>
             </a:r>
           </a:p>
         </p:txBody>
@@ -29826,14 +29826,16 @@
           <a:p>
             <a:pPr algn="l"/>
             <a:r>
-              <a:rPr sz="1300" b="0">
+              <a:rPr sz="1200" b="0">
                 <a:solidFill>
                   <a:srgbClr val="1C1C1C"/>
                 </a:solidFill>
                 <a:latin typeface="Calibri"/>
               </a:rPr>
-              <a:t>Default for intact haired skin: 2–4% CHG, usually with 70% alcohol. Hours of residual activity.
-Rinse gross debris first. Anionic soaps reduce activity.
+              <a:t>Intact skin: 2% or 4% CHG.
+Aqueous CHG: 3 minutes of wet contact.
+CHG–alcohol (2% / 70%): 30 seconds on dry skin, 2 minutes on moist skin.
+Residual activity 6 hours.
 Destroys cornea. Ototoxic in the middle ear. Not for meninges, synovium, or open viscera.
 Do not mix with povidone-iodine on the same field.
 Do not store homemade dilute jugs (outbreak risk).</a:t>
@@ -29951,13 +29953,13 @@
           <a:p>
             <a:pPr algn="ctr"/>
             <a:r>
-              <a:rPr sz="1600" b="1">
+              <a:rPr sz="1500" b="1">
                 <a:solidFill>
                   <a:srgbClr val="0B2C4A"/>
                 </a:solidFill>
                 <a:latin typeface="Calibri"/>
               </a:rPr>
-              <a:t>Povidone-iodine</a:t>
+              <a:t>Povidone-iodine — 5 minutes</a:t>
             </a:r>
           </a:p>
         </p:txBody>
@@ -29984,17 +29986,17 @@
           <a:p>
             <a:pPr algn="l"/>
             <a:r>
-              <a:rPr sz="1300" b="0">
+              <a:rPr sz="1200" b="0">
                 <a:solidFill>
                   <a:srgbClr val="1C1C1C"/>
                 </a:solidFill>
                 <a:latin typeface="Calibri"/>
               </a:rPr>
-              <a:t>Intact skin: 10% solution or 7.5% scrub, used as labeled. Do not invent a skin dilution.
-Mucosa / eye / prepuce: 10% SOLUTION only, 1 to 20 to 1 to 50, as above.
-Organic matter inactivates it — that is why the dirty prep comes first.
-Contact time 2–5 minutes; allow to dry.
-Not sporicidal at surgical contact times. Iodine hypersensitivity. Stains.</a:t>
+              <a:t>Intact skin: 7.5% scrub, lather 5 minutes, rinse, paint 10% solution, dry before you drape. Do not invent a skin dilution.
+Mucosa / eye / prepuce: 10% SOLUTION only, 1 to 20 to 1 to 50.
+Eye at 1:50: 2-minute scrub + 2-minute soak.
+Organic matter inactivates it — dirty prep first.
+Not sporicidal at 5 minutes. Residual 90 minutes after dry. Hypersensitivity. Stains.</a:t>
             </a:r>
           </a:p>
         </p:txBody>
@@ -30109,13 +30111,13 @@
           <a:p>
             <a:pPr algn="ctr"/>
             <a:r>
-              <a:rPr sz="1600" b="1">
+              <a:rPr sz="1500" b="1">
                 <a:solidFill>
                   <a:srgbClr val="C5A35A"/>
                 </a:solidFill>
                 <a:latin typeface="Calibri"/>
               </a:rPr>
-              <a:t>Alcohol &amp; others</a:t>
+              <a:t>Alcohol — 30 seconds</a:t>
             </a:r>
           </a:p>
         </p:txBody>
@@ -30148,11 +30150,11 @@
                 </a:solidFill>
                 <a:latin typeface="Calibri"/>
               </a:rPr>
-              <a:t>70% isopropyl or ethyl: rapid kill, no residual. Flammable — no pooling near cautery.
+              <a:t>70% isopropyl or ethyl: 30 seconds, then dry. No residual.
+Flammable — no pooling near cautery.
 Rinse or paint between CHG cycles on intact skin.
 Not for open wounds, mucous membranes, or the eye.
-Hydrogen peroxide is not a surgical antiseptic.
-Contact time is part of the prep. Follow the labeled product in your hospital.</a:t>
+Hydrogen peroxide is not a surgical antiseptic.</a:t>
             </a:r>
           </a:p>
         </p:txBody>
@@ -30690,7 +30692,7 @@
                 </a:solidFill>
                 <a:latin typeface="Calibri"/>
               </a:rPr>
-              <a:t>▸  Timed 3–5 min or labeled product cycles, then a final paint. Damp-to-dry, not a lake.</a:t>
+              <a:t>▸  PVP-I: 5 minutes wet contact, rinse, paint 10% solution, dry. Aqueous CHG: 3 minutes. Damp-to-dry, not a lake.</a:t>
             </a:r>
           </a:p>
           <a:p>
@@ -30706,7 +30708,7 @@
                 </a:solidFill>
                 <a:latin typeface="Calibri"/>
               </a:rPr>
-              <a:t>▸  Intact skin: 2–4% CHG–alcohol or labeled 10% PVP-I.</a:t>
+              <a:t>▸  Mucosa, conjunctiva, prepuce: 10% PVP-I solution, 1 to 20 to 1 to 50. Eye at 1:50: 2-minute scrub + 2-minute soak.</a:t>
             </a:r>
           </a:p>
           <a:p>
@@ -30722,7 +30724,7 @@
                 </a:solidFill>
                 <a:latin typeface="Calibri"/>
               </a:rPr>
-              <a:t>▸  Mucosa, conjunctiva, prepuce: 10% PVP-I solution, 1 to 20 to 1 to 50. Never CHG in the eye or middle ear — Willie’s swollen drum.</a:t>
+              <a:t>▸  Never CHG in the eye or middle ear — Willie’s swollen drum.</a:t>
             </a:r>
           </a:p>
         </p:txBody>
@@ -35598,7 +35600,7 @@
                 </a:solidFill>
                 <a:latin typeface="Calibri"/>
               </a:rPr>
-              <a:t>Yes. 1 mL + 19 mL = 1:20 (0.5%). 1 mL + 49 mL = 1:50 (0.2%). Never the 7.5% detergent scrub in an eye.</a:t>
+              <a:t>Yes. 1:20 = 0.5%; 1:50 = 0.2%. Intact skin: 5 min wet. Eye: 2 min scrub + 2 min soak. Never detergent scrub in an eye.</a:t>
             </a:r>
           </a:p>
         </p:txBody>
@@ -45953,7 +45955,7 @@
                 </a:solidFill>
                 <a:latin typeface="Calibri"/>
               </a:rPr>
-              <a:t>Airway protected, monitors on, then alfaxalone to a depth that is safe to clip and flush. CHG off the eye and drum. Mucosa/periocular: 10% PVP-I 1 to 20 to 1 to 50. Pad him — he falls.</a:t>
+              <a:t>Airway protected, monitors on, then alfaxalone to a depth that is safe to clip and flush. CHG off the eye and drum. Periocular/mucosa: 10% PVP-I 1 to 20 to 1 to 50; eye 2 min scrub + 2 min soak. Pad him — he falls.</a:t>
             </a:r>
           </a:p>
         </p:txBody>
@@ -48069,7 +48071,7 @@
                 </a:solidFill>
                 <a:latin typeface="Calibri"/>
               </a:rPr>
-              <a:t>Intact skin: 2–4% CHG or labeled 10% PVP-I. Mucosa, conjunctiva, prepuce: 10% PVP-I solution 1 to 20 to 1 to 50. CHG never on cornea or in the middle ear.</a:t>
+              <a:t>Intact skin: PVP-I 5 minutes wet contact (then paint and dry), or aqueous CHG 3 minutes. Mucosa/eye: 10% PVP-I 1 to 20 to 1 to 50; eye 2 min + 2 min. CHG never on cornea or in the middle ear.</a:t>
             </a:r>
           </a:p>
         </p:txBody>
@@ -49121,7 +49123,7 @@
                 </a:solidFill>
                 <a:latin typeface="Calibri"/>
               </a:rPr>
-              <a:t>▸  Roberts S.M., Severin G.A., Lavach J.D. Antibacterial activity of dilute povidone-iodine solutions used for ocular surface disinfection in dogs. Am J Vet Res. 1986;47(6):1207–1210. — 10% PVP-I (1% available iodine) diluted 1:50 (0.2%) is the classic canine ocular recommendation; 1:2 (5%) caused corneal edema.</a:t>
+              <a:t>▸  Roberts S.M., Severin G.A., Lavach J.D. Am J Vet Res. 1986;47(6):1207–1210. Canine ocular 1:50 (0.2%): 2-minute scrub + 2-minute soak. 1:2 (5%) caused corneal edema.</a:t>
             </a:r>
           </a:p>
           <a:p>
@@ -49137,7 +49139,7 @@
                 </a:solidFill>
                 <a:latin typeface="Calibri"/>
               </a:rPr>
-              <a:t>▸  AAHA/AAFP Antimicrobial Stewardship Guidelines, 2022 — surgical prophylaxis.  ·  AAHA Anesthesia and Monitoring Guidelines — fasting, PE, monitoring, recovery.</a:t>
+              <a:t>▸  Betadine Surgical Scrub (povidone-iodine 7.5%), veterinary label: lather 5 minutes, rinse, paint 10% solution, dry.  ·  AAHA/AAFP Antimicrobial Stewardship 2022: cefazolin 22 mg/kg IV 30 minutes before incision; redose every 90 minutes.</a:t>
             </a:r>
           </a:p>
           <a:p>

</xml_diff>

<commit_message>
Remove em-dashes and slogan-style titles from the lecture.
Slide titles are now topic labels. Taglines of the form “Title — extra line” are gone, including client-handout phrasing.

Co-authored-by: drkimvet <drkimvet@users.noreply.github.com>
</commit_message>
<xml_diff>
--- a/lectures/DVM-612_Week4_Preop_PatientPrep_Postop.pptx
+++ b/lectures/DVM-612_Week4_Preop_PatientPrep_Postop.pptx
@@ -560,7 +560,7 @@
           <a:lstStyle/>
           <a:p>
             <a:r>
-              <a:t>Welcome. This hour is preoperative evaluation, patient and surgeon preparation, and postoperative care. Two real patients from the same hospital. Willie, a 6-year 11-month MN Cavalier, 13.7 kg, acute vestibular crisis plus left otitis — we sedated him. MoMo, a 6-year SF DSH, 4.25 kg, vomiting that looked like a foreign-body surgery — imaging cancelled the cut. Assign both ASA statuses. Owner identifiers stay off these slides.</a:t>
+              <a:t>Welcome. This hour is preoperative evaluation, patient and surgeon preparation, and postoperative care. Two real patients from the same hospital. Willie, a 6-year 11-month MN Cavalier, 13.7 kg, acute vestibular crisis plus left otitis. We sedated him. MoMo, a 6-year SF DSH, 4.25 kg, vomiting that looked like a foreign-body surgery. Imaging cancelled the exploratory. Assign both ASA statuses. Owner identifiers stay off these slides.</a:t>
             </a:r>
           </a:p>
         </p:txBody>
@@ -770,7 +770,7 @@
           <a:lstStyle/>
           <a:p>
             <a:r>
-              <a:t>Cold-call four students. C is Willie — we will unpack the sedation. D is MoMo — the preoperative evaluation cancelled the exploratory. The hyperkalemic blocked cat still appears in the knowledge check; do not lose that trap.</a:t>
+              <a:t>Cold-call four students. C is Willie (sedation). D is MoMo (exploratory cancelled). The hyperkalemic blocked cat is in the knowledge check.</a:t>
             </a:r>
           </a:p>
         </p:txBody>
@@ -1050,7 +1050,7 @@
           <a:lstStyle/>
           <a:p>
             <a:r>
-              <a:t>NSAIDs are contraindicated. Diuresis will not fix a destroyed kidney. If someone still wants to ‘just look inside,’ that is not surgery — that is harm. Be respectful; this cat died. The teaching point is judgment, not spectacle.</a:t>
+              <a:t>NSAIDs are contraindicated. Diuresis will not fix a destroyed kidney. If someone still wants to ‘just look inside,’ that is not surgery. It is harm. Be respectful; this cat died. The teaching point is judgment, not spectacle.</a:t>
             </a:r>
           </a:p>
         </p:txBody>
@@ -1540,7 +1540,7 @@
           <a:lstStyle/>
           <a:p>
             <a:r>
-              <a:t>Teach AAHA-style 4–6 h for healthy small animals as best practice. Older sources still say overnight NPO — explain aspiration vs hypoglycemia. Ruminants are a different physiology, not a different lecture.</a:t>
+              <a:t>Teach AAHA-style 4–6 h for healthy small animals as best practice. Older sources still say overnight NPO. Explain aspiration versus hypoglycemia. Ruminants are a different physiology, not a different lecture.</a:t>
             </a:r>
           </a:p>
         </p:txBody>
@@ -1890,7 +1890,7 @@
           <a:lstStyle/>
           <a:p>
             <a:r>
-              <a:t>This is the point of the hour. The form is not only for patients who get clipped. Recording the decision not to operate is a surgical document. NSAIDs contraindicated. Rising creatinine. Owner elected euthanasia — say it once, respectfully, then move.</a:t>
+              <a:t>This is the point of the hour. The form is not only for patients who get clipped. Recording the decision not to operate is a surgical document. NSAIDs contraindicated. Rising creatinine. Owner elected euthanasia. Say it once, respectfully, then continue.</a:t>
             </a:r>
           </a:p>
         </p:txBody>
@@ -1960,7 +1960,7 @@
           <a:lstStyle/>
           <a:p>
             <a:r>
-              <a:t>Elective canine OHE is a clean procedure — do not invent a 14-day cephalexin prescription. Willie’s left ear is infected, so antimicrobials are treatment, not clean prophylaxis.</a:t>
+              <a:t>Elective canine OHE is a clean procedure. Do not prescribe 14 days of cephalexin. Willie’s left ear is infected, so antimicrobials are treatment, not clean prophylaxis.</a:t>
             </a:r>
           </a:p>
         </p:txBody>
@@ -2310,7 +2310,7 @@
           <a:lstStyle/>
           <a:p>
             <a:r>
-              <a:t>Classic fail: clipping in the OR, or sterile prep in the prep room then dragging a wet dog across a dirty corridor without a clean transfer. Another fail: starting the clip before adequate anesthetic depth — the patient wakes, contaminates, and is lacerated. Step 5: 10% PVP-I on intact skin is 5 minutes of wet contact — lather the 7.5% scrub for 5 minutes, rinse, paint 10% solution, dry before you drape. Mucosa and eye: 1 to 20 to 1 to 50. Eye at 1:50 is a 2-minute scrub plus a 2-minute soak.</a:t>
+              <a:t>Classic fail: clipping in the OR, or sterile prep in the prep room then dragging a wet dog across a dirty corridor without a clean transfer. Another fail: starting the clip before adequate anesthetic depth. The patient wakes, contaminates, and is lacerated. Step 5: 10% PVP-I on intact skin is 5 minutes of wet contact. Lather the 7.5% scrub for 5 minutes, rinse, paint 10% solution, dry before you drape. Mucosa and eye: 1 to 20 to 1 to 50. Eye at 1:50 is a 2-minute scrub plus a 2-minute soak.</a:t>
             </a:r>
           </a:p>
         </p:txBody>
@@ -2380,7 +2380,7 @@
           <a:lstStyle/>
           <a:p>
             <a:r>
-              <a:t>Left photo is a real clip in progress and still too narrow — that is the teaching point. Right photo is a real 24-hour OHE: the clip is the field you needed yesterday. Willie: TECA field is pinna and skull, not abdomen. MoMo never reached clippers.</a:t>
+              <a:t>Left photo is a real clip in progress and still too narrow. That is the teaching point. Right photo is a real 24-hour OHE: the clip is the field you needed yesterday. Willie: TECA field is pinna and skull, not abdomen. MoMo never reached clippers.</a:t>
             </a:r>
           </a:p>
         </p:txBody>
@@ -2520,7 +2520,7 @@
           <a:lstStyle/>
           <a:p>
             <a:r>
-              <a:t>Write the numbers on the board. Intact skin, 7.5% povidone-iodine scrub: lather 5 minutes, rinse, paint 10% solution, dry before draping — that is the veterinary Betadine label. Mucosa, conjunctiva, prepuce: 10% SOLUTION diluted 1 to 20 to 1 to 50. Eye at 1:50: 2-minute scrub plus 2-minute soak (Roberts, AJVR 1986). 1:2 (5%) caused corneal edema; do not use it on cornea. Aqueous chlorhexidine: 3 minutes wet contact; residual 6 hours. CHG–alcohol 2%/70%: 30 seconds dry skin, 2 minutes moist skin. Alcohol 70%: 30 seconds, then dry. PVP-I is not sporicidal at 5 minutes. Willie: swollen tympanum — not a chlorhexidine ear.</a:t>
+              <a:t>Write the numbers on the board. Intact skin, 7.5% povidone-iodine scrub: lather 5 minutes, rinse, paint 10% solution, dry before draping. Veterinary Betadine label. Mucosa, conjunctiva, prepuce: 10% SOLUTION diluted 1 to 20 to 1 to 50. Eye at 1:50: 2-minute scrub plus 2-minute soak (Roberts, AJVR 1986). 1:2 (5%) caused corneal edema; do not use it on cornea. Aqueous chlorhexidine: 3 minutes wet contact; residual 6 hours. CHG–alcohol 2%/70%: 30 seconds dry skin, 2 minutes moist skin. Alcohol 70%: 30 seconds, then dry. PVP-I is not sporicidal at 5 minutes. Willie: swollen tympanum. Do not use chlorhexidine in that ear.</a:t>
             </a:r>
           </a:p>
         </p:txBody>
@@ -2730,7 +2730,7 @@
           <a:lstStyle/>
           <a:p>
             <a:r>
-              <a:t>Left is a real spay: gown/mask/drape are present, but hair is still at the window — that is the fail. Right is a real sterile field. Then timeout before you cut.</a:t>
+              <a:t>Left is a real spay: gown/mask/drape are present, but hair is still at the window. The clip is inadequate. Right is a real sterile field. Then timeout before you cut.</a:t>
             </a:r>
           </a:p>
         </p:txBody>
@@ -2870,7 +2870,7 @@
           <a:lstStyle/>
           <a:p>
             <a:r>
-              <a:t>DVM 612 will hold you to this: a beautiful closure that bleeds in recovery is a failed surgery. The first 24 hours are part of the operation.</a:t>
+              <a:t>A closure that hemorrhages in recovery is a failed surgery. The first 24 hours are part of the operation.</a:t>
             </a:r>
           </a:p>
         </p:txBody>
@@ -3080,7 +3080,7 @@
           <a:lstStyle/>
           <a:p>
             <a:r>
-              <a:t>C is the safety slide. D: 1 to 20 to 1 to 50, 5 minutes wet on intact skin, 2 minutes plus 2 minutes on the eye. Hair at the drape edge is still a fail — an adequate clip, not a salvage towel.</a:t>
+              <a:t>C is the safety slide. D: 1 to 20 to 1 to 50, 5 minutes wet on intact skin, 2 minutes plus 2 minutes on the eye. Hair at the drape edge is still a fail. Clip an adequate field. Do not cover hair with a salvage towel.</a:t>
             </a:r>
           </a:p>
         </p:txBody>
@@ -3360,7 +3360,7 @@
           <a:lstStyle/>
           <a:p>
             <a:r>
-              <a:t>Score pain. NSAIDs: not in hypovolemia, kidney injury, GI ulcer, or concurrent steroids — Willie already received DexSP.</a:t>
+              <a:t>Score pain. NSAIDs: not in hypovolemia, kidney injury, GI ulcer, or concurrent steroids. Willie already received DexSP.</a:t>
             </a:r>
           </a:p>
         </p:txBody>
@@ -4340,7 +4340,7 @@
           <a:lstStyle/>
           <a:p>
             <a:r>
-              <a:t>Take questions. If none: Willie vs MoMo ASA, then iodine — 1 to 20 to 1 to 50, 5 minutes wet on intact skin, 2 minutes plus 2 minutes on the eye. Dismiss on time.</a:t>
+              <a:t>Take questions. If none: Willie vs MoMo ASA, then iodine: 1 to 20 to 1 to 50, 5 minutes wet on intact skin, 2 minutes plus 2 minutes on the eye. Dismiss on time.</a:t>
             </a:r>
           </a:p>
         </p:txBody>
@@ -4410,7 +4410,7 @@
           <a:lstStyle/>
           <a:p>
             <a:r>
-              <a:t>The red thread: you do not hand off responsibility at the OR door. Anesthesia gets the dog ready for surgical prep; surgery owns prep through the last skin suture; both own recovery.</a:t>
+              <a:t>You do not hand off responsibility at the OR door. Anesthesia prepares the patient for surgical prep. Surgery owns prep through the last skin suture. Both own recovery.</a:t>
             </a:r>
           </a:p>
         </p:txBody>
@@ -7951,7 +7951,7 @@
                 <a:latin typeface="Calibri"/>
               </a:rPr>
               <a:t>Preoperative evaluation · patient and surgeon preparation · postoperative care.
-Two real hospital cases: Willie (Cavalier, ASA III-E) and MoMo (cat, ASA IV-E — surgery cancelled).</a:t>
+Two hospital cases: Willie (Cavalier, ASA III-E) and MoMo (cat, ASA IV-E; exploratory cancelled).</a:t>
             </a:r>
           </a:p>
         </p:txBody>
@@ -8197,7 +8197,7 @@
                 </a:solidFill>
                 <a:latin typeface="Calibri"/>
               </a:rPr>
-              <a:t>PREANESTHETIC PE, INDICATED LABS, INTERPRET, THEN ASSIGN ASA</a:t>
+              <a:t>EXAMINE, REQUEST INDICATED LABS, INTERPRET, THEN ASSIGN ASA</a:t>
             </a:r>
           </a:p>
         </p:txBody>
@@ -8273,7 +8273,7 @@
                 </a:solidFill>
                 <a:latin typeface="Calibri"/>
               </a:rPr>
-              <a:t>Physical examination — do it yourself</a:t>
+              <a:t>Physical examination</a:t>
             </a:r>
           </a:p>
         </p:txBody>
@@ -8360,7 +8360,7 @@
                 </a:solidFill>
                 <a:latin typeface="Calibri"/>
               </a:rPr>
-              <a:t>▸  Abdomen: pain, distension, organomegaly, fluid wave — and empty the bladder if possible.</a:t>
+              <a:t>▸  Abdomen: pain, distension, organomegaly, fluid wave. Empty the bladder if possible.</a:t>
             </a:r>
           </a:p>
           <a:p>
@@ -8510,7 +8510,7 @@
 4. Assign ASA status
 5. Adjust the drug plan
 6. Then premedicate
-Premedicating before the exam is a never-event.</a:t>
+Do not premedicate before the examination.</a:t>
             </a:r>
           </a:p>
         </p:txBody>
@@ -8799,7 +8799,7 @@
                 </a:solidFill>
                 <a:latin typeface="Calibri"/>
               </a:rPr>
-              <a:t>AMERICAN SOCIETY OF ANESTHESIOLOGISTS (ASA) CLASSIFICATION SYSTEM</a:t>
+              <a:t>AMERICAN SOCIETY OF ANESTHESIOLOGISTS CLASSIFICATION</a:t>
             </a:r>
           </a:p>
         </p:txBody>
@@ -8875,7 +8875,7 @@
                 </a:solidFill>
                 <a:latin typeface="Calibri"/>
               </a:rPr>
-              <a:t>ASA physical status — memorize this wording</a:t>
+              <a:t>ASA physical status</a:t>
             </a:r>
           </a:p>
         </p:txBody>
@@ -8984,7 +8984,7 @@
                 </a:solidFill>
                 <a:latin typeface="Calibri"/>
               </a:rPr>
-              <a:t>Definition — this is the wording to memorize</a:t>
+              <a:t>Definition</a:t>
             </a:r>
           </a:p>
         </p:txBody>
@@ -9578,7 +9578,7 @@
                 </a:solidFill>
                 <a:latin typeface="Calibri"/>
               </a:rPr>
-              <a:t>Willie — vestibular + otitis, walking, compensated murmur</a:t>
+              <a:t>Willie: vestibular disease, otitis, walking, compensated murmur</a:t>
             </a:r>
           </a:p>
         </p:txBody>
@@ -9765,7 +9765,7 @@
                 </a:solidFill>
                 <a:latin typeface="Calibri"/>
               </a:rPr>
-              <a:t>MoMo — rising azotemia, non-functional kidney; GDV; septic abdomen</a:t>
+              <a:t>MoMo: rising azotemia, non-functional kidney; GDV; septic abdomen</a:t>
             </a:r>
           </a:p>
         </p:txBody>
@@ -10319,7 +10319,7 @@
                 </a:solidFill>
                 <a:latin typeface="Calibri"/>
               </a:rPr>
-              <a:t>SAY THE NUMBER, THEN WHETHER YOU PROCEED TODAY</a:t>
+              <a:t>ASSIGN STATUS, THEN SAY WHETHER YOU PROCEED TODAY</a:t>
             </a:r>
           </a:p>
         </p:txBody>
@@ -10395,7 +10395,7 @@
                 </a:solidFill>
                 <a:latin typeface="Calibri"/>
               </a:rPr>
-              <a:t>Assign the ASA — 60-second cases</a:t>
+              <a:t>ASA practice cases</a:t>
             </a:r>
           </a:p>
         </p:txBody>
@@ -10956,7 +10956,7 @@
                 </a:solidFill>
                 <a:latin typeface="Calibri"/>
               </a:rPr>
-              <a:t>ASA Status 3-E  ·  not ‘just dirty ears’ — next slides</a:t>
+              <a:t>ASA Status 3-E. Not an isolated otitis.</a:t>
             </a:r>
           </a:p>
         </p:txBody>
@@ -11110,7 +11110,7 @@
                 </a:solidFill>
                 <a:latin typeface="Calibri"/>
               </a:rPr>
-              <a:t>MoMo: 6 yo SF DSH, 4.25 kg. Acute vomiting ×2, lethargy, construction at home — possible FB. T 98.0 °F, HR 200, mm pink tacky. Mildly enlarged abdomen.</a:t>
+              <a:t>MoMo: 6 yo SF DSH, 4.25 kg. Acute vomiting ×2, lethargy, construction at home; possible foreign body. T 98.0 °F, HR 200, mm pink tacky. Mildly enlarged abdomen.</a:t>
             </a:r>
           </a:p>
         </p:txBody>
@@ -11432,7 +11432,7 @@
                 </a:solidFill>
                 <a:latin typeface="Calibri"/>
               </a:rPr>
-              <a:t>6 Y 11 MO MN CAVALIER KING CHARLES SPANIEL  ·  13.7 KG  ·  BCS 6/9</a:t>
+              <a:t>6 Y 11 MO MN CAVALIER KING CHARLES SPANIEL, 13.7 KG, BCS 6/9</a:t>
             </a:r>
           </a:p>
         </p:txBody>
@@ -11508,7 +11508,7 @@
                 </a:solidFill>
                 <a:latin typeface="Calibri"/>
               </a:rPr>
-              <a:t>Real ASA III case — Willie</a:t>
+              <a:t>Willie, ASA Status 3-E</a:t>
             </a:r>
           </a:p>
         </p:txBody>
@@ -11894,7 +11894,7 @@
                 </a:solidFill>
                 <a:latin typeface="Calibri"/>
               </a:rPr>
-              <a:t>Circling left. Horizontal nystagmus — fast left, slow right. Right knuckling and delayed proprioception. Wheelbarrow absent on the right. That is not a simple peripheral ear.</a:t>
+              <a:t>Circling left. Horizontal nystagmus, fast left, slow right. Right knuckling and delayed proprioception. Wheelbarrow absent on the right. That is not a simple peripheral ear.</a:t>
             </a:r>
           </a:p>
         </p:txBody>
@@ -12337,7 +12337,7 @@
                 </a:solidFill>
                 <a:latin typeface="Calibri"/>
               </a:rPr>
-              <a:t>COMPENSATED  ·  FUNCTIONAL LIMITATION  ·  ACUTE  ·  NOT A CONSTANT THREAT TO LIFE</a:t>
+              <a:t>COMPENSATED, FUNCTIONAL LIMITATION, ACUTE, NOT A CONSTANT THREAT TO LIFE</a:t>
             </a:r>
           </a:p>
         </p:txBody>
@@ -12413,7 +12413,7 @@
                 </a:solidFill>
                 <a:latin typeface="Calibri"/>
               </a:rPr>
-              <a:t>Why Willie is ASA III-E — and what we actually did</a:t>
+              <a:t>Why Willie is ASA Status 3-E</a:t>
             </a:r>
           </a:p>
         </p:txBody>
@@ -12692,7 +12692,7 @@
                 </a:solidFill>
                 <a:latin typeface="Calibri"/>
               </a:rPr>
-              <a:t>▸  Films: bullae radiographically intact, skull intact, L7–S1 discospondylosis — that does not explain acute circling.</a:t>
+              <a:t>▸  Films: bullae radiographically intact, skull intact, L7–S1 discospondylosis. That does not explain acute circling.</a:t>
             </a:r>
           </a:p>
           <a:p>
@@ -13013,7 +13013,7 @@
                 </a:solidFill>
                 <a:latin typeface="Calibri"/>
               </a:rPr>
-              <a:t>6 YO SF DSH  ·  4.25 KG  ·  BCS 5/9  ·  SAME HOSPITAL, SAME WEEK</a:t>
+              <a:t>6 YO SF DSH, 4.25 KG, BCS 5/9</a:t>
             </a:r>
           </a:p>
         </p:txBody>
@@ -13089,7 +13089,7 @@
                 </a:solidFill>
                 <a:latin typeface="Calibri"/>
               </a:rPr>
-              <a:t>Real ASA IV-E case — MoMo</a:t>
+              <a:t>MoMo, ASA Status 4-E</a:t>
             </a:r>
           </a:p>
         </p:txBody>
@@ -13167,7 +13167,7 @@
                 </a:solidFill>
                 <a:latin typeface="Calibri"/>
               </a:rPr>
-              <a:t>Acute vomiting and lethargy this morning. Two vomits (food, then liquid). Ate normally yesterday. Household construction — possible foreign material or toxin. Refused a favored treat. Vaccines uncertain; last wellness ~2 years. Vitals: T 98.0 °F, HR 200, RR 30, mm pink tacky, CRT &lt;2 s, QAR.</a:t>
+              <a:t>Acute vomiting and lethargy this morning. Two vomits (food, then liquid). Ate normally yesterday. Household construction. Possible foreign material or toxin. Refused a favored treat. Vaccines uncertain; last wellness ~2 years. Vitals: T 98.0 °F, HR 200, RR 30, mm pink tacky, CRT &lt;2 s, QAR.</a:t>
             </a:r>
           </a:p>
         </p:txBody>
@@ -13918,7 +13918,7 @@
                 </a:solidFill>
                 <a:latin typeface="Calibri"/>
               </a:rPr>
-              <a:t>UNCOMPENSATED  ·  CONSTANT THREAT  ·  ACUTE  ·  NOT A SURGICAL ABDOMEN</a:t>
+              <a:t>UNCOMPENSATED, CONSTANT THREAT, ACUTE; NOT A SURGICAL ABDOMEN</a:t>
             </a:r>
           </a:p>
         </p:txBody>
@@ -13994,7 +13994,7 @@
                 </a:solidFill>
                 <a:latin typeface="Calibri"/>
               </a:rPr>
-              <a:t>Why MoMo is ASA IV-E — and why we did not cut</a:t>
+              <a:t>Why MoMo is ASA Status 4-E</a:t>
             </a:r>
           </a:p>
         </p:txBody>
@@ -14106,7 +14106,7 @@
                 <a:latin typeface="Calibri"/>
               </a:rPr>
               <a:t>III = compensated disease you can still anesthetize with a plan.
-IV = severe systemic disease that is a constant threat — here, rising azotemia and a non-functional kidney.
+IV = severe systemic disease that is a constant threat: rising azotemia and a non-functional kidney.
 She was QAR and walking, so not ASA V (moribund).
 E = acute presentation.
 A cancelled exploratory is a successful preoperative evaluation.</a:t>
@@ -14258,7 +14258,7 @@
                 </a:solidFill>
                 <a:latin typeface="Calibri"/>
               </a:rPr>
-              <a:t>▸  Chem day 0: BUN 49.7, creatinine 3.0, phosphorus 8.0. USG 1.042 — concentrating, so this is not ‘end-stage CKD, ignore it.’</a:t>
+              <a:t>▸  Chem day 0: BUN 49.7, creatinine 3.0, phosphorus 8.0. USG 1.042 (concentrating). This is not end-stage isosthenuric CKD that can be ignored.</a:t>
             </a:r>
           </a:p>
           <a:p>
@@ -14595,7 +14595,7 @@
                 </a:solidFill>
                 <a:latin typeface="Calibri"/>
               </a:rPr>
-              <a:t>REQUEST THE MINIMUM TESTS THIS PATIENT AND THIS PROCEDURE ACTUALLY NEED</a:t>
+              <a:t>TESTS INDICATED FOR THIS PATIENT AND THIS PROCEDURE</a:t>
             </a:r>
           </a:p>
         </p:txBody>
@@ -14671,7 +14671,7 @@
                 </a:solidFill>
                 <a:latin typeface="Calibri"/>
               </a:rPr>
-              <a:t>Preoperative diagnostics — indicated, not automatic</a:t>
+              <a:t>Preoperative diagnostics</a:t>
             </a:r>
           </a:p>
         </p:txBody>
@@ -14825,7 +14825,7 @@
                 </a:solidFill>
                 <a:latin typeface="Calibri"/>
               </a:rPr>
-              <a:t>PCV/TS ± blood glucose and Azo stick is a defensible minimum. Many hospitals still run a preanesthetic chemistry/CBC — know your hospital policy and be able to defend either choice.</a:t>
+              <a:t>PCV/TS ± blood glucose and Azo stick is a defensible minimum. Many hospitals still run a preanesthetic chemistry/CBC. Know your hospital policy and be able to defend either choice.</a:t>
             </a:r>
           </a:p>
         </p:txBody>
@@ -15057,7 +15057,7 @@
                 </a:solidFill>
                 <a:latin typeface="Calibri"/>
               </a:rPr>
-              <a:t>Do not order tests you will ignore — and do not ignore tests you ordered</a:t>
+              <a:t>Do not order tests you will ignore, and do not ignore tests you ordered</a:t>
             </a:r>
           </a:p>
         </p:txBody>
@@ -15128,7 +15128,7 @@
                 </a:solidFill>
                 <a:latin typeface="Calibri"/>
               </a:rPr>
-              <a:t>▸  Large animal: stall-side PCV/TS, fibrinogen, and physical exam often outweigh a full chemistry in the field — still document the risk conversation.</a:t>
+              <a:t>▸  Large animal: stall-side PCV/TS, fibrinogen, and physical exam often outweigh a full chemistry in the field. Document the risk conversation.</a:t>
             </a:r>
           </a:p>
         </p:txBody>
@@ -15417,7 +15417,7 @@
                 </a:solidFill>
                 <a:latin typeface="Calibri"/>
               </a:rPr>
-              <a:t>WORKING TEACHING TABLE  ·  THESE BANDS INFORM STATUS; THEY DO NOT ASSIGN IT BY THEMSELVES</a:t>
+              <a:t>THESE BANDS INFORM STATUS. THEY DO NOT ASSIGN IT.</a:t>
             </a:r>
           </a:p>
         </p:txBody>
@@ -16195,7 +16195,7 @@
                 </a:solidFill>
                 <a:latin typeface="Calibri"/>
               </a:rPr>
-              <a:t>LEARNING OBJECTIVES</a:t>
+              <a:t>DVM 612 WEEK 4</a:t>
             </a:r>
           </a:p>
         </p:txBody>
@@ -16271,7 +16271,7 @@
                 </a:solidFill>
                 <a:latin typeface="Calibri"/>
               </a:rPr>
-              <a:t>By the end of this hour you will be able to</a:t>
+              <a:t>Learning objectives</a:t>
             </a:r>
           </a:p>
         </p:txBody>
@@ -16374,7 +16374,7 @@
                 </a:solidFill>
                 <a:latin typeface="Calibri"/>
               </a:rPr>
-              <a:t>▸  Write a postoperative plan, surgical report elements, and client discharge instructions — including 24-hour emergency criteria.</a:t>
+              <a:t>▸  Write a postoperative plan, surgical report elements, and client discharge instructions, including 24-hour emergency criteria.</a:t>
             </a:r>
           </a:p>
         </p:txBody>
@@ -16452,7 +16452,7 @@
                 </a:solidFill>
                 <a:latin typeface="Calibri"/>
               </a:rPr>
-              <a:t>Today is judgment, asepsis, and aftercare. Poor prep cannot be rescued by elegant suture. Willie is the patient we prepare. MoMo is the patient we do not cut.</a:t>
+              <a:t>Willie is the patient we prepare and sedate. MoMo is the patient we do not take to surgery.</a:t>
             </a:r>
           </a:p>
         </p:txBody>
@@ -16741,7 +16741,7 @@
                 </a:solidFill>
                 <a:latin typeface="Calibri"/>
               </a:rPr>
-              <a:t>LABS INFORM ASA. THE PHYSICAL EXAM STILL OWNS THE NUMBER.</a:t>
+              <a:t>LABS INFORM ASA STATUS. THE PHYSICAL EXAMINATION ASSIGNS IT.</a:t>
             </a:r>
           </a:p>
         </p:txBody>
@@ -16817,7 +16817,7 @@
                 </a:solidFill>
                 <a:latin typeface="Calibri"/>
               </a:rPr>
-              <a:t>Put both patients on the lab tables</a:t>
+              <a:t>Applying the lab tables</a:t>
             </a:r>
           </a:p>
         </p:txBody>
@@ -16938,7 +16938,7 @@
                 </a:solidFill>
                 <a:latin typeface="Calibri"/>
               </a:rPr>
-              <a:t>Willie — labs look quieter than the dog</a:t>
+              <a:t>Willie, laboratory results</a:t>
             </a:r>
           </a:p>
         </p:txBody>
@@ -16972,11 +16972,11 @@
                 <a:latin typeface="Calibri"/>
               </a:rPr>
               <a:t>CBC WNL (Status 1 band).
-Phosphorus 6.0 — mild ↑ (Status 2).
-Glucose 130 — stress (Status 2 band).
+Phosphorus 6.0, mild increase (Status 2).
+Glucose 130, stress (Status 2 band).
 Kidneys, liver, electrolytes normal.
 No EPOC indicated for this ear clean.
-ASA Status 3-E anyway: acute vestibular disease, severe AS otitis, murmur. An unremarkable chemistry does not down-stage a neurologic patient.</a:t>
+ASA Status 3-E: acute vestibular disease, severe AS otitis, murmur. An unremarkable chemistry does not down-stage a neurologic patient.</a:t>
             </a:r>
           </a:p>
         </p:txBody>
@@ -17097,7 +17097,7 @@
                 </a:solidFill>
                 <a:latin typeface="Calibri"/>
               </a:rPr>
-              <a:t>MoMo — labs and EPOC support Status 4-E</a:t>
+              <a:t>MoMo, laboratory results and EPOC</a:t>
             </a:r>
           </a:p>
         </p:txBody>
@@ -17130,13 +17130,13 @@
                 </a:solidFill>
                 <a:latin typeface="Calibri"/>
               </a:rPr>
-              <a:t>WBC ~26K with neutrophilia — Status 3–4 inflammatory band.
-Platelets 74 K — Status 3.
-Creatinine 3.0 → 4.71; BUN 49.7 → 100 — Status 4 (severe ↑ + uremia).
-Phosphorus 8.0 — Status 3–4.
+              <a:t>WBC about 26K with neutrophilia (Status 3 to 4 inflammatory band).
+Platelets 74 K (Status 3).
+Creatinine 3.0 to 4.71; BUN 49.7 to 100 (Status 4).
+Phosphorus 8.0 (Status 3 to 4).
 EPOC pH 7.255 (Status 3); BE −7.4 (Status 2); lactate 2.05 (Status 1).
 Venous pO2 33 is not arterial hypoxemia.
-Whole patient = Status 4-E. Do not cut.</a:t>
+Whole-patient status is 4-E. Do not induce.</a:t>
             </a:r>
           </a:p>
         </p:txBody>
@@ -17425,7 +17425,7 @@
                 </a:solidFill>
                 <a:latin typeface="Calibri"/>
               </a:rPr>
-              <a:t>ELECTIVE SURGERY IS CANCELLED MORE OFTEN BY GOOD JUDGMENT THAN BY BAD LUCK</a:t>
+              <a:t>WHEN TO DELAY, WHEN TO PROCEED URGENTLY</a:t>
             </a:r>
           </a:p>
         </p:txBody>
@@ -17501,7 +17501,7 @@
                 </a:solidFill>
                 <a:latin typeface="Calibri"/>
               </a:rPr>
-              <a:t>Stabilize before you sterilize</a:t>
+              <a:t>Stabilization before elective surgery</a:t>
             </a:r>
           </a:p>
         </p:txBody>
@@ -18270,7 +18270,7 @@
                 </a:solidFill>
                 <a:latin typeface="Calibri"/>
               </a:rPr>
-              <a:t>KNOW BOTH: FOSSUM/TRADITIONAL LANGUAGE AND AAHA-STYLE SHORTER FASTS</a:t>
+              <a:t>AAHA 4 TO 6 HOURS IN HEALTHY DOGS AND CATS; FOSSUM-ERA 8 TO 12 HOURS STILL USED IN SOME HOSPITALS</a:t>
             </a:r>
           </a:p>
         </p:txBody>
@@ -18346,7 +18346,7 @@
                 </a:solidFill>
                 <a:latin typeface="Calibri"/>
               </a:rPr>
-              <a:t>Fasting — traditional teaching vs. current practice</a:t>
+              <a:t>Preoperative fasting</a:t>
             </a:r>
           </a:p>
         </p:txBody>
@@ -18479,7 +18479,7 @@
                 </a:solidFill>
                 <a:latin typeface="Calibri"/>
               </a:rPr>
-              <a:t>▸  Traditional/Fossum-era: often 8–12 h NPO — still used in some hospitals; be able to discuss aspiration versus hypoglycemia.</a:t>
+              <a:t>▸  Traditional/Fossum-era: often 8–12 h NPO, still used in some hospitals. Discuss aspiration versus hypoglycemia.</a:t>
             </a:r>
           </a:p>
           <a:p>
@@ -18543,7 +18543,7 @@
                 </a:solidFill>
                 <a:latin typeface="Calibri"/>
               </a:rPr>
-              <a:t>▸  Horses: typically 8–12 h grain/hay protocols vary — follow hospital/field SOP.</a:t>
+              <a:t>▸  Horses: typically 8–12 h grain/hay protocols vary. Follow the hospital or field SOP.</a:t>
             </a:r>
           </a:p>
         </p:txBody>
@@ -18724,7 +18724,7 @@
                 </a:solidFill>
                 <a:latin typeface="Calibri"/>
               </a:rPr>
-              <a:t>▸  Diabetics: coordinate insulin and a small meal with anesthesia — do not improvise.</a:t>
+              <a:t>▸  Diabetics: coordinate insulin and a small meal with anesthesia. Do not improvise.</a:t>
             </a:r>
           </a:p>
         </p:txBody>
@@ -19013,7 +19013,7 @@
                 </a:solidFill>
                 <a:latin typeface="Calibri"/>
               </a:rPr>
-              <a:t>IF YOU DID NOT SAY IT, YOU DID NOT CONSENT</a:t>
+              <a:t>PROCEDURE, RISKS, ALTERNATIVES, ESTIMATE, RESUSCITATION CODE</a:t>
             </a:r>
           </a:p>
         </p:txBody>
@@ -19089,7 +19089,7 @@
                 </a:solidFill>
                 <a:latin typeface="Calibri"/>
               </a:rPr>
-              <a:t>Informed consent is a surgical skill</a:t>
+              <a:t>Informed consent</a:t>
             </a:r>
           </a:p>
         </p:txBody>
@@ -19160,7 +19160,7 @@
                 </a:solidFill>
                 <a:latin typeface="Calibri"/>
               </a:rPr>
-              <a:t>▸  Material risks: anesthesia death (rare but real), hemorrhage, infection, dehiscence, incomplete excision, recurrence. Urinary incontinence after OHE is a real risk in some bitches, especially large-breed — quote it; do not omit it and do not inflate it.</a:t>
+              <a:t>▸  Material risks: anesthesia death (rare but real), hemorrhage, infection, dehiscence, incomplete excision, recurrence. Urinary incontinence after OHE is a real risk in some bitches, especially large-breed bitches. State the risk. Do not omit it and do not inflate it.</a:t>
             </a:r>
           </a:p>
           <a:p>
@@ -19286,7 +19286,7 @@
                 </a:solidFill>
                 <a:latin typeface="Calibri"/>
               </a:rPr>
-              <a:t>Client in the lobby</a:t>
+              <a:t>Client-owned patients</a:t>
             </a:r>
           </a:p>
         </p:txBody>
@@ -19320,7 +19320,7 @@
                 <a:latin typeface="Calibri"/>
               </a:rPr>
               <a:t>Assume every OHE is a client-owned animal going home after recovery in your hospital.
-Operate, document, and speak as if that client is waiting in reception — because they are.</a:t>
+Operate, document, and speak as if that client is waiting in reception.</a:t>
             </a:r>
           </a:p>
         </p:txBody>
@@ -19609,7 +19609,7 @@
                 </a:solidFill>
                 <a:latin typeface="Calibri"/>
               </a:rPr>
-              <a:t>PAIN IS NOT A POSTOPERATIVE SURPRISE</a:t>
+              <a:t>WHO-ADAPTED TIMEOUT AND MULTIMODAL PLAN</a:t>
             </a:r>
           </a:p>
         </p:txBody>
@@ -19685,7 +19685,7 @@
                 </a:solidFill>
                 <a:latin typeface="Calibri"/>
               </a:rPr>
-              <a:t>Checklist and the analgesia plan belong in preop</a:t>
+              <a:t>Pre-incision checklist and analgesia</a:t>
             </a:r>
           </a:p>
         </p:txBody>
@@ -20008,7 +20008,7 @@
                 </a:solidFill>
                 <a:latin typeface="Calibri"/>
               </a:rPr>
-              <a:t>Multimodal analgesia — plan it now</a:t>
+              <a:t>Multimodal analgesia</a:t>
             </a:r>
           </a:p>
         </p:txBody>
@@ -20063,7 +20063,7 @@
                 </a:solidFill>
                 <a:latin typeface="Calibri"/>
               </a:rPr>
-              <a:t>▸  NSAID if perfusion and kidneys/GI allow — often at recovery, not in hypotensive shock.</a:t>
+              <a:t>▸  NSAID if perfusion, kidneys, and GI tract allow. Often given at recovery, not during hypotensive shock.</a:t>
             </a:r>
           </a:p>
           <a:p>
@@ -20416,7 +20416,7 @@
                 </a:solidFill>
                 <a:latin typeface="Calibri"/>
               </a:rPr>
-              <a:t>IF IT IS NOT HERE BEFORE INDUCTION, YOU ARE NOT READY</a:t>
+              <a:t>CONFIRM BEFORE INDUCTION</a:t>
             </a:r>
           </a:p>
         </p:txBody>
@@ -20492,7 +20492,7 @@
                 </a:solidFill>
                 <a:latin typeface="Calibri"/>
               </a:rPr>
-              <a:t>What must be in the room</a:t>
+              <a:t>Equipment and supplies</a:t>
             </a:r>
           </a:p>
         </p:txBody>
@@ -20805,7 +20805,7 @@
                 </a:solidFill>
                 <a:latin typeface="Calibri"/>
               </a:rPr>
-              <a:t>FILL IT BEFORE THE FIRST DRUG  ·  THIS IS A TEACHING FORM, NOT A HOSPITAL ORIGINAL</a:t>
+              <a:t>TEACHING FORM. COMPLETE THE HEADER BEFORE THE FIRST DRUG.</a:t>
             </a:r>
           </a:p>
         </p:txBody>
@@ -20881,7 +20881,7 @@
                 </a:solidFill>
                 <a:latin typeface="Calibri"/>
               </a:rPr>
-              <a:t>Anesthesia / sedation record — Willie</a:t>
+              <a:t>Anesthesia record, Willie</a:t>
             </a:r>
           </a:p>
         </p:txBody>
@@ -21194,7 +21194,7 @@
                 </a:solidFill>
                 <a:latin typeface="Calibri"/>
               </a:rPr>
-              <a:t>A COMPLETED PREOPERATIVE EVALUATION CAN END WITH DO NOT INDUCE</a:t>
+              <a:t>PREOPERATIVE EVALUATION DOCUMENTED; INDUCTION CANCELLED</a:t>
             </a:r>
           </a:p>
         </p:txBody>
@@ -21270,7 +21270,7 @@
                 </a:solidFill>
                 <a:latin typeface="Calibri"/>
               </a:rPr>
-              <a:t>The same record — MoMo</a:t>
+              <a:t>Anesthesia record, MoMo</a:t>
             </a:r>
           </a:p>
         </p:txBody>
@@ -21659,7 +21659,7 @@
                 </a:solidFill>
                 <a:latin typeface="Calibri"/>
               </a:rPr>
-              <a:t>Surgical antimicrobial prophylaxis — stewardship, not ritual</a:t>
+              <a:t>Surgical antimicrobial prophylaxis</a:t>
             </a:r>
           </a:p>
         </p:txBody>
@@ -21853,7 +21853,7 @@
                 </a:solidFill>
                 <a:latin typeface="Calibri"/>
               </a:rPr>
-              <a:t>YES — timed IV, then stop</a:t>
+              <a:t>Indicated: timed IV, then stop</a:t>
             </a:r>
           </a:p>
         </p:txBody>
@@ -21893,7 +21893,7 @@
 • Hollow viscus entry
 • Surgery &gt;90 minutes or a known break in asepsis
 • Patient immunocompromised
-• Infection would be catastrophic (some neuro/implant cases — still think, don’t reflex)</a:t>
+• Infection would be catastrophic (some neurologic or implant cases. Decide case by case; do not give prophylaxis by habit)</a:t>
             </a:r>
           </a:p>
         </p:txBody>
@@ -22156,40 +22156,7 @@
       </p:sp>
       <p:sp>
         <p:nvSpPr>
-          <p:cNvPr id="5" name="TextBox 4"/>
-          <p:cNvSpPr txBox="1"/>
-          <p:nvPr/>
-        </p:nvSpPr>
-        <p:spPr>
-          <a:xfrm>
-            <a:off x="457200" y="256032"/>
-            <a:ext cx="11247120" cy="256032"/>
-          </a:xfrm>
-          <a:prstGeom prst="rect">
-            <a:avLst/>
-          </a:prstGeom>
-          <a:noFill/>
-        </p:spPr>
-        <p:txBody>
-          <a:bodyPr wrap="square" anchor="t"/>
-          <a:lstStyle/>
-          <a:p>
-            <a:pPr algn="l"/>
-            <a:r>
-              <a:rPr sz="1100" b="1">
-                <a:solidFill>
-                  <a:srgbClr val="1B6B7A"/>
-                </a:solidFill>
-                <a:latin typeface="Calibri"/>
-              </a:rPr>
-              <a:t>ANSWER BEFORE WE WALK TO THE PREP ROOM</a:t>
-            </a:r>
-          </a:p>
-        </p:txBody>
-      </p:sp>
-      <p:sp>
-        <p:nvSpPr>
-          <p:cNvPr id="6" name="Rectangle 5"/>
+          <p:cNvPr id="5" name="Rectangle 4"/>
           <p:cNvSpPr/>
           <p:nvPr/>
         </p:nvSpPr>
@@ -22232,7 +22199,7 @@
       </p:sp>
       <p:sp>
         <p:nvSpPr>
-          <p:cNvPr id="7" name="TextBox 6"/>
+          <p:cNvPr id="6" name="TextBox 5"/>
           <p:cNvSpPr txBox="1"/>
           <p:nvPr/>
         </p:nvSpPr>
@@ -22258,14 +22225,14 @@
                 </a:solidFill>
                 <a:latin typeface="Calibri"/>
               </a:rPr>
-              <a:t>Knowledge check — preoperative</a:t>
-            </a:r>
-          </a:p>
-        </p:txBody>
-      </p:sp>
-      <p:sp>
-        <p:nvSpPr>
-          <p:cNvPr id="8" name="Rounded Rectangle 7"/>
+              <a:t>Knowledge check: preoperative evaluation</a:t>
+            </a:r>
+          </a:p>
+        </p:txBody>
+      </p:sp>
+      <p:sp>
+        <p:nvSpPr>
+          <p:cNvPr id="7" name="Rounded Rectangle 6"/>
           <p:cNvSpPr/>
           <p:nvPr/>
         </p:nvSpPr>
@@ -22310,7 +22277,7 @@
       </p:sp>
       <p:sp>
         <p:nvSpPr>
-          <p:cNvPr id="9" name="Rectangle 8"/>
+          <p:cNvPr id="8" name="Rectangle 7"/>
           <p:cNvSpPr/>
           <p:nvPr/>
         </p:nvSpPr>
@@ -22353,7 +22320,7 @@
       </p:sp>
       <p:sp>
         <p:nvSpPr>
-          <p:cNvPr id="10" name="TextBox 9"/>
+          <p:cNvPr id="9" name="TextBox 8"/>
           <p:cNvSpPr txBox="1"/>
           <p:nvPr/>
         </p:nvSpPr>
@@ -22386,7 +22353,7 @@
       </p:sp>
       <p:sp>
         <p:nvSpPr>
-          <p:cNvPr id="11" name="TextBox 10"/>
+          <p:cNvPr id="10" name="TextBox 9"/>
           <p:cNvSpPr txBox="1"/>
           <p:nvPr/>
         </p:nvSpPr>
@@ -22419,7 +22386,7 @@
       </p:sp>
       <p:sp>
         <p:nvSpPr>
-          <p:cNvPr id="12" name="TextBox 11"/>
+          <p:cNvPr id="11" name="TextBox 10"/>
           <p:cNvSpPr txBox="1"/>
           <p:nvPr/>
         </p:nvSpPr>
@@ -22452,7 +22419,7 @@
       </p:sp>
       <p:sp>
         <p:nvSpPr>
-          <p:cNvPr id="13" name="Rounded Rectangle 12"/>
+          <p:cNvPr id="12" name="Rounded Rectangle 11"/>
           <p:cNvSpPr/>
           <p:nvPr/>
         </p:nvSpPr>
@@ -22497,7 +22464,7 @@
       </p:sp>
       <p:sp>
         <p:nvSpPr>
-          <p:cNvPr id="14" name="Rectangle 13"/>
+          <p:cNvPr id="13" name="Rectangle 12"/>
           <p:cNvSpPr/>
           <p:nvPr/>
         </p:nvSpPr>
@@ -22540,7 +22507,7 @@
       </p:sp>
       <p:sp>
         <p:nvSpPr>
-          <p:cNvPr id="15" name="TextBox 14"/>
+          <p:cNvPr id="14" name="TextBox 13"/>
           <p:cNvSpPr txBox="1"/>
           <p:nvPr/>
         </p:nvSpPr>
@@ -22573,7 +22540,7 @@
       </p:sp>
       <p:sp>
         <p:nvSpPr>
-          <p:cNvPr id="16" name="TextBox 15"/>
+          <p:cNvPr id="15" name="TextBox 14"/>
           <p:cNvSpPr txBox="1"/>
           <p:nvPr/>
         </p:nvSpPr>
@@ -22606,7 +22573,7 @@
       </p:sp>
       <p:sp>
         <p:nvSpPr>
-          <p:cNvPr id="17" name="TextBox 16"/>
+          <p:cNvPr id="16" name="TextBox 15"/>
           <p:cNvSpPr txBox="1"/>
           <p:nvPr/>
         </p:nvSpPr>
@@ -22639,7 +22606,7 @@
       </p:sp>
       <p:sp>
         <p:nvSpPr>
-          <p:cNvPr id="18" name="Rounded Rectangle 17"/>
+          <p:cNvPr id="17" name="Rounded Rectangle 16"/>
           <p:cNvSpPr/>
           <p:nvPr/>
         </p:nvSpPr>
@@ -22684,7 +22651,7 @@
       </p:sp>
       <p:sp>
         <p:nvSpPr>
-          <p:cNvPr id="19" name="Rectangle 18"/>
+          <p:cNvPr id="18" name="Rectangle 17"/>
           <p:cNvSpPr/>
           <p:nvPr/>
         </p:nvSpPr>
@@ -22727,7 +22694,7 @@
       </p:sp>
       <p:sp>
         <p:nvSpPr>
-          <p:cNvPr id="20" name="TextBox 19"/>
+          <p:cNvPr id="19" name="TextBox 18"/>
           <p:cNvSpPr txBox="1"/>
           <p:nvPr/>
         </p:nvSpPr>
@@ -22760,7 +22727,7 @@
       </p:sp>
       <p:sp>
         <p:nvSpPr>
-          <p:cNvPr id="21" name="TextBox 20"/>
+          <p:cNvPr id="20" name="TextBox 19"/>
           <p:cNvSpPr txBox="1"/>
           <p:nvPr/>
         </p:nvSpPr>
@@ -22793,7 +22760,7 @@
       </p:sp>
       <p:sp>
         <p:nvSpPr>
-          <p:cNvPr id="22" name="TextBox 21"/>
+          <p:cNvPr id="21" name="TextBox 20"/>
           <p:cNvSpPr txBox="1"/>
           <p:nvPr/>
         </p:nvSpPr>
@@ -22826,7 +22793,7 @@
       </p:sp>
       <p:sp>
         <p:nvSpPr>
-          <p:cNvPr id="23" name="Rectangle 22"/>
+          <p:cNvPr id="22" name="Rectangle 21"/>
           <p:cNvSpPr/>
           <p:nvPr/>
         </p:nvSpPr>
@@ -22869,7 +22836,7 @@
       </p:sp>
       <p:sp>
         <p:nvSpPr>
-          <p:cNvPr id="24" name="TextBox 23"/>
+          <p:cNvPr id="23" name="TextBox 22"/>
           <p:cNvSpPr txBox="1"/>
           <p:nvPr/>
         </p:nvSpPr>
@@ -22902,7 +22869,7 @@
       </p:sp>
       <p:sp>
         <p:nvSpPr>
-          <p:cNvPr id="25" name="TextBox 24"/>
+          <p:cNvPr id="24" name="TextBox 23"/>
           <p:cNvSpPr txBox="1"/>
           <p:nvPr/>
         </p:nvSpPr>
@@ -23108,7 +23075,7 @@
                 </a:solidFill>
                 <a:latin typeface="Calibri"/>
               </a:rPr>
-              <a:t>HOW WE WILL SPEND THE HOUR</a:t>
+              <a:t>60 MINUTES</a:t>
             </a:r>
           </a:p>
         </p:txBody>
@@ -23184,7 +23151,7 @@
                 </a:solidFill>
                 <a:latin typeface="Calibri"/>
               </a:rPr>
-              <a:t>Sixty-minute plan</a:t>
+              <a:t>Hour plan</a:t>
             </a:r>
           </a:p>
         </p:txBody>
@@ -23338,7 +23305,7 @@
                 </a:solidFill>
                 <a:latin typeface="Calibri"/>
               </a:rPr>
-              <a:t>Frame + Halsted as the through-line</a:t>
+              <a:t>Introduction and Halsted’s principles</a:t>
             </a:r>
           </a:p>
         </p:txBody>
@@ -23646,7 +23613,7 @@
                 </a:solidFill>
                 <a:latin typeface="Calibri"/>
               </a:rPr>
-              <a:t>II. Patient and surgeon preparation — with pictures</a:t>
+              <a:t>II. Patient and surgeon preparation</a:t>
             </a:r>
           </a:p>
         </p:txBody>
@@ -24601,7 +24568,7 @@
                 </a:solidFill>
                 <a:latin typeface="Calibri"/>
               </a:rPr>
-              <a:t>THE SAME SIX BOXES EVERY TIME YOU TAKE A PATIENT TO SURGERY</a:t>
+              <a:t>HAIR, SKIN, POSITIONING, SCRUB, GOWN AND GLOVE, DRAPE</a:t>
             </a:r>
           </a:p>
         </p:txBody>
@@ -24677,7 +24644,7 @@
                 </a:solidFill>
                 <a:latin typeface="Calibri"/>
               </a:rPr>
-              <a:t>What we actually check in patient and surgeon prep</a:t>
+              <a:t>Patient and surgeon preparation</a:t>
             </a:r>
           </a:p>
         </p:txBody>
@@ -25956,7 +25923,7 @@
                 </a:solidFill>
                 <a:latin typeface="Calibri"/>
               </a:rPr>
-              <a:t>PREP ROOM IS DIRTY. OR IS STERILE. THE DOG MOVES ONCE.</a:t>
+              <a:t>PREP ROOM, THEN OPERATING ROOM</a:t>
             </a:r>
           </a:p>
         </p:txBody>
@@ -26032,7 +25999,7 @@
                 </a:solidFill>
                 <a:latin typeface="Calibri"/>
               </a:rPr>
-              <a:t>Sequence — do not invert the rooms</a:t>
+              <a:t>Sequence of patient preparation</a:t>
             </a:r>
           </a:p>
         </p:txBody>
@@ -26802,7 +26769,7 @@
                 </a:solidFill>
                 <a:latin typeface="Calibri"/>
               </a:rPr>
-              <a:t>Sterile prep (gloved). PVP-I 5 min wet contact. Mucosa/eye: 1 to 20 – 1 to 50</a:t>
+              <a:t>Sterile prep (gloved). PVP-I 5 min wet contact. Mucosa/eye: 1 to 20 to 1 to 50</a:t>
             </a:r>
           </a:p>
         </p:txBody>
@@ -27553,7 +27520,7 @@
                 </a:solidFill>
                 <a:latin typeface="Calibri"/>
               </a:rPr>
-              <a:t>REAL CLINIC PHOTOGRAPHS  ·  #40 CLIPPER, NOT RAZOR  ·  FIELD WIDE ENOUGH TO EXTEND</a:t>
+              <a:t>#40 CLIPPER AFTER INDUCTION. FIELD 20 CM BEYOND THE PLANNED INCISION.</a:t>
             </a:r>
           </a:p>
         </p:txBody>
@@ -27629,7 +27596,7 @@
                 </a:solidFill>
                 <a:latin typeface="Calibri"/>
               </a:rPr>
-              <a:t>Hair removal — clip after induction, not last night</a:t>
+              <a:t>Hair removal</a:t>
             </a:r>
           </a:p>
         </p:txBody>
@@ -27707,7 +27674,7 @@
                 </a:solidFill>
                 <a:latin typeface="Calibri"/>
               </a:rPr>
-              <a:t>Too narrow — hair still at the margin</a:t>
+              <a:t>Too narrow. Hair remains at the margin.</a:t>
             </a:r>
           </a:p>
         </p:txBody>
@@ -27809,7 +27776,7 @@
                 </a:solidFill>
                 <a:latin typeface="Calibri"/>
               </a:rPr>
-              <a:t>24 h after OHE — this is the clip you needed</a:t>
+              <a:t>24 hours after OHE. Clip width was adequate.</a:t>
             </a:r>
           </a:p>
         </p:txBody>
@@ -27911,7 +27878,7 @@
                 </a:solidFill>
                 <a:latin typeface="Calibri"/>
               </a:rPr>
-              <a:t>Xiphoid, or slightly cranial to it, to the pubis, and widely lateral past the nipples — a rectangle, not a narrow strip of hair. Clip with the grain, then against, to the skin. Vacuum. 20 cm beyond the planned incision. Do not clip the night before. Razors create micro-nicks and raise SSI risk. Airway in and a surgical plane before the clippers start.
+              <a:t>Xiphoid, or slightly cranial to it, to the pubis, and widely lateral past the nipples. Clip a rectangle, not a narrow strip of hair. Clip with the grain, then against, to the skin. Vacuum. 20 cm beyond the planned incision. Do not clip the night before. Razors create micro-nicks and raise SSI risk. Airway in and a surgical plane before the clippers start.
 Photos: Uwe Gille, CC0 (cat clip); Liannadavis, CC BY-SA 4.0 (OHE incision).</a:t>
             </a:r>
           </a:p>
@@ -28201,7 +28168,7 @@
                 </a:solidFill>
                 <a:latin typeface="Calibri"/>
               </a:rPr>
-              <a:t>IF YOU CANNOT DESCRIBE THE FIELD, YOU ARE NOT READY TO CUT</a:t>
+              <a:t>OHE, CASTRATION, ORTHOPEDIC, FIELD SURGERY</a:t>
             </a:r>
           </a:p>
         </p:txBody>
@@ -28277,7 +28244,7 @@
                 </a:solidFill>
                 <a:latin typeface="Calibri"/>
               </a:rPr>
-              <a:t>Know the field before you pick up the clippers</a:t>
+              <a:t>Clip fields</a:t>
             </a:r>
           </a:p>
         </p:txBody>
@@ -28585,7 +28552,7 @@
                 </a:solidFill>
                 <a:latin typeface="Calibri"/>
               </a:rPr>
-              <a:t>Scrotum ± prescrotal abdomen; some surgeons shave scrotum, some don’t — follow your hospital SOP. Clip wide enough for drape.</a:t>
+              <a:t>Scrotum ± prescrotal abdomen; some surgeons shave scrotum, some do not. Follow your hospital SOP. Clip wide enough for drape.</a:t>
             </a:r>
           </a:p>
         </p:txBody>
@@ -29490,7 +29457,7 @@
                 </a:solidFill>
                 <a:latin typeface="Calibri"/>
               </a:rPr>
-              <a:t>THIS IS DVM 612, NOT A CLIENT HANDOUT. YOU ARE THE VETERINARIAN AT THE TABLE.</a:t>
+              <a:t>CONCENTRATIONS, DILUTION, AND CONTACT TIMES</a:t>
             </a:r>
           </a:p>
         </p:txBody>
@@ -29566,7 +29533,7 @@
                 </a:solidFill>
                 <a:latin typeface="Calibri"/>
               </a:rPr>
-              <a:t>Skin antiseptics — you mix the iodine. Memorize the ratio.</a:t>
+              <a:t>Skin antiseptics</a:t>
             </a:r>
           </a:p>
         </p:txBody>
@@ -29799,7 +29766,7 @@
                 </a:solidFill>
                 <a:latin typeface="Calibri"/>
               </a:rPr>
-              <a:t>Chlorhexidine — 3 minutes</a:t>
+              <a:t>Chlorhexidine (3 min)</a:t>
             </a:r>
           </a:p>
         </p:txBody>
@@ -29959,7 +29926,7 @@
                 </a:solidFill>
                 <a:latin typeface="Calibri"/>
               </a:rPr>
-              <a:t>Povidone-iodine — 5 minutes</a:t>
+              <a:t>Povidone-iodine (5 min)</a:t>
             </a:r>
           </a:p>
         </p:txBody>
@@ -29995,7 +29962,7 @@
               <a:t>Intact skin: 7.5% scrub, lather 5 minutes, rinse, paint 10% solution, dry before you drape. Do not invent a skin dilution.
 Mucosa / eye / prepuce: 10% SOLUTION only, 1 to 20 to 1 to 50.
 Eye at 1:50: 2-minute scrub + 2-minute soak.
-Organic matter inactivates it — dirty prep first.
+Organic matter inactivates it. Complete the dirty prep first.
 Not sporicidal at 5 minutes. Residual 90 minutes after dry. Hypersensitivity. Stains.</a:t>
             </a:r>
           </a:p>
@@ -30117,7 +30084,7 @@
                 </a:solidFill>
                 <a:latin typeface="Calibri"/>
               </a:rPr>
-              <a:t>Alcohol — 30 seconds</a:t>
+              <a:t>Alcohol (30 sec)</a:t>
             </a:r>
           </a:p>
         </p:txBody>
@@ -30151,7 +30118,7 @@
                 <a:latin typeface="Calibri"/>
               </a:rPr>
               <a:t>70% isopropyl or ethyl: 30 seconds, then dry. No residual.
-Flammable — no pooling near cautery.
+Flammable. Do not pool near cautery.
 Rinse or paint between CHG cycles on intact skin.
 Not for open wounds, mucous membranes, or the eye.
 Hydrogen peroxide is not a surgical antiseptic.</a:t>
@@ -30443,7 +30410,7 @@
                 </a:solidFill>
                 <a:latin typeface="Calibri"/>
               </a:rPr>
-              <a:t>TECHNIQUE DIAGRAM  ·  CENTER → PERIPHERY  ·  REAL PHOTOS ARE ON THE CLIP AND DRAPE SLIDES</a:t>
+              <a:t>CENTER TO PERIPHERY. DIRTY PREP, THEN STERILE PREP.</a:t>
             </a:r>
           </a:p>
         </p:txBody>
@@ -30519,7 +30486,7 @@
                 </a:solidFill>
                 <a:latin typeface="Calibri"/>
               </a:rPr>
-              <a:t>How to scrub the patient</a:t>
+              <a:t>Patient skin preparation technique</a:t>
             </a:r>
           </a:p>
         </p:txBody>
@@ -30692,7 +30659,7 @@
                 </a:solidFill>
                 <a:latin typeface="Calibri"/>
               </a:rPr>
-              <a:t>▸  PVP-I: 5 minutes wet contact, rinse, paint 10% solution, dry. Aqueous CHG: 3 minutes. Damp-to-dry, not a lake.</a:t>
+              <a:t>▸  PVP-I: 5 minutes wet contact, rinse, paint 10% solution, dry. Aqueous CHG: 3 minutes. Do not leave a pool of antiseptic.</a:t>
             </a:r>
           </a:p>
           <a:p>
@@ -30724,7 +30691,7 @@
                 </a:solidFill>
                 <a:latin typeface="Calibri"/>
               </a:rPr>
-              <a:t>▸  Never CHG in the eye or middle ear — Willie’s swollen drum.</a:t>
+              <a:t>▸  Never CHG in the eye or middle ear. Willie has a swollen tympanic membrane.</a:t>
             </a:r>
           </a:p>
         </p:txBody>
@@ -31013,7 +30980,7 @@
                 </a:solidFill>
                 <a:latin typeface="Calibri"/>
               </a:rPr>
-              <a:t>REAL OR PHOTOGRAPH  ·  DORSAL RECUMBENCY, AIRWAY, IV, MONITORING, V-TROUGH</a:t>
+              <a:t>DORSAL RECUMBENCY, AIRWAY, IV CATHETER, MONITORING, V-TROUGH</a:t>
             </a:r>
           </a:p>
         </p:txBody>
@@ -31089,7 +31056,7 @@
                 </a:solidFill>
                 <a:latin typeface="Calibri"/>
               </a:rPr>
-              <a:t>Positioning is physiology, not just ‘on its back’</a:t>
+              <a:t>Patient positioning</a:t>
             </a:r>
           </a:p>
         </p:txBody>
@@ -31191,7 +31158,7 @@
                 </a:solidFill>
                 <a:latin typeface="Calibri"/>
               </a:rPr>
-              <a:t>Name what you see</a:t>
+              <a:t>Visible in this photograph</a:t>
             </a:r>
           </a:p>
         </p:txBody>
@@ -31229,7 +31196,7 @@
 • Anesthesia machine
 • V-trough / padding
 • Ties that are not tourniquets
-• Abdomen not yet clipped — that is next, after a surgical plane
+• Abdomen not yet clipped. Clip after a surgical plane of anesthesia
 Do not over-split the hips.
 Eyes lubricated. Tube not kinked.
 Photo: Anja, CC BY-SA 4.0.</a:t>
@@ -31521,7 +31488,7 @@
                 </a:solidFill>
                 <a:latin typeface="Calibri"/>
               </a:rPr>
-              <a:t>REAL CLINIC PHOTOGRAPHS  ·  GOWN, GLOVE, BOX THE FIELD, THEN THE LARGE DRAPE</a:t>
+              <a:t>FOUR-QUADRANT TOWELS, THEN THE LARGE DRAPE. HAIR MUST NOT SHOW AT THE EDGE.</a:t>
             </a:r>
           </a:p>
         </p:txBody>
@@ -31597,7 +31564,7 @@
                 </a:solidFill>
                 <a:latin typeface="Calibri"/>
               </a:rPr>
-              <a:t>Draping — hair at the edge fails the prep</a:t>
+              <a:t>Draping</a:t>
             </a:r>
           </a:p>
         </p:txBody>
@@ -31675,7 +31642,7 @@
                 </a:solidFill>
                 <a:latin typeface="Calibri"/>
               </a:rPr>
-              <a:t>Real OHE — hair still at the drape</a:t>
+              <a:t>OHE: hair visible at the drape edge</a:t>
             </a:r>
           </a:p>
         </p:txBody>
@@ -31777,7 +31744,7 @@
                 </a:solidFill>
                 <a:latin typeface="Calibri"/>
               </a:rPr>
-              <a:t>Real sterile field — gown, glove, drape</a:t>
+              <a:t>Sterile field: gown, glove, drape</a:t>
             </a:r>
           </a:p>
         </p:txBody>
@@ -31879,7 +31846,7 @@
                 </a:solidFill>
                 <a:latin typeface="Calibri"/>
               </a:rPr>
-              <a:t>Four towels box the field (near towel first). Hair must not show at any edge — re-clip or re-drape. Large drape over towels; cuff your hands. Wet-through is contaminated. Hands stay on the field.
+              <a:t>Four towels box the field (near towel first). Hair must not show at any edge. Re-clip or re-drape. Large drape over towels; cuff your hands. Wet-through is contaminated. Hands stay on the field.
 Photos: Cpl. Samuel A. Nasso, U.S. Marine Corps, public domain (left); MSgt Carlotta Holley, U.S. Air Force, public domain (right).</a:t>
             </a:r>
           </a:p>
@@ -32169,7 +32136,7 @@
                 </a:solidFill>
                 <a:latin typeface="Calibri"/>
               </a:rPr>
-              <a:t>DIAGRAM FOR THE GLOVE  ·  PHOTOGRAPH FOR THE MACHINE</a:t>
+              <a:t>TECHNIQUE DIAGRAM AND OPERATING-ROOM PHOTOGRAPH</a:t>
             </a:r>
           </a:p>
         </p:txBody>
@@ -32245,7 +32212,7 @@
                 </a:solidFill>
                 <a:latin typeface="Calibri"/>
               </a:rPr>
-              <a:t>Closed gloving and a real anesthesia workstation</a:t>
+              <a:t>Closed gloving and the anesthesia workstation</a:t>
             </a:r>
           </a:p>
         </p:txBody>
@@ -32371,7 +32338,7 @@
                 </a:solidFill>
                 <a:latin typeface="Calibri"/>
               </a:rPr>
-              <a:t>Left: closed-gloving technique diagram (hands stay inside the gown cuffs). Right: real K9 anesthesia — cap, mask, ECG/SpO2/ETCO2 monitors, circle system, IV fluids, airway. Monitoring is on before the first drug. Willie needed this for an ear clean. MoMo never reached induction.
+              <a:t>Left: closed-gloving technique diagram (hands stay inside the gown cuffs). Right: working K9 anesthesia: cap, mask, ECG/SpO2/ETCO2 monitors, circle system, IV fluids, airway. Monitoring is on before the first drug. Willie needed this for an ear clean. MoMo never reached induction.
 Photo: MSgt Carlotta Holley, U.S. Air Force, public domain.</a:t>
             </a:r>
           </a:p>
@@ -32661,7 +32628,7 @@
                 </a:solidFill>
                 <a:latin typeface="Calibri"/>
               </a:rPr>
-              <a:t>SURGICAL SITE INFECTION, HARM, AND PROFESSIONAL STANDARD</a:t>
+              <a:t>PREOPERATIVE EVALUATION, PREPARATION, POSTOPERATIVE CARE</a:t>
             </a:r>
           </a:p>
         </p:txBody>
@@ -32737,7 +32704,7 @@
                 </a:solidFill>
                 <a:latin typeface="Calibri"/>
               </a:rPr>
-              <a:t>Why this hour is not optional</a:t>
+              <a:t>Surgical site infection</a:t>
             </a:r>
           </a:p>
         </p:txBody>
@@ -32858,7 +32825,7 @@
                 </a:solidFill>
                 <a:latin typeface="Calibri"/>
               </a:rPr>
-              <a:t>Most SSIs are preventable</a:t>
+              <a:t>Causes of SSI</a:t>
             </a:r>
           </a:p>
         </p:txBody>
@@ -32891,7 +32858,7 @@
                 </a:solidFill>
                 <a:latin typeface="Calibri"/>
               </a:rPr>
-              <a:t>Hair, skin flora, hypothermia, poor hemostasis, dead space, and broken asepsis — not ‘bad luck’ — drive surgical site infection.</a:t>
+              <a:t>Hair, skin flora, hypothermia, poor hemostasis, dead space, and breaks in asepsis.</a:t>
             </a:r>
           </a:p>
         </p:txBody>
@@ -33012,7 +32979,7 @@
                 </a:solidFill>
                 <a:latin typeface="Calibri"/>
               </a:rPr>
-              <a:t>The incision is a contract</a:t>
+              <a:t>Client-owned patients</a:t>
             </a:r>
           </a:p>
         </p:txBody>
@@ -33045,7 +33012,7 @@
                 </a:solidFill>
                 <a:latin typeface="Calibri"/>
               </a:rPr>
-              <a:t>The client trusts you with a living animal (often an elective OHE) that is going home. Operate, document, and speak as if that client is waiting in reception.</a:t>
+              <a:t>Elective OHE patients go home to the owner after recovery. Documentation and the discharge conversation are part of the operation.</a:t>
             </a:r>
           </a:p>
         </p:txBody>
@@ -33166,7 +33133,7 @@
                 </a:solidFill>
                 <a:latin typeface="Calibri"/>
               </a:rPr>
-              <a:t>Postop starts in preop</a:t>
+              <a:t>Decisions made before incision</a:t>
             </a:r>
           </a:p>
         </p:txBody>
@@ -33199,7 +33166,7 @@
                 </a:solidFill>
                 <a:latin typeface="Calibri"/>
               </a:rPr>
-              <a:t>Analgesia, antibiotics, temperature, and client expectations are decided before the scalpel, not at discharge.</a:t>
+              <a:t>Analgesia, antibiotics, temperature management, and client expectations are set in the preoperative period.</a:t>
             </a:r>
           </a:p>
         </p:txBody>
@@ -33277,7 +33244,7 @@
                 </a:solidFill>
                 <a:latin typeface="Calibri"/>
               </a:rPr>
-              <a:t>Three verbs for this hour — and they are all yours</a:t>
+              <a:t>Surgeon responsibilities</a:t>
             </a:r>
           </a:p>
         </p:txBody>
@@ -33348,7 +33315,7 @@
                 </a:solidFill>
                 <a:latin typeface="Calibri"/>
               </a:rPr>
-              <a:t>▸  Perform the surgical procedure — and a beautiful closure that bleeds or herniates in recovery is still a failed surgery. The first 24 hours count.</a:t>
+              <a:t>▸  Perform the procedure. Hemorrhage or herniation in recovery means the surgery failed, even if the closure looked adequate. The first 24 hours are part of the operation.</a:t>
             </a:r>
           </a:p>
         </p:txBody>
@@ -33637,7 +33604,7 @@
                 </a:solidFill>
                 <a:latin typeface="Calibri"/>
               </a:rPr>
-              <a:t>IF YOU CONTAMINATE AND STAY SILENT, THE PATIENT PAYS</a:t>
+              <a:t>RECOGNIZE, ANNOUNCE, AND CORRECT</a:t>
             </a:r>
           </a:p>
         </p:txBody>
@@ -33713,7 +33680,7 @@
                 </a:solidFill>
                 <a:latin typeface="Calibri"/>
               </a:rPr>
-              <a:t>Breaks in asepsis — recognize, announce, fix</a:t>
+              <a:t>Breaks in asepsis</a:t>
             </a:r>
           </a:p>
         </p:txBody>
@@ -33824,7 +33791,7 @@
                 </a:solidFill>
                 <a:latin typeface="Calibri"/>
               </a:rPr>
-              <a:t>If you contaminate yourself or the field: say it immediately and correct it — re-glove, re-gown, or re-drape.
+              <a:t>If you contaminate yourself or the field: say it immediately and correct it. Re-glove, re-gown, or re-drape.
 Name the break once. Fix it completely.
 A second unrecognized break means you cannot maintain an aseptic field. Stop.
 This is how we protect a client-owned animal.</a:t>
@@ -33938,9 +33905,8 @@
                 </a:solidFill>
                 <a:latin typeface="Calibri"/>
               </a:rPr>
-              <a:t>Once the incision is made, there is no free pass.
-You must notice, announce, and completely correct.
-If you do not, or if you correct incompletely, you have put the animal at risk.
+              <a:t>Once the incision is made, contamination must still be noticed, announced, and corrected.
+Incomplete correction puts the animal at risk.
 Examples: sleeve in the abdomen, instrument off the table used again, hole in glove ignored, dripping sweat onto the field.</a:t>
             </a:r>
           </a:p>
@@ -34230,7 +34196,7 @@
                 </a:solidFill>
                 <a:latin typeface="Calibri"/>
               </a:rPr>
-              <a:t>DVM 612 PROFESSIONAL STANDARD  ·  PATIENT SAFETY, NOT A TRIVIA LIST</a:t>
+              <a:t>DVM 612 PROFESSIONAL STANDARD</a:t>
             </a:r>
           </a:p>
         </p:txBody>
@@ -34306,7 +34272,7 @@
                 </a:solidFill>
                 <a:latin typeface="Calibri"/>
               </a:rPr>
-              <a:t>Never-events — these stop the surgery</a:t>
+              <a:t>Never-events</a:t>
             </a:r>
           </a:p>
         </p:txBody>
@@ -34750,40 +34716,7 @@
       </p:sp>
       <p:sp>
         <p:nvSpPr>
-          <p:cNvPr id="5" name="TextBox 4"/>
-          <p:cNvSpPr txBox="1"/>
-          <p:nvPr/>
-        </p:nvSpPr>
-        <p:spPr>
-          <a:xfrm>
-            <a:off x="457200" y="256032"/>
-            <a:ext cx="11247120" cy="256032"/>
-          </a:xfrm>
-          <a:prstGeom prst="rect">
-            <a:avLst/>
-          </a:prstGeom>
-          <a:noFill/>
-        </p:spPr>
-        <p:txBody>
-          <a:bodyPr wrap="square" anchor="t"/>
-          <a:lstStyle/>
-          <a:p>
-            <a:pPr algn="l"/>
-            <a:r>
-              <a:rPr sz="1100" b="1">
-                <a:solidFill>
-                  <a:srgbClr val="1B6B7A"/>
-                </a:solidFill>
-                <a:latin typeface="Calibri"/>
-              </a:rPr>
-              <a:t>WHICH OF THESE IS ACCEPTABLE?</a:t>
-            </a:r>
-          </a:p>
-        </p:txBody>
-      </p:sp>
-      <p:sp>
-        <p:nvSpPr>
-          <p:cNvPr id="6" name="Rectangle 5"/>
+          <p:cNvPr id="5" name="Rectangle 4"/>
           <p:cNvSpPr/>
           <p:nvPr/>
         </p:nvSpPr>
@@ -34826,7 +34759,7 @@
       </p:sp>
       <p:sp>
         <p:nvSpPr>
-          <p:cNvPr id="7" name="TextBox 6"/>
+          <p:cNvPr id="6" name="TextBox 5"/>
           <p:cNvSpPr txBox="1"/>
           <p:nvPr/>
         </p:nvSpPr>
@@ -34852,14 +34785,14 @@
                 </a:solidFill>
                 <a:latin typeface="Calibri"/>
               </a:rPr>
-              <a:t>Knowledge check — preparation</a:t>
-            </a:r>
-          </a:p>
-        </p:txBody>
-      </p:sp>
-      <p:sp>
-        <p:nvSpPr>
-          <p:cNvPr id="8" name="Rounded Rectangle 7"/>
+              <a:t>Knowledge check: preparation</a:t>
+            </a:r>
+          </a:p>
+        </p:txBody>
+      </p:sp>
+      <p:sp>
+        <p:nvSpPr>
+          <p:cNvPr id="7" name="Rounded Rectangle 6"/>
           <p:cNvSpPr/>
           <p:nvPr/>
         </p:nvSpPr>
@@ -34904,7 +34837,7 @@
       </p:sp>
       <p:sp>
         <p:nvSpPr>
-          <p:cNvPr id="9" name="Rectangle 8"/>
+          <p:cNvPr id="8" name="Rectangle 7"/>
           <p:cNvSpPr/>
           <p:nvPr/>
         </p:nvSpPr>
@@ -34947,7 +34880,7 @@
       </p:sp>
       <p:sp>
         <p:nvSpPr>
-          <p:cNvPr id="10" name="TextBox 9"/>
+          <p:cNvPr id="9" name="TextBox 8"/>
           <p:cNvSpPr txBox="1"/>
           <p:nvPr/>
         </p:nvSpPr>
@@ -34980,7 +34913,7 @@
       </p:sp>
       <p:sp>
         <p:nvSpPr>
-          <p:cNvPr id="11" name="TextBox 10"/>
+          <p:cNvPr id="10" name="TextBox 9"/>
           <p:cNvSpPr txBox="1"/>
           <p:nvPr/>
         </p:nvSpPr>
@@ -35013,7 +34946,7 @@
       </p:sp>
       <p:sp>
         <p:nvSpPr>
-          <p:cNvPr id="12" name="TextBox 11"/>
+          <p:cNvPr id="11" name="TextBox 10"/>
           <p:cNvSpPr txBox="1"/>
           <p:nvPr/>
         </p:nvSpPr>
@@ -35046,7 +34979,7 @@
       </p:sp>
       <p:sp>
         <p:nvSpPr>
-          <p:cNvPr id="13" name="Rounded Rectangle 12"/>
+          <p:cNvPr id="12" name="Rounded Rectangle 11"/>
           <p:cNvSpPr/>
           <p:nvPr/>
         </p:nvSpPr>
@@ -35091,7 +35024,7 @@
       </p:sp>
       <p:sp>
         <p:nvSpPr>
-          <p:cNvPr id="14" name="Rectangle 13"/>
+          <p:cNvPr id="13" name="Rectangle 12"/>
           <p:cNvSpPr/>
           <p:nvPr/>
         </p:nvSpPr>
@@ -35134,7 +35067,7 @@
       </p:sp>
       <p:sp>
         <p:nvSpPr>
-          <p:cNvPr id="15" name="TextBox 14"/>
+          <p:cNvPr id="14" name="TextBox 13"/>
           <p:cNvSpPr txBox="1"/>
           <p:nvPr/>
         </p:nvSpPr>
@@ -35167,7 +35100,7 @@
       </p:sp>
       <p:sp>
         <p:nvSpPr>
-          <p:cNvPr id="16" name="TextBox 15"/>
+          <p:cNvPr id="15" name="TextBox 14"/>
           <p:cNvSpPr txBox="1"/>
           <p:nvPr/>
         </p:nvSpPr>
@@ -35200,7 +35133,7 @@
       </p:sp>
       <p:sp>
         <p:nvSpPr>
-          <p:cNvPr id="17" name="TextBox 16"/>
+          <p:cNvPr id="16" name="TextBox 15"/>
           <p:cNvSpPr txBox="1"/>
           <p:nvPr/>
         </p:nvSpPr>
@@ -35233,7 +35166,7 @@
       </p:sp>
       <p:sp>
         <p:nvSpPr>
-          <p:cNvPr id="18" name="Rounded Rectangle 17"/>
+          <p:cNvPr id="17" name="Rounded Rectangle 16"/>
           <p:cNvSpPr/>
           <p:nvPr/>
         </p:nvSpPr>
@@ -35278,7 +35211,7 @@
       </p:sp>
       <p:sp>
         <p:nvSpPr>
-          <p:cNvPr id="19" name="Rectangle 18"/>
+          <p:cNvPr id="18" name="Rectangle 17"/>
           <p:cNvSpPr/>
           <p:nvPr/>
         </p:nvSpPr>
@@ -35321,7 +35254,7 @@
       </p:sp>
       <p:sp>
         <p:nvSpPr>
-          <p:cNvPr id="20" name="TextBox 19"/>
+          <p:cNvPr id="19" name="TextBox 18"/>
           <p:cNvSpPr txBox="1"/>
           <p:nvPr/>
         </p:nvSpPr>
@@ -35354,7 +35287,7 @@
       </p:sp>
       <p:sp>
         <p:nvSpPr>
-          <p:cNvPr id="21" name="TextBox 20"/>
+          <p:cNvPr id="20" name="TextBox 19"/>
           <p:cNvSpPr txBox="1"/>
           <p:nvPr/>
         </p:nvSpPr>
@@ -35380,14 +35313,14 @@
                 </a:solidFill>
                 <a:latin typeface="Calibri"/>
               </a:rPr>
-              <a:t>CHG scrub, then a drop of CHG runs into the eye — rinse and continue.</a:t>
-            </a:r>
-          </a:p>
-        </p:txBody>
-      </p:sp>
-      <p:sp>
-        <p:nvSpPr>
-          <p:cNvPr id="22" name="TextBox 21"/>
+              <a:t>CHG scrub, then a drop of CHG runs into the eye, then rinse and continue.</a:t>
+            </a:r>
+          </a:p>
+        </p:txBody>
+      </p:sp>
+      <p:sp>
+        <p:nvSpPr>
+          <p:cNvPr id="21" name="TextBox 20"/>
           <p:cNvSpPr txBox="1"/>
           <p:nvPr/>
         </p:nvSpPr>
@@ -35420,7 +35353,7 @@
       </p:sp>
       <p:sp>
         <p:nvSpPr>
-          <p:cNvPr id="23" name="Rounded Rectangle 22"/>
+          <p:cNvPr id="22" name="Rounded Rectangle 21"/>
           <p:cNvSpPr/>
           <p:nvPr/>
         </p:nvSpPr>
@@ -35465,7 +35398,7 @@
       </p:sp>
       <p:sp>
         <p:nvSpPr>
-          <p:cNvPr id="24" name="Rectangle 23"/>
+          <p:cNvPr id="23" name="Rectangle 22"/>
           <p:cNvSpPr/>
           <p:nvPr/>
         </p:nvSpPr>
@@ -35508,7 +35441,7 @@
       </p:sp>
       <p:sp>
         <p:nvSpPr>
-          <p:cNvPr id="25" name="TextBox 24"/>
+          <p:cNvPr id="24" name="TextBox 23"/>
           <p:cNvSpPr txBox="1"/>
           <p:nvPr/>
         </p:nvSpPr>
@@ -35541,7 +35474,7 @@
       </p:sp>
       <p:sp>
         <p:nvSpPr>
-          <p:cNvPr id="26" name="TextBox 25"/>
+          <p:cNvPr id="25" name="TextBox 24"/>
           <p:cNvSpPr txBox="1"/>
           <p:nvPr/>
         </p:nvSpPr>
@@ -35574,7 +35507,7 @@
       </p:sp>
       <p:sp>
         <p:nvSpPr>
-          <p:cNvPr id="27" name="TextBox 26"/>
+          <p:cNvPr id="26" name="TextBox 25"/>
           <p:cNvSpPr txBox="1"/>
           <p:nvPr/>
         </p:nvSpPr>
@@ -35607,7 +35540,7 @@
       </p:sp>
       <p:sp>
         <p:nvSpPr>
-          <p:cNvPr id="28" name="Rectangle 27"/>
+          <p:cNvPr id="27" name="Rectangle 26"/>
           <p:cNvSpPr/>
           <p:nvPr/>
         </p:nvSpPr>
@@ -35650,7 +35583,7 @@
       </p:sp>
       <p:sp>
         <p:nvSpPr>
-          <p:cNvPr id="29" name="TextBox 28"/>
+          <p:cNvPr id="28" name="TextBox 27"/>
           <p:cNvSpPr txBox="1"/>
           <p:nvPr/>
         </p:nvSpPr>
@@ -35683,7 +35616,7 @@
       </p:sp>
       <p:sp>
         <p:nvSpPr>
-          <p:cNvPr id="30" name="TextBox 29"/>
+          <p:cNvPr id="29" name="TextBox 28"/>
           <p:cNvSpPr txBox="1"/>
           <p:nvPr/>
         </p:nvSpPr>
@@ -36246,7 +36179,7 @@
                 </a:solidFill>
                 <a:latin typeface="Calibri"/>
               </a:rPr>
-              <a:t>REAL CLINIC PHOTOGRAPH  ·  E-COLLAR, IV, CLIPPED ABDOMEN, NOT LEFT ALONE</a:t>
+              <a:t>REMAIN WITH THE PATIENT UNTIL AIRWAY AND CIRCULATION ARE STABLE</a:t>
             </a:r>
           </a:p>
         </p:txBody>
@@ -36322,7 +36255,7 @@
                 </a:solidFill>
                 <a:latin typeface="Calibri"/>
               </a:rPr>
-              <a:t>Immediate recovery — stay with the patient</a:t>
+              <a:t>Immediate recovery</a:t>
             </a:r>
           </a:p>
         </p:txBody>
@@ -36424,7 +36357,7 @@
                 </a:solidFill>
                 <a:latin typeface="Calibri"/>
               </a:rPr>
-              <a:t>Do not leave</a:t>
+              <a:t>Recovery priorities</a:t>
             </a:r>
           </a:p>
         </p:txBody>
@@ -36849,7 +36782,7 @@
                 </a:solidFill>
                 <a:latin typeface="Calibri"/>
               </a:rPr>
-              <a:t>IF IT IS NOT WRITTEN, IT WAS NOT DONE  ·  TEACHING FORM</a:t>
+              <a:t>TEACHING FORM</a:t>
             </a:r>
           </a:p>
         </p:txBody>
@@ -36925,7 +36858,7 @@
                 </a:solidFill>
                 <a:latin typeface="Calibri"/>
               </a:rPr>
-              <a:t>Postoperative flowsheet — first 2 hours</a:t>
+              <a:t>Postoperative flowsheet, first 2 hours</a:t>
             </a:r>
           </a:p>
         </p:txBody>
@@ -37238,7 +37171,7 @@
                 </a:solidFill>
                 <a:latin typeface="Calibri"/>
               </a:rPr>
-              <a:t>IF YOU DO NOT SCORE IT, YOU WILL NOT TREAT IT</a:t>
+              <a:t>GLASGOW CMPS-SF, FELINE GRIMACE SCALE, CSU SCALES</a:t>
             </a:r>
           </a:p>
         </p:txBody>
@@ -37314,7 +37247,7 @@
                 </a:solidFill>
                 <a:latin typeface="Calibri"/>
               </a:rPr>
-              <a:t>Pain assessment is a vital sign</a:t>
+              <a:t>Pain assessment</a:t>
             </a:r>
           </a:p>
         </p:txBody>
@@ -37392,7 +37325,7 @@
                 </a:solidFill>
                 <a:latin typeface="Calibri"/>
               </a:rPr>
-              <a:t>Use a scale. Write the number.</a:t>
+              <a:t>Score pain and record the number</a:t>
             </a:r>
           </a:p>
         </p:txBody>
@@ -37573,7 +37506,7 @@
                 </a:solidFill>
                 <a:latin typeface="Calibri"/>
               </a:rPr>
-              <a:t>Treat to the surgery you did</a:t>
+              <a:t>Match analgesia to the procedure</a:t>
             </a:r>
           </a:p>
         </p:txBody>
@@ -37628,7 +37561,7 @@
                 </a:solidFill>
                 <a:latin typeface="Calibri"/>
               </a:rPr>
-              <a:t>▸  Celiotomy / orthopedic: expect more — CRIs, additional locals, overnight monitoring.</a:t>
+              <a:t>▸  Celiotomy / orthopedic: expect more: CRIs, additional local blocks, overnight monitoring.</a:t>
             </a:r>
           </a:p>
           <a:p>
@@ -37965,7 +37898,7 @@
                 </a:solidFill>
                 <a:latin typeface="Calibri"/>
               </a:rPr>
-              <a:t>REAL 24-HOUR OHE PHOTOGRAPH  ·  PROTECT THE APPOSITION YOU JUST CREATED</a:t>
+              <a:t>24-HOUR OHE PHOTOGRAPH</a:t>
             </a:r>
           </a:p>
         </p:txBody>
@@ -38041,7 +37974,7 @@
                 </a:solidFill>
                 <a:latin typeface="Calibri"/>
               </a:rPr>
-              <a:t>The incision after you leave it</a:t>
+              <a:t>Incision care</a:t>
             </a:r>
           </a:p>
         </p:txBody>
@@ -38143,7 +38076,7 @@
                 </a:solidFill>
                 <a:latin typeface="Calibri"/>
               </a:rPr>
-              <a:t>Protect it</a:t>
+              <a:t>Incision care</a:t>
             </a:r>
           </a:p>
         </p:txBody>
@@ -38551,7 +38484,7 @@
                 </a:solidFill>
                 <a:latin typeface="Calibri"/>
               </a:rPr>
-              <a:t>HEMORRHAGE, HERNIA, AND DEHISCENCE SHOW UP AFTER YOU HAVE GONE HOME</a:t>
+              <a:t>HEMORRHAGE, AIRWAY, HERNIA, DEHISCENCE, SSI, SEROMA</a:t>
             </a:r>
           </a:p>
         </p:txBody>
@@ -38627,7 +38560,7 @@
                 </a:solidFill>
                 <a:latin typeface="Calibri"/>
               </a:rPr>
-              <a:t>The first 24 hours — what fails a surgery after the OR</a:t>
+              <a:t>Complications in the first 24 hours</a:t>
             </a:r>
           </a:p>
         </p:txBody>
@@ -39243,7 +39176,7 @@
                 </a:solidFill>
                 <a:latin typeface="Calibri"/>
               </a:rPr>
-              <a:t>Often day 3–5 as inflammation peaks and the patient licks. Skin vs. fascia — fascia is the emergency.</a:t>
+              <a:t>Often day 3–5 as inflammation peaks and the patient licks. Skin versus fascia: fascial dehiscence is the emergency.</a:t>
             </a:r>
           </a:p>
         </p:txBody>
@@ -39840,7 +39773,7 @@
                 </a:solidFill>
                 <a:latin typeface="Calibri"/>
               </a:rPr>
-              <a:t>THE NEXT DOCTOR AT 2 A.M. IS YOUR AUDIENCE</a:t>
+              <a:t>REQUIRED ELEMENTS</a:t>
             </a:r>
           </a:p>
         </p:txBody>
@@ -39916,7 +39849,7 @@
                 </a:solidFill>
                 <a:latin typeface="Calibri"/>
               </a:rPr>
-              <a:t>Surgical report — if it is not written, it was not done</a:t>
+              <a:t>Surgical report</a:t>
             </a:r>
           </a:p>
         </p:txBody>
@@ -40113,7 +40046,7 @@
                 </a:solidFill>
                 <a:latin typeface="Calibri"/>
               </a:rPr>
-              <a:t>▸  What was done — ligatures, implants, samples.</a:t>
+              <a:t>▸  What was done: ligatures, implants, samples.</a:t>
             </a:r>
           </a:p>
           <a:p>
@@ -40255,7 +40188,7 @@
                 </a:solidFill>
                 <a:latin typeface="Calibri"/>
               </a:rPr>
-              <a:t>Why the next doctor cares</a:t>
+              <a:t>What the overnight clinician needs</a:t>
             </a:r>
           </a:p>
         </p:txBody>
@@ -40289,8 +40222,7 @@
                 <a:latin typeface="Calibri"/>
               </a:rPr>
               <a:t>At 2 a.m. someone will open this record because the abdomen is swelling.
-They need: how the pedicles were ligated, whether a sponge count was complete, what suture is in the linea, and whether the client was already called.
-Operate as if that night-call is tonight.</a:t>
+They need how the pedicles were ligated, whether a sponge count was complete, what suture is in the linea, and whether the client was already called.</a:t>
             </a:r>
           </a:p>
         </p:txBody>
@@ -40579,7 +40511,7 @@
                 </a:solidFill>
                 <a:latin typeface="Calibri"/>
               </a:rPr>
-              <a:t>EVERY PRINCIPLE HAS A PREOP OR POSTOP ACTION, NOT ONLY AN INTRAOPERATIVE ONE</a:t>
+              <a:t>EACH PRINCIPLE HAS A PREOPERATIVE OR POSTOPERATIVE ACTION</a:t>
             </a:r>
           </a:p>
         </p:txBody>
@@ -40655,7 +40587,7 @@
                 </a:solidFill>
                 <a:latin typeface="Calibri"/>
               </a:rPr>
-              <a:t>Halsted’s principles — the through-line for today</a:t>
+              <a:t>Halsted’s principles</a:t>
             </a:r>
           </a:p>
         </p:txBody>
@@ -41271,7 +41203,7 @@
                 </a:solidFill>
                 <a:latin typeface="Calibri"/>
               </a:rPr>
-              <a:t>Patient prep, surgeon prep, draping — today’s center of gravity.</a:t>
+              <a:t>Patient preparation, surgeon preparation, and draping.</a:t>
             </a:r>
           </a:p>
         </p:txBody>
@@ -42022,7 +41954,7 @@
                 </a:solidFill>
                 <a:latin typeface="Calibri"/>
               </a:rPr>
-              <a:t>VERBAL + WRITTEN. TEACH-BACK. ONE CAREGIVER DEMONSTRATES THE E-COLLAR.</a:t>
+              <a:t>VERBAL AND WRITTEN. TEACH-BACK. ONE CAREGIVER DEMONSTRATES THE E-COLLAR.</a:t>
             </a:r>
           </a:p>
         </p:txBody>
@@ -42098,7 +42030,7 @@
                 </a:solidFill>
                 <a:latin typeface="Calibri"/>
               </a:rPr>
-              <a:t>Discharge instructions — in the client’s language</a:t>
+              <a:t>Discharge instructions</a:t>
             </a:r>
           </a:p>
         </p:txBody>
@@ -42582,7 +42514,7 @@
                 </a:solidFill>
                 <a:latin typeface="Calibri"/>
               </a:rPr>
-              <a:t>Incision care and activity restriction — specific, timed (e.g., 14 days leash-only).</a:t>
+              <a:t>Incision care and activity restriction. Specify duration (example: 14 days leash only).</a:t>
             </a:r>
           </a:p>
         </p:txBody>
@@ -43355,7 +43287,7 @@
                 </a:solidFill>
                 <a:latin typeface="Calibri"/>
               </a:rPr>
-              <a:t>IF THE CLIENT CANNOT REPEAT THESE, YOU DID NOT DISCHARGE</a:t>
+              <a:t>THE CLIENT MUST BE ABLE TO REPEAT THESE</a:t>
             </a:r>
           </a:p>
         </p:txBody>
@@ -43431,7 +43363,7 @@
                 </a:solidFill>
                 <a:latin typeface="Calibri"/>
               </a:rPr>
-              <a:t>When to come back tonight — teach this verbatim</a:t>
+              <a:t>Emergency criteria for discharge</a:t>
             </a:r>
           </a:p>
         </p:txBody>
@@ -44156,40 +44088,7 @@
       </p:sp>
       <p:sp>
         <p:nvSpPr>
-          <p:cNvPr id="5" name="TextBox 4"/>
-          <p:cNvSpPr txBox="1"/>
-          <p:nvPr/>
-        </p:nvSpPr>
-        <p:spPr>
-          <a:xfrm>
-            <a:off x="457200" y="256032"/>
-            <a:ext cx="11247120" cy="256032"/>
-          </a:xfrm>
-          <a:prstGeom prst="rect">
-            <a:avLst/>
-          </a:prstGeom>
-          <a:noFill/>
-        </p:spPr>
-        <p:txBody>
-          <a:bodyPr wrap="square" anchor="t"/>
-          <a:lstStyle/>
-          <a:p>
-            <a:pPr algn="l"/>
-            <a:r>
-              <a:rPr sz="1100" b="1">
-                <a:solidFill>
-                  <a:srgbClr val="1B6B7A"/>
-                </a:solidFill>
-                <a:latin typeface="Calibri"/>
-              </a:rPr>
-              <a:t>SURGERY IS A WHOLE-PATIENT EVENT</a:t>
-            </a:r>
-          </a:p>
-        </p:txBody>
-      </p:sp>
-      <p:sp>
-        <p:nvSpPr>
-          <p:cNvPr id="6" name="Rectangle 5"/>
+          <p:cNvPr id="5" name="Rectangle 4"/>
           <p:cNvSpPr/>
           <p:nvPr/>
         </p:nvSpPr>
@@ -44232,7 +44131,7 @@
       </p:sp>
       <p:sp>
         <p:nvSpPr>
-          <p:cNvPr id="7" name="TextBox 6"/>
+          <p:cNvPr id="6" name="TextBox 5"/>
           <p:cNvSpPr txBox="1"/>
           <p:nvPr/>
         </p:nvSpPr>
@@ -44258,14 +44157,14 @@
                 </a:solidFill>
                 <a:latin typeface="Calibri"/>
               </a:rPr>
-              <a:t>Fluids, feeding, and the rest of the animal</a:t>
-            </a:r>
-          </a:p>
-        </p:txBody>
-      </p:sp>
-      <p:sp>
-        <p:nvSpPr>
-          <p:cNvPr id="8" name="Rounded Rectangle 7"/>
+              <a:t>Fluids, feeding, and other systems</a:t>
+            </a:r>
+          </a:p>
+        </p:txBody>
+      </p:sp>
+      <p:sp>
+        <p:nvSpPr>
+          <p:cNvPr id="7" name="Rounded Rectangle 6"/>
           <p:cNvSpPr/>
           <p:nvPr/>
         </p:nvSpPr>
@@ -44310,7 +44209,7 @@
       </p:sp>
       <p:sp>
         <p:nvSpPr>
-          <p:cNvPr id="9" name="Rectangle 8"/>
+          <p:cNvPr id="8" name="Rectangle 7"/>
           <p:cNvSpPr/>
           <p:nvPr/>
         </p:nvSpPr>
@@ -44353,7 +44252,7 @@
       </p:sp>
       <p:sp>
         <p:nvSpPr>
-          <p:cNvPr id="10" name="TextBox 9"/>
+          <p:cNvPr id="9" name="TextBox 8"/>
           <p:cNvSpPr txBox="1"/>
           <p:nvPr/>
         </p:nvSpPr>
@@ -44386,7 +44285,7 @@
       </p:sp>
       <p:sp>
         <p:nvSpPr>
-          <p:cNvPr id="11" name="TextBox 10"/>
+          <p:cNvPr id="10" name="TextBox 9"/>
           <p:cNvSpPr txBox="1"/>
           <p:nvPr/>
         </p:nvSpPr>
@@ -44419,7 +44318,7 @@
       </p:sp>
       <p:sp>
         <p:nvSpPr>
-          <p:cNvPr id="12" name="Rounded Rectangle 11"/>
+          <p:cNvPr id="11" name="Rounded Rectangle 10"/>
           <p:cNvSpPr/>
           <p:nvPr/>
         </p:nvSpPr>
@@ -44464,7 +44363,7 @@
       </p:sp>
       <p:sp>
         <p:nvSpPr>
-          <p:cNvPr id="13" name="Rectangle 12"/>
+          <p:cNvPr id="12" name="Rectangle 11"/>
           <p:cNvSpPr/>
           <p:nvPr/>
         </p:nvSpPr>
@@ -44507,7 +44406,7 @@
       </p:sp>
       <p:sp>
         <p:nvSpPr>
-          <p:cNvPr id="14" name="TextBox 13"/>
+          <p:cNvPr id="13" name="TextBox 12"/>
           <p:cNvSpPr txBox="1"/>
           <p:nvPr/>
         </p:nvSpPr>
@@ -44540,7 +44439,7 @@
       </p:sp>
       <p:sp>
         <p:nvSpPr>
-          <p:cNvPr id="15" name="TextBox 14"/>
+          <p:cNvPr id="14" name="TextBox 13"/>
           <p:cNvSpPr txBox="1"/>
           <p:nvPr/>
         </p:nvSpPr>
@@ -44566,14 +44465,14 @@
                 </a:solidFill>
                 <a:latin typeface="Calibri"/>
               </a:rPr>
-              <a:t>Offer water, then a small bland or usual meal when fully awake (procedure-dependent). GI surgery: surgeon specifies. Cats: prevent hepatic lipidosis — do not ‘wait and see’ for days. Consider mirtazapine/capromorelin as directed.</a:t>
-            </a:r>
-          </a:p>
-        </p:txBody>
-      </p:sp>
-      <p:sp>
-        <p:nvSpPr>
-          <p:cNvPr id="16" name="Rounded Rectangle 15"/>
+              <a:t>Offer water, then a small bland or usual meal when fully awake (procedure-dependent). GI surgery: surgeon specifies. Cats: prevent hepatic lipidosis. Do not wait days to feed. Consider mirtazapine/capromorelin as directed.</a:t>
+            </a:r>
+          </a:p>
+        </p:txBody>
+      </p:sp>
+      <p:sp>
+        <p:nvSpPr>
+          <p:cNvPr id="15" name="Rounded Rectangle 14"/>
           <p:cNvSpPr/>
           <p:nvPr/>
         </p:nvSpPr>
@@ -44618,7 +44517,7 @@
       </p:sp>
       <p:sp>
         <p:nvSpPr>
-          <p:cNvPr id="17" name="Rectangle 16"/>
+          <p:cNvPr id="16" name="Rectangle 15"/>
           <p:cNvSpPr/>
           <p:nvPr/>
         </p:nvSpPr>
@@ -44661,7 +44560,7 @@
       </p:sp>
       <p:sp>
         <p:nvSpPr>
-          <p:cNvPr id="18" name="TextBox 17"/>
+          <p:cNvPr id="17" name="TextBox 16"/>
           <p:cNvSpPr txBox="1"/>
           <p:nvPr/>
         </p:nvSpPr>
@@ -44694,7 +44593,7 @@
       </p:sp>
       <p:sp>
         <p:nvSpPr>
-          <p:cNvPr id="19" name="TextBox 18"/>
+          <p:cNvPr id="18" name="TextBox 17"/>
           <p:cNvSpPr txBox="1"/>
           <p:nvPr/>
         </p:nvSpPr>
@@ -44720,14 +44619,14 @@
                 </a:solidFill>
                 <a:latin typeface="Calibri"/>
               </a:rPr>
-              <a:t>Urinate before discharge. Bowel movements after laparotomy may lag. Eyes: lubrication after anesthesia. Recheck glucose in diabetics. Walk the dog out — do not assume the crate is fine.</a:t>
-            </a:r>
-          </a:p>
-        </p:txBody>
-      </p:sp>
-      <p:sp>
-        <p:nvSpPr>
-          <p:cNvPr id="20" name="Rectangle 19"/>
+              <a:t>Urinate before discharge. Bowel movements after laparotomy may lag. Eyes: lubrication after anesthesia. Recheck glucose in diabetics. Walk the dog out. Do not assume the crate is adequate.</a:t>
+            </a:r>
+          </a:p>
+        </p:txBody>
+      </p:sp>
+      <p:sp>
+        <p:nvSpPr>
+          <p:cNvPr id="19" name="Rectangle 18"/>
           <p:cNvSpPr/>
           <p:nvPr/>
         </p:nvSpPr>
@@ -44770,7 +44669,7 @@
       </p:sp>
       <p:sp>
         <p:nvSpPr>
-          <p:cNvPr id="21" name="TextBox 20"/>
+          <p:cNvPr id="20" name="TextBox 19"/>
           <p:cNvSpPr txBox="1"/>
           <p:nvPr/>
         </p:nvSpPr>
@@ -44803,7 +44702,7 @@
       </p:sp>
       <p:sp>
         <p:nvSpPr>
-          <p:cNvPr id="22" name="TextBox 21"/>
+          <p:cNvPr id="21" name="TextBox 20"/>
           <p:cNvSpPr txBox="1"/>
           <p:nvPr/>
         </p:nvSpPr>
@@ -45009,7 +44908,7 @@
                 </a:solidFill>
                 <a:latin typeface="Calibri"/>
               </a:rPr>
-              <a:t>FIELD SURGERY IS STILL HALSTED; IT IS NOT AN EXCUSE TO SKIP CLIP, GLOVES, AND A DRAPE</a:t>
+              <a:t>CLIP, GLOVES, AND A DRAPE STILL APPLY IN THE FIELD</a:t>
             </a:r>
           </a:p>
         </p:txBody>
@@ -45085,7 +44984,7 @@
                 </a:solidFill>
                 <a:latin typeface="Calibri"/>
               </a:rPr>
-              <a:t>Large animal — same principles, different dirt</a:t>
+              <a:t>Large animal surgery</a:t>
             </a:r>
           </a:p>
         </p:txBody>
@@ -45188,7 +45087,7 @@
                 </a:solidFill>
                 <a:latin typeface="Calibri"/>
               </a:rPr>
-              <a:t>▸  Antimicrobial use in food animals has residue and regulatory obligations — prophylaxis is not a default pour-on.</a:t>
+              <a:t>▸  Antimicrobial use in food animals has residue and regulatory obligations. Prophylaxis is not a default pour-on.</a:t>
             </a:r>
           </a:p>
           <a:p>
@@ -45493,7 +45392,7 @@
                 </a:solidFill>
                 <a:latin typeface="Calibri"/>
               </a:rPr>
-              <a:t>YOU ARE THE SURGEON. THE OWNER IS IN RECEPTION.</a:t>
+              <a:t>ASA STATUS 3-E</a:t>
             </a:r>
           </a:p>
         </p:txBody>
@@ -45569,7 +45468,7 @@
                 </a:solidFill>
                 <a:latin typeface="Calibri"/>
               </a:rPr>
-              <a:t>Walk Willie through the whole hour</a:t>
+              <a:t>Willie: complete perioperative plan</a:t>
             </a:r>
           </a:p>
         </p:txBody>
@@ -45955,7 +45854,7 @@
                 </a:solidFill>
                 <a:latin typeface="Calibri"/>
               </a:rPr>
-              <a:t>Airway protected, monitors on, then alfaxalone to a depth that is safe to clip and flush. CHG off the eye and drum. Periocular/mucosa: 10% PVP-I 1 to 20 to 1 to 50; eye 2 min scrub + 2 min soak. Pad him — he falls.</a:t>
+              <a:t>Airway protected, monitors on, then alfaxalone to a depth that is safe to clip and flush. CHG off the eye and drum. Periocular/mucosa: 10% PVP-I 1 to 20 to 1 to 50; eye 2 min scrub + 2 min soak. Pad him. He falls.</a:t>
             </a:r>
           </a:p>
         </p:txBody>
@@ -46263,7 +46162,7 @@
                 </a:solidFill>
                 <a:latin typeface="Calibri"/>
               </a:rPr>
-              <a:t>Confine, no stairs. Watch neuro signs, vomiting, seizures. MRI next. TECA-LBO only after culture if medical therapy fails. You own hour 23.</a:t>
+              <a:t>Confine, no stairs. Watch neuro signs, vomiting, seizures. MRI next. TECA-LBO only after culture if medical therapy fails.</a:t>
             </a:r>
           </a:p>
         </p:txBody>
@@ -46552,7 +46451,7 @@
                 </a:solidFill>
                 <a:latin typeface="Calibri"/>
               </a:rPr>
-              <a:t>BOTH ARE PREOPERATIVE EVALUATION  ·  ONLY ONE REACHES THE CLIPPERS</a:t>
+              <a:t>BOTH RECEIVED A PREOPERATIVE EVALUATION. ONLY WILLIE WAS ANESTHETIZED.</a:t>
             </a:r>
           </a:p>
         </p:txBody>
@@ -46628,7 +46527,7 @@
                 </a:solidFill>
                 <a:latin typeface="Calibri"/>
               </a:rPr>
-              <a:t>Same hour, opposite decisions</a:t>
+              <a:t>Willie and MoMo</a:t>
             </a:r>
           </a:p>
         </p:txBody>
@@ -46749,7 +46648,7 @@
                 </a:solidFill>
                 <a:latin typeface="Calibri"/>
               </a:rPr>
-              <a:t>Willie — ASA III-E — proceed (sedation)</a:t>
+              <a:t>Willie, ASA Status 3-E. Proceed with sedation.</a:t>
             </a:r>
           </a:p>
         </p:txBody>
@@ -46782,7 +46681,7 @@
                 </a:solidFill>
                 <a:latin typeface="Calibri"/>
               </a:rPr>
-              <a:t>Cavalier, 13.7 kg. Acute vestibular + AS otitis + murmur. Compensated. Fill the anesthesia record. Alfaxalone, monitoring, ear clean, no NSAID after DexSP. Own the next 24 hours. MRI / possible TECA-LBO later — that future surgery still needs a new ASA that day.</a:t>
+              <a:t>Cavalier, 13.7 kg. Acute vestibular + AS otitis + murmur. Compensated. Fill the anesthesia record. Alfaxalone, monitoring, ear clean, no NSAID after DexSP. Own the next 24 hours. MRI / possible TECA-LBO later. Assign a new ASA status on the day of that surgery.</a:t>
             </a:r>
           </a:p>
         </p:txBody>
@@ -46903,7 +46802,7 @@
                 </a:solidFill>
                 <a:latin typeface="Calibri"/>
               </a:rPr>
-              <a:t>MoMo — ASA IV-E — do not induce</a:t>
+              <a:t>MoMo, ASA Status 4-E. Do not induce.</a:t>
             </a:r>
           </a:p>
         </p:txBody>
@@ -46936,7 +46835,7 @@
                 </a:solidFill>
                 <a:latin typeface="Calibri"/>
               </a:rPr>
-              <a:t>DSH, 4.25 kg. Vomiting that looked like FB. Labs + POCUS + AUS: structural renal disease, creatinine 3.0 → 4.71 on fluids. Exploratory cancelled. NSAIDs contraindicated. Record the decision. Supportive care vs referral vs euthanasia is still a surgical conversation — you just do not cut.</a:t>
+              <a:t>DSH, 4.25 kg. Vomiting that looked like FB. Labs + POCUS + AUS: structural renal disease, creatinine 3.0 → 4.71 on fluids. Exploratory cancelled. NSAIDs contraindicated. Record the decision. Supportive care, referral, or euthanasia is still a surgical conversation. You do not perform an exploratory.</a:t>
             </a:r>
           </a:p>
         </p:txBody>
@@ -47199,40 +47098,7 @@
       </p:sp>
       <p:sp>
         <p:nvSpPr>
-          <p:cNvPr id="5" name="TextBox 4"/>
-          <p:cNvSpPr txBox="1"/>
-          <p:nvPr/>
-        </p:nvSpPr>
-        <p:spPr>
-          <a:xfrm>
-            <a:off x="457200" y="256032"/>
-            <a:ext cx="11247120" cy="256032"/>
-          </a:xfrm>
-          <a:prstGeom prst="rect">
-            <a:avLst/>
-          </a:prstGeom>
-          <a:noFill/>
-        </p:spPr>
-        <p:txBody>
-          <a:bodyPr wrap="square" anchor="t"/>
-          <a:lstStyle/>
-          <a:p>
-            <a:pPr algn="l"/>
-            <a:r>
-              <a:rPr sz="1100" b="1">
-                <a:solidFill>
-                  <a:srgbClr val="1B6B7A"/>
-                </a:solidFill>
-                <a:latin typeface="Calibri"/>
-              </a:rPr>
-              <a:t>IF YOU REMEMBER SIX THINGS, REMEMBER THESE</a:t>
-            </a:r>
-          </a:p>
-        </p:txBody>
-      </p:sp>
-      <p:sp>
-        <p:nvSpPr>
-          <p:cNvPr id="6" name="Rectangle 5"/>
+          <p:cNvPr id="5" name="Rectangle 4"/>
           <p:cNvSpPr/>
           <p:nvPr/>
         </p:nvSpPr>
@@ -47275,7 +47141,7 @@
       </p:sp>
       <p:sp>
         <p:nvSpPr>
-          <p:cNvPr id="7" name="TextBox 6"/>
+          <p:cNvPr id="6" name="TextBox 5"/>
           <p:cNvSpPr txBox="1"/>
           <p:nvPr/>
         </p:nvSpPr>
@@ -47301,14 +47167,14 @@
                 </a:solidFill>
                 <a:latin typeface="Calibri"/>
               </a:rPr>
-              <a:t>Key points from this hour</a:t>
-            </a:r>
-          </a:p>
-        </p:txBody>
-      </p:sp>
-      <p:sp>
-        <p:nvSpPr>
-          <p:cNvPr id="8" name="Rounded Rectangle 7"/>
+              <a:t>Key points</a:t>
+            </a:r>
+          </a:p>
+        </p:txBody>
+      </p:sp>
+      <p:sp>
+        <p:nvSpPr>
+          <p:cNvPr id="7" name="Rounded Rectangle 6"/>
           <p:cNvSpPr/>
           <p:nvPr/>
         </p:nvSpPr>
@@ -47353,7 +47219,7 @@
       </p:sp>
       <p:sp>
         <p:nvSpPr>
-          <p:cNvPr id="9" name="Rectangle 8"/>
+          <p:cNvPr id="8" name="Rectangle 7"/>
           <p:cNvSpPr/>
           <p:nvPr/>
         </p:nvSpPr>
@@ -47396,7 +47262,7 @@
       </p:sp>
       <p:sp>
         <p:nvSpPr>
-          <p:cNvPr id="10" name="TextBox 9"/>
+          <p:cNvPr id="9" name="TextBox 8"/>
           <p:cNvSpPr txBox="1"/>
           <p:nvPr/>
         </p:nvSpPr>
@@ -47429,7 +47295,7 @@
       </p:sp>
       <p:sp>
         <p:nvSpPr>
-          <p:cNvPr id="11" name="TextBox 10"/>
+          <p:cNvPr id="10" name="TextBox 9"/>
           <p:cNvSpPr txBox="1"/>
           <p:nvPr/>
         </p:nvSpPr>
@@ -47462,7 +47328,7 @@
       </p:sp>
       <p:sp>
         <p:nvSpPr>
-          <p:cNvPr id="12" name="Rounded Rectangle 11"/>
+          <p:cNvPr id="11" name="Rounded Rectangle 10"/>
           <p:cNvSpPr/>
           <p:nvPr/>
         </p:nvSpPr>
@@ -47507,7 +47373,7 @@
       </p:sp>
       <p:sp>
         <p:nvSpPr>
-          <p:cNvPr id="13" name="Rectangle 12"/>
+          <p:cNvPr id="12" name="Rectangle 11"/>
           <p:cNvSpPr/>
           <p:nvPr/>
         </p:nvSpPr>
@@ -47550,7 +47416,7 @@
       </p:sp>
       <p:sp>
         <p:nvSpPr>
-          <p:cNvPr id="14" name="TextBox 13"/>
+          <p:cNvPr id="13" name="TextBox 12"/>
           <p:cNvSpPr txBox="1"/>
           <p:nvPr/>
         </p:nvSpPr>
@@ -47583,7 +47449,7 @@
       </p:sp>
       <p:sp>
         <p:nvSpPr>
-          <p:cNvPr id="15" name="TextBox 14"/>
+          <p:cNvPr id="14" name="TextBox 13"/>
           <p:cNvSpPr txBox="1"/>
           <p:nvPr/>
         </p:nvSpPr>
@@ -47616,7 +47482,7 @@
       </p:sp>
       <p:sp>
         <p:nvSpPr>
-          <p:cNvPr id="16" name="Rounded Rectangle 15"/>
+          <p:cNvPr id="15" name="Rounded Rectangle 14"/>
           <p:cNvSpPr/>
           <p:nvPr/>
         </p:nvSpPr>
@@ -47661,7 +47527,7 @@
       </p:sp>
       <p:sp>
         <p:nvSpPr>
-          <p:cNvPr id="17" name="Rectangle 16"/>
+          <p:cNvPr id="16" name="Rectangle 15"/>
           <p:cNvSpPr/>
           <p:nvPr/>
         </p:nvSpPr>
@@ -47704,7 +47570,7 @@
       </p:sp>
       <p:sp>
         <p:nvSpPr>
-          <p:cNvPr id="18" name="TextBox 17"/>
+          <p:cNvPr id="17" name="TextBox 16"/>
           <p:cNvSpPr txBox="1"/>
           <p:nvPr/>
         </p:nvSpPr>
@@ -47737,7 +47603,7 @@
       </p:sp>
       <p:sp>
         <p:nvSpPr>
-          <p:cNvPr id="19" name="TextBox 18"/>
+          <p:cNvPr id="18" name="TextBox 17"/>
           <p:cNvSpPr txBox="1"/>
           <p:nvPr/>
         </p:nvSpPr>
@@ -47770,7 +47636,7 @@
       </p:sp>
       <p:sp>
         <p:nvSpPr>
-          <p:cNvPr id="20" name="Rounded Rectangle 19"/>
+          <p:cNvPr id="19" name="Rounded Rectangle 18"/>
           <p:cNvSpPr/>
           <p:nvPr/>
         </p:nvSpPr>
@@ -47815,7 +47681,7 @@
       </p:sp>
       <p:sp>
         <p:nvSpPr>
-          <p:cNvPr id="21" name="Rectangle 20"/>
+          <p:cNvPr id="20" name="Rectangle 19"/>
           <p:cNvSpPr/>
           <p:nvPr/>
         </p:nvSpPr>
@@ -47858,7 +47724,7 @@
       </p:sp>
       <p:sp>
         <p:nvSpPr>
-          <p:cNvPr id="22" name="TextBox 21"/>
+          <p:cNvPr id="21" name="TextBox 20"/>
           <p:cNvSpPr txBox="1"/>
           <p:nvPr/>
         </p:nvSpPr>
@@ -47891,7 +47757,7 @@
       </p:sp>
       <p:sp>
         <p:nvSpPr>
-          <p:cNvPr id="23" name="TextBox 22"/>
+          <p:cNvPr id="22" name="TextBox 21"/>
           <p:cNvSpPr txBox="1"/>
           <p:nvPr/>
         </p:nvSpPr>
@@ -47924,7 +47790,7 @@
       </p:sp>
       <p:sp>
         <p:nvSpPr>
-          <p:cNvPr id="24" name="Rounded Rectangle 23"/>
+          <p:cNvPr id="23" name="Rounded Rectangle 22"/>
           <p:cNvSpPr/>
           <p:nvPr/>
         </p:nvSpPr>
@@ -47969,7 +47835,7 @@
       </p:sp>
       <p:sp>
         <p:nvSpPr>
-          <p:cNvPr id="25" name="Rectangle 24"/>
+          <p:cNvPr id="24" name="Rectangle 23"/>
           <p:cNvSpPr/>
           <p:nvPr/>
         </p:nvSpPr>
@@ -48012,7 +47878,7 @@
       </p:sp>
       <p:sp>
         <p:nvSpPr>
-          <p:cNvPr id="26" name="TextBox 25"/>
+          <p:cNvPr id="25" name="TextBox 24"/>
           <p:cNvSpPr txBox="1"/>
           <p:nvPr/>
         </p:nvSpPr>
@@ -48045,7 +47911,7 @@
       </p:sp>
       <p:sp>
         <p:nvSpPr>
-          <p:cNvPr id="27" name="TextBox 26"/>
+          <p:cNvPr id="26" name="TextBox 25"/>
           <p:cNvSpPr txBox="1"/>
           <p:nvPr/>
         </p:nvSpPr>
@@ -48078,7 +47944,7 @@
       </p:sp>
       <p:sp>
         <p:nvSpPr>
-          <p:cNvPr id="28" name="Rounded Rectangle 27"/>
+          <p:cNvPr id="27" name="Rounded Rectangle 26"/>
           <p:cNvSpPr/>
           <p:nvPr/>
         </p:nvSpPr>
@@ -48123,7 +47989,7 @@
       </p:sp>
       <p:sp>
         <p:nvSpPr>
-          <p:cNvPr id="29" name="Rectangle 28"/>
+          <p:cNvPr id="28" name="Rectangle 27"/>
           <p:cNvSpPr/>
           <p:nvPr/>
         </p:nvSpPr>
@@ -48166,7 +48032,7 @@
       </p:sp>
       <p:sp>
         <p:nvSpPr>
-          <p:cNvPr id="30" name="TextBox 29"/>
+          <p:cNvPr id="29" name="TextBox 28"/>
           <p:cNvSpPr txBox="1"/>
           <p:nvPr/>
         </p:nvSpPr>
@@ -48199,7 +48065,7 @@
       </p:sp>
       <p:sp>
         <p:nvSpPr>
-          <p:cNvPr id="31" name="TextBox 30"/>
+          <p:cNvPr id="30" name="TextBox 29"/>
           <p:cNvSpPr txBox="1"/>
           <p:nvPr/>
         </p:nvSpPr>
@@ -48232,7 +48098,7 @@
       </p:sp>
       <p:sp>
         <p:nvSpPr>
-          <p:cNvPr id="32" name="Rectangle 31"/>
+          <p:cNvPr id="31" name="Rectangle 30"/>
           <p:cNvSpPr/>
           <p:nvPr/>
         </p:nvSpPr>
@@ -48275,7 +48141,7 @@
       </p:sp>
       <p:sp>
         <p:nvSpPr>
-          <p:cNvPr id="33" name="TextBox 32"/>
+          <p:cNvPr id="32" name="TextBox 31"/>
           <p:cNvSpPr txBox="1"/>
           <p:nvPr/>
         </p:nvSpPr>
@@ -48308,7 +48174,7 @@
       </p:sp>
       <p:sp>
         <p:nvSpPr>
-          <p:cNvPr id="34" name="TextBox 33"/>
+          <p:cNvPr id="33" name="TextBox 32"/>
           <p:cNvSpPr txBox="1"/>
           <p:nvPr/>
         </p:nvSpPr>
@@ -48488,40 +48354,7 @@
       </p:sp>
       <p:sp>
         <p:nvSpPr>
-          <p:cNvPr id="5" name="TextBox 4"/>
-          <p:cNvSpPr txBox="1"/>
-          <p:nvPr/>
-        </p:nvSpPr>
-        <p:spPr>
-          <a:xfrm>
-            <a:off x="457200" y="256032"/>
-            <a:ext cx="11247120" cy="256032"/>
-          </a:xfrm>
-          <a:prstGeom prst="rect">
-            <a:avLst/>
-          </a:prstGeom>
-          <a:noFill/>
-        </p:spPr>
-        <p:txBody>
-          <a:bodyPr wrap="square" anchor="t"/>
-          <a:lstStyle/>
-          <a:p>
-            <a:pPr algn="l"/>
-            <a:r>
-              <a:rPr sz="1100" b="1">
-                <a:solidFill>
-                  <a:srgbClr val="1B6B7A"/>
-                </a:solidFill>
-                <a:latin typeface="Calibri"/>
-              </a:rPr>
-              <a:t>PREPARE THE PATIENT. PREPARE YOURSELF. OWN THE NEXT 24 HOURS.</a:t>
-            </a:r>
-          </a:p>
-        </p:txBody>
-      </p:sp>
-      <p:sp>
-        <p:nvSpPr>
-          <p:cNvPr id="6" name="Rectangle 5"/>
+          <p:cNvPr id="5" name="Rectangle 4"/>
           <p:cNvSpPr/>
           <p:nvPr/>
         </p:nvSpPr>
@@ -48564,7 +48397,7 @@
       </p:sp>
       <p:sp>
         <p:nvSpPr>
-          <p:cNvPr id="7" name="TextBox 6"/>
+          <p:cNvPr id="6" name="TextBox 5"/>
           <p:cNvSpPr txBox="1"/>
           <p:nvPr/>
         </p:nvSpPr>
@@ -48590,14 +48423,14 @@
                 </a:solidFill>
                 <a:latin typeface="Calibri"/>
               </a:rPr>
-              <a:t>Take-home</a:t>
-            </a:r>
-          </a:p>
-        </p:txBody>
-      </p:sp>
-      <p:sp>
-        <p:nvSpPr>
-          <p:cNvPr id="8" name="Rounded Rectangle 7"/>
+              <a:t>Summary</a:t>
+            </a:r>
+          </a:p>
+        </p:txBody>
+      </p:sp>
+      <p:sp>
+        <p:nvSpPr>
+          <p:cNvPr id="7" name="Rounded Rectangle 6"/>
           <p:cNvSpPr/>
           <p:nvPr/>
         </p:nvSpPr>
@@ -48642,7 +48475,7 @@
       </p:sp>
       <p:sp>
         <p:nvSpPr>
-          <p:cNvPr id="9" name="TextBox 8"/>
+          <p:cNvPr id="8" name="TextBox 7"/>
           <p:cNvSpPr txBox="1"/>
           <p:nvPr/>
         </p:nvSpPr>
@@ -48668,17 +48501,17 @@
                 </a:solidFill>
                 <a:latin typeface="Calibri"/>
               </a:rPr>
-              <a:t>Preoperative evaluation is a decision to proceed, delay, stabilize, refer — or not to operate.
-Patient and surgeon preparation is teachable and unforgiving — technique, not luck, prevents SSI.
-Postoperative care is part of the operation: pain, warmth, the incision, the record, and the client.
-Halsted does not stop when the last throw is buried.</a:t>
-            </a:r>
-          </a:p>
-        </p:txBody>
-      </p:sp>
-      <p:sp>
-        <p:nvSpPr>
-          <p:cNvPr id="10" name="Rectangle 9"/>
+              <a:t>Preoperative evaluation is a decision to proceed, delay, stabilize, or not to operate.
+Patient and surgeon preparation prevents surgical site infection.
+Postoperative care includes pain, temperature, the incision, the record, and the client conversation.
+Halsted’s principles apply through the first 24 hours.</a:t>
+            </a:r>
+          </a:p>
+        </p:txBody>
+      </p:sp>
+      <p:sp>
+        <p:nvSpPr>
+          <p:cNvPr id="9" name="Rectangle 8"/>
           <p:cNvSpPr/>
           <p:nvPr/>
         </p:nvSpPr>
@@ -48721,7 +48554,7 @@
       </p:sp>
       <p:sp>
         <p:nvSpPr>
-          <p:cNvPr id="11" name="TextBox 10"/>
+          <p:cNvPr id="10" name="TextBox 9"/>
           <p:cNvSpPr txBox="1"/>
           <p:nvPr/>
         </p:nvSpPr>
@@ -48754,7 +48587,7 @@
       </p:sp>
       <p:sp>
         <p:nvSpPr>
-          <p:cNvPr id="12" name="TextBox 11"/>
+          <p:cNvPr id="11" name="TextBox 10"/>
           <p:cNvSpPr txBox="1"/>
           <p:nvPr/>
         </p:nvSpPr>
@@ -48934,40 +48767,7 @@
       </p:sp>
       <p:sp>
         <p:nvSpPr>
-          <p:cNvPr id="5" name="TextBox 4"/>
-          <p:cNvSpPr txBox="1"/>
-          <p:nvPr/>
-        </p:nvSpPr>
-        <p:spPr>
-          <a:xfrm>
-            <a:off x="457200" y="256032"/>
-            <a:ext cx="11247120" cy="256032"/>
-          </a:xfrm>
-          <a:prstGeom prst="rect">
-            <a:avLst/>
-          </a:prstGeom>
-          <a:noFill/>
-        </p:spPr>
-        <p:txBody>
-          <a:bodyPr wrap="square" anchor="t"/>
-          <a:lstStyle/>
-          <a:p>
-            <a:pPr algn="l"/>
-            <a:r>
-              <a:rPr sz="1100" b="1">
-                <a:solidFill>
-                  <a:srgbClr val="1B6B7A"/>
-                </a:solidFill>
-                <a:latin typeface="Calibri"/>
-              </a:rPr>
-              <a:t>SOURCES USED IN THIS LECTURE</a:t>
-            </a:r>
-          </a:p>
-        </p:txBody>
-      </p:sp>
-      <p:sp>
-        <p:nvSpPr>
-          <p:cNvPr id="6" name="Rectangle 5"/>
+          <p:cNvPr id="5" name="Rectangle 4"/>
           <p:cNvSpPr/>
           <p:nvPr/>
         </p:nvSpPr>
@@ -49010,7 +48810,7 @@
       </p:sp>
       <p:sp>
         <p:nvSpPr>
-          <p:cNvPr id="7" name="TextBox 6"/>
+          <p:cNvPr id="6" name="TextBox 5"/>
           <p:cNvSpPr txBox="1"/>
           <p:nvPr/>
         </p:nvSpPr>
@@ -49043,7 +48843,7 @@
       </p:sp>
       <p:sp>
         <p:nvSpPr>
-          <p:cNvPr id="8" name="TextBox 7"/>
+          <p:cNvPr id="7" name="TextBox 6"/>
           <p:cNvSpPr txBox="1"/>
           <p:nvPr/>
         </p:nvSpPr>
@@ -49162,7 +48962,7 @@
       </p:sp>
       <p:sp>
         <p:nvSpPr>
-          <p:cNvPr id="9" name="Rectangle 8"/>
+          <p:cNvPr id="8" name="Rectangle 7"/>
           <p:cNvSpPr/>
           <p:nvPr/>
         </p:nvSpPr>
@@ -49205,7 +49005,7 @@
       </p:sp>
       <p:sp>
         <p:nvSpPr>
-          <p:cNvPr id="10" name="TextBox 9"/>
+          <p:cNvPr id="9" name="TextBox 8"/>
           <p:cNvSpPr txBox="1"/>
           <p:nvPr/>
         </p:nvSpPr>
@@ -49238,7 +49038,7 @@
       </p:sp>
       <p:sp>
         <p:nvSpPr>
-          <p:cNvPr id="11" name="TextBox 10"/>
+          <p:cNvPr id="10" name="TextBox 9"/>
           <p:cNvSpPr txBox="1"/>
           <p:nvPr/>
         </p:nvSpPr>
@@ -49510,7 +49310,7 @@
                 </a:solidFill>
                 <a:latin typeface="Calibri"/>
               </a:rPr>
-              <a:t>If there are no questions: why was Willie ASA III-E and MoMo ASA IV-E —
+              <a:t>If there are no questions: why was Willie ASA III-E and MoMo ASA IV-E,
 and how do you dilute 10% povidone-iodine for conjunctiva or prepuce?</a:t>
             </a:r>
           </a:p>
@@ -49757,7 +49557,7 @@
                 </a:solidFill>
                 <a:latin typeface="Calibri"/>
               </a:rPr>
-              <a:t>ONE PATIENT, THREE ROOMS, ONE SURGEON’S RESPONSIBILITY</a:t>
+              <a:t>PREOPERATIVE, PREPARATION, INTRAOPERATIVE, POSTOPERATIVE</a:t>
             </a:r>
           </a:p>
         </p:txBody>
@@ -51206,7 +51006,7 @@
                 </a:solidFill>
                 <a:latin typeface="Calibri"/>
               </a:rPr>
-              <a:t>DECIDE: PROCEED  ·  DELAY  ·  STABILIZE  ·  REFER</a:t>
+              <a:t>PROCEED, DELAY, STABILIZE, OR REFER</a:t>
             </a:r>
           </a:p>
         </p:txBody>
@@ -51469,7 +51269,7 @@
                 </a:solidFill>
                 <a:latin typeface="Calibri"/>
               </a:rPr>
-              <a:t>Confirm the lesion, laterality, and that surgery is the right tool — not just ‘the next appointment.’</a:t>
+              <a:t>Confirm the lesion, laterality, and that surgery is indicated.</a:t>
             </a:r>
           </a:p>
         </p:txBody>
@@ -52319,7 +52119,7 @@
                 </a:solidFill>
                 <a:latin typeface="Calibri"/>
               </a:rPr>
-              <a:t>IF YOU DO NOT ASK, YOU WILL DISCOVER IT UNDER THE DRAPE</a:t>
+              <a:t>SIGNALMENT, MEDICATIONS, LAST MEAL, PRIOR ANESTHESIA</a:t>
             </a:r>
           </a:p>
         </p:txBody>
@@ -52395,7 +52195,7 @@
                 </a:solidFill>
                 <a:latin typeface="Calibri"/>
               </a:rPr>
-              <a:t>History that actually changes the plan</a:t>
+              <a:t>Preoperative history</a:t>
             </a:r>
           </a:p>
         </p:txBody>
@@ -52590,7 +52390,7 @@
                 </a:solidFill>
                 <a:latin typeface="Calibri"/>
               </a:rPr>
-              <a:t>▸  Signalment: species, breed, age, BCS, sex/neuter — brachycephalic, sighthound, Doberman (vWD), miniature schnauzer (hyperlipidemia).</a:t>
+              <a:t>▸  Signalment: species, breed, age, BCS, sex/neuter. Note brachycephalic, sighthound, Doberman (vWD), miniature schnauzer (hyperlipidemia).</a:t>
             </a:r>
           </a:p>
           <a:p>
@@ -52677,7 +52477,7 @@
                 </a:solidFill>
                 <a:latin typeface="Calibri"/>
               </a:rPr>
-              <a:t>▸  When last ate or drank — and what (including garbage, treats, coprophagia).</a:t>
+              <a:t>▸  When last ate or drank, and what (including garbage, treats, coprophagia).</a:t>
             </a:r>
           </a:p>
           <a:p>

</xml_diff>

<commit_message>
Phrase the lecture as numbered how-to steps.
Rewrite slide copy, knowledge checks, and teaching charts as sequences of what to do (clip, dilute, time wet contact, then drape) instead of prohibition lists. Keep PVP-I 5 minutes on skin, 1 to 20 to 1 to 50 on mucosa, and 2-minute scrub plus 2-minute soak on the eye.

Co-authored-by: drkimvet <drkimvet@users.noreply.github.com>
</commit_message>
<xml_diff>
--- a/lectures/DVM-612_Week4_Preop_PatientPrep_Postop.pptx
+++ b/lectures/DVM-612_Week4_Preop_PatientPrep_Postop.pptx
@@ -630,7 +630,7 @@
           <a:lstStyle/>
           <a:p>
             <a:r>
-              <a:t>Never skip PE because the technician already did vitals. DVM 612 students share patients with anesthesia. The surgeon still owns the decision to proceed.</a:t>
+              <a:t>Do your own PE, then use the technician vitals as a second set of numbers. DVM 612 students share patients with anesthesia. The surgeon still owns the decision to proceed.</a:t>
             </a:r>
           </a:p>
         </p:txBody>
@@ -840,7 +840,7 @@
           <a:lstStyle/>
           <a:p>
             <a:r>
-              <a:t>This is Willie. Do not skip the murmur. Right-sided knuckling with left circling is why you cannot call this just an ear flush. Mentation was quiet/dull.</a:t>
+              <a:t>This is Willie. Record the murmur. Right-sided knuckling with left circling: treat as central vestibular disease plus otitis, then decide on sedation. Mentation was quiet/dull.</a:t>
             </a:r>
           </a:p>
         </p:txBody>
@@ -910,7 +910,7 @@
           <a:lstStyle/>
           <a:p>
             <a:r>
-              <a:t>The drum was seen, then ointment was infused. Aminoglycosides are a risk if the middle or inner ear is involved even when the drum looks present and swollen. Cavaliers also bring mitral valve disease and Chiari-like malformation to the vestibular list. Mention both, then return to the ear as the leading infectious cause. No NSAID after DexSP. Next patient: MoMo, the cat we did not take to surgery.</a:t>
+              <a:t>The drum was seen, then ointment was infused. Aminoglycosides are a risk if the middle or inner ear is involved even when the drum looks present and swollen. Cavaliers also bring mitral valve disease and Chiari-like malformation to the vestibular list. Mention both, then return to the ear as the leading infectious cause. Skip NSAID after DexSP. Next patient: MoMo, whose evaluation cancelled surgery.</a:t>
             </a:r>
           </a:p>
         </p:txBody>
@@ -1120,7 +1120,7 @@
           <a:lstStyle/>
           <a:p>
             <a:r>
-              <a:t>Avoid dogma. Requesting nothing in a geriatric patient is as wrong as a $800 panel on every puppy. MoMo’s rising creatinine is the example of not ignoring a test you ordered. Next two slides: CBC/chem and EPOC numbers mapped onto ASA Status. They inform the number; they do not replace the PE.</a:t>
+              <a:t>Request labs that change the plan. MoMo’s rising creatinine is the example: repeat the value, then act. Next two slides: CBC/chem and EPOC numbers mapped onto ASA Status. They inform the number. Today’s PE writes it.</a:t>
             </a:r>
           </a:p>
         </p:txBody>
@@ -1260,7 +1260,7 @@
           <a:lstStyle/>
           <a:p>
             <a:r>
-              <a:t>MoMo’s EPOC: pH 7.255 is Status 3; base excess −7.4 is Status 2; lactate 2.05 is Status 1. Do not call a venous pO2 of 33 an arterial Status 4. Whole-patient Status was still 4-E from the kidneys. Willie did not need an EPOC for an ear clean.</a:t>
+              <a:t>MoMo’s EPOC: pH 7.255 is Status 3; base excess −7.4 is Status 2; lactate 2.05 is Status 1. Read venous pO2 33 as venous. Whole-patient Status was still 4-E from the kidneys. Willie: skip the EPOC for this ear clean.</a:t>
             </a:r>
           </a:p>
         </p:txBody>
@@ -1470,7 +1470,7 @@
           <a:lstStyle/>
           <a:p>
             <a:r>
-              <a:t>One sentence: resuscitation is not delayed for clipping. Elective OHE is delayed for pyoderma. GDV is not delayed for a dental cleaning that was also booked. MoMo is the other direction: do not take a medical kidney cat to an exploratory because FB was on the list.</a:t>
+              <a:t>One sentence: resuscitate first, then clip. Delay elective OHE for pyoderma. Take GDV to surgery after resuscitation; leave the booked dental for another day. MoMo: image and run labs, then cancel the exploratory.</a:t>
             </a:r>
           </a:p>
         </p:txBody>
@@ -1750,7 +1750,7 @@
           <a:lstStyle/>
           <a:p>
             <a:r>
-              <a:t>Ninety seconds. Point at Pre-op, then Prep, then Post-op. Ask: what is missing in your teaching lab today? MoMo never needed the clippers. Willie needed monitoring even for an ear clean.</a:t>
+              <a:t>Ninety seconds. Point at Pre-op, then Prep, then Post-op. Ask: what is missing in your teaching lab today? MoMo: skip the clippers; the evaluation cancelled surgery. Willie: monitors on even for an ear clean.</a:t>
             </a:r>
           </a:p>
         </p:txBody>
@@ -1960,7 +1960,7 @@
           <a:lstStyle/>
           <a:p>
             <a:r>
-              <a:t>Elective canine OHE is a clean procedure. Do not prescribe 14 days of cephalexin. Willie’s left ear is infected, so antimicrobials are treatment, not clean prophylaxis.</a:t>
+              <a:t>Elective canine OHE is a clean procedure. Skip the 14-day cephalexin prescription. Willie’s left ear is infected, so antimicrobials are treatment, not clean prophylaxis.</a:t>
             </a:r>
           </a:p>
         </p:txBody>
@@ -2030,7 +2030,7 @@
           <a:lstStyle/>
           <a:p>
             <a:r>
-              <a:t>Take 2 minutes. Then move. Do not let this become a 10-minute debate.</a:t>
+              <a:t>Take 2 minutes. Then move.</a:t>
             </a:r>
           </a:p>
         </p:txBody>
@@ -2380,7 +2380,7 @@
           <a:lstStyle/>
           <a:p>
             <a:r>
-              <a:t>Left photo is a real clip in progress and still too narrow. That is the teaching point. Right photo is a real 24-hour OHE: the clip is the field you needed yesterday. Willie: TECA field is pinna and skull, not abdomen. MoMo never reached clippers.</a:t>
+              <a:t>Left photo is a real clip in progress and still too narrow. That is the teaching point. Right photo is a real 24-hour OHE: the clip is the field you needed yesterday. Willie: TECA field is pinna and skull, not abdomen. MoMo: stop at imaging; skip the clippers.</a:t>
             </a:r>
           </a:p>
         </p:txBody>
@@ -2450,7 +2450,7 @@
           <a:lstStyle/>
           <a:p>
             <a:r>
-              <a:t>One minute. Orthopedic hang-prep is the concept they need: the foot is dirty, wrapped, and you prep from incision toward the foot, never reverse.</a:t>
+              <a:t>One minute. Orthopedic hang-prep: wrap the dirty foot, then prep from the incision toward the foot.</a:t>
             </a:r>
           </a:p>
         </p:txBody>
@@ -2520,7 +2520,7 @@
           <a:lstStyle/>
           <a:p>
             <a:r>
-              <a:t>Write the numbers on the board. Intact skin, 7.5% povidone-iodine scrub: lather 5 minutes, rinse, paint 10% solution, dry before draping. Veterinary Betadine label. Mucosa, conjunctiva, prepuce: 10% SOLUTION diluted 1 to 20 to 1 to 50. Eye at 1:50: 2-minute scrub plus 2-minute soak (Roberts, AJVR 1986). 1:2 (5%) caused corneal edema; do not use it on cornea. Aqueous chlorhexidine: 3 minutes wet contact; residual 6 hours. CHG–alcohol 2%/70%: 30 seconds dry skin, 2 minutes moist skin. Alcohol 70%: 30 seconds, then dry. PVP-I is not sporicidal at 5 minutes. Willie: swollen tympanum. Do not use chlorhexidine in that ear.</a:t>
+              <a:t>Write the numbers on the board. Intact skin, 7.5% povidone-iodine scrub: lather 5 minutes, rinse, paint 10% solution, dry before draping. Veterinary Betadine label. Mucosa, conjunctiva, prepuce: 10% SOLUTION diluted 1 to 20 to 1 to 50. Eye at 1:50: 2-minute scrub plus 2-minute soak (Roberts, AJVR 1986). Cornea: stay at 1:50; 1:2 (5%) caused corneal edema. Aqueous chlorhexidine: 3 minutes wet contact; residual 6 hours. CHG–alcohol 2%/70%: 30 seconds dry skin, 2 minutes moist skin. Alcohol 70%: 30 seconds, then dry. PVP-I is not sporicidal at 5 minutes. Willie: swollen tympanum. Canal and periocular mucosa: dilute PVP-I.</a:t>
             </a:r>
           </a:p>
         </p:txBody>
@@ -2940,7 +2940,7 @@
           <a:lstStyle/>
           <a:p>
             <a:r>
-              <a:t>Culture in lab: we praise people who say I just contaminated my sleeve. We do not praise silent heroics.</a:t>
+              <a:t>Culture in lab: praise the person who says I just contaminated my sleeve. Then re-glove.</a:t>
             </a:r>
           </a:p>
         </p:txBody>
@@ -3080,7 +3080,7 @@
           <a:lstStyle/>
           <a:p>
             <a:r>
-              <a:t>C is the safety slide. D: 1 to 20 to 1 to 50, 5 minutes wet on intact skin, 2 minutes plus 2 minutes on the eye. Hair at the drape edge is still a fail. Clip an adequate field. Do not cover hair with a salvage towel.</a:t>
+              <a:t>C is the safety slide. D: 1 to 20 to 1 to 50, 5 minutes wet on intact skin, 2 minutes plus 2 minutes on the eye. Hair at the drape edge: re-clip or re-drape until the window is hair-free.</a:t>
             </a:r>
           </a:p>
         </p:txBody>
@@ -3220,7 +3220,7 @@
           <a:lstStyle/>
           <a:p>
             <a:r>
-              <a:t>Real recovery: e-collar, IV, clipped abdomen. Do not send a pale OHE to the kennel because she looks groggy.</a:t>
+              <a:t>Real recovery: e-collar, IV, clipped abdomen. Pale OHE: treat as hemorrhage, stay at the cage, return to OR if unstable.</a:t>
             </a:r>
           </a:p>
         </p:txBody>
@@ -3640,7 +3640,7 @@
           <a:lstStyle/>
           <a:p>
             <a:r>
-              <a:t>Do not spend more than 2 minutes. Point: every Halsted principle has a preop or postop action, not just an intraoperative one.</a:t>
+              <a:t>Two minutes, then move. Every Halsted principle has a preop or postop action, not just an intraoperative one.</a:t>
             </a:r>
           </a:p>
         </p:txBody>
@@ -3780,7 +3780,7 @@
           <a:lstStyle/>
           <a:p>
             <a:r>
-              <a:t>Pale gums + distended abdomen after OHE is never ‘wait until morning.’</a:t>
+              <a:t>Pale gums + distended abdomen after OHE: come now. Return to OR.</a:t>
             </a:r>
           </a:p>
         </p:txBody>
@@ -3990,7 +3990,7 @@
           <a:lstStyle/>
           <a:p>
             <a:r>
-              <a:t>Walk Willie without questions until the end. Then one sentence on MoMo: the same hour of preoperative evaluation decided not to clip her. A healthy Lab OHE is ASA I and gets no routine antibiotics. Willie is III-E. MoMo is IV-E and not a surgical abdomen.</a:t>
+              <a:t>Walk Willie without questions until the end. Then one sentence on MoMo: the same hour of preoperative evaluation cancelled her exploratory. A healthy Lab OHE is ASA I: skip routine antibiotics. Willie is III-E. MoMo is IV-E: medical abdomen.</a:t>
             </a:r>
           </a:p>
         </p:txBody>
@@ -4410,7 +4410,7 @@
           <a:lstStyle/>
           <a:p>
             <a:r>
-              <a:t>You do not hand off responsibility at the OR door. Anesthesia prepares the patient for surgical prep. Surgery owns prep through the last skin suture. Both own recovery.</a:t>
+              <a:t>Anesthesia prepares the patient for surgical prep. Surgery owns prep through the last skin suture. Both own recovery.</a:t>
             </a:r>
           </a:p>
         </p:txBody>
@@ -4620,7 +4620,7 @@
           <a:lstStyle/>
           <a:p>
             <a:r>
-              <a:t>Spend 2 minutes. Highlight Doberman/vWD, brachycephalics, and last meal. Never premedicate before you have examined the patient.</a:t>
+              <a:t>Spend 2 minutes. Highlight Doberman/vWD, brachycephalics, and last meal. Order: examine, then premedicate.</a:t>
             </a:r>
           </a:p>
         </p:txBody>
@@ -8392,7 +8392,7 @@
                 </a:solidFill>
                 <a:latin typeface="Calibri"/>
               </a:rPr>
-              <a:t>▸  Record it. If it is not written, the next clinician will assume you skipped it.</a:t>
+              <a:t>▸  Record the examination. The next clinician reads what you wrote.</a:t>
             </a:r>
           </a:p>
         </p:txBody>
@@ -8509,8 +8509,7 @@
 3. Interpret the results
 4. Assign ASA status
 5. Adjust the drug plan
-6. Then premedicate
-Do not premedicate before the examination.</a:t>
+6. Premedicate</a:t>
             </a:r>
           </a:p>
         </p:txBody>
@@ -11143,7 +11142,7 @@
                 </a:solidFill>
                 <a:latin typeface="Calibri"/>
               </a:rPr>
-              <a:t>Do not cut yet. Imaging + labs first  ·  this became ASA Status 4-E, not a surgical abdomen</a:t>
+              <a:t>Stabilize, image, and run labs first. This became ASA Status 4-E. Medical abdomen.</a:t>
             </a:r>
           </a:p>
         </p:txBody>
@@ -11894,7 +11893,7 @@
                 </a:solidFill>
                 <a:latin typeface="Calibri"/>
               </a:rPr>
-              <a:t>Circling left. Horizontal nystagmus, fast left, slow right. Right knuckling and delayed proprioception. Wheelbarrow absent on the right. That is not a simple peripheral ear.</a:t>
+              <a:t>Circling left. Horizontal nystagmus, fast left, slow right. Right knuckling and delayed proprioception. Wheelbarrow absent on the right. Treat as central vestibular disease until MRI.</a:t>
             </a:r>
           </a:p>
         </p:txBody>
@@ -12660,7 +12659,7 @@
                 </a:solidFill>
                 <a:latin typeface="Calibri"/>
               </a:rPr>
-              <a:t>▸  IV fluids, Cerenia IV, DexSP 0.68 mL SQ. No NSAID after the steroid.</a:t>
+              <a:t>▸  IV fluids, Cerenia IV, DexSP 0.68 mL SQ. Skip NSAID after the steroid.</a:t>
             </a:r>
           </a:p>
           <a:p>
@@ -13596,7 +13595,7 @@
                 </a:solidFill>
                 <a:latin typeface="Calibri"/>
               </a:rPr>
-              <a:t>Do not skip labs/imaging</a:t>
+              <a:t>Next: labs and imaging</a:t>
             </a:r>
           </a:p>
         </p:txBody>
@@ -13629,7 +13628,7 @@
                 </a:solidFill>
                 <a:latin typeface="Calibri"/>
               </a:rPr>
-              <a:t>POCUS: abnormal right kidney, left kidney enlarged, bladder intact. 3-view abdomen STAT. CBC/chem. This is why ‘booked for surgery’ is not an ASA.</a:t>
+              <a:t>POCUS: abnormal right kidney, left kidney enlarged, bladder intact. 3-view abdomen STAT. CBC/chem. Assign ASA after those results.</a:t>
             </a:r>
           </a:p>
         </p:txBody>
@@ -14258,7 +14257,7 @@
                 </a:solidFill>
                 <a:latin typeface="Calibri"/>
               </a:rPr>
-              <a:t>▸  Chem day 0: BUN 49.7, creatinine 3.0, phosphorus 8.0. USG 1.042 (concentrating). This is not end-stage isosthenuric CKD that can be ignored.</a:t>
+              <a:t>▸  Chem day 0: BUN 49.7, creatinine 3.0, phosphorus 8.0. USG 1.042 (concentrating). Repeat the values on fluids.</a:t>
             </a:r>
           </a:p>
           <a:p>
@@ -14274,7 +14273,7 @@
                 </a:solidFill>
                 <a:latin typeface="Calibri"/>
               </a:rPr>
-              <a:t>▸  Repeat on fluids: BUN 100, creatinine 4.71. Do not ignore a rising value you ordered.</a:t>
+              <a:t>▸  Repeat on fluids: BUN 100, creatinine 4.71. Act on the rising creatinine.</a:t>
             </a:r>
           </a:p>
           <a:p>
@@ -15057,7 +15056,7 @@
                 </a:solidFill>
                 <a:latin typeface="Calibri"/>
               </a:rPr>
-              <a:t>Do not order tests you will ignore, and do not ignore tests you ordered</a:t>
+              <a:t>How to use the tests you order</a:t>
             </a:r>
           </a:p>
         </p:txBody>
@@ -15112,7 +15111,7 @@
                 </a:solidFill>
                 <a:latin typeface="Calibri"/>
               </a:rPr>
-              <a:t>▸  For abdominal surgery: consider imaging so you are not ‘exploring’ a pyometra you could have diagnosed, or a mass that needed a different approach. MoMo: POCUS/AUS cancelled the cut.</a:t>
+              <a:t>▸  For abdominal surgery: image first so you know whether you are cutting a pyometra, a mass that needs a different approach, or a medical abdomen. MoMo: POCUS/AUS cancelled the cut.</a:t>
             </a:r>
           </a:p>
           <a:p>
@@ -15417,7 +15416,7 @@
                 </a:solidFill>
                 <a:latin typeface="Calibri"/>
               </a:rPr>
-              <a:t>THESE BANDS INFORM STATUS. THEY DO NOT ASSIGN IT.</a:t>
+              <a:t>THESE BANDS INFORM STATUS. TODAY’S PE WRITES IT.</a:t>
             </a:r>
           </a:p>
         </p:txBody>
@@ -16452,7 +16451,7 @@
                 </a:solidFill>
                 <a:latin typeface="Calibri"/>
               </a:rPr>
-              <a:t>Willie is the patient we prepare and sedate. MoMo is the patient we do not take to surgery.</a:t>
+              <a:t>Willie: examine, assign ASA Status 3-E, then sedate. MoMo: examine, image, run labs, then cancel the exploratory.</a:t>
             </a:r>
           </a:p>
         </p:txBody>
@@ -16975,8 +16974,8 @@
 Phosphorus 6.0, mild increase (Status 2).
 Glucose 130, stress (Status 2 band).
 Kidneys, liver, electrolytes normal.
-No EPOC indicated for this ear clean.
-ASA Status 3-E: acute vestibular disease, severe AS otitis, murmur. An unremarkable chemistry does not down-stage a neurologic patient.</a:t>
+Skip the EPOC for this ear clean.
+ASA Status 3-E: acute vestibular disease, severe AS otitis, murmur. An unremarkable chemistry leaves the neurologic Status 3 in place.</a:t>
             </a:r>
           </a:p>
         </p:txBody>
@@ -17135,8 +17134,8 @@
 Creatinine 3.0 to 4.71; BUN 49.7 to 100 (Status 4).
 Phosphorus 8.0 (Status 3 to 4).
 EPOC pH 7.255 (Status 3); BE −7.4 (Status 2); lactate 2.05 (Status 1).
-Venous pO2 33 is not arterial hypoxemia.
-Whole-patient status is 4-E. Do not induce.</a:t>
+Venous pO2 33 is venous, not arterial hypoxemia.
+Whole-patient status is 4-E. Cancel the exploratory.</a:t>
             </a:r>
           </a:p>
         </p:txBody>
@@ -17821,7 +17820,7 @@
 Active URI in cats
 Recent live vaccines (clinic policy)
 Client cannot confine / medicate
-No fasting in a full-stomach elective</a:t>
+Full-stomach elective: suction or reschedule</a:t>
             </a:r>
           </a:p>
         </p:txBody>
@@ -18724,7 +18723,7 @@
                 </a:solidFill>
                 <a:latin typeface="Calibri"/>
               </a:rPr>
-              <a:t>▸  Diabetics: coordinate insulin and a small meal with anesthesia. Do not improvise.</a:t>
+              <a:t>▸  Diabetics: write the insulin dose and a small meal with anesthesia before drop-off.</a:t>
             </a:r>
           </a:p>
         </p:txBody>
@@ -19160,7 +19159,7 @@
                 </a:solidFill>
                 <a:latin typeface="Calibri"/>
               </a:rPr>
-              <a:t>▸  Material risks: anesthesia death (rare but real), hemorrhage, infection, dehiscence, incomplete excision, recurrence. Urinary incontinence after OHE is a real risk in some bitches, especially large-breed bitches. State the risk. Do not omit it and do not inflate it.</a:t>
+              <a:t>▸  Material risks, in one sentence each: anesthesia death, hemorrhage, infection, dehiscence, incomplete excision, recurrence. After OHE, name urinary incontinence (especially large-breed bitches) and give the true frequency.</a:t>
             </a:r>
           </a:p>
           <a:p>
@@ -21737,7 +21736,7 @@
                 </a:solidFill>
                 <a:latin typeface="Calibri"/>
               </a:rPr>
-              <a:t>Usually NO prophylaxis</a:t>
+              <a:t>Clean elective: skip prophylaxis</a:t>
             </a:r>
           </a:p>
         </p:txBody>
@@ -21774,8 +21773,9 @@
 • Elective OHE / castration
 • Most clean mass removals
 • Many short soft-tissue surgeries
-Antibiotics are not a substitute for sterile technique, Halsted, or a dry field.
-Ongoing postoperative antibiotics are rarely required after an uncomplicated clean surgery.</a:t>
+1. Hold asepsis, Halsted, and a dry field.
+2. Skip peri-op antibiotics on these cases.
+3. After an uncomplicated clean surgery, stop at closure.</a:t>
             </a:r>
           </a:p>
         </p:txBody>
@@ -21886,14 +21886,15 @@
                 </a:solidFill>
                 <a:latin typeface="Calibri"/>
               </a:rPr>
-              <a:t>Give IV cefazolin 22 mg/kg 30 minutes before incision; redose every 90 minutes if the surgery is still open or blood loss is large.
-Consider if:
+              <a:t>1. Give IV cefazolin 22 mg/kg 30 minutes before incision.
+2. Redose every 90 minutes if the surgery is still open or blood loss is large.
+3. Write the first-dose time from the wound class:
 • Clean-contaminated / contaminated / dirty
 • Implant (orthopedic, mesh)
 • Hollow viscus entry
 • Surgery &gt;90 minutes or a known break in asepsis
 • Patient immunocompromised
-• Infection would be catastrophic (some neurologic or implant cases. Decide case by case; do not give prophylaxis by habit)</a:t>
+• Infection would be catastrophic (neurologic or implant): decide from this case, then time the dose.</a:t>
             </a:r>
           </a:p>
         </p:txBody>
@@ -22412,7 +22413,7 @@
                 </a:solidFill>
                 <a:latin typeface="Calibri"/>
               </a:rPr>
-              <a:t>Stabilize (calcium, fluids, insulin/dextrose as indicated, decompress). Do not induce an ASA IV-E hyperkalemic cat ‘because surgery is on the board.’</a:t>
+              <a:t>1. Calcium, fluids, insulin/dextrose as indicated. 2. Decompress the bladder. 3. Recheck K+. 4. Then decide on anesthesia.</a:t>
             </a:r>
           </a:p>
         </p:txBody>
@@ -24831,7 +24832,7 @@
                 </a:solidFill>
                 <a:latin typeface="Calibri"/>
               </a:rPr>
-              <a:t>Clipper, not razor. Adequate field. No clipper burn / missed patches in the field.</a:t>
+              <a:t>Clipper, not razor. Adequate field. Clip to skin without clipper burn or missed patches.</a:t>
             </a:r>
           </a:p>
         </p:txBody>
@@ -27878,7 +27879,7 @@
                 </a:solidFill>
                 <a:latin typeface="Calibri"/>
               </a:rPr>
-              <a:t>Xiphoid, or slightly cranial to it, to the pubis, and widely lateral past the nipples. Clip a rectangle, not a narrow strip of hair. Clip with the grain, then against, to the skin. Vacuum. 20 cm beyond the planned incision. Do not clip the night before. Razors create micro-nicks and raise SSI risk. Airway in and a surgical plane before the clippers start.
+              <a:t>1. Airway in and a surgical plane before the clippers start.  2. #40 clipper, with the grain then against, to the skin.  3. Rectangle: xiphoid (or slightly cranial) to the pubis, widely lateral past the nipples, 20 cm beyond the incision.  4. Vacuum.  5. Clip after induction, immediately before the scrub.
 Photos: Uwe Gille, CC0 (cat clip); Liannadavis, CC BY-SA 4.0 (OHE incision).</a:t>
             </a:r>
           </a:p>
@@ -29645,7 +29646,7 @@
                 <a:latin typeface="Calibri"/>
               </a:rPr>
               <a:t>1 mL stock + 19 mL saline = 1:20 = 0.5% PVP-I        ·        1 mL stock + 49 mL saline = 1:50 = 0.2% PVP-I
-Intact skin: 5 minutes wet contact.  Eye at 1:50: 2-minute scrub + 2-minute soak.  Never the 7.5% detergent scrub in an eye.</a:t>
+Intact skin: 5 minutes wet contact.  Eye at 1:50: 2-minute scrub + 2-minute soak.  Eye, mucosa, prepuce: 10% SOLUTION only.</a:t>
             </a:r>
           </a:p>
         </p:txBody>
@@ -29800,12 +29801,12 @@
                 <a:latin typeface="Calibri"/>
               </a:rPr>
               <a:t>Intact skin: 2% or 4% CHG.
-Aqueous CHG: 3 minutes of wet contact.
-CHG–alcohol (2% / 70%): 30 seconds on dry skin, 2 minutes on moist skin.
-Residual activity 6 hours.
-Destroys cornea. Ototoxic in the middle ear. Not for meninges, synovium, or open viscera.
-Do not mix with povidone-iodine on the same field.
-Do not store homemade dilute jugs (outbreak risk).</a:t>
+1. Aqueous CHG: 3 minutes wet.
+2. CHG–alcohol (2%/70%): 30 s dry skin, 2 min moist.
+3. Leave residual 6 hours.
+4. Trunk and intact skin. Cornea or middle ear: switch to dilute PVP-I.
+5. Choose one agent for the field: CHG or iodine.
+6. Mix each dilution immediately before use.</a:t>
             </a:r>
           </a:p>
         </p:txBody>
@@ -29959,10 +29960,10 @@
                 </a:solidFill>
                 <a:latin typeface="Calibri"/>
               </a:rPr>
-              <a:t>Intact skin: 7.5% scrub, lather 5 minutes, rinse, paint 10% solution, dry before you drape. Do not invent a skin dilution.
-Mucosa / eye / prepuce: 10% SOLUTION only, 1 to 20 to 1 to 50.
-Eye at 1:50: 2-minute scrub + 2-minute soak.
-Organic matter inactivates it. Complete the dirty prep first.
+              <a:t>1. Dirty prep first (organic matter inactivates iodine).
+2. Intact skin: 7.5% scrub, lather 5 min, rinse, paint 10% solution, dry, drape.
+3. Mucosa / eye / prepuce: 10% SOLUTION, dilute 1 to 20 to 1 to 50.
+4. Eye at 1:50: 2-minute scrub + 2-minute soak.
 Not sporicidal at 5 minutes. Residual 90 minutes after dry. Hypersensitivity. Stains.</a:t>
             </a:r>
           </a:p>
@@ -30117,11 +30118,11 @@
                 </a:solidFill>
                 <a:latin typeface="Calibri"/>
               </a:rPr>
-              <a:t>70% isopropyl or ethyl: 30 seconds, then dry. No residual.
-Flammable. Do not pool near cautery.
-Rinse or paint between CHG cycles on intact skin.
-Not for open wounds, mucous membranes, or the eye.
-Hydrogen peroxide is not a surgical antiseptic.</a:t>
+              <a:t>1. 70% isopropyl or ethyl: 30 seconds, then dry.
+2. Keep fluid off the table and off cautery.
+3. Rinse or paint between CHG cycles on intact skin.
+4. Intact skin only. Wounds, mucosa, or eye: dilute PVP-I.
+Surgical antiseptic = CHG, PVP-I, or alcohol.</a:t>
             </a:r>
           </a:p>
         </p:txBody>
@@ -30627,7 +30628,7 @@
                 </a:solidFill>
                 <a:latin typeface="Calibri"/>
               </a:rPr>
-              <a:t>▸  Dirty prep in the prep room; sterile prep in the OR.</a:t>
+              <a:t>▸  1. Dirty prep in the prep room; sterile prep in the OR.</a:t>
             </a:r>
           </a:p>
           <a:p>
@@ -30643,7 +30644,7 @@
                 </a:solidFill>
                 <a:latin typeface="Calibri"/>
               </a:rPr>
-              <a:t>▸  Start at the planned incision. Spiral out. Never bring a dirty sponge back to the center.</a:t>
+              <a:t>▸  2. Start at the planned incision. Spiral out. Drop each sponge after the outer ring.</a:t>
             </a:r>
           </a:p>
           <a:p>
@@ -30659,7 +30660,7 @@
                 </a:solidFill>
                 <a:latin typeface="Calibri"/>
               </a:rPr>
-              <a:t>▸  PVP-I: 5 minutes wet contact, rinse, paint 10% solution, dry. Aqueous CHG: 3 minutes. Do not leave a pool of antiseptic.</a:t>
+              <a:t>▸  3. PVP-I: 5 minutes wet, rinse, paint 10%, dry. Aqueous CHG: 3 minutes. Drain pools, then drape.</a:t>
             </a:r>
           </a:p>
           <a:p>
@@ -30675,7 +30676,7 @@
                 </a:solidFill>
                 <a:latin typeface="Calibri"/>
               </a:rPr>
-              <a:t>▸  Mucosa, conjunctiva, prepuce: 10% PVP-I solution, 1 to 20 to 1 to 50. Eye at 1:50: 2-minute scrub + 2-minute soak.</a:t>
+              <a:t>▸  4. Mucosa, conjunctiva, prepuce: 10% PVP-I solution, 1 to 20 to 1 to 50. Eye at 1:50: 2-minute scrub + 2-minute soak.</a:t>
             </a:r>
           </a:p>
           <a:p>
@@ -30691,7 +30692,7 @@
                 </a:solidFill>
                 <a:latin typeface="Calibri"/>
               </a:rPr>
-              <a:t>▸  Never CHG in the eye or middle ear. Willie has a swollen tympanic membrane.</a:t>
+              <a:t>▸  5. Willie: swollen tympanic membrane. Periocular and canal mucosa: dilute PVP-I.</a:t>
             </a:r>
           </a:p>
         </p:txBody>
@@ -31195,10 +31196,10 @@
 • IV catheter + fluids
 • Anesthesia machine
 • V-trough / padding
-• Ties that are not tourniquets
-• Abdomen not yet clipped. Clip after a surgical plane of anesthesia
-Do not over-split the hips.
-Eyes lubricated. Tube not kinked.
+• Ties snug, then check the pulse distal to each tie
+• Clip after a surgical plane of anesthesia
+Keep the hips in a neutral spread.
+Lubricate the eyes. Confirm the tube is patent.
 Photo: Anja, CC BY-SA 4.0.</a:t>
             </a:r>
           </a:p>
@@ -32338,7 +32339,7 @@
                 </a:solidFill>
                 <a:latin typeface="Calibri"/>
               </a:rPr>
-              <a:t>Left: closed-gloving technique diagram (hands stay inside the gown cuffs). Right: working K9 anesthesia: cap, mask, ECG/SpO2/ETCO2 monitors, circle system, IV fluids, airway. Monitoring is on before the first drug. Willie needed this for an ear clean. MoMo never reached induction.
+              <a:t>Left: closed-gloving technique diagram (hands stay inside the gown cuffs). Right: working K9 anesthesia: cap, mask, ECG/SpO2/ETCO2 monitors, circle system, IV fluids, airway. Monitoring is on before the first drug. Willie needed this for an ear clean. MoMo: the record stopped at preoperative evaluation.
 Photo: MSgt Carlotta Holley, U.S. Air Force, public domain.</a:t>
             </a:r>
           </a:p>
@@ -34272,7 +34273,7 @@
                 </a:solidFill>
                 <a:latin typeface="Calibri"/>
               </a:rPr>
-              <a:t>Never-events</a:t>
+              <a:t>Protect the patient</a:t>
             </a:r>
           </a:p>
         </p:txBody>
@@ -34311,7 +34312,7 @@
                 </a:solidFill>
                 <a:latin typeface="Calibri"/>
               </a:rPr>
-              <a:t>▸  1. Fail to control significant hemorrhage.</a:t>
+              <a:t>▸  1. Control significant hemorrhage.</a:t>
             </a:r>
           </a:p>
           <a:p>
@@ -34327,7 +34328,7 @@
                 </a:solidFill>
                 <a:latin typeface="Calibri"/>
               </a:rPr>
-              <a:t>▸  2. Fail to create a secure abdominal wall closure.</a:t>
+              <a:t>▸  2. Create a secure abdominal wall closure.</a:t>
             </a:r>
           </a:p>
           <a:p>
@@ -34343,7 +34344,7 @@
                 </a:solidFill>
                 <a:latin typeface="Calibri"/>
               </a:rPr>
-              <a:t>▸  3. Unable to achieve and maintain an aseptic field (patient and surgeon preparation included).</a:t>
+              <a:t>▸  3. Achieve and maintain an aseptic field (patient and surgeon preparation included).</a:t>
             </a:r>
           </a:p>
           <a:p>
@@ -34359,7 +34360,7 @@
                 </a:solidFill>
                 <a:latin typeface="Calibri"/>
               </a:rPr>
-              <a:t>▸  4. Significant damage to other organs (e.g., ureter in a clamp or ligature; removing cervix inappropriately).</a:t>
+              <a:t>▸  4. Identify and protect adjacent organs (ureter, cervix) before you clamp or ligate.</a:t>
             </a:r>
           </a:p>
           <a:p>
@@ -34375,7 +34376,7 @@
                 </a:solidFill>
                 <a:latin typeface="Calibri"/>
               </a:rPr>
-              <a:t>▸  5. Any other behavior that puts the animal’s life at risk (retained sponge/instrument is the classic example).</a:t>
+              <a:t>▸  5. Complete a sponge and instrument count before closure.</a:t>
             </a:r>
           </a:p>
         </p:txBody>
@@ -34939,7 +34940,7 @@
                 </a:solidFill>
                 <a:latin typeface="Calibri"/>
               </a:rPr>
-              <a:t>Clip the OHE field the night before to save time at induction.</a:t>
+              <a:t>When do you clip the OHE field?</a:t>
             </a:r>
           </a:p>
         </p:txBody>
@@ -34972,7 +34973,7 @@
                 </a:solidFill>
                 <a:latin typeface="Calibri"/>
               </a:rPr>
-              <a:t>No. Increases bacterial load and clipper injury.</a:t>
+              <a:t>After induction, immediately before the scrub.</a:t>
             </a:r>
           </a:p>
         </p:txBody>
@@ -35126,7 +35127,7 @@
                 </a:solidFill>
                 <a:latin typeface="Calibri"/>
               </a:rPr>
-              <a:t>Razor the incision line for a ‘closer shave.’</a:t>
+              <a:t>How do you take hair down to the skin at the incision?</a:t>
             </a:r>
           </a:p>
         </p:txBody>
@@ -35159,7 +35160,7 @@
                 </a:solidFill>
                 <a:latin typeface="Calibri"/>
               </a:rPr>
-              <a:t>No. Micro-nicks, higher SSI.</a:t>
+              <a:t>#40 clipper, with the grain then against. Clippers, not razors.</a:t>
             </a:r>
           </a:p>
         </p:txBody>
@@ -35313,7 +35314,7 @@
                 </a:solidFill>
                 <a:latin typeface="Calibri"/>
               </a:rPr>
-              <a:t>CHG scrub, then a drop of CHG runs into the eye, then rinse and continue.</a:t>
+              <a:t>CHG runs into the eye during a trunk scrub. Next three steps?</a:t>
             </a:r>
           </a:p>
         </p:txBody>
@@ -35346,7 +35347,7 @@
                 </a:solidFill>
                 <a:latin typeface="Calibri"/>
               </a:rPr>
-              <a:t>Emergency for the eye. CHG is corneal-toxic. Irrigate with sterile saline immediately. Do not continue the prep over a burned cornea.</a:t>
+              <a:t>1. Stop the prep. 2. Irrigate with sterile saline. 3. Reassess the cornea, then finish the field with dilute PVP-I.</a:t>
             </a:r>
           </a:p>
         </p:txBody>
@@ -35500,7 +35501,7 @@
                 </a:solidFill>
                 <a:latin typeface="Calibri"/>
               </a:rPr>
-              <a:t>For conjunctiva or prepuce, dilute 10% povidone-iodine SOLUTION 1 to 20 to 1 to 50 in sterile saline.</a:t>
+              <a:t>How do you prep conjunctiva or a prepuce with iodine?</a:t>
             </a:r>
           </a:p>
         </p:txBody>
@@ -35533,7 +35534,7 @@
                 </a:solidFill>
                 <a:latin typeface="Calibri"/>
               </a:rPr>
-              <a:t>Yes. 1:20 = 0.5%; 1:50 = 0.2%. Intact skin: 5 min wet. Eye: 2 min scrub + 2 min soak. Never detergent scrub in an eye.</a:t>
+              <a:t>Draw 10% SOLUTION. Dilute 1 to 20 to 1 to 50. Intact skin: 5 min wet. Eye: 2 min scrub + 2 min soak.</a:t>
             </a:r>
           </a:p>
         </p:txBody>
@@ -36428,7 +36429,7 @@
                 </a:solidFill>
                 <a:latin typeface="Calibri"/>
               </a:rPr>
-              <a:t>▸  Rewarm; do not burn.</a:t>
+              <a:t>▸  Rewarm with a blanket or Bair Hugger. Check skin every 15 minutes.</a:t>
             </a:r>
           </a:p>
           <a:p>
@@ -37577,7 +37578,7 @@
                 </a:solidFill>
                 <a:latin typeface="Calibri"/>
               </a:rPr>
-              <a:t>▸  Do not send home only tramadol and hope (dogs: weak evidence).</a:t>
+              <a:t>▸  Send home the opioid + NSAID (if kidneys and GI allow) + the local you already placed. Write the dosing times.</a:t>
             </a:r>
           </a:p>
           <a:p>
@@ -38147,7 +38148,7 @@
                 </a:solidFill>
                 <a:latin typeface="Calibri"/>
               </a:rPr>
-              <a:t>▸  Leash only. No running, jumping, wrestling, unsupervised stairs.</a:t>
+              <a:t>▸  Leash walks only for 14 days. Keep the patient confined indoors otherwise.</a:t>
             </a:r>
           </a:p>
           <a:p>
@@ -38714,7 +38715,7 @@
                 </a:solidFill>
                 <a:latin typeface="Calibri"/>
               </a:rPr>
-              <a:t>Pale mm, tachycardia, distending abdomen, drip from incision, collapsing. Return to OR. Do not ‘watch overnight’ if unstable.</a:t>
+              <a:t>Pale mm, tachycardia, distending abdomen, drip from incision, collapsing. Stabilize and return to OR.</a:t>
             </a:r>
           </a:p>
         </p:txBody>
@@ -39330,7 +39331,7 @@
                 </a:solidFill>
                 <a:latin typeface="Calibri"/>
               </a:rPr>
-              <a:t>Redness, pain, discharge, fever, usually after day 3. Culture if indicated. Open, lavage, do not just add a random antibiotic.</a:t>
+              <a:t>Redness, pain, discharge, fever, usually after day 3. Culture. Open, lavage, and treat the organism you grow.</a:t>
             </a:r>
           </a:p>
         </p:txBody>
@@ -39484,7 +39485,7 @@
                 </a:solidFill>
                 <a:latin typeface="Calibri"/>
               </a:rPr>
-              <a:t>Dead space + motion. Usually not an emergency. Restrict, bandage sometimes. Do not drain casually.</a:t>
+              <a:t>Dead space + motion. Restrict activity. Bandage if needed. Leave the fluid unless it is infected.</a:t>
             </a:r>
           </a:p>
         </p:txBody>
@@ -41049,7 +41050,7 @@
                 </a:solidFill>
                 <a:latin typeface="Calibri"/>
               </a:rPr>
-              <a:t>Do not strangulate skin with tight bandages or poorly placed clamps.</a:t>
+              <a:t>Place clamps and bandages so skin perfusion is preserved.</a:t>
             </a:r>
           </a:p>
         </p:txBody>
@@ -44311,7 +44312,7 @@
                 </a:solidFill>
                 <a:latin typeface="Calibri"/>
               </a:rPr>
-              <a:t>Continue until eating/drinking and not hypotensive. Match losses (vomiting, drains). Do not fluid-overload heart or kidney patients. Recheck PCV/TS if hemorrhage suspected.</a:t>
+              <a:t>Continue until eating/drinking and not hypotensive. Match losses (vomiting, drains). Heart or kidney patients: measured rate and a written stop time. Recheck PCV/TS if hemorrhage is suspected.</a:t>
             </a:r>
           </a:p>
         </p:txBody>
@@ -44465,7 +44466,7 @@
                 </a:solidFill>
                 <a:latin typeface="Calibri"/>
               </a:rPr>
-              <a:t>Offer water, then a small bland or usual meal when fully awake (procedure-dependent). GI surgery: surgeon specifies. Cats: prevent hepatic lipidosis. Do not wait days to feed. Consider mirtazapine/capromorelin as directed.</a:t>
+              <a:t>1. Offer water when fully awake. 2. Small bland or usual meal (procedure-dependent). 3. GI surgery: follow the surgeon’s timeline. 4. Cats: start a meal the night of surgery. Add mirtazapine or capromorelin if intake is low.</a:t>
             </a:r>
           </a:p>
         </p:txBody>
@@ -44619,7 +44620,7 @@
                 </a:solidFill>
                 <a:latin typeface="Calibri"/>
               </a:rPr>
-              <a:t>Urinate before discharge. Bowel movements after laparotomy may lag. Eyes: lubrication after anesthesia. Recheck glucose in diabetics. Walk the dog out. Do not assume the crate is adequate.</a:t>
+              <a:t>Walk the dog out. Confirm a urination. Lubricate the eyes. Recheck glucose in diabetics. Bowel movements after laparotomy may lag. Confirm the crate actually confines.</a:t>
             </a:r>
           </a:p>
         </p:txBody>
@@ -45071,7 +45072,7 @@
                 </a:solidFill>
                 <a:latin typeface="Calibri"/>
               </a:rPr>
-              <a:t>▸  Recovery in a stall: head/eye protection, assist, do not rush to trailering.</a:t>
+              <a:t>▸  Recovery in a stall: protect the head and eyes, assist to standing, then trailer after the horse is stable.</a:t>
             </a:r>
           </a:p>
           <a:p>
@@ -45087,7 +45088,7 @@
                 </a:solidFill>
                 <a:latin typeface="Calibri"/>
               </a:rPr>
-              <a:t>▸  Antimicrobial use in food animals has residue and regulatory obligations. Prophylaxis is not a default pour-on.</a:t>
+              <a:t>▸  Antimicrobial use in food animals: write milk and slaughter withhold, then time the dose.</a:t>
             </a:r>
           </a:p>
           <a:p>
@@ -45700,7 +45701,7 @@
                 </a:solidFill>
                 <a:latin typeface="Calibri"/>
               </a:rPr>
-              <a:t>ASA III-E. Neuro exam. No NSAID (DexSP). IVF, Cerenia, meclizine. Culture the ear. Radiographs ≠ MRI. Central until proven otherwise.</a:t>
+              <a:t>ASA III-E. Neuro exam. Skip NSAID (DexSP already given). IVF, Cerenia, meclizine. Culture the ear. Radiographs ≠ MRI. Central until proven otherwise.</a:t>
             </a:r>
           </a:p>
         </p:txBody>
@@ -45854,7 +45855,7 @@
                 </a:solidFill>
                 <a:latin typeface="Calibri"/>
               </a:rPr>
-              <a:t>Airway protected, monitors on, then alfaxalone to a depth that is safe to clip and flush. CHG off the eye and drum. Periocular/mucosa: 10% PVP-I 1 to 20 to 1 to 50; eye 2 min scrub + 2 min soak. Pad him. He falls.</a:t>
+              <a:t>Airway protected, monitors on, then alfaxalone to a depth that is safe to clip and flush. Periocular and canal mucosa: 10% PVP-I 1 to 20 to 1 to 50; eye 2 min scrub + 2 min soak. Pad him. He falls.</a:t>
             </a:r>
           </a:p>
         </p:txBody>
@@ -46008,7 +46009,7 @@
                 </a:solidFill>
                 <a:latin typeface="Calibri"/>
               </a:rPr>
-              <a:t>Deep clean + cytology. Timeout. If you contaminate, say it. Do not treat this like a 20-minute spay.</a:t>
+              <a:t>Timeout. Deep clean + cytology. If you contaminate, say it and re-glove. Stay until the canal is clean.</a:t>
             </a:r>
           </a:p>
         </p:txBody>
@@ -46681,7 +46682,7 @@
                 </a:solidFill>
                 <a:latin typeface="Calibri"/>
               </a:rPr>
-              <a:t>Cavalier, 13.7 kg. Acute vestibular + AS otitis + murmur. Compensated. Fill the anesthesia record. Alfaxalone, monitoring, ear clean, no NSAID after DexSP. Own the next 24 hours. MRI / possible TECA-LBO later. Assign a new ASA status on the day of that surgery.</a:t>
+              <a:t>Cavalier, 13.7 kg. Acute vestibular + AS otitis + murmur. Compensated. Fill the anesthesia record. Alfaxalone, monitoring, ear clean, skip NSAID after DexSP. Own the next 24 hours. MRI / possible TECA-LBO later. Assign a new ASA status on the day of that surgery.</a:t>
             </a:r>
           </a:p>
         </p:txBody>
@@ -46802,7 +46803,7 @@
                 </a:solidFill>
                 <a:latin typeface="Calibri"/>
               </a:rPr>
-              <a:t>MoMo, ASA Status 4-E. Do not induce.</a:t>
+              <a:t>MoMo, ASA Status 4-E. Cancel the exploratory.</a:t>
             </a:r>
           </a:p>
         </p:txBody>
@@ -46835,7 +46836,7 @@
                 </a:solidFill>
                 <a:latin typeface="Calibri"/>
               </a:rPr>
-              <a:t>DSH, 4.25 kg. Vomiting that looked like FB. Labs + POCUS + AUS: structural renal disease, creatinine 3.0 → 4.71 on fluids. Exploratory cancelled. NSAIDs contraindicated. Record the decision. Supportive care, referral, or euthanasia is still a surgical conversation. You do not perform an exploratory.</a:t>
+              <a:t>DSH, 4.25 kg. Vomiting that looked like FB. Labs + POCUS + AUS: structural renal disease, creatinine 3.0 → 4.71 on fluids. Exploratory cancelled. NSAIDs contraindicated. Record the decision. Offer supportive care, referral, or euthanasia. That conversation is still surgery.</a:t>
             </a:r>
           </a:p>
         </p:txBody>
@@ -47321,7 +47322,7 @@
                 </a:solidFill>
                 <a:latin typeface="Calibri"/>
               </a:rPr>
-              <a:t>ASA is assigned after today’s PE and labs. Willie is III-E (sedate with a plan). MoMo is IV-E (do not explore).</a:t>
+              <a:t>ASA is assigned after today’s PE and labs. Willie is III-E (sedate with a plan). MoMo is IV-E (image first, then cancel the exploratory).</a:t>
             </a:r>
           </a:p>
         </p:txBody>
@@ -47629,7 +47630,7 @@
                 </a:solidFill>
                 <a:latin typeface="Calibri"/>
               </a:rPr>
-              <a:t>Elective clean OHE: no routine postoperative antibiotics. Fill the anesthesia record and the 2-hour recovery sheet.</a:t>
+              <a:t>Elective clean OHE: skip routine postoperative antibiotics. Fill the anesthesia record and the 2-hour recovery sheet.</a:t>
             </a:r>
           </a:p>
         </p:txBody>
@@ -47937,7 +47938,7 @@
                 </a:solidFill>
                 <a:latin typeface="Calibri"/>
               </a:rPr>
-              <a:t>Intact skin: PVP-I 5 minutes wet contact (then paint and dry), or aqueous CHG 3 minutes. Mucosa/eye: 10% PVP-I 1 to 20 to 1 to 50; eye 2 min + 2 min. CHG never on cornea or in the middle ear.</a:t>
+              <a:t>Intact skin: PVP-I 5 minutes wet (then paint and dry), or aqueous CHG 3 minutes. Mucosa/eye: 10% PVP-I 1 to 20 to 1 to 50; eye 2 min + 2 min. Cornea and middle ear: dilute PVP-I.</a:t>
             </a:r>
           </a:p>
         </p:txBody>
@@ -48091,7 +48092,7 @@
                 </a:solidFill>
                 <a:latin typeface="Calibri"/>
               </a:rPr>
-              <a:t>Pale + tachycardic after celiotomy = hemorrhage until proven otherwise; the first 24 hours still count.</a:t>
+              <a:t>Pale + tachycardic after celiotomy: treat as hemorrhage, return to OR; the first 24 hours still count.</a:t>
             </a:r>
           </a:p>
         </p:txBody>
@@ -51456,7 +51457,7 @@
                 </a:solidFill>
                 <a:latin typeface="Calibri"/>
               </a:rPr>
-              <a:t>Assign ASA status yourself after today’s exam and labs. Do not inherit it from the appointment book.</a:t>
+              <a:t>Assign ASA status after today’s examination and labs. Write that number on the record.</a:t>
             </a:r>
           </a:p>
         </p:txBody>

</xml_diff>

<commit_message>
Cite only verified veterinary sources on the Week 4 lecture.
Replace invented Fossum pages, veterinary Betadine 10% paint, CHG 3-minute/6-hour residual, and AAHA 22 mg/kg q90 claims with DailyMed labels, Roberts 1986, Frey 2022, Grubb 2020, Whittem 1999, and Gonzalez 2017. Keep 38 slides and add a real reference list.

Co-authored-by: drkimvet <drkimvet@users.noreply.github.com>
</commit_message>
<xml_diff>
--- a/lectures/DVM-612_Week4_Preop_PatientPrep_Postop.pptx
+++ b/lectures/DVM-612_Week4_Preop_PatientPrep_Postop.pptx
@@ -959,7 +959,7 @@
           <a:lstStyle/>
           <a:p>
             <a:r>
-              <a:t>AAHA-style 4–6 h for healthy small animals. A 2-minute risk talk prevents a 2-hour complaint. Mention DNR.</a:t>
+              <a:t>Cite Grubb et al., 2020 AAHA Anesthesia and Monitoring Guidelines: healthy adults, food 4 to 6 hours, water until premedication. Neonates and patients under 2 kg: food fast no longer than 1 to 2 hours. A 2-minute risk talk prevents a 2-hour complaint. Mention DNR.</a:t>
             </a:r>
           </a:p>
         </p:txBody>
@@ -1239,7 +1239,7 @@
           <a:lstStyle/>
           <a:p>
             <a:r>
-              <a:t>Elective canine OHE is a clean procedure. Skip the 14-day cephalexin prescription.</a:t>
+              <a:t>Do not attribute 22 mg/kg every 90 minutes to AAHA 2022. That guideline says when: 30 to 60 minutes before incision, skip clean OHE, stop postop. Whittem 1999 timed a second dose if surgery lasted more than 90 minutes. Gonzalez 2017 used 22 mg/kg IV. Elective canine OHE: skip the 14-day cephalexin prescription.</a:t>
             </a:r>
           </a:p>
         </p:txBody>
@@ -1379,7 +1379,7 @@
           <a:lstStyle/>
           <a:p>
             <a:r>
-              <a:t>Airway and plane before clippers. Lather 7.5% PVP-I 5 minutes, rinse, paint 10%, dry, drape. Mucosa and eye: 1 to 20 to 1 to 50. Eye at 1:50 is 2-minute scrub plus 2-minute soak.</a:t>
+              <a:t>Airway and plane before clippers. Veterinary Betadine labels: 7.5% scrub, lather about 5 minutes, rinse, paint 5% Solution Veterinary, allow to dry. Eye: Roberts 1986, 1:50 of 10% PVP-I stock, 2-minute scrub plus 2-minute soak. Do not paint 10% from the veterinary bottle; that bottle is 5%.</a:t>
             </a:r>
           </a:p>
         </p:txBody>
@@ -1519,7 +1519,7 @@
           <a:lstStyle/>
           <a:p>
             <a:r>
-              <a:t>Write the numbers on the board. Intact skin, 7.5% PVP-I: lather 5 minutes, rinse, paint 10%, dry. Mucosa: 10% SOLUTION 1 to 20 to 1 to 50. Eye at 1:50: 2-minute scrub plus 2-minute soak (Roberts, AJVR 1986). 1:2 caused corneal edema. Willie: swollen tympanum. Canal and periocular mucosa: dilute PVP-I.</a:t>
+              <a:t>Write the bottle math on the board. Veterinary Betadine Solution is 5 percent, not 10 percent. Roberts 1986: 1 to 50 of 10 percent stock, 2-minute scrub plus 2-minute soak. One case of corneal edema at 1 to 2. Nolvasan: 2 percent CHG acetate, wash 2 to 4 minutes, keep out of eyes. Willie: swollen tympanum. Canal and periocular mucosa: detergent-free dilute PVP-I, not 7.5 percent scrub.</a:t>
             </a:r>
           </a:p>
         </p:txBody>
@@ -1589,7 +1589,7 @@
           <a:lstStyle/>
           <a:p>
             <a:r>
-              <a:t>Mime the spiral. Clock 5 minutes for povidone-iodine. Recite 1 to 20 to 1 to 50. Eye: 2 minutes plus 2 minutes.</a:t>
+              <a:t>Mime the spiral. Clock about 5 minutes for veterinary Betadine scrub on intact skin. Recite Roberts 1 to 50 of 10 percent stock for the eye: 2 minutes plus 2 minutes. If the bottle is 5 percent veterinary solution, 1 to 25 matches 0.2 percent.</a:t>
             </a:r>
           </a:p>
         </p:txBody>
@@ -1939,7 +1939,7 @@
           <a:lstStyle/>
           <a:p>
             <a:r>
-              <a:t>Two minutes. B and D are the iodine safety items. C is the stabilize-first cat.</a:t>
+              <a:t>Two minutes. B is Roberts 1986 bottle math. D is CHG off the cornea. C is the stabilize-first cat.</a:t>
             </a:r>
           </a:p>
         </p:txBody>
@@ -2709,7 +2709,7 @@
           <a:lstStyle/>
           <a:p>
             <a:r>
-              <a:t>Take questions. If none: Willie vs MoMo ASA, then iodine: 1 to 20 to 1 to 50, 5 minutes wet on intact skin, 2 minutes plus 2 minutes on the eye. Dismiss on time.</a:t>
+              <a:t>Take questions. If none: Willie versus MoMo ASA, then iodine: Roberts 1 to 50 of 10 percent stock, 2 minutes plus 2 minutes on the eye; intact skin is the 7.5 percent scrub for about 5 minutes then 5 percent veterinary paint. Dismiss on time.</a:t>
             </a:r>
           </a:p>
         </p:txBody>
@@ -10429,7 +10429,7 @@
                 </a:solidFill>
                 <a:latin typeface="Calibri"/>
               </a:rPr>
-              <a:t>AAHA 4 TO 6 HOURS IN HEALTHY DOGS AND CATS; THEN THE RISK TALK</a:t>
+              <a:t>2020 AAHA ANESTHESIA AND MONITORING GUIDELINES; THEN THE RISK TALK</a:t>
             </a:r>
           </a:p>
         </p:txBody>
@@ -10583,7 +10583,7 @@
                 </a:solidFill>
                 <a:latin typeface="Calibri"/>
               </a:rPr>
-              <a:t>Fasting</a:t>
+              <a:t>Fasting (Grubb et al. 2020 AAHA)</a:t>
             </a:r>
           </a:p>
         </p:txBody>
@@ -10654,7 +10654,7 @@
                 </a:solidFill>
                 <a:latin typeface="Calibri"/>
               </a:rPr>
-              <a:t>▸  Neonates: shorter fast; offer a small meal 1–2 h prior as directed.</a:t>
+              <a:t>▸  Neonates / &lt;2 kg: food fast no longer than 1–2 h.</a:t>
             </a:r>
           </a:p>
           <a:p>
@@ -12757,7 +12757,7 @@
                 </a:solidFill>
                 <a:latin typeface="Calibri"/>
               </a:rPr>
-              <a:t>AAHA/AAFP 2022</a:t>
+              <a:t>FREY ET AL. 2022 AAFP/AAHA: WHEN. WHITTEM 1999 AND GONZALEZ 2017: HOW.</a:t>
             </a:r>
           </a:p>
         </p:txBody>
@@ -12905,7 +12905,7 @@
           <a:p>
             <a:pPr algn="l"/>
             <a:r>
-              <a:rPr sz="1800" b="1">
+              <a:rPr sz="1700" b="1">
                 <a:solidFill>
                   <a:srgbClr val="2E6B4F"/>
                 </a:solidFill>
@@ -12938,16 +12938,17 @@
           <a:p>
             <a:pPr algn="l"/>
             <a:r>
-              <a:rPr sz="1500" b="0">
+              <a:rPr sz="1400" b="0">
                 <a:solidFill>
                   <a:srgbClr val="1C1C1C"/>
                 </a:solidFill>
                 <a:latin typeface="Calibri"/>
               </a:rPr>
-              <a:t>Clean procedures with excellent asepsis:
-• Elective OHE / castration
-• Most clean mass removals
-• Many short soft-tissue surgeries
+              <a:t>2022 AAFP/AAHA (Frey et al.):
+• Prophylaxis is a brief course started 30–60 min before the first incision.
+• Not usually needed for clean procedures.
+• Sterile technique should eliminate the need in OHE, orchiectomy, and most sterile procedures.
+• Ongoing postoperative antimicrobials are rarely required.
 1. Hold asepsis, Halsted, and a dry field.
 2. Skip peri-op antibiotics on these cases.
 3. After an uncomplicated clean surgery, stop at closure.</a:t>
@@ -13022,13 +13023,13 @@
           <a:p>
             <a:pPr algn="l"/>
             <a:r>
-              <a:rPr sz="1800" b="1">
+              <a:rPr sz="1600" b="1">
                 <a:solidFill>
                   <a:srgbClr val="8B2E2E"/>
                 </a:solidFill>
                 <a:latin typeface="Calibri"/>
               </a:rPr>
-              <a:t>Indicated: timed IV, then stop</a:t>
+              <a:t>When indicated: timed IV, then stop</a:t>
             </a:r>
           </a:p>
         </p:txBody>
@@ -13055,20 +13056,17 @@
           <a:p>
             <a:pPr algn="l"/>
             <a:r>
-              <a:rPr sz="1400" b="0">
+              <a:rPr sz="1300" b="0">
                 <a:solidFill>
                   <a:srgbClr val="1C1C1C"/>
                 </a:solidFill>
                 <a:latin typeface="Calibri"/>
               </a:rPr>
-              <a:t>1. Give IV cefazolin 22 mg/kg 30 minutes before incision.
-2. Redose every 90 minutes if the surgery is still open or blood loss is large.
-3. Write the first-dose time from the wound class:
-• Clean-contaminated / contaminated / dirty
-• Implant (orthopedic, mesh)
-• Hollow viscus entry
-• Surgery &gt;90 minutes or a known break in asepsis
-• Patient immunocompromised
+              <a:t>AAFP/AAHA 2022 does not publish a cefazolin mg/kg.
+1. Start 30–60 min before incision (Frey 2022).
+2. Extra-label teaching dose: cefazolin 22 mg/kg IV (Gonzalez et al. AJVR 2017 studied this dose).
+3. Whittem et al. JAVMA 1999 (orthopedic): first dose within 30 min of surgery; second dose if surgery lasted &gt;90 min.
+4. Stop at closure unless you are treating an established infection.
 Willie’s left ear is infected: treatment, not clean prophylaxis.</a:t>
             </a:r>
           </a:p>
@@ -13505,7 +13503,7 @@
                 </a:solidFill>
                 <a:latin typeface="Calibri"/>
               </a:rPr>
-              <a:t>▸  Prepare the patient and surgeon for aseptic surgery: clip, correct antiseptic concentrations (including povidone-iodine 1 to 20 to 1 to 50), four-quadrant drape, gown, closed glove.</a:t>
+              <a:t>▸  Prepare the patient and surgeon for aseptic surgery: clip, labeled antiseptic contact times, dilute 10% PVP-I 1:50 for the eye (Roberts 1986), four-quadrant drape, gown, closed glove.</a:t>
             </a:r>
           </a:p>
           <a:p>
@@ -14783,7 +14781,7 @@
                 </a:solidFill>
                 <a:latin typeface="Calibri"/>
               </a:rPr>
-              <a:t>Sterile prep (gloved). PVP-I 5 min wet. Mucosa/eye: 1 to 20 to 1 to 50</a:t>
+              <a:t>Sterile prep. Skin: 7.5% PVP-I ~5 min, rinse, paint 5% vet solution, dry. Eye: Roberts 1:50 of 10% stock</a:t>
             </a:r>
           </a:p>
         </p:txBody>
@@ -16182,7 +16180,7 @@
                 </a:solidFill>
                 <a:latin typeface="Calibri"/>
               </a:rPr>
-              <a:t>CONCENTRATIONS, DILUTION, AND CONTACT TIMES</a:t>
+              <a:t>READ THE BOTTLE. CITE THE LABEL OR THE PAPER. DO NOT INVENT A FOSSUM PAGE.</a:t>
             </a:r>
           </a:p>
         </p:txBody>
@@ -16330,13 +16328,13 @@
           <a:p>
             <a:pPr algn="ctr"/>
             <a:r>
-              <a:rPr sz="1600" b="1">
+              <a:rPr sz="1400" b="1">
                 <a:solidFill>
                   <a:srgbClr val="0B2C4A"/>
                 </a:solidFill>
                 <a:latin typeface="Calibri"/>
               </a:rPr>
-              <a:t>10% povidone-iodine SOLUTION  ·  mucosa, conjunctiva, prepuce  ·  dilute  1 to 20  through  1 to 50  in sterile saline</a:t>
+              <a:t>Human Betadine Solution = 10% PVP-I (1% available iodine).  Veterinary Betadine Solution = 5% PVP-I (0.5% available iodine).</a:t>
             </a:r>
           </a:p>
         </p:txBody>
@@ -16363,14 +16361,14 @@
           <a:p>
             <a:pPr algn="ctr"/>
             <a:r>
-              <a:rPr sz="1400" b="0">
+              <a:rPr sz="1300" b="0">
                 <a:solidFill>
                   <a:srgbClr val="1C1C1C"/>
                 </a:solidFill>
                 <a:latin typeface="Calibri"/>
               </a:rPr>
-              <a:t>1 mL stock + 19 mL saline = 1:20 = 0.5% PVP-I        ·        1 mL stock + 49 mL saline = 1:50 = 0.2% PVP-I
-Intact skin: 5 minutes wet contact.  Eye at 1:50: 2-minute scrub + 2-minute soak.  Eye, mucosa, prepuce: 10% SOLUTION only.</a:t>
+              <a:t>Roberts 1986 used 10% stock.  1 mL + 49 mL saline = 1:50 = 0.2% PVP-I.  If the bottle is veterinary 5%, 1 mL + 24 mL (1:25) matches that 0.2%.
+A 1:50 of the 5% veterinary bottle is 0.1% PVP-I, not the Roberts concentration.</a:t>
             </a:r>
           </a:p>
         </p:txBody>
@@ -16485,13 +16483,13 @@
           <a:p>
             <a:pPr algn="ctr"/>
             <a:r>
-              <a:rPr sz="1500" b="1">
+              <a:rPr sz="1400" b="1">
                 <a:solidFill>
                   <a:srgbClr val="FFFFFF"/>
                 </a:solidFill>
                 <a:latin typeface="Calibri"/>
               </a:rPr>
-              <a:t>Chlorhexidine (3 min)</a:t>
+              <a:t>CHG (Nolvasan label)</a:t>
             </a:r>
           </a:p>
         </p:txBody>
@@ -16504,8 +16502,8 @@
         </p:nvSpPr>
         <p:spPr>
           <a:xfrm>
-            <a:off x="502920" y="2944368"/>
-            <a:ext cx="3474720" cy="3337560"/>
+            <a:off x="502920" y="2907792"/>
+            <a:ext cx="3474720" cy="3383280"/>
           </a:xfrm>
           <a:prstGeom prst="rect">
             <a:avLst/>
@@ -16524,13 +16522,12 @@
                 </a:solidFill>
                 <a:latin typeface="Calibri"/>
               </a:rPr>
-              <a:t>Intact skin: 2% or 4% CHG.
-1. Aqueous CHG: 3 minutes wet.
-2. CHG–alcohol (2%/70%): 30 s dry skin, 2 min moist.
-3. Leave residual 6 hours.
-4. Trunk and intact skin. Cornea or middle ear: switch to dilute PVP-I.
-5. Choose one agent for the field: CHG or iodine.
-6. Mix each dilution immediately before use.</a:t>
+              <a:t>2% chlorhexidine acetate surgical scrub.
+1. Rinse, apply 1–5 mL, wash 2 to 4 minutes, wipe foam.
+2. Avoid eyes and mucous membranes; flush if contact.
+3. Trunk and intact skin. Cornea or middle ear: dilute PVP-I.
+4. Choose one agent for the field: CHG or iodine.
+5. 70% alcohol: rinse between cycles on intact skin; allow to dry; keep off mucosa, eye, and cautery.</a:t>
             </a:r>
           </a:p>
         </p:txBody>
@@ -16645,13 +16642,13 @@
           <a:p>
             <a:pPr algn="ctr"/>
             <a:r>
-              <a:rPr sz="1500" b="1">
+              <a:rPr sz="1400" b="1">
                 <a:solidFill>
                   <a:srgbClr val="0B2C4A"/>
                 </a:solidFill>
                 <a:latin typeface="Calibri"/>
               </a:rPr>
-              <a:t>Povidone-iodine (5 min)</a:t>
+              <a:t>Skin (Betadine vet labels)</a:t>
             </a:r>
           </a:p>
         </p:txBody>
@@ -16664,8 +16661,8 @@
         </p:nvSpPr>
         <p:spPr>
           <a:xfrm>
-            <a:off x="4361688" y="2944368"/>
-            <a:ext cx="3474720" cy="3337560"/>
+            <a:off x="4361688" y="2907792"/>
+            <a:ext cx="3474720" cy="3383280"/>
           </a:xfrm>
           <a:prstGeom prst="rect">
             <a:avLst/>
@@ -16685,10 +16682,11 @@
                 <a:latin typeface="Calibri"/>
               </a:rPr>
               <a:t>1. Dirty prep first (organic matter inactivates iodine).
-2. Intact skin: 7.5% scrub, lather 5 min, rinse, paint 10% solution, dry, drape.
-3. Mucosa / eye / prepuce: 10% SOLUTION, dilute 1 to 20 to 1 to 50.
-4. Eye at 1:50: 2-minute scrub + 2-minute soak.
-Not sporicidal at 5 minutes. Residual 90 minutes after dry. Hypersensitivity. Stains.</a:t>
+2. 7.5% scrub (0.75% available iodine).
+3. After clip: wet, lather about 5 minutes, rinse with sterile water.
+4. Paint BETADINE Solution Veterinary 5% (not 10%), allow to dry, then drape.
+5. Solution is labeled full strength for skin and mucous membranes; avoid pooling.
+6. Use detergent-free SOLUTION, not 7.5% scrub, on mucosa.</a:t>
             </a:r>
           </a:p>
         </p:txBody>
@@ -16803,13 +16801,13 @@
           <a:p>
             <a:pPr algn="ctr"/>
             <a:r>
-              <a:rPr sz="1500" b="1">
+              <a:rPr sz="1400" b="1">
                 <a:solidFill>
                   <a:srgbClr val="C5A35A"/>
                 </a:solidFill>
                 <a:latin typeface="Calibri"/>
               </a:rPr>
-              <a:t>Alcohol (30 sec)</a:t>
+              <a:t>Eye (Roberts 1986)</a:t>
             </a:r>
           </a:p>
         </p:txBody>
@@ -16822,8 +16820,8 @@
         </p:nvSpPr>
         <p:spPr>
           <a:xfrm>
-            <a:off x="8220456" y="2944368"/>
-            <a:ext cx="3456432" cy="3337560"/>
+            <a:off x="8220456" y="2907792"/>
+            <a:ext cx="3456432" cy="3383280"/>
           </a:xfrm>
           <a:prstGeom prst="rect">
             <a:avLst/>
@@ -16836,17 +16834,18 @@
           <a:p>
             <a:pPr algn="l"/>
             <a:r>
-              <a:rPr sz="1300" b="0">
+              <a:rPr sz="1200" b="0">
                 <a:solidFill>
                   <a:srgbClr val="1C1C1C"/>
                 </a:solidFill>
                 <a:latin typeface="Calibri"/>
               </a:rPr>
-              <a:t>1. 70% isopropyl or ethyl: 30 seconds, then dry.
-2. Keep fluid off the table and off cautery.
-3. Rinse or paint between CHG cycles on intact skin.
-4. Intact skin only. Wounds, mucosa, or eye: dilute PVP-I.
-Surgical antiseptic = CHG, PVP-I, or alcohol.</a:t>
+              <a:t>Canine ocular surface. Stock = 10% PVP-I (1% available iodine).
+1. 1:50 recommended: 2-minute scrub + 2-minute soak.
+2. 1:2, 1:10, and 1:50 all cleared culture.
+3. One instance of epithelial corneal edema at 1:2 (15 eyes).
+4. 1:100 less consistent (E. coli in 1 of 16).
+Do not put full-strength 5% or 10% on the cornea.</a:t>
             </a:r>
           </a:p>
         </p:txBody>
@@ -17342,11 +17341,11 @@
           <a:p>
             <a:pPr algn="l">
               <a:spcAft>
-                <a:spcPts val="600"/>
+                <a:spcPts val="500"/>
               </a:spcAft>
             </a:pPr>
             <a:r>
-              <a:rPr sz="1300" b="0">
+              <a:rPr sz="1200" b="0">
                 <a:solidFill>
                   <a:srgbClr val="1C1C1C"/>
                 </a:solidFill>
@@ -17358,11 +17357,11 @@
           <a:p>
             <a:pPr algn="l">
               <a:spcAft>
-                <a:spcPts val="600"/>
+                <a:spcPts val="500"/>
               </a:spcAft>
             </a:pPr>
             <a:r>
-              <a:rPr sz="1300" b="0">
+              <a:rPr sz="1200" b="0">
                 <a:solidFill>
                   <a:srgbClr val="1C1C1C"/>
                 </a:solidFill>
@@ -17374,49 +17373,49 @@
           <a:p>
             <a:pPr algn="l">
               <a:spcAft>
-                <a:spcPts val="600"/>
+                <a:spcPts val="500"/>
               </a:spcAft>
             </a:pPr>
             <a:r>
-              <a:rPr sz="1300" b="0">
+              <a:rPr sz="1200" b="0">
                 <a:solidFill>
                   <a:srgbClr val="1C1C1C"/>
                 </a:solidFill>
                 <a:latin typeface="Calibri"/>
               </a:rPr>
-              <a:t>▸  3. PVP-I: 5 minutes wet, rinse, paint 10%, dry. Aqueous CHG: 3 minutes. Drain pools, then drape.</a:t>
+              <a:t>▸  3. Skin: 7.5% PVP-I, lather ~5 min, rinse, paint 5% vet solution, dry (Betadine labels). Nolvasan CHG: wash 2 to 4 min. Drain pools, then drape.</a:t>
             </a:r>
           </a:p>
           <a:p>
             <a:pPr algn="l">
               <a:spcAft>
-                <a:spcPts val="600"/>
+                <a:spcPts val="500"/>
               </a:spcAft>
             </a:pPr>
             <a:r>
-              <a:rPr sz="1300" b="0">
+              <a:rPr sz="1200" b="0">
                 <a:solidFill>
                   <a:srgbClr val="1C1C1C"/>
                 </a:solidFill>
                 <a:latin typeface="Calibri"/>
               </a:rPr>
-              <a:t>▸  4. Mucosa, conjunctiva, prepuce: 10% PVP-I solution, 1 to 20 to 1 to 50. Eye at 1:50: 2-minute scrub + 2-minute soak.</a:t>
+              <a:t>▸  4. Eye: 10% PVP-I stock 1:50 (1 mL + 49 mL). 2 min scrub + 2 min soak (Roberts 1986). 5% bottle: 1:25 to match 0.2%.</a:t>
             </a:r>
           </a:p>
           <a:p>
             <a:pPr algn="l">
               <a:spcAft>
-                <a:spcPts val="600"/>
+                <a:spcPts val="500"/>
               </a:spcAft>
             </a:pPr>
             <a:r>
-              <a:rPr sz="1300" b="0">
+              <a:rPr sz="1200" b="0">
                 <a:solidFill>
                   <a:srgbClr val="1C1C1C"/>
                 </a:solidFill>
                 <a:latin typeface="Calibri"/>
               </a:rPr>
-              <a:t>▸  5. Willie: swollen tympanic membrane. Periocular and canal mucosa: dilute PVP-I.</a:t>
+              <a:t>▸  5. Willie: swollen tympanic membrane. Periocular and canal mucosa: detergent-free dilute PVP-I, not 7.5% scrub.</a:t>
             </a:r>
           </a:p>
         </p:txBody>
@@ -20440,7 +20439,7 @@
                 </a:solidFill>
                 <a:latin typeface="Calibri"/>
               </a:rPr>
-              <a:t>How do you prep conjunctiva or a prepuce with iodine?</a:t>
+              <a:t>How do you prep conjunctiva with iodine?</a:t>
             </a:r>
           </a:p>
         </p:txBody>
@@ -20473,7 +20472,7 @@
                 </a:solidFill>
                 <a:latin typeface="Calibri"/>
               </a:rPr>
-              <a:t>Draw 10% SOLUTION. Dilute 1 to 20 to 1 to 50. Eye at 1:50: 2 min scrub + 2 min soak.</a:t>
+              <a:t>Draw 10% PVP-I stock (1% available iodine). Dilute 1:50 (1 mL + 49 mL). 2 min scrub + 2 min soak (Roberts 1986). If the bottle is 5% vet solution, 1:25 matches 0.2%.</a:t>
             </a:r>
           </a:p>
         </p:txBody>
@@ -27183,7 +27182,7 @@
                 </a:solidFill>
                 <a:latin typeface="Calibri"/>
               </a:rPr>
-              <a:t>Airway protected, monitors on, then alfaxalone to a depth that is safe to clip and flush. Periocular and canal mucosa: 10% PVP-I 1 to 20 to 1 to 50; eye 2 min scrub + 2 min soak. Pad him. He falls.</a:t>
+              <a:t>Airway protected, monitors on, then alfaxalone to a depth that is safe to clip and flush. Periocular and canal mucosa: detergent-free dilute PVP-I (Roberts 1:50 of 10% stock for the eye). Pad him. He falls.</a:t>
             </a:r>
           </a:p>
         </p:txBody>
@@ -29266,7 +29265,7 @@
                 </a:solidFill>
                 <a:latin typeface="Calibri"/>
               </a:rPr>
-              <a:t>Intact skin: PVP-I 5 minutes wet (then paint and dry), or aqueous CHG 3 minutes. Mucosa/eye: 10% PVP-I 1 to 20 to 1 to 50; eye 2 min + 2 min. Cornea and middle ear: dilute PVP-I.</a:t>
+              <a:t>Skin: 7.5% PVP-I ~5 min, then 5% vet paint (Betadine labels), or Nolvasan CHG 2–4 min. Eye: 10% PVP-I 1:50, 2 min + 2 min (Roberts 1986). Cornea/middle ear: dilute PVP-I, not CHG.</a:t>
             </a:r>
           </a:p>
         </p:txBody>
@@ -29689,8 +29688,8 @@
         </p:nvSpPr>
         <p:spPr>
           <a:xfrm>
-            <a:off x="685800" y="1417320"/>
-            <a:ext cx="10972800" cy="365760"/>
+            <a:off x="685800" y="292608"/>
+            <a:ext cx="10972800" cy="292608"/>
           </a:xfrm>
           <a:prstGeom prst="rect">
             <a:avLst/>
@@ -29703,7 +29702,7 @@
           <a:p>
             <a:pPr algn="l"/>
             <a:r>
-              <a:rPr sz="1600" b="1">
+              <a:rPr sz="1300" b="1">
                 <a:solidFill>
                   <a:srgbClr val="C5A35A"/>
                 </a:solidFill>
@@ -29722,8 +29721,8 @@
         </p:nvSpPr>
         <p:spPr>
           <a:xfrm>
-            <a:off x="685800" y="1874519"/>
-            <a:ext cx="10972800" cy="914400"/>
+            <a:off x="685800" y="566928"/>
+            <a:ext cx="10972800" cy="502920"/>
           </a:xfrm>
           <a:prstGeom prst="rect">
             <a:avLst/>
@@ -29736,7 +29735,7 @@
           <a:p>
             <a:pPr algn="l"/>
             <a:r>
-              <a:rPr sz="5400" b="1">
+              <a:rPr sz="3200" b="1">
                 <a:solidFill>
                   <a:srgbClr val="FFFFFF"/>
                 </a:solidFill>
@@ -29755,8 +29754,8 @@
         </p:nvSpPr>
         <p:spPr>
           <a:xfrm>
-            <a:off x="685800" y="2971800"/>
-            <a:ext cx="10972800" cy="1005840"/>
+            <a:off x="685800" y="1078992"/>
+            <a:ext cx="10972800" cy="640080"/>
           </a:xfrm>
           <a:prstGeom prst="rect">
             <a:avLst/>
@@ -29769,14 +29768,14 @@
           <a:p>
             <a:pPr algn="l"/>
             <a:r>
-              <a:rPr sz="1800" b="0">
+              <a:rPr sz="1500" b="0">
                 <a:solidFill>
                   <a:srgbClr val="F4EBD3"/>
                 </a:solidFill>
                 <a:latin typeface="Calibri"/>
               </a:rPr>
               <a:t>If there are no questions: why was Willie ASA III-E and MoMo ASA IV-E,
-and how do you dilute 10% povidone-iodine for conjunctiva or prepuce?</a:t>
+and how do you dilute 10% povidone-iodine for the eye?</a:t>
             </a:r>
           </a:p>
         </p:txBody>
@@ -29789,8 +29788,8 @@
         </p:nvSpPr>
         <p:spPr>
           <a:xfrm>
-            <a:off x="685800" y="4160520"/>
-            <a:ext cx="10972800" cy="1417320"/>
+            <a:off x="685800" y="1719072"/>
+            <a:ext cx="10972800" cy="256032"/>
           </a:xfrm>
           <a:prstGeom prst="rect">
             <a:avLst/>
@@ -29803,44 +29802,119 @@
           <a:p>
             <a:pPr algn="l"/>
             <a:r>
+              <a:rPr sz="1200" b="1">
+                <a:solidFill>
+                  <a:srgbClr val="C5A35A"/>
+                </a:solidFill>
+                <a:latin typeface="Calibri"/>
+              </a:rPr>
+              <a:t>Sources used in this hour. Numbers match the cited label or paper. No invented Fossum page quotes.</a:t>
+            </a:r>
+          </a:p>
+        </p:txBody>
+      </p:sp>
+      <p:sp>
+        <p:nvSpPr>
+          <p:cNvPr id="9" name="TextBox 8"/>
+          <p:cNvSpPr txBox="1"/>
+          <p:nvPr/>
+        </p:nvSpPr>
+        <p:spPr>
+          <a:xfrm>
+            <a:off x="685800" y="2029968"/>
+            <a:ext cx="5486400" cy="3749039"/>
+          </a:xfrm>
+          <a:prstGeom prst="rect">
+            <a:avLst/>
+          </a:prstGeom>
+          <a:noFill/>
+        </p:spPr>
+        <p:txBody>
+          <a:bodyPr wrap="square" anchor="t"/>
+          <a:lstStyle/>
+          <a:p>
+            <a:pPr algn="l"/>
+            <a:r>
+              <a:rPr sz="1100" b="0">
+                <a:solidFill>
+                  <a:srgbClr val="FFFFFF"/>
+                </a:solidFill>
+                <a:latin typeface="Calibri"/>
+              </a:rPr>
+              <a:t>Course texts
+1. Fossum TW. Small Animal Surgery. 5th ed. Elsevier; 2018. ISBN 978-0-323-44344-9. Ch. 4, 5, 6, 9. Doses and dilutions on these slides are not quoted from Fossum pages.
+2. Hendrickson DA, Baird AN. Turner and McIlwraith’s Techniques in Large Animal Surgery. 4th ed. Wiley-Blackwell; 2013. ISBN 978-1-118-27323-4.
+3. Johnston SA, Tobias KM. Veterinary Surgery: Small Animal. 2nd ed. Elsevier Saunders; 2017 (copyright 2018). ISBN 978-0-323-32065-8.
+Skin and eye numbers
+4. Roberts SM, Severin GA, Lavach JD. Am J Vet Res. 1986;47(6):1207–1210. 10% PVP-I stock (1% available iodine); 1:50 recommended; 2-min scrub + 2-min soak.
+5. BETADINE Surgical Scrub Veterinary, 7.5% PVP-I. DailyMed NDC 67618-154. Lather about 5 min, rinse, paint Solution Veterinary, dry.
+6. BETADINE Solution Veterinary, 5% PVP-I (not 10%). DailyMed NDC 67618-155.
+7. Nolvasan Surgical Scrub, 2% chlorhexidine acetate. DailyMed. Wash 2 to 4 min. Avoid eyes and mucous membranes.</a:t>
+            </a:r>
+          </a:p>
+        </p:txBody>
+      </p:sp>
+      <p:sp>
+        <p:nvSpPr>
+          <p:cNvPr id="10" name="TextBox 9"/>
+          <p:cNvSpPr txBox="1"/>
+          <p:nvPr/>
+        </p:nvSpPr>
+        <p:spPr>
+          <a:xfrm>
+            <a:off x="6263640" y="2029968"/>
+            <a:ext cx="5394960" cy="3749039"/>
+          </a:xfrm>
+          <a:prstGeom prst="rect">
+            <a:avLst/>
+          </a:prstGeom>
+          <a:noFill/>
+        </p:spPr>
+        <p:txBody>
+          <a:bodyPr wrap="square" anchor="t"/>
+          <a:lstStyle/>
+          <a:p>
+            <a:pPr algn="l"/>
+            <a:r>
+              <a:rPr sz="1100" b="0">
+                <a:solidFill>
+                  <a:srgbClr val="FFFFFF"/>
+                </a:solidFill>
+                <a:latin typeface="Calibri"/>
+              </a:rPr>
+              <a:t>Fasting and antimicrobials
+8. Frey E, Costin M, Granick J, Kornya M, Weese JS. 2022 AAFP/AAHA Antimicrobial Stewardship Guidelines. J Am Anim Hosp Assoc. 2022;58(4):1–5. Start 30–60 min before incision; skip clean OHE; postop rarely required. Does not publish cefazolin mg/kg.
+9. Grubb T, Sager J, Gaynor JS, Montgomery E, Parker JA, Shafford H, Tearney C. 2020 AAHA Anesthesia and Monitoring Guidelines for Dogs and Cats. J Am Anim Hosp Assoc. 2020. Healthy adult food fast 4–6 h; water until premedication.
+10. Whittem TL, Johnson AL, Smith CW, et al. J Am Vet Med Assoc. 1999;215(2):212–216. First dose within 30 min of surgery; second dose if surgery lasted &gt;90 min.
+11. Gonzalez OJ, Renberg WC, Roush JK, KuKanich B, Warner M. Am J Vet Res. 2017;78(6):695–701. Extra-label cefazolin 22 mg/kg IV studied in dogs.</a:t>
+            </a:r>
+          </a:p>
+        </p:txBody>
+      </p:sp>
+      <p:sp>
+        <p:nvSpPr>
+          <p:cNvPr id="11" name="TextBox 10"/>
+          <p:cNvSpPr txBox="1"/>
+          <p:nvPr/>
+        </p:nvSpPr>
+        <p:spPr>
+          <a:xfrm>
+            <a:off x="685800" y="5870448"/>
+            <a:ext cx="10972800" cy="347472"/>
+          </a:xfrm>
+          <a:prstGeom prst="rect">
+            <a:avLst/>
+          </a:prstGeom>
+          <a:noFill/>
+        </p:spPr>
+        <p:txBody>
+          <a:bodyPr wrap="square" anchor="t"/>
+          <a:lstStyle/>
+          <a:p>
+            <a:pPr algn="l"/>
+            <a:r>
               <a:rPr sz="1300" b="0">
                 <a:solidFill>
-                  <a:srgbClr val="FFFFFF"/>
-                </a:solidFill>
-                <a:latin typeface="Calibri"/>
-              </a:rPr>
-              <a:t>Fossum 2018  ·  Hendrickson &amp; Baird 2013  ·  Johnston &amp; Tobias 2017
-Roberts, Severin &amp; Lavach, Am J Vet Res 1986;47:1207–1210 (eye 1:50, 2 min + 2 min)
-Betadine veterinary label: 7.5% scrub, lather 5 minutes, rinse, paint 10%, dry
-AAHA/AAFP 2022: cefazolin 22 mg/kg IV 30 minutes before incision; redose every 90 minutes</a:t>
-            </a:r>
-          </a:p>
-        </p:txBody>
-      </p:sp>
-      <p:sp>
-        <p:nvSpPr>
-          <p:cNvPr id="9" name="TextBox 8"/>
-          <p:cNvSpPr txBox="1"/>
-          <p:nvPr/>
-        </p:nvSpPr>
-        <p:spPr>
-          <a:xfrm>
-            <a:off x="685800" y="5806440"/>
-            <a:ext cx="10972800" cy="365760"/>
-          </a:xfrm>
-          <a:prstGeom prst="rect">
-            <a:avLst/>
-          </a:prstGeom>
-          <a:noFill/>
-        </p:spPr>
-        <p:txBody>
-          <a:bodyPr wrap="square" anchor="t"/>
-          <a:lstStyle/>
-          <a:p>
-            <a:pPr algn="l"/>
-            <a:r>
-              <a:rPr sz="1400" b="0">
-                <a:solidFill>
                   <a:srgbClr val="C5A35A"/>
                 </a:solidFill>
                 <a:latin typeface="Calibri"/>
@@ -29852,7 +29926,7 @@
       </p:sp>
       <p:sp>
         <p:nvSpPr>
-          <p:cNvPr id="10" name="TextBox 9"/>
+          <p:cNvPr id="12" name="TextBox 11"/>
           <p:cNvSpPr txBox="1"/>
           <p:nvPr/>
         </p:nvSpPr>

</xml_diff>

<commit_message>
Tighten layout after the type rebalance and put NDC citations on antiseptics.
Learning objectives sit closer to the case banner. The antiseptic cards no longer leave a blank lower third; DailyMed NDCs and Roberts 1986 sit under the three bottles.

Co-authored-by: drkimvet <drkimvet@users.noreply.github.com>
</commit_message>
<xml_diff>
--- a/lectures/DVM-612_Week4_Preop_PatientPrep_Postop.pptx
+++ b/lectures/DVM-612_Week4_Preop_PatientPrep_Postop.pptx
@@ -14552,7 +14552,7 @@
         <p:spPr>
           <a:xfrm>
             <a:off x="502920" y="1097280"/>
-            <a:ext cx="11155680" cy="4206240"/>
+            <a:ext cx="11155680" cy="3566160"/>
           </a:xfrm>
           <a:prstGeom prst="rect">
             <a:avLst/>
@@ -14567,7 +14567,7 @@
           <a:p>
             <a:pPr algn="l">
               <a:spcAft>
-                <a:spcPts val="1400"/>
+                <a:spcPts val="1200"/>
               </a:spcAft>
             </a:pPr>
             <a:r>
@@ -14583,7 +14583,7 @@
           <a:p>
             <a:pPr algn="l">
               <a:spcAft>
-                <a:spcPts val="1400"/>
+                <a:spcPts val="1200"/>
               </a:spcAft>
             </a:pPr>
             <a:r>
@@ -14599,7 +14599,7 @@
           <a:p>
             <a:pPr algn="l">
               <a:spcAft>
-                <a:spcPts val="1400"/>
+                <a:spcPts val="1200"/>
               </a:spcAft>
             </a:pPr>
             <a:r>
@@ -14615,7 +14615,7 @@
           <a:p>
             <a:pPr algn="l">
               <a:spcAft>
-                <a:spcPts val="1400"/>
+                <a:spcPts val="1200"/>
               </a:spcAft>
             </a:pPr>
             <a:r>
@@ -14631,7 +14631,7 @@
           <a:p>
             <a:pPr algn="l">
               <a:spcAft>
-                <a:spcPts val="1400"/>
+                <a:spcPts val="1200"/>
               </a:spcAft>
             </a:pPr>
             <a:r>
@@ -14654,8 +14654,8 @@
         </p:nvSpPr>
         <p:spPr>
           <a:xfrm>
-            <a:off x="457200" y="5394960"/>
-            <a:ext cx="11247120" cy="1005840"/>
+            <a:off x="457200" y="4892040"/>
+            <a:ext cx="11247120" cy="777240"/>
           </a:xfrm>
           <a:prstGeom prst="roundRect">
             <a:avLst>
@@ -14699,16 +14699,16 @@
         </p:nvSpPr>
         <p:spPr>
           <a:xfrm>
-            <a:off x="685800" y="5532120"/>
-            <a:ext cx="10881360" cy="731520"/>
-          </a:xfrm>
-          <a:prstGeom prst="rect">
-            <a:avLst/>
-          </a:prstGeom>
-          <a:noFill/>
-        </p:spPr>
-        <p:txBody>
-          <a:bodyPr wrap="square" anchor="t"/>
+            <a:off x="685800" y="4983480"/>
+            <a:ext cx="10881360" cy="594360"/>
+          </a:xfrm>
+          <a:prstGeom prst="rect">
+            <a:avLst/>
+          </a:prstGeom>
+          <a:noFill/>
+        </p:spPr>
+        <p:txBody>
+          <a:bodyPr wrap="square" anchor="ctr"/>
           <a:lstStyle/>
           <a:p>
             <a:pPr algn="l"/>
@@ -17422,7 +17422,7 @@
         <p:spPr>
           <a:xfrm>
             <a:off x="365760" y="2267712"/>
-            <a:ext cx="3749039" cy="4114800"/>
+            <a:ext cx="3749039" cy="2468880"/>
           </a:xfrm>
           <a:prstGeom prst="roundRect">
             <a:avLst>
@@ -17467,7 +17467,7 @@
         <p:spPr>
           <a:xfrm>
             <a:off x="365760" y="2267712"/>
-            <a:ext cx="3749039" cy="530352"/>
+            <a:ext cx="3749039" cy="438912"/>
           </a:xfrm>
           <a:prstGeom prst="rect">
             <a:avLst/>
@@ -17510,7 +17510,7 @@
         <p:spPr>
           <a:xfrm>
             <a:off x="365760" y="2267712"/>
-            <a:ext cx="3749039" cy="530352"/>
+            <a:ext cx="3749039" cy="438912"/>
           </a:xfrm>
           <a:prstGeom prst="rect">
             <a:avLst/>
@@ -17542,8 +17542,8 @@
         </p:nvSpPr>
         <p:spPr>
           <a:xfrm>
-            <a:off x="502920" y="2907792"/>
-            <a:ext cx="3474720" cy="3291840"/>
+            <a:off x="502920" y="2779776"/>
+            <a:ext cx="3474720" cy="1828800"/>
           </a:xfrm>
           <a:prstGeom prst="rect">
             <a:avLst/>
@@ -17580,7 +17580,7 @@
         <p:spPr>
           <a:xfrm>
             <a:off x="4224528" y="2267712"/>
-            <a:ext cx="3749039" cy="4114800"/>
+            <a:ext cx="3749039" cy="2468880"/>
           </a:xfrm>
           <a:prstGeom prst="roundRect">
             <a:avLst>
@@ -17625,7 +17625,7 @@
         <p:spPr>
           <a:xfrm>
             <a:off x="4224528" y="2267712"/>
-            <a:ext cx="3749039" cy="530352"/>
+            <a:ext cx="3749039" cy="438912"/>
           </a:xfrm>
           <a:prstGeom prst="rect">
             <a:avLst/>
@@ -17668,7 +17668,7 @@
         <p:spPr>
           <a:xfrm>
             <a:off x="4224528" y="2267712"/>
-            <a:ext cx="3749039" cy="530352"/>
+            <a:ext cx="3749039" cy="438912"/>
           </a:xfrm>
           <a:prstGeom prst="rect">
             <a:avLst/>
@@ -17700,8 +17700,8 @@
         </p:nvSpPr>
         <p:spPr>
           <a:xfrm>
-            <a:off x="4361688" y="2907792"/>
-            <a:ext cx="3474720" cy="3291840"/>
+            <a:off x="4361688" y="2779776"/>
+            <a:ext cx="3474720" cy="1828800"/>
           </a:xfrm>
           <a:prstGeom prst="rect">
             <a:avLst/>
@@ -17738,7 +17738,7 @@
         <p:spPr>
           <a:xfrm>
             <a:off x="8083296" y="2267712"/>
-            <a:ext cx="3730752" cy="4114800"/>
+            <a:ext cx="3730752" cy="2468880"/>
           </a:xfrm>
           <a:prstGeom prst="roundRect">
             <a:avLst>
@@ -17783,7 +17783,7 @@
         <p:spPr>
           <a:xfrm>
             <a:off x="8083296" y="2267712"/>
-            <a:ext cx="3730752" cy="530352"/>
+            <a:ext cx="3730752" cy="438912"/>
           </a:xfrm>
           <a:prstGeom prst="rect">
             <a:avLst/>
@@ -17826,7 +17826,7 @@
         <p:spPr>
           <a:xfrm>
             <a:off x="8083296" y="2267712"/>
-            <a:ext cx="3730752" cy="530352"/>
+            <a:ext cx="3730752" cy="438912"/>
           </a:xfrm>
           <a:prstGeom prst="rect">
             <a:avLst/>
@@ -17858,8 +17858,8 @@
         </p:nvSpPr>
         <p:spPr>
           <a:xfrm>
-            <a:off x="8220456" y="2907792"/>
-            <a:ext cx="3456432" cy="3291840"/>
+            <a:off x="8220456" y="2779776"/>
+            <a:ext cx="3456432" cy="1828800"/>
           </a:xfrm>
           <a:prstGeom prst="rect">
             <a:avLst/>
@@ -17889,20 +17889,22 @@
       </p:sp>
       <p:sp>
         <p:nvSpPr>
-          <p:cNvPr id="22" name="Rectangle 21"/>
+          <p:cNvPr id="22" name="Rounded Rectangle 21"/>
           <p:cNvSpPr/>
           <p:nvPr/>
         </p:nvSpPr>
         <p:spPr>
           <a:xfrm>
-            <a:off x="0" y="6565392"/>
-            <a:ext cx="12191695" cy="292608"/>
-          </a:xfrm>
-          <a:prstGeom prst="rect">
-            <a:avLst/>
-          </a:prstGeom>
-          <a:solidFill>
-            <a:srgbClr val="0B2C4A"/>
+            <a:off x="365760" y="4919472"/>
+            <a:ext cx="11448288" cy="1463040"/>
+          </a:xfrm>
+          <a:prstGeom prst="roundRect">
+            <a:avLst>
+              <a:gd name="adj" fmla="val 8000"/>
+            </a:avLst>
+          </a:prstGeom>
+          <a:solidFill>
+            <a:srgbClr val="FFFFFF"/>
           </a:solidFill>
           <a:ln>
             <a:noFill/>
@@ -17938,6 +17940,84 @@
         </p:nvSpPr>
         <p:spPr>
           <a:xfrm>
+            <a:off x="548640" y="5029200"/>
+            <a:ext cx="11082528" cy="1243584"/>
+          </a:xfrm>
+          <a:prstGeom prst="rect">
+            <a:avLst/>
+          </a:prstGeom>
+          <a:noFill/>
+        </p:spPr>
+        <p:txBody>
+          <a:bodyPr wrap="square" anchor="t"/>
+          <a:lstStyle/>
+          <a:p>
+            <a:pPr algn="l"/>
+            <a:r>
+              <a:rPr sz="1400" b="0">
+                <a:solidFill>
+                  <a:srgbClr val="3D4A57"/>
+                </a:solidFill>
+                <a:latin typeface="Calibri"/>
+              </a:rPr>
+              <a:t>Nolvasan Surgical Scrub: 2% chlorhexidine acetate, DailyMed NDC 54771-8701, wash 2 to 4 min, keep out of eyes.
+BETADINE Surgical Scrub Veterinary NDC 67618-154 (7.5%, lather about 5 min). BETADINE Solution Veterinary NDC 67618-155 (5% paint, not 10%).
+Eye: Roberts 1986, 1:50 of 10% stock, 2-min scrub + 2-min soak. If the bottle is 5% veterinary solution, 1:25 matches 0.2%.</a:t>
+            </a:r>
+          </a:p>
+        </p:txBody>
+      </p:sp>
+      <p:sp>
+        <p:nvSpPr>
+          <p:cNvPr id="24" name="Rectangle 23"/>
+          <p:cNvSpPr/>
+          <p:nvPr/>
+        </p:nvSpPr>
+        <p:spPr>
+          <a:xfrm>
+            <a:off x="0" y="6565392"/>
+            <a:ext cx="12191695" cy="292608"/>
+          </a:xfrm>
+          <a:prstGeom prst="rect">
+            <a:avLst/>
+          </a:prstGeom>
+          <a:solidFill>
+            <a:srgbClr val="0B2C4A"/>
+          </a:solidFill>
+          <a:ln>
+            <a:noFill/>
+          </a:ln>
+        </p:spPr>
+        <p:style>
+          <a:lnRef idx="1">
+            <a:schemeClr val="accent1"/>
+          </a:lnRef>
+          <a:fillRef idx="3">
+            <a:schemeClr val="accent1"/>
+          </a:fillRef>
+          <a:effectRef idx="2">
+            <a:schemeClr val="accent1"/>
+          </a:effectRef>
+          <a:fontRef idx="minor">
+            <a:schemeClr val="lt1"/>
+          </a:fontRef>
+        </p:style>
+        <p:txBody>
+          <a:bodyPr rtlCol="0" anchor="ctr"/>
+          <a:lstStyle/>
+          <a:p>
+            <a:pPr algn="ctr"/>
+          </a:p>
+        </p:txBody>
+      </p:sp>
+      <p:sp>
+        <p:nvSpPr>
+          <p:cNvPr id="25" name="TextBox 24"/>
+          <p:cNvSpPr txBox="1"/>
+          <p:nvPr/>
+        </p:nvSpPr>
+        <p:spPr>
+          <a:xfrm>
             <a:off x="320040" y="6565392"/>
             <a:ext cx="9875520" cy="292608"/>
           </a:xfrm>
@@ -17965,7 +18045,7 @@
       </p:sp>
       <p:sp>
         <p:nvSpPr>
-          <p:cNvPr id="24" name="TextBox 23"/>
+          <p:cNvPr id="26" name="TextBox 25"/>
           <p:cNvSpPr txBox="1"/>
           <p:nvPr/>
         </p:nvSpPr>
@@ -29789,7 +29869,7 @@
                 </a:solidFill>
                 <a:latin typeface="Calibri"/>
               </a:rPr>
-              <a:t>Willie is ASA III-E: sedate with a plan. MoMo is IV-E: image first, then cancel.</a:t>
+              <a:t>Willie is ASA Status 3-E: sedate with a plan. MoMo is Status 4-E: image first, then cancel.</a:t>
             </a:r>
           </a:p>
         </p:txBody>

</xml_diff>

<commit_message>
Enlarge the perioperative record and put preop and recovery first.
Drop the tiny intra-op grid and the side panel that shrunk the form. Willie and MoMo now fill the slide with a large preop header, preop boxes, and a 24-hour recovery column. The postoperative flowsheet is the same treatment.

Co-authored-by: drkimvet <drkimvet@users.noreply.github.com>
</commit_message>
<xml_diff>
--- a/lectures/DVM-612_Week4_Preop_PatientPrep_Postop.pptx
+++ b/lectures/DVM-612_Week4_Preop_PatientPrep_Postop.pptx
@@ -1099,7 +1099,7 @@
           <a:lstStyle/>
           <a:p>
             <a:r>
-              <a:t>Walk the header: ASA III-E is written before alfaxalone. DexSP means skip NSAID. Grid every 5 minutes while sedated. Recovery boxes are part of the same page.</a:t>
+              <a:t>Walk the large boxes: ASA Status 3-E before alfaxalone. Skip NSAID after DexSP. Recovery is on the same page. This hour is preop, patient prep, and recovery, not the intra-op grid.</a:t>
             </a:r>
           </a:p>
         </p:txBody>
@@ -1169,7 +1169,7 @@
           <a:lstStyle/>
           <a:p>
             <a:r>
-              <a:t>The form is not only for patients who get clipped. Recording the cancellation is a surgical document. Say it once, respectfully, then continue.</a:t>
+              <a:t>The form is not only for patients who get clipped. Preop boxes and SURGERY CANCELLED are the document. Say it once, respectfully, then continue.</a:t>
             </a:r>
           </a:p>
         </p:txBody>
@@ -2149,7 +2149,7 @@
           <a:lstStyle/>
           <a:p>
             <a:r>
-              <a:t>Students should be able to fill this after a spay. Photograph it.</a:t>
+              <a:t>Students should be able to fill this after a spay. Photograph it. Pale plus tachycardic after celiotomy: return to OR.</a:t>
             </a:r>
           </a:p>
         </p:txBody>
@@ -12851,7 +12851,7 @@
                 </a:solidFill>
                 <a:latin typeface="Calibri"/>
               </a:rPr>
-              <a:t>COMPLETE THE HEADER BEFORE THE FIRST DRUG.</a:t>
+              <a:t>PREOP HEADER AND RECOVERY. COMPLETE BEFORE THE FIRST DRUG.</a:t>
             </a:r>
           </a:p>
         </p:txBody>
@@ -12927,7 +12927,7 @@
                 </a:solidFill>
                 <a:latin typeface="Calibri"/>
               </a:rPr>
-              <a:t>Anesthesia record, Willie</a:t>
+              <a:t>Willie’s perioperative record</a:t>
             </a:r>
           </a:p>
         </p:txBody>
@@ -12948,8 +12948,8 @@
         </p:blipFill>
         <p:spPr>
           <a:xfrm>
-            <a:off x="320040" y="1024128"/>
-            <a:ext cx="7589520" cy="5349240"/>
+            <a:off x="256032" y="987552"/>
+            <a:ext cx="11686032" cy="5440680"/>
           </a:xfrm>
           <a:prstGeom prst="rect">
             <a:avLst/>
@@ -12958,19 +12958,17 @@
       </p:pic>
       <p:sp>
         <p:nvSpPr>
-          <p:cNvPr id="9" name="Rounded Rectangle 8"/>
+          <p:cNvPr id="9" name="Rectangle 8"/>
           <p:cNvSpPr/>
           <p:nvPr/>
         </p:nvSpPr>
         <p:spPr>
           <a:xfrm>
-            <a:off x="8046720" y="1024128"/>
-            <a:ext cx="3794760" cy="5349240"/>
-          </a:xfrm>
-          <a:prstGeom prst="roundRect">
-            <a:avLst>
-              <a:gd name="adj" fmla="val 8000"/>
-            </a:avLst>
+            <a:off x="0" y="6565392"/>
+            <a:ext cx="12191695" cy="292608"/>
+          </a:xfrm>
+          <a:prstGeom prst="rect">
+            <a:avLst/>
           </a:prstGeom>
           <a:solidFill>
             <a:srgbClr val="0B2C4A"/>
@@ -13009,122 +13007,6 @@
         </p:nvSpPr>
         <p:spPr>
           <a:xfrm>
-            <a:off x="8229600" y="1188720"/>
-            <a:ext cx="3474720" cy="457200"/>
-          </a:xfrm>
-          <a:prstGeom prst="rect">
-            <a:avLst/>
-          </a:prstGeom>
-          <a:noFill/>
-        </p:spPr>
-        <p:txBody>
-          <a:bodyPr wrap="square" anchor="t"/>
-          <a:lstStyle/>
-          <a:p>
-            <a:pPr algn="l"/>
-            <a:r>
-              <a:rPr sz="1800" b="1">
-                <a:solidFill>
-                  <a:srgbClr val="C5A35A"/>
-                </a:solidFill>
-                <a:latin typeface="Calibri"/>
-              </a:rPr>
-              <a:t>Read this</a:t>
-            </a:r>
-          </a:p>
-        </p:txBody>
-      </p:sp>
-      <p:sp>
-        <p:nvSpPr>
-          <p:cNvPr id="11" name="TextBox 10"/>
-          <p:cNvSpPr txBox="1"/>
-          <p:nvPr/>
-        </p:nvSpPr>
-        <p:spPr>
-          <a:xfrm>
-            <a:off x="8229600" y="1737360"/>
-            <a:ext cx="3474720" cy="4389120"/>
-          </a:xfrm>
-          <a:prstGeom prst="rect">
-            <a:avLst/>
-          </a:prstGeom>
-          <a:noFill/>
-        </p:spPr>
-        <p:txBody>
-          <a:bodyPr wrap="square" anchor="t"/>
-          <a:lstStyle/>
-          <a:p>
-            <a:pPr algn="l"/>
-            <a:r>
-              <a:rPr sz="1800" b="0">
-                <a:solidFill>
-                  <a:srgbClr val="FFFFFF"/>
-                </a:solidFill>
-                <a:latin typeface="Calibri"/>
-              </a:rPr>
-              <a:t>ASA III-E
-before alfaxalone
-Skip NSAID
-(DexSP already given)
-Grid every 5 min
-while sedated
-Recovery is on
-the same page</a:t>
-            </a:r>
-          </a:p>
-        </p:txBody>
-      </p:sp>
-      <p:sp>
-        <p:nvSpPr>
-          <p:cNvPr id="12" name="Rectangle 11"/>
-          <p:cNvSpPr/>
-          <p:nvPr/>
-        </p:nvSpPr>
-        <p:spPr>
-          <a:xfrm>
-            <a:off x="0" y="6565392"/>
-            <a:ext cx="12191695" cy="292608"/>
-          </a:xfrm>
-          <a:prstGeom prst="rect">
-            <a:avLst/>
-          </a:prstGeom>
-          <a:solidFill>
-            <a:srgbClr val="0B2C4A"/>
-          </a:solidFill>
-          <a:ln>
-            <a:noFill/>
-          </a:ln>
-        </p:spPr>
-        <p:style>
-          <a:lnRef idx="1">
-            <a:schemeClr val="accent1"/>
-          </a:lnRef>
-          <a:fillRef idx="3">
-            <a:schemeClr val="accent1"/>
-          </a:fillRef>
-          <a:effectRef idx="2">
-            <a:schemeClr val="accent1"/>
-          </a:effectRef>
-          <a:fontRef idx="minor">
-            <a:schemeClr val="lt1"/>
-          </a:fontRef>
-        </p:style>
-        <p:txBody>
-          <a:bodyPr rtlCol="0" anchor="ctr"/>
-          <a:lstStyle/>
-          <a:p>
-            <a:pPr algn="ctr"/>
-          </a:p>
-        </p:txBody>
-      </p:sp>
-      <p:sp>
-        <p:nvSpPr>
-          <p:cNvPr id="13" name="TextBox 12"/>
-          <p:cNvSpPr txBox="1"/>
-          <p:nvPr/>
-        </p:nvSpPr>
-        <p:spPr>
-          <a:xfrm>
             <a:off x="320040" y="6565392"/>
             <a:ext cx="9875520" cy="292608"/>
           </a:xfrm>
@@ -13152,7 +13034,7 @@
       </p:sp>
       <p:sp>
         <p:nvSpPr>
-          <p:cNvPr id="14" name="TextBox 13"/>
+          <p:cNvPr id="11" name="TextBox 10"/>
           <p:cNvSpPr txBox="1"/>
           <p:nvPr/>
         </p:nvSpPr>
@@ -13434,7 +13316,7 @@
                 </a:solidFill>
                 <a:latin typeface="Calibri"/>
               </a:rPr>
-              <a:t>Anesthesia record, MoMo</a:t>
+              <a:t>MoMo’s perioperative record</a:t>
             </a:r>
           </a:p>
         </p:txBody>
@@ -13455,8 +13337,8 @@
         </p:blipFill>
         <p:spPr>
           <a:xfrm>
-            <a:off x="320040" y="1024128"/>
-            <a:ext cx="7589520" cy="5349240"/>
+            <a:off x="256032" y="987552"/>
+            <a:ext cx="11686032" cy="5440680"/>
           </a:xfrm>
           <a:prstGeom prst="rect">
             <a:avLst/>
@@ -13465,22 +13347,20 @@
       </p:pic>
       <p:sp>
         <p:nvSpPr>
-          <p:cNvPr id="9" name="Rounded Rectangle 8"/>
+          <p:cNvPr id="9" name="Rectangle 8"/>
           <p:cNvSpPr/>
           <p:nvPr/>
         </p:nvSpPr>
         <p:spPr>
           <a:xfrm>
-            <a:off x="8046720" y="1024128"/>
-            <a:ext cx="3794760" cy="5349240"/>
-          </a:xfrm>
-          <a:prstGeom prst="roundRect">
-            <a:avLst>
-              <a:gd name="adj" fmla="val 8000"/>
-            </a:avLst>
-          </a:prstGeom>
-          <a:solidFill>
-            <a:srgbClr val="8B2E2E"/>
+            <a:off x="0" y="6565392"/>
+            <a:ext cx="12191695" cy="292608"/>
+          </a:xfrm>
+          <a:prstGeom prst="rect">
+            <a:avLst/>
+          </a:prstGeom>
+          <a:solidFill>
+            <a:srgbClr val="0B2C4A"/>
           </a:solidFill>
           <a:ln>
             <a:noFill/>
@@ -13516,122 +13396,6 @@
         </p:nvSpPr>
         <p:spPr>
           <a:xfrm>
-            <a:off x="8229600" y="1188720"/>
-            <a:ext cx="3474720" cy="457200"/>
-          </a:xfrm>
-          <a:prstGeom prst="rect">
-            <a:avLst/>
-          </a:prstGeom>
-          <a:noFill/>
-        </p:spPr>
-        <p:txBody>
-          <a:bodyPr wrap="square" anchor="t"/>
-          <a:lstStyle/>
-          <a:p>
-            <a:pPr algn="l"/>
-            <a:r>
-              <a:rPr sz="1800" b="1">
-                <a:solidFill>
-                  <a:srgbClr val="C5A35A"/>
-                </a:solidFill>
-                <a:latin typeface="Calibri"/>
-              </a:rPr>
-              <a:t>Read this</a:t>
-            </a:r>
-          </a:p>
-        </p:txBody>
-      </p:sp>
-      <p:sp>
-        <p:nvSpPr>
-          <p:cNvPr id="11" name="TextBox 10"/>
-          <p:cNvSpPr txBox="1"/>
-          <p:nvPr/>
-        </p:nvSpPr>
-        <p:spPr>
-          <a:xfrm>
-            <a:off x="8229600" y="1737360"/>
-            <a:ext cx="3474720" cy="4389120"/>
-          </a:xfrm>
-          <a:prstGeom prst="rect">
-            <a:avLst/>
-          </a:prstGeom>
-          <a:noFill/>
-        </p:spPr>
-        <p:txBody>
-          <a:bodyPr wrap="square" anchor="t"/>
-          <a:lstStyle/>
-          <a:p>
-            <a:pPr algn="l"/>
-            <a:r>
-              <a:rPr sz="1800" b="0">
-                <a:solidFill>
-                  <a:srgbClr val="FFFFFF"/>
-                </a:solidFill>
-                <a:latin typeface="Calibri"/>
-              </a:rPr>
-              <a:t>ASA IV-E
-No clippers
-No incision
-Creatinine 3.0
-then 4.71
-Write:
-SURGERY
-CANCELLED</a:t>
-            </a:r>
-          </a:p>
-        </p:txBody>
-      </p:sp>
-      <p:sp>
-        <p:nvSpPr>
-          <p:cNvPr id="12" name="Rectangle 11"/>
-          <p:cNvSpPr/>
-          <p:nvPr/>
-        </p:nvSpPr>
-        <p:spPr>
-          <a:xfrm>
-            <a:off x="0" y="6565392"/>
-            <a:ext cx="12191695" cy="292608"/>
-          </a:xfrm>
-          <a:prstGeom prst="rect">
-            <a:avLst/>
-          </a:prstGeom>
-          <a:solidFill>
-            <a:srgbClr val="0B2C4A"/>
-          </a:solidFill>
-          <a:ln>
-            <a:noFill/>
-          </a:ln>
-        </p:spPr>
-        <p:style>
-          <a:lnRef idx="1">
-            <a:schemeClr val="accent1"/>
-          </a:lnRef>
-          <a:fillRef idx="3">
-            <a:schemeClr val="accent1"/>
-          </a:fillRef>
-          <a:effectRef idx="2">
-            <a:schemeClr val="accent1"/>
-          </a:effectRef>
-          <a:fontRef idx="minor">
-            <a:schemeClr val="lt1"/>
-          </a:fontRef>
-        </p:style>
-        <p:txBody>
-          <a:bodyPr rtlCol="0" anchor="ctr"/>
-          <a:lstStyle/>
-          <a:p>
-            <a:pPr algn="ctr"/>
-          </a:p>
-        </p:txBody>
-      </p:sp>
-      <p:sp>
-        <p:nvSpPr>
-          <p:cNvPr id="13" name="TextBox 12"/>
-          <p:cNvSpPr txBox="1"/>
-          <p:nvPr/>
-        </p:nvSpPr>
-        <p:spPr>
-          <a:xfrm>
             <a:off x="320040" y="6565392"/>
             <a:ext cx="9875520" cy="292608"/>
           </a:xfrm>
@@ -13659,7 +13423,7 @@
       </p:sp>
       <p:sp>
         <p:nvSpPr>
-          <p:cNvPr id="14" name="TextBox 13"/>
+          <p:cNvPr id="11" name="TextBox 10"/>
           <p:cNvSpPr txBox="1"/>
           <p:nvPr/>
         </p:nvSpPr>
@@ -23798,7 +23562,7 @@
                 </a:solidFill>
                 <a:latin typeface="Calibri"/>
               </a:rPr>
-              <a:t>STAY WITH THE PATIENT</a:t>
+              <a:t>AIRWAY, PERFUSION, HEAT, PAIN, INCISION. STAY WITH THE PATIENT.</a:t>
             </a:r>
           </a:p>
         </p:txBody>
@@ -23895,8 +23659,8 @@
         </p:blipFill>
         <p:spPr>
           <a:xfrm>
-            <a:off x="320040" y="1024128"/>
-            <a:ext cx="7589520" cy="5349240"/>
+            <a:off x="256032" y="987552"/>
+            <a:ext cx="11686032" cy="5440680"/>
           </a:xfrm>
           <a:prstGeom prst="rect">
             <a:avLst/>
@@ -23905,19 +23669,17 @@
       </p:pic>
       <p:sp>
         <p:nvSpPr>
-          <p:cNvPr id="9" name="Rounded Rectangle 8"/>
+          <p:cNvPr id="9" name="Rectangle 8"/>
           <p:cNvSpPr/>
           <p:nvPr/>
         </p:nvSpPr>
         <p:spPr>
           <a:xfrm>
-            <a:off x="8046720" y="1024128"/>
-            <a:ext cx="3794760" cy="5349240"/>
-          </a:xfrm>
-          <a:prstGeom prst="roundRect">
-            <a:avLst>
-              <a:gd name="adj" fmla="val 8000"/>
-            </a:avLst>
+            <a:off x="0" y="6565392"/>
+            <a:ext cx="12191695" cy="292608"/>
+          </a:xfrm>
+          <a:prstGeom prst="rect">
+            <a:avLst/>
           </a:prstGeom>
           <a:solidFill>
             <a:srgbClr val="0B2C4A"/>
@@ -23956,123 +23718,6 @@
         </p:nvSpPr>
         <p:spPr>
           <a:xfrm>
-            <a:off x="8229600" y="1188720"/>
-            <a:ext cx="3474720" cy="457200"/>
-          </a:xfrm>
-          <a:prstGeom prst="rect">
-            <a:avLst/>
-          </a:prstGeom>
-          <a:noFill/>
-        </p:spPr>
-        <p:txBody>
-          <a:bodyPr wrap="square" anchor="t"/>
-          <a:lstStyle/>
-          <a:p>
-            <a:pPr algn="l"/>
-            <a:r>
-              <a:rPr sz="1800" b="1">
-                <a:solidFill>
-                  <a:srgbClr val="C5A35A"/>
-                </a:solidFill>
-                <a:latin typeface="Calibri"/>
-              </a:rPr>
-              <a:t>Every 15 minutes</a:t>
-            </a:r>
-          </a:p>
-        </p:txBody>
-      </p:sp>
-      <p:sp>
-        <p:nvSpPr>
-          <p:cNvPr id="11" name="TextBox 10"/>
-          <p:cNvSpPr txBox="1"/>
-          <p:nvPr/>
-        </p:nvSpPr>
-        <p:spPr>
-          <a:xfrm>
-            <a:off x="8229600" y="1737360"/>
-            <a:ext cx="3474720" cy="4389120"/>
-          </a:xfrm>
-          <a:prstGeom prst="rect">
-            <a:avLst/>
-          </a:prstGeom>
-          <a:noFill/>
-        </p:spPr>
-        <p:txBody>
-          <a:bodyPr wrap="square" anchor="t"/>
-          <a:lstStyle/>
-          <a:p>
-            <a:pPr algn="l"/>
-            <a:r>
-              <a:rPr sz="1800" b="0">
-                <a:solidFill>
-                  <a:srgbClr val="FFFFFF"/>
-                </a:solidFill>
-                <a:latin typeface="Calibri"/>
-              </a:rPr>
-              <a:t>Airway
-mm / CRT / pulse
-Temperature
-Pain score
-Incision
-E-collar on
-Pale + tachycardic
-after celiotomy:
-return to OR</a:t>
-            </a:r>
-          </a:p>
-        </p:txBody>
-      </p:sp>
-      <p:sp>
-        <p:nvSpPr>
-          <p:cNvPr id="12" name="Rectangle 11"/>
-          <p:cNvSpPr/>
-          <p:nvPr/>
-        </p:nvSpPr>
-        <p:spPr>
-          <a:xfrm>
-            <a:off x="0" y="6565392"/>
-            <a:ext cx="12191695" cy="292608"/>
-          </a:xfrm>
-          <a:prstGeom prst="rect">
-            <a:avLst/>
-          </a:prstGeom>
-          <a:solidFill>
-            <a:srgbClr val="0B2C4A"/>
-          </a:solidFill>
-          <a:ln>
-            <a:noFill/>
-          </a:ln>
-        </p:spPr>
-        <p:style>
-          <a:lnRef idx="1">
-            <a:schemeClr val="accent1"/>
-          </a:lnRef>
-          <a:fillRef idx="3">
-            <a:schemeClr val="accent1"/>
-          </a:fillRef>
-          <a:effectRef idx="2">
-            <a:schemeClr val="accent1"/>
-          </a:effectRef>
-          <a:fontRef idx="minor">
-            <a:schemeClr val="lt1"/>
-          </a:fontRef>
-        </p:style>
-        <p:txBody>
-          <a:bodyPr rtlCol="0" anchor="ctr"/>
-          <a:lstStyle/>
-          <a:p>
-            <a:pPr algn="ctr"/>
-          </a:p>
-        </p:txBody>
-      </p:sp>
-      <p:sp>
-        <p:nvSpPr>
-          <p:cNvPr id="13" name="TextBox 12"/>
-          <p:cNvSpPr txBox="1"/>
-          <p:nvPr/>
-        </p:nvSpPr>
-        <p:spPr>
-          <a:xfrm>
             <a:off x="320040" y="6565392"/>
             <a:ext cx="9875520" cy="292608"/>
           </a:xfrm>
@@ -24100,7 +23745,7 @@
       </p:sp>
       <p:sp>
         <p:nvSpPr>
-          <p:cNvPr id="14" name="TextBox 13"/>
+          <p:cNvPr id="11" name="TextBox 10"/>
           <p:cNvSpPr txBox="1"/>
           <p:nvPr/>
         </p:nvSpPr>

</xml_diff>

<commit_message>
Add min contact time, cefazolin 22 mg/kg IV, and a brief premed/MAC note.
Clock labeled antiseptic times. Headline extra-label cefazolin 22 mg/kg IV (Gonzalez 2017) with Frey timing and Whittem redose. Introduce premed purpose, MAC, DKT, BAA, and alfaxalone for heart-compromised patients. Postop names Onsior and carprofen; an antibiotic injection is treatment.

Co-authored-by: drkimvet <drkimvet@users.noreply.github.com>
</commit_message>
<xml_diff>
--- a/lectures/DVM-612_Week4_Preop_PatientPrep_Postop.pptx
+++ b/lectures/DVM-612_Week4_Preop_PatientPrep_Postop.pptx
@@ -1029,7 +1029,7 @@
           <a:lstStyle/>
           <a:p>
             <a:r>
-              <a:t>Checklist takes 90 seconds and prevents wrong-site and forgotten cefazolin. Locals are underused.</a:t>
+              <a:t>Two minutes. Purpose of premed: calm, analgesia, lower induction dose, lower MAC. DKT is dexmedetomidine, ketamine, butorphanol. BAA is butorphanol, acepromazine, atropine. Ace and dexmed are not the default in heart-compromised patients; Willie got alfaxalone. MAC is how we talk about inhalant dose. Timeout includes cefazolin 22 mg/kg IV when prophylaxis is indicated.</a:t>
             </a:r>
           </a:p>
         </p:txBody>
@@ -1239,7 +1239,7 @@
           <a:lstStyle/>
           <a:p>
             <a:r>
-              <a:t>Do not attribute 22 mg/kg every 90 minutes to AAHA 2022. That guideline says when: 30 to 60 minutes before incision, skip clean OHE, stop postop. Whittem 1999 timed a second dose if surgery lasted more than 90 minutes. Gonzalez 2017 used 22 mg/kg IV. Elective canine OHE: skip the 14-day cephalexin prescription.</a:t>
+              <a:t>Say 22 milligrams per kilogram IV out loud. Do not attribute that dose to AAHA 2022. Frey 2022 says when: 30 to 60 minutes before incision, skip clean OHE, stop postop. Whittem 1999 timed a second dose if surgery lasted more than 90 minutes. Gonzalez 2017 used 22 mg/kg IV. Elective canine OHE: skip the 14-day cephalexin prescription.</a:t>
             </a:r>
           </a:p>
         </p:txBody>
@@ -2219,7 +2219,7 @@
           <a:lstStyle/>
           <a:p>
             <a:r>
-              <a:t>Licking and unsupervised running are the two discharge failures after otherwise adequate closure.</a:t>
+              <a:t>Name carprofen for dogs and Onsior 2 mg/kg SQ for cats or dogs per label. Do not combine NSAID with DexSP. A postop antibiotic shot is not automatic. Clean spay: skip. Infected ear: treat.</a:t>
             </a:r>
           </a:p>
         </p:txBody>
@@ -12060,7 +12060,7 @@
                 </a:solidFill>
                 <a:latin typeface="Calibri"/>
               </a:rPr>
-              <a:t>WHO-ADAPTED TIMEOUT AND MULTIMODAL PLAN</a:t>
+              <a:t>BRIEF ANESTHESIA VOCABULARY FOR THIS HOUR. NOT AN ANESTHESIA COURSE.</a:t>
             </a:r>
           </a:p>
         </p:txBody>
@@ -12136,7 +12136,7 @@
                 </a:solidFill>
                 <a:latin typeface="Calibri"/>
               </a:rPr>
-              <a:t>Pre-incision checklist and analgesia</a:t>
+              <a:t>Premedication, MAC, and the timeout</a:t>
             </a:r>
           </a:p>
         </p:txBody>
@@ -12149,8 +12149,8 @@
         </p:nvSpPr>
         <p:spPr>
           <a:xfrm>
-            <a:off x="457200" y="1097280"/>
-            <a:ext cx="5577840" cy="5029200"/>
+            <a:off x="365760" y="1051560"/>
+            <a:ext cx="3767328" cy="5074920"/>
           </a:xfrm>
           <a:prstGeom prst="roundRect">
             <a:avLst>
@@ -12188,206 +12188,20 @@
       </p:sp>
       <p:sp>
         <p:nvSpPr>
-          <p:cNvPr id="9" name="TextBox 8"/>
-          <p:cNvSpPr txBox="1"/>
-          <p:nvPr/>
-        </p:nvSpPr>
-        <p:spPr>
-          <a:xfrm>
-            <a:off x="685800" y="1280160"/>
-            <a:ext cx="5120640" cy="365760"/>
-          </a:xfrm>
-          <a:prstGeom prst="rect">
-            <a:avLst/>
-          </a:prstGeom>
-          <a:noFill/>
-        </p:spPr>
-        <p:txBody>
-          <a:bodyPr wrap="square" anchor="t"/>
-          <a:lstStyle/>
-          <a:p>
-            <a:pPr algn="l"/>
-            <a:r>
-              <a:rPr sz="1800" b="1">
-                <a:solidFill>
-                  <a:srgbClr val="0B2C4A"/>
-                </a:solidFill>
-                <a:latin typeface="Calibri"/>
-              </a:rPr>
-              <a:t>Pre-incision checklist</a:t>
-            </a:r>
-          </a:p>
-        </p:txBody>
-      </p:sp>
-      <p:sp>
-        <p:nvSpPr>
-          <p:cNvPr id="10" name="TextBox 9"/>
-          <p:cNvSpPr txBox="1"/>
-          <p:nvPr/>
-        </p:nvSpPr>
-        <p:spPr>
-          <a:xfrm>
-            <a:off x="640080" y="1737360"/>
-            <a:ext cx="5212080" cy="4114800"/>
-          </a:xfrm>
-          <a:prstGeom prst="rect">
-            <a:avLst/>
-          </a:prstGeom>
-          <a:noFill/>
-        </p:spPr>
-        <p:txBody>
-          <a:bodyPr wrap="square">
-            <a:spAutoFit/>
-          </a:bodyPr>
-          <a:lstStyle/>
-          <a:p>
-            <a:pPr algn="l">
-              <a:spcAft>
-                <a:spcPts val="500"/>
-              </a:spcAft>
-            </a:pPr>
-            <a:r>
-              <a:rPr sz="1600" b="0">
-                <a:solidFill>
-                  <a:srgbClr val="1C1C1C"/>
-                </a:solidFill>
-                <a:latin typeface="Calibri"/>
-              </a:rPr>
-              <a:t>▸  Identity, procedure, site/side confirmed.</a:t>
-            </a:r>
-          </a:p>
-          <a:p>
-            <a:pPr algn="l">
-              <a:spcAft>
-                <a:spcPts val="500"/>
-              </a:spcAft>
-            </a:pPr>
-            <a:r>
-              <a:rPr sz="1600" b="0">
-                <a:solidFill>
-                  <a:srgbClr val="1C1C1C"/>
-                </a:solidFill>
-                <a:latin typeface="Calibri"/>
-              </a:rPr>
-              <a:t>▸  Consent, estimate, DNR documented.</a:t>
-            </a:r>
-          </a:p>
-          <a:p>
-            <a:pPr algn="l">
-              <a:spcAft>
-                <a:spcPts val="500"/>
-              </a:spcAft>
-            </a:pPr>
-            <a:r>
-              <a:rPr sz="1600" b="0">
-                <a:solidFill>
-                  <a:srgbClr val="1C1C1C"/>
-                </a:solidFill>
-                <a:latin typeface="Calibri"/>
-              </a:rPr>
-              <a:t>▸  ASA, allergies, last meal.</a:t>
-            </a:r>
-          </a:p>
-          <a:p>
-            <a:pPr algn="l">
-              <a:spcAft>
-                <a:spcPts val="500"/>
-              </a:spcAft>
-            </a:pPr>
-            <a:r>
-              <a:rPr sz="1600" b="0">
-                <a:solidFill>
-                  <a:srgbClr val="1C1C1C"/>
-                </a:solidFill>
-                <a:latin typeface="Calibri"/>
-              </a:rPr>
-              <a:t>▸  IV catheter patent; fluids running.</a:t>
-            </a:r>
-          </a:p>
-          <a:p>
-            <a:pPr algn="l">
-              <a:spcAft>
-                <a:spcPts val="500"/>
-              </a:spcAft>
-            </a:pPr>
-            <a:r>
-              <a:rPr sz="1600" b="0">
-                <a:solidFill>
-                  <a:srgbClr val="1C1C1C"/>
-                </a:solidFill>
-                <a:latin typeface="Calibri"/>
-              </a:rPr>
-              <a:t>▸  Airway secured; monitoring on.</a:t>
-            </a:r>
-          </a:p>
-          <a:p>
-            <a:pPr algn="l">
-              <a:spcAft>
-                <a:spcPts val="500"/>
-              </a:spcAft>
-            </a:pPr>
-            <a:r>
-              <a:rPr sz="1600" b="0">
-                <a:solidFill>
-                  <a:srgbClr val="1C1C1C"/>
-                </a:solidFill>
-                <a:latin typeface="Calibri"/>
-              </a:rPr>
-              <a:t>▸  Antibiotics given (if indicated) 30 minutes before incision.</a:t>
-            </a:r>
-          </a:p>
-          <a:p>
-            <a:pPr algn="l">
-              <a:spcAft>
-                <a:spcPts val="500"/>
-              </a:spcAft>
-            </a:pPr>
-            <a:r>
-              <a:rPr sz="1600" b="0">
-                <a:solidFill>
-                  <a:srgbClr val="1C1C1C"/>
-                </a:solidFill>
-                <a:latin typeface="Calibri"/>
-              </a:rPr>
-              <a:t>▸  Local block planned (incisional, testicular, TAP, splash).</a:t>
-            </a:r>
-          </a:p>
-          <a:p>
-            <a:pPr algn="l">
-              <a:spcAft>
-                <a:spcPts val="500"/>
-              </a:spcAft>
-            </a:pPr>
-            <a:r>
-              <a:rPr sz="1600" b="0">
-                <a:solidFill>
-                  <a:srgbClr val="1C1C1C"/>
-                </a:solidFill>
-                <a:latin typeface="Calibri"/>
-              </a:rPr>
-              <a:t>▸  Instruments, suture, extra gloves, cautery, suction.</a:t>
-            </a:r>
-          </a:p>
-        </p:txBody>
-      </p:sp>
-      <p:sp>
-        <p:nvSpPr>
-          <p:cNvPr id="11" name="Rounded Rectangle 10"/>
+          <p:cNvPr id="9" name="Rectangle 8"/>
           <p:cNvSpPr/>
           <p:nvPr/>
         </p:nvSpPr>
         <p:spPr>
           <a:xfrm>
-            <a:off x="6263640" y="1097280"/>
-            <a:ext cx="5440680" cy="5029200"/>
-          </a:xfrm>
-          <a:prstGeom prst="roundRect">
-            <a:avLst>
-              <a:gd name="adj" fmla="val 8000"/>
-            </a:avLst>
-          </a:prstGeom>
-          <a:solidFill>
-            <a:srgbClr val="FFFFFF"/>
+            <a:off x="365760" y="1051560"/>
+            <a:ext cx="3767328" cy="502920"/>
+          </a:xfrm>
+          <a:prstGeom prst="rect">
+            <a:avLst/>
+          </a:prstGeom>
+          <a:solidFill>
+            <a:srgbClr val="1B6B7A"/>
           </a:solidFill>
           <a:ln>
             <a:noFill/>
@@ -12417,14 +12231,47 @@
       </p:sp>
       <p:sp>
         <p:nvSpPr>
-          <p:cNvPr id="12" name="TextBox 11"/>
-          <p:cNvSpPr txBox="1"/>
-          <p:nvPr/>
-        </p:nvSpPr>
-        <p:spPr>
-          <a:xfrm>
-            <a:off x="6492240" y="1280160"/>
-            <a:ext cx="5029200" cy="365760"/>
+          <p:cNvPr id="10" name="TextBox 9"/>
+          <p:cNvSpPr txBox="1"/>
+          <p:nvPr/>
+        </p:nvSpPr>
+        <p:spPr>
+          <a:xfrm>
+            <a:off x="365760" y="1051560"/>
+            <a:ext cx="3767328" cy="502920"/>
+          </a:xfrm>
+          <a:prstGeom prst="rect">
+            <a:avLst/>
+          </a:prstGeom>
+          <a:noFill/>
+        </p:spPr>
+        <p:txBody>
+          <a:bodyPr wrap="square" anchor="ctr"/>
+          <a:lstStyle/>
+          <a:p>
+            <a:pPr algn="ctr"/>
+            <a:r>
+              <a:rPr sz="1600" b="1">
+                <a:solidFill>
+                  <a:srgbClr val="FFFFFF"/>
+                </a:solidFill>
+                <a:latin typeface="Calibri"/>
+              </a:rPr>
+              <a:t>Why we premedicate</a:t>
+            </a:r>
+          </a:p>
+        </p:txBody>
+      </p:sp>
+      <p:sp>
+        <p:nvSpPr>
+          <p:cNvPr id="11" name="TextBox 10"/>
+          <p:cNvSpPr txBox="1"/>
+          <p:nvPr/>
+        </p:nvSpPr>
+        <p:spPr>
+          <a:xfrm>
+            <a:off x="530352" y="1664208"/>
+            <a:ext cx="3438144" cy="4297680"/>
           </a:xfrm>
           <a:prstGeom prst="rect">
             <a:avLst/>
@@ -12437,152 +12284,39 @@
           <a:p>
             <a:pPr algn="l"/>
             <a:r>
-              <a:rPr sz="1800" b="1">
-                <a:solidFill>
-                  <a:srgbClr val="0B2C4A"/>
-                </a:solidFill>
-                <a:latin typeface="Calibri"/>
-              </a:rPr>
-              <a:t>Multimodal analgesia</a:t>
-            </a:r>
-          </a:p>
-        </p:txBody>
-      </p:sp>
-      <p:sp>
-        <p:nvSpPr>
-          <p:cNvPr id="13" name="TextBox 12"/>
-          <p:cNvSpPr txBox="1"/>
-          <p:nvPr/>
-        </p:nvSpPr>
-        <p:spPr>
-          <a:xfrm>
-            <a:off x="6446520" y="1737360"/>
-            <a:ext cx="5074920" cy="4114800"/>
-          </a:xfrm>
-          <a:prstGeom prst="rect">
-            <a:avLst/>
-          </a:prstGeom>
-          <a:noFill/>
-        </p:spPr>
-        <p:txBody>
-          <a:bodyPr wrap="square">
-            <a:spAutoFit/>
-          </a:bodyPr>
-          <a:lstStyle/>
-          <a:p>
-            <a:pPr algn="l">
-              <a:spcAft>
-                <a:spcPts val="600"/>
-              </a:spcAft>
-            </a:pPr>
-            <a:r>
-              <a:rPr sz="1600" b="0">
+              <a:rPr sz="1500" b="0">
                 <a:solidFill>
                   <a:srgbClr val="1C1C1C"/>
                 </a:solidFill>
                 <a:latin typeface="Calibri"/>
               </a:rPr>
-              <a:t>▸  Opioid as part of premed or induction.</a:t>
-            </a:r>
-          </a:p>
-          <a:p>
-            <a:pPr algn="l">
-              <a:spcAft>
-                <a:spcPts val="600"/>
-              </a:spcAft>
-            </a:pPr>
-            <a:r>
-              <a:rPr sz="1600" b="0">
-                <a:solidFill>
-                  <a:srgbClr val="1C1C1C"/>
-                </a:solidFill>
-                <a:latin typeface="Calibri"/>
-              </a:rPr>
-              <a:t>▸  NSAID if perfusion, kidneys, and GI tract allow. Often at recovery.</a:t>
-            </a:r>
-          </a:p>
-          <a:p>
-            <a:pPr algn="l">
-              <a:spcAft>
-                <a:spcPts val="600"/>
-              </a:spcAft>
-            </a:pPr>
-            <a:r>
-              <a:rPr sz="1600" b="0">
-                <a:solidFill>
-                  <a:srgbClr val="1C1C1C"/>
-                </a:solidFill>
-                <a:latin typeface="Calibri"/>
-              </a:rPr>
-              <a:t>▸  Local/regional: the cheapest MAC-sparing tool you have.</a:t>
-            </a:r>
-          </a:p>
-          <a:p>
-            <a:pPr algn="l">
-              <a:spcAft>
-                <a:spcPts val="600"/>
-              </a:spcAft>
-            </a:pPr>
-            <a:r>
-              <a:rPr sz="1600" b="0">
-                <a:solidFill>
-                  <a:srgbClr val="1C1C1C"/>
-                </a:solidFill>
-                <a:latin typeface="Calibri"/>
-              </a:rPr>
-              <a:t>▸  Adjuncts: ketamine CRI, dexmedetomidine CRI, gabapentin, acetaminophen (dog only).</a:t>
-            </a:r>
-          </a:p>
-          <a:p>
-            <a:pPr algn="l">
-              <a:spcAft>
-                <a:spcPts val="600"/>
-              </a:spcAft>
-            </a:pPr>
-            <a:r>
-              <a:rPr sz="1600" b="0">
-                <a:solidFill>
-                  <a:srgbClr val="1C1C1C"/>
-                </a:solidFill>
-                <a:latin typeface="Calibri"/>
-              </a:rPr>
-              <a:t>▸  Cats: skip acetaminophen; careful NSAID choice and dose.</a:t>
-            </a:r>
-          </a:p>
-          <a:p>
-            <a:pPr algn="l">
-              <a:spcAft>
-                <a:spcPts val="600"/>
-              </a:spcAft>
-            </a:pPr>
-            <a:r>
-              <a:rPr sz="1600" b="0">
-                <a:solidFill>
-                  <a:srgbClr val="1C1C1C"/>
-                </a:solidFill>
-                <a:latin typeface="Calibri"/>
-              </a:rPr>
-              <a:t>▸  Write the pain plan before the patient leaves the table.</a:t>
-            </a:r>
-          </a:p>
-        </p:txBody>
-      </p:sp>
-      <p:sp>
-        <p:nvSpPr>
-          <p:cNvPr id="14" name="Rectangle 13"/>
+              <a:t>Calm the patient. Give preemptive analgesia.
+Lower the induction dose.
+Lower MAC of the vaporizer.
+Smoother intubation and recovery.
+Safer handling before the clip.</a:t>
+            </a:r>
+          </a:p>
+        </p:txBody>
+      </p:sp>
+      <p:sp>
+        <p:nvSpPr>
+          <p:cNvPr id="12" name="Rounded Rectangle 11"/>
           <p:cNvSpPr/>
           <p:nvPr/>
         </p:nvSpPr>
         <p:spPr>
           <a:xfrm>
-            <a:off x="0" y="6565392"/>
-            <a:ext cx="12191695" cy="292608"/>
-          </a:xfrm>
-          <a:prstGeom prst="rect">
-            <a:avLst/>
-          </a:prstGeom>
-          <a:solidFill>
-            <a:srgbClr val="0B2C4A"/>
+            <a:off x="4279392" y="1051560"/>
+            <a:ext cx="3767328" cy="5074920"/>
+          </a:xfrm>
+          <a:prstGeom prst="roundRect">
+            <a:avLst>
+              <a:gd name="adj" fmla="val 8000"/>
+            </a:avLst>
+          </a:prstGeom>
+          <a:solidFill>
+            <a:srgbClr val="FFFFFF"/>
           </a:solidFill>
           <a:ln>
             <a:noFill/>
@@ -12612,7 +12346,318 @@
       </p:sp>
       <p:sp>
         <p:nvSpPr>
+          <p:cNvPr id="13" name="Rectangle 12"/>
+          <p:cNvSpPr/>
+          <p:nvPr/>
+        </p:nvSpPr>
+        <p:spPr>
+          <a:xfrm>
+            <a:off x="4279392" y="1051560"/>
+            <a:ext cx="3767328" cy="502920"/>
+          </a:xfrm>
+          <a:prstGeom prst="rect">
+            <a:avLst/>
+          </a:prstGeom>
+          <a:solidFill>
+            <a:srgbClr val="C5A35A"/>
+          </a:solidFill>
+          <a:ln>
+            <a:noFill/>
+          </a:ln>
+        </p:spPr>
+        <p:style>
+          <a:lnRef idx="1">
+            <a:schemeClr val="accent1"/>
+          </a:lnRef>
+          <a:fillRef idx="3">
+            <a:schemeClr val="accent1"/>
+          </a:fillRef>
+          <a:effectRef idx="2">
+            <a:schemeClr val="accent1"/>
+          </a:effectRef>
+          <a:fontRef idx="minor">
+            <a:schemeClr val="lt1"/>
+          </a:fontRef>
+        </p:style>
+        <p:txBody>
+          <a:bodyPr rtlCol="0" anchor="ctr"/>
+          <a:lstStyle/>
+          <a:p>
+            <a:pPr algn="ctr"/>
+          </a:p>
+        </p:txBody>
+      </p:sp>
+      <p:sp>
+        <p:nvSpPr>
+          <p:cNvPr id="14" name="TextBox 13"/>
+          <p:cNvSpPr txBox="1"/>
+          <p:nvPr/>
+        </p:nvSpPr>
+        <p:spPr>
+          <a:xfrm>
+            <a:off x="4279392" y="1051560"/>
+            <a:ext cx="3767328" cy="502920"/>
+          </a:xfrm>
+          <a:prstGeom prst="rect">
+            <a:avLst/>
+          </a:prstGeom>
+          <a:noFill/>
+        </p:spPr>
+        <p:txBody>
+          <a:bodyPr wrap="square" anchor="ctr"/>
+          <a:lstStyle/>
+          <a:p>
+            <a:pPr algn="ctr"/>
+            <a:r>
+              <a:rPr sz="1600" b="1">
+                <a:solidFill>
+                  <a:srgbClr val="FFFFFF"/>
+                </a:solidFill>
+                <a:latin typeface="Calibri"/>
+              </a:rPr>
+              <a:t>Injectables you will hear</a:t>
+            </a:r>
+          </a:p>
+        </p:txBody>
+      </p:sp>
+      <p:sp>
+        <p:nvSpPr>
           <p:cNvPr id="15" name="TextBox 14"/>
+          <p:cNvSpPr txBox="1"/>
+          <p:nvPr/>
+        </p:nvSpPr>
+        <p:spPr>
+          <a:xfrm>
+            <a:off x="4443984" y="1664208"/>
+            <a:ext cx="3438144" cy="4297680"/>
+          </a:xfrm>
+          <a:prstGeom prst="rect">
+            <a:avLst/>
+          </a:prstGeom>
+          <a:noFill/>
+        </p:spPr>
+        <p:txBody>
+          <a:bodyPr wrap="square" anchor="t"/>
+          <a:lstStyle/>
+          <a:p>
+            <a:pPr algn="l"/>
+            <a:r>
+              <a:rPr sz="1500" b="0">
+                <a:solidFill>
+                  <a:srgbClr val="1C1C1C"/>
+                </a:solidFill>
+                <a:latin typeface="Calibri"/>
+              </a:rPr>
+              <a:t>DKT: dexmedetomidine + ketamine + butorphanol (torb). One IM syringe: sedation, analgesia, muscle relaxation. Ketamine supports HR. Dexmed is reversible. Healthy ASA 1–2 short procedures.
+BAA: butorphanol (torb) + acepromazine + atropine. Classic MAC-sparing premed in healthy patients.
+Heart-compromised / murmur: skip acepromazine and dexmedetomidine as the default. Opioid + alfaxalone is a common plan. That is why Willie received alfaxalone.</a:t>
+            </a:r>
+          </a:p>
+        </p:txBody>
+      </p:sp>
+      <p:sp>
+        <p:nvSpPr>
+          <p:cNvPr id="16" name="Rounded Rectangle 15"/>
+          <p:cNvSpPr/>
+          <p:nvPr/>
+        </p:nvSpPr>
+        <p:spPr>
+          <a:xfrm>
+            <a:off x="8193024" y="1051560"/>
+            <a:ext cx="3767328" cy="5074920"/>
+          </a:xfrm>
+          <a:prstGeom prst="roundRect">
+            <a:avLst>
+              <a:gd name="adj" fmla="val 8000"/>
+            </a:avLst>
+          </a:prstGeom>
+          <a:solidFill>
+            <a:srgbClr val="FFFFFF"/>
+          </a:solidFill>
+          <a:ln>
+            <a:noFill/>
+          </a:ln>
+        </p:spPr>
+        <p:style>
+          <a:lnRef idx="1">
+            <a:schemeClr val="accent1"/>
+          </a:lnRef>
+          <a:fillRef idx="3">
+            <a:schemeClr val="accent1"/>
+          </a:fillRef>
+          <a:effectRef idx="2">
+            <a:schemeClr val="accent1"/>
+          </a:effectRef>
+          <a:fontRef idx="minor">
+            <a:schemeClr val="lt1"/>
+          </a:fontRef>
+        </p:style>
+        <p:txBody>
+          <a:bodyPr rtlCol="0" anchor="ctr"/>
+          <a:lstStyle/>
+          <a:p>
+            <a:pPr algn="ctr"/>
+          </a:p>
+        </p:txBody>
+      </p:sp>
+      <p:sp>
+        <p:nvSpPr>
+          <p:cNvPr id="17" name="Rectangle 16"/>
+          <p:cNvSpPr/>
+          <p:nvPr/>
+        </p:nvSpPr>
+        <p:spPr>
+          <a:xfrm>
+            <a:off x="8193024" y="1051560"/>
+            <a:ext cx="3767328" cy="502920"/>
+          </a:xfrm>
+          <a:prstGeom prst="rect">
+            <a:avLst/>
+          </a:prstGeom>
+          <a:solidFill>
+            <a:srgbClr val="0B2C4A"/>
+          </a:solidFill>
+          <a:ln>
+            <a:noFill/>
+          </a:ln>
+        </p:spPr>
+        <p:style>
+          <a:lnRef idx="1">
+            <a:schemeClr val="accent1"/>
+          </a:lnRef>
+          <a:fillRef idx="3">
+            <a:schemeClr val="accent1"/>
+          </a:fillRef>
+          <a:effectRef idx="2">
+            <a:schemeClr val="accent1"/>
+          </a:effectRef>
+          <a:fontRef idx="minor">
+            <a:schemeClr val="lt1"/>
+          </a:fontRef>
+        </p:style>
+        <p:txBody>
+          <a:bodyPr rtlCol="0" anchor="ctr"/>
+          <a:lstStyle/>
+          <a:p>
+            <a:pPr algn="ctr"/>
+          </a:p>
+        </p:txBody>
+      </p:sp>
+      <p:sp>
+        <p:nvSpPr>
+          <p:cNvPr id="18" name="TextBox 17"/>
+          <p:cNvSpPr txBox="1"/>
+          <p:nvPr/>
+        </p:nvSpPr>
+        <p:spPr>
+          <a:xfrm>
+            <a:off x="8193024" y="1051560"/>
+            <a:ext cx="3767328" cy="502920"/>
+          </a:xfrm>
+          <a:prstGeom prst="rect">
+            <a:avLst/>
+          </a:prstGeom>
+          <a:noFill/>
+        </p:spPr>
+        <p:txBody>
+          <a:bodyPr wrap="square" anchor="ctr"/>
+          <a:lstStyle/>
+          <a:p>
+            <a:pPr algn="ctr"/>
+            <a:r>
+              <a:rPr sz="1600" b="1">
+                <a:solidFill>
+                  <a:srgbClr val="FFFFFF"/>
+                </a:solidFill>
+                <a:latin typeface="Calibri"/>
+              </a:rPr>
+              <a:t>Gas and MAC</a:t>
+            </a:r>
+          </a:p>
+        </p:txBody>
+      </p:sp>
+      <p:sp>
+        <p:nvSpPr>
+          <p:cNvPr id="19" name="TextBox 18"/>
+          <p:cNvSpPr txBox="1"/>
+          <p:nvPr/>
+        </p:nvSpPr>
+        <p:spPr>
+          <a:xfrm>
+            <a:off x="8357616" y="1664208"/>
+            <a:ext cx="3438144" cy="4297680"/>
+          </a:xfrm>
+          <a:prstGeom prst="rect">
+            <a:avLst/>
+          </a:prstGeom>
+          <a:noFill/>
+        </p:spPr>
+        <p:txBody>
+          <a:bodyPr wrap="square" anchor="t"/>
+          <a:lstStyle/>
+          <a:p>
+            <a:pPr algn="l"/>
+            <a:r>
+              <a:rPr sz="1500" b="0">
+                <a:solidFill>
+                  <a:srgbClr val="1C1C1C"/>
+                </a:solidFill>
+                <a:latin typeface="Calibri"/>
+              </a:rPr>
+              <a:t>MAC = minimum alveolar concentration: the alveolar % of inhalant that stops movement in 50% of patients to a surgical stimulus.
+Isoflurane or sevoflurane maintain anesthesia after injectable induction.
+Premeds, local blocks, and hypothermia lower MAC. Turn the vaporizer down.
+Timeout before incision: identity, site, ASA, last meal, monitors on, cefazolin 22 mg/kg IV if indicated.</a:t>
+            </a:r>
+          </a:p>
+        </p:txBody>
+      </p:sp>
+      <p:sp>
+        <p:nvSpPr>
+          <p:cNvPr id="20" name="Rectangle 19"/>
+          <p:cNvSpPr/>
+          <p:nvPr/>
+        </p:nvSpPr>
+        <p:spPr>
+          <a:xfrm>
+            <a:off x="0" y="6565392"/>
+            <a:ext cx="12191695" cy="292608"/>
+          </a:xfrm>
+          <a:prstGeom prst="rect">
+            <a:avLst/>
+          </a:prstGeom>
+          <a:solidFill>
+            <a:srgbClr val="0B2C4A"/>
+          </a:solidFill>
+          <a:ln>
+            <a:noFill/>
+          </a:ln>
+        </p:spPr>
+        <p:style>
+          <a:lnRef idx="1">
+            <a:schemeClr val="accent1"/>
+          </a:lnRef>
+          <a:fillRef idx="3">
+            <a:schemeClr val="accent1"/>
+          </a:fillRef>
+          <a:effectRef idx="2">
+            <a:schemeClr val="accent1"/>
+          </a:effectRef>
+          <a:fontRef idx="minor">
+            <a:schemeClr val="lt1"/>
+          </a:fontRef>
+        </p:style>
+        <p:txBody>
+          <a:bodyPr rtlCol="0" anchor="ctr"/>
+          <a:lstStyle/>
+          <a:p>
+            <a:pPr algn="ctr"/>
+          </a:p>
+        </p:txBody>
+      </p:sp>
+      <p:sp>
+        <p:nvSpPr>
+          <p:cNvPr id="21" name="TextBox 20"/>
           <p:cNvSpPr txBox="1"/>
           <p:nvPr/>
         </p:nvSpPr>
@@ -12645,7 +12690,7 @@
       </p:sp>
       <p:sp>
         <p:nvSpPr>
-          <p:cNvPr id="16" name="TextBox 15"/>
+          <p:cNvPr id="22" name="TextBox 21"/>
           <p:cNvSpPr txBox="1"/>
           <p:nvPr/>
         </p:nvSpPr>
@@ -13629,7 +13674,7 @@
                 </a:solidFill>
                 <a:latin typeface="Calibri"/>
               </a:rPr>
-              <a:t>FREY ET AL. 2022 AAFP/AAHA: WHEN. WHITTEM 1999 AND GONZALEZ 2017: HOW.</a:t>
+              <a:t>FREY ET AL. 2022: WHEN. GONZALEZ 2017: 22 MG/KG IV. WHITTEM 1999: REDOSE IF &gt;90 MIN.</a:t>
             </a:r>
           </a:p>
         </p:txBody>
@@ -13705,7 +13750,7 @@
                 </a:solidFill>
                 <a:latin typeface="Calibri"/>
               </a:rPr>
-              <a:t>Surgical antimicrobial prophylaxis</a:t>
+              <a:t>Perioperative cefazolin</a:t>
             </a:r>
           </a:p>
         </p:txBody>
@@ -13821,7 +13866,8 @@
 Not usually needed for clean procedures.
 Skip OHE, orchiectomy, most sterile cases.
 Postop antimicrobials are rarely required.
-Hold asepsis. Stop at closure.</a:t>
+Hold asepsis. Stop at closure.
+A postoperative antibiotic injection is treatment, not a gift after every spay.</a:t>
             </a:r>
           </a:p>
         </p:txBody>
@@ -13880,7 +13926,7 @@
         <p:spPr>
           <a:xfrm>
             <a:off x="6492240" y="1234440"/>
-            <a:ext cx="5029200" cy="457200"/>
+            <a:ext cx="5029200" cy="411480"/>
           </a:xfrm>
           <a:prstGeom prst="rect">
             <a:avLst/>
@@ -13899,7 +13945,7 @@
                 </a:solidFill>
                 <a:latin typeface="Calibri"/>
               </a:rPr>
-              <a:t>When indicated: timed IV, then stop</a:t>
+              <a:t>When indicated</a:t>
             </a:r>
           </a:p>
         </p:txBody>
@@ -13912,8 +13958,8 @@
         </p:nvSpPr>
         <p:spPr>
           <a:xfrm>
-            <a:off x="6492240" y="1783080"/>
-            <a:ext cx="5029200" cy="4114800"/>
+            <a:off x="6492240" y="1691640"/>
+            <a:ext cx="5029200" cy="777240"/>
           </a:xfrm>
           <a:prstGeom prst="rect">
             <a:avLst/>
@@ -13926,17 +13972,50 @@
           <a:p>
             <a:pPr algn="l"/>
             <a:r>
+              <a:rPr sz="2800" b="1">
+                <a:solidFill>
+                  <a:srgbClr val="8B2E2E"/>
+                </a:solidFill>
+                <a:latin typeface="Calibri"/>
+              </a:rPr>
+              <a:t>Cefazolin 22 mg/kg IV</a:t>
+            </a:r>
+          </a:p>
+        </p:txBody>
+      </p:sp>
+      <p:sp>
+        <p:nvSpPr>
+          <p:cNvPr id="14" name="TextBox 13"/>
+          <p:cNvSpPr txBox="1"/>
+          <p:nvPr/>
+        </p:nvSpPr>
+        <p:spPr>
+          <a:xfrm>
+            <a:off x="6492240" y="2468880"/>
+            <a:ext cx="5029200" cy="3383280"/>
+          </a:xfrm>
+          <a:prstGeom prst="rect">
+            <a:avLst/>
+          </a:prstGeom>
+          <a:noFill/>
+        </p:spPr>
+        <p:txBody>
+          <a:bodyPr wrap="square" anchor="t"/>
+          <a:lstStyle/>
+          <a:p>
+            <a:pPr algn="l"/>
+            <a:r>
               <a:rPr sz="1600" b="0">
                 <a:solidFill>
                   <a:srgbClr val="1C1C1C"/>
                 </a:solidFill>
                 <a:latin typeface="Calibri"/>
               </a:rPr>
-              <a:t>AAFP/AAHA 2022 has no cefazolin mg/kg.
-1. Start 30–60 min before incision.
-2. Extra-label: 22 mg/kg IV (Gonzalez 2017).
-3. Second dose if &gt;90 min (Whittem 1999).
-4. Stop at closure unless treating infection.
+              <a:t>Gonzalez 2017: extra-label 22 mg/kg IV in dogs.
+1. Give 30–60 min before incision (Frey 2022).
+2. Second dose if surgery lasts &gt;90 min (Whittem 1999).
+3. Stop at closure unless you are treating infection.
+AAFP/AAHA 2022 has no cefazolin mg/kg.
 Willie’s infected ear: treatment, not prophylaxis.</a:t>
             </a:r>
           </a:p>
@@ -13944,7 +14023,7 @@
       </p:sp>
       <p:sp>
         <p:nvSpPr>
-          <p:cNvPr id="14" name="Rectangle 13"/>
+          <p:cNvPr id="15" name="Rectangle 14"/>
           <p:cNvSpPr/>
           <p:nvPr/>
         </p:nvSpPr>
@@ -13987,7 +14066,7 @@
       </p:sp>
       <p:sp>
         <p:nvSpPr>
-          <p:cNvPr id="15" name="TextBox 14"/>
+          <p:cNvPr id="16" name="TextBox 15"/>
           <p:cNvSpPr txBox="1"/>
           <p:nvPr/>
         </p:nvSpPr>
@@ -14020,7 +14099,7 @@
       </p:sp>
       <p:sp>
         <p:nvSpPr>
-          <p:cNvPr id="16" name="TextBox 15"/>
+          <p:cNvPr id="17" name="TextBox 16"/>
           <p:cNvSpPr txBox="1"/>
           <p:nvPr/>
         </p:nvSpPr>
@@ -15618,7 +15697,7 @@
                 </a:solidFill>
                 <a:latin typeface="Calibri"/>
               </a:rPr>
-              <a:t>Sterile prep. Skin: 7.5% ~5 min, then 5% paint. Eye: 1:50 of 10%</a:t>
+              <a:t>Sterile prep. Clock minimum contact time. Skin: 7.5% ~5 min, then 5% paint. Eye: 2 min + 2 min</a:t>
             </a:r>
           </a:p>
         </p:txBody>
@@ -17017,7 +17096,7 @@
                 </a:solidFill>
                 <a:latin typeface="Calibri"/>
               </a:rPr>
-              <a:t>READ THE BOTTLE. CITE THE LABEL OR THE PAPER.</a:t>
+              <a:t>MINIMUM CONTACT TIME. CLOCK IT. THEN DRAPE.</a:t>
             </a:r>
           </a:p>
         </p:txBody>
@@ -17327,7 +17406,7 @@
                 <a:latin typeface="Calibri"/>
               </a:rPr>
               <a:t>2% chlorhexidine acetate
-Wash 2 to 4 minutes
+MIN contact: 2 to 4 min
 Keep out of eyes
 Trunk / intact skin
 Alcohol: rinse, then dry</a:t>
@@ -17485,7 +17564,7 @@
                 <a:latin typeface="Calibri"/>
               </a:rPr>
               <a:t>7.5% scrub
-Lather about 5 minutes
+MIN contact: about 5 min
 Rinse with sterile water
 Paint 5% solution
 Dry, then drape</a:t>
@@ -17643,7 +17722,7 @@
                 <a:latin typeface="Calibri"/>
               </a:rPr>
               <a:t>10% stock, dilute 1:50
-2 min scrub + 2 min soak
+MIN contact: 2 min + 2 min
 1:2: corneal edema (1/15)
 5% bottle: use 1:25
 Not full strength on cornea</a:t>
@@ -18264,6 +18343,22 @@
                 </a:solidFill>
                 <a:latin typeface="Calibri"/>
               </a:rPr>
+              <a:t>▸  Clock the minimum contact time.</a:t>
+            </a:r>
+          </a:p>
+          <a:p>
+            <a:pPr algn="l">
+              <a:spcAft>
+                <a:spcPts val="1000"/>
+              </a:spcAft>
+            </a:pPr>
+            <a:r>
+              <a:rPr sz="1600" b="0">
+                <a:solidFill>
+                  <a:srgbClr val="1C1C1C"/>
+                </a:solidFill>
+                <a:latin typeface="Calibri"/>
+              </a:rPr>
               <a:t>▸  Skin: 7.5% ~5 min, then 5% paint.</a:t>
             </a:r>
           </a:p>
@@ -19943,7 +20038,7 @@
                 </a:solidFill>
                 <a:latin typeface="Calibri"/>
               </a:rPr>
-              <a:t>Left: closed-gloving technique (hands stay inside the gown cuffs). Right: cap, mask, ECG/SpO2/ETCO2, circle system, IV fluids, airway. Monitoring is on before the first drug. Willie needed this for an ear clean. MoMo: the record stopped at preoperative evaluation.
+              <a:t>Left: closed-gloving technique (hands stay inside the gown cuffs). Right: cap, mask, ECG/SpO2/ETCO2, circle system, IV fluids, airway. The vaporizer delivers inhalant; MAC is how we talk about that dose. Monitoring is on before the first drug. Willie: alfaxalone sedation. MoMo: the record stopped at preoperative evaluation.
 Photo: MSgt Carlotta Holley, U.S. Air Force, public domain.</a:t>
             </a:r>
           </a:p>
@@ -21353,7 +21448,7 @@
                 </a:solidFill>
                 <a:latin typeface="Calibri"/>
               </a:rPr>
-              <a:t>10% stock 1:50 (1 + 49 mL). 2 min + 2 min. 5% bottle: 1:25.</a:t>
+              <a:t>10% stock 1:50. MIN contact 2 min + 2 min. 5% bottle: 1:25.</a:t>
             </a:r>
           </a:p>
         </p:txBody>
@@ -22265,7 +22360,7 @@
                 </a:solidFill>
                 <a:latin typeface="Calibri"/>
               </a:rPr>
-              <a:t>▸  Rewarm. Check skin every 15 minutes.</a:t>
+              <a:t>▸  NSAID injection if kidneys and GI allow. Willie: skip after DexSP.</a:t>
             </a:r>
           </a:p>
           <a:p>
@@ -22297,7 +22392,7 @@
                 </a:solidFill>
                 <a:latin typeface="Calibri"/>
               </a:rPr>
-              <a:t>▸  Willie: skip NSAID after DexSP.</a:t>
+              <a:t>▸  Antibiotic injection only if you are treating.</a:t>
             </a:r>
           </a:p>
         </p:txBody>
@@ -23951,7 +24046,7 @@
                 </a:solidFill>
                 <a:latin typeface="Calibri"/>
               </a:rPr>
-              <a:t>SCORE PAIN. THEN TEACH THE E-COLLAR.</a:t>
+              <a:t>INJECTIONS AT RECOVERY. THEN TEACH THE E-COLLAR.</a:t>
             </a:r>
           </a:p>
         </p:txBody>
@@ -24027,7 +24122,7 @@
                 </a:solidFill>
                 <a:latin typeface="Calibri"/>
               </a:rPr>
-              <a:t>Pain and incision care</a:t>
+              <a:t>Postop analgesia and incision care</a:t>
             </a:r>
           </a:p>
         </p:txBody>
@@ -24105,7 +24200,7 @@
                 </a:solidFill>
                 <a:latin typeface="Calibri"/>
               </a:rPr>
-              <a:t>Score pain and record the number</a:t>
+              <a:t>Analgesia injection at recovery</a:t>
             </a:r>
           </a:p>
         </p:txBody>
@@ -24134,97 +24229,97 @@
           <a:p>
             <a:pPr algn="l">
               <a:spcAft>
-                <a:spcPts val="600"/>
+                <a:spcPts val="500"/>
               </a:spcAft>
             </a:pPr>
             <a:r>
-              <a:rPr sz="1600" b="0">
+              <a:rPr sz="1500" b="0">
                 <a:solidFill>
                   <a:srgbClr val="1C1C1C"/>
                 </a:solidFill>
                 <a:latin typeface="Calibri"/>
               </a:rPr>
-              <a:t>▸  Dogs: Glasgow CMPS-SF. Cats: Feline Grimace Scale plus behavior.</a:t>
+              <a:t>▸  Score pain. Dogs: Glasgow CMPS-SF. Cats: Feline Grimace Scale.</a:t>
             </a:r>
           </a:p>
           <a:p>
             <a:pPr algn="l">
               <a:spcAft>
-                <a:spcPts val="600"/>
+                <a:spcPts val="500"/>
               </a:spcAft>
             </a:pPr>
             <a:r>
-              <a:rPr sz="1600" b="0">
+              <a:rPr sz="1500" b="0">
                 <a:solidFill>
                   <a:srgbClr val="1C1C1C"/>
                 </a:solidFill>
                 <a:latin typeface="Calibri"/>
               </a:rPr>
-              <a:t>▸  Re-score after intervention.</a:t>
+              <a:t>▸  Opioid injection as planned. Re-score after you give it.</a:t>
             </a:r>
           </a:p>
           <a:p>
             <a:pPr algn="l">
               <a:spcAft>
-                <a:spcPts val="600"/>
+                <a:spcPts val="500"/>
               </a:spcAft>
             </a:pPr>
             <a:r>
-              <a:rPr sz="1600" b="0">
+              <a:rPr sz="1500" b="0">
                 <a:solidFill>
                   <a:srgbClr val="1C1C1C"/>
                 </a:solidFill>
                 <a:latin typeface="Calibri"/>
               </a:rPr>
-              <a:t>▸  Soft tissue elective: opioid ± NSAID ± local.</a:t>
+              <a:t>▸  NSAID if perfusion, kidneys, and GI allow. Do not stack with a steroid.</a:t>
             </a:r>
           </a:p>
           <a:p>
             <a:pPr algn="l">
               <a:spcAft>
-                <a:spcPts val="600"/>
+                <a:spcPts val="500"/>
               </a:spcAft>
             </a:pPr>
             <a:r>
-              <a:rPr sz="1600" b="0">
+              <a:rPr sz="1500" b="0">
                 <a:solidFill>
                   <a:srgbClr val="1C1C1C"/>
                 </a:solidFill>
                 <a:latin typeface="Calibri"/>
               </a:rPr>
-              <a:t>▸  Celiotomy / orthopedic: CRIs, extra locals, overnight monitoring.</a:t>
+              <a:t>▸  Carprofen: dog. Onsior (robenacoxib) 2 mg/kg SQ: dog or cat, labeled up to 3 days.</a:t>
             </a:r>
           </a:p>
           <a:p>
             <a:pPr algn="l">
               <a:spcAft>
-                <a:spcPts val="600"/>
+                <a:spcPts val="500"/>
               </a:spcAft>
             </a:pPr>
             <a:r>
-              <a:rPr sz="1600" b="0">
+              <a:rPr sz="1500" b="0">
                 <a:solidFill>
                   <a:srgbClr val="1C1C1C"/>
                 </a:solidFill>
                 <a:latin typeface="Calibri"/>
               </a:rPr>
-              <a:t>▸  Send home the opioid + NSAID (if kidneys and GI allow) + the local you already placed. Write the dosing times.</a:t>
+              <a:t>▸  Onsior first dose: about 45 min before incision in dogs, 30 min in cats (label). Later doses at recovery or SQ/PO.</a:t>
             </a:r>
           </a:p>
           <a:p>
             <a:pPr algn="l">
               <a:spcAft>
-                <a:spcPts val="600"/>
+                <a:spcPts val="500"/>
               </a:spcAft>
             </a:pPr>
             <a:r>
-              <a:rPr sz="1600" b="0">
+              <a:rPr sz="1500" b="0">
                 <a:solidFill>
                   <a:srgbClr val="1C1C1C"/>
                 </a:solidFill>
                 <a:latin typeface="Calibri"/>
               </a:rPr>
-              <a:t>▸  Willie already received DexSP: skip NSAID.</a:t>
+              <a:t>▸  Willie already received DexSP: skip NSAID. MoMo: azotemic, skip NSAID.</a:t>
             </a:r>
           </a:p>
         </p:txBody>
@@ -24302,7 +24397,7 @@
                 </a:solidFill>
                 <a:latin typeface="Calibri"/>
               </a:rPr>
-              <a:t>Incision care</a:t>
+              <a:t>Antibiotic injection and incision</a:t>
             </a:r>
           </a:p>
         </p:txBody>
@@ -24331,97 +24426,97 @@
           <a:p>
             <a:pPr algn="l">
               <a:spcAft>
-                <a:spcPts val="600"/>
+                <a:spcPts val="500"/>
               </a:spcAft>
             </a:pPr>
             <a:r>
-              <a:rPr sz="1600" b="0">
+              <a:rPr sz="1500" b="0">
                 <a:solidFill>
                   <a:srgbClr val="1C1C1C"/>
                 </a:solidFill>
                 <a:latin typeface="Calibri"/>
               </a:rPr>
-              <a:t>▸  Look twice daily: swelling, discharge, gapping, smell, heat.</a:t>
+              <a:t>▸  A postoperative antibiotic injection is treatment. Write the drug, dose, and why.</a:t>
             </a:r>
           </a:p>
           <a:p>
             <a:pPr algn="l">
               <a:spcAft>
-                <a:spcPts val="600"/>
+                <a:spcPts val="500"/>
               </a:spcAft>
             </a:pPr>
             <a:r>
-              <a:rPr sz="1600" b="0">
+              <a:rPr sz="1500" b="0">
                 <a:solidFill>
                   <a:srgbClr val="1C1C1C"/>
                 </a:solidFill>
                 <a:latin typeface="Calibri"/>
               </a:rPr>
-              <a:t>▸  E-collar that actually stays on.</a:t>
+              <a:t>▸  Clean elective OHE: skip (Frey 2022). Do not send home 14 days of cephalexin.</a:t>
             </a:r>
           </a:p>
           <a:p>
             <a:pPr algn="l">
               <a:spcAft>
-                <a:spcPts val="600"/>
+                <a:spcPts val="500"/>
               </a:spcAft>
             </a:pPr>
             <a:r>
-              <a:rPr sz="1600" b="0">
+              <a:rPr sz="1500" b="0">
                 <a:solidFill>
                   <a:srgbClr val="1C1C1C"/>
                 </a:solidFill>
                 <a:latin typeface="Calibri"/>
               </a:rPr>
-              <a:t>▸  Leash walks only for 14 days. Keep the patient confined indoors otherwise.</a:t>
+              <a:t>▸  Dirty or infected: continue as therapy. Willie’s ear is treatment, not prophylaxis.</a:t>
             </a:r>
           </a:p>
           <a:p>
             <a:pPr algn="l">
               <a:spcAft>
-                <a:spcPts val="600"/>
+                <a:spcPts val="500"/>
               </a:spcAft>
             </a:pPr>
             <a:r>
-              <a:rPr sz="1600" b="0">
+              <a:rPr sz="1500" b="0">
                 <a:solidFill>
                   <a:srgbClr val="1C1C1C"/>
                 </a:solidFill>
                 <a:latin typeface="Calibri"/>
               </a:rPr>
-              <a:t>▸  Saline if dirty. Skin sutures typically 10–14 days.</a:t>
+              <a:t>▸  Look twice daily: swelling, discharge, gapping, smell, heat.</a:t>
             </a:r>
           </a:p>
           <a:p>
             <a:pPr algn="l">
               <a:spcAft>
-                <a:spcPts val="600"/>
+                <a:spcPts val="500"/>
               </a:spcAft>
             </a:pPr>
             <a:r>
-              <a:rPr sz="1600" b="0">
+              <a:rPr sz="1500" b="0">
                 <a:solidFill>
                   <a:srgbClr val="1C1C1C"/>
                 </a:solidFill>
                 <a:latin typeface="Calibri"/>
               </a:rPr>
-              <a:t>▸  Heart or kidney patients: measured fluid rate and a written stop time.</a:t>
+              <a:t>▸  E-collar that stays on. Leash walks 14 days.</a:t>
             </a:r>
           </a:p>
           <a:p>
             <a:pPr algn="l">
               <a:spcAft>
-                <a:spcPts val="600"/>
+                <a:spcPts val="500"/>
               </a:spcAft>
             </a:pPr>
             <a:r>
-              <a:rPr sz="1600" b="0">
+              <a:rPr sz="1500" b="0">
                 <a:solidFill>
                   <a:srgbClr val="1C1C1C"/>
                 </a:solidFill>
                 <a:latin typeface="Calibri"/>
               </a:rPr>
-              <a:t>▸  Cats: start a meal the night of surgery.</a:t>
+              <a:t>▸  Skin sutures typically 10–14 days. Cats: start a meal the night of surgery.</a:t>
             </a:r>
           </a:p>
         </p:txBody>
@@ -29822,7 +29917,7 @@
                 </a:solidFill>
                 <a:latin typeface="Calibri"/>
               </a:rPr>
-              <a:t>Clean elective OHE: skip routine postoperative antibiotics.</a:t>
+              <a:t>When prophylaxis is indicated: cefazolin 22 mg/kg IV 30–60 min before incision. Clean OHE: skip.</a:t>
             </a:r>
           </a:p>
         </p:txBody>
@@ -29976,7 +30071,7 @@
                 </a:solidFill>
                 <a:latin typeface="Calibri"/>
               </a:rPr>
-              <a:t>Clip after induction. Spiral prep. Re-clip until the window is hair-free.</a:t>
+              <a:t>Clock minimum contact time. Skin: 7.5% ~5 min, then 5% paint. Eye: 10% 1:50, 2 min + 2 min.</a:t>
             </a:r>
           </a:p>
         </p:txBody>
@@ -30130,7 +30225,7 @@
                 </a:solidFill>
                 <a:latin typeface="Calibri"/>
               </a:rPr>
-              <a:t>Skin: 7.5% PVP-I ~5 min, then 5% paint. Eye: 10% 1:50, 2 min + 2 min.</a:t>
+              <a:t>Premed lowers MAC. Heart-compromised: opioid + alfaxalone. DKT and BAA are healthy-patient combinations.</a:t>
             </a:r>
           </a:p>
         </p:txBody>

</xml_diff>

<commit_message>
Cite CPE MOA 2026 anesthesia and surgery, with tube and bag math.
Use the ECFVG CPE Manual of Administration as the competency list for this DVM 612 hour: exam before IM/SQ premed, ASA, ready-for-prep and last-skin-suture clocks, and the one-warning asepsis rule. Teach ETT and reservoir-bag selection with Willie as the worked example (7.0 mm, 1 L).

Co-authored-by: drkimvet <drkimvet@users.noreply.github.com>
</commit_message>
<xml_diff>
--- a/lectures/DVM-612_Week4_Preop_PatientPrep_Postop.pptx
+++ b/lectures/DVM-612_Week4_Preop_PatientPrep_Postop.pptx
@@ -539,7 +539,7 @@
           <a:lstStyle/>
           <a:p>
             <a:r>
-              <a:t>Welcome. This hour is preoperative evaluation, patient and surgeon preparation, and postoperative care. Two real patients from the same hospital. Willie, a 6-year 11-month MN Cavalier, 13.7 kg, acute vestibular crisis plus left otitis. We sedated him. MoMo, a 6-year SF DSH, 4.25 kg, vomiting that looked like a foreign-body surgery. Imaging cancelled the exploratory. Assign both ASA statuses. Owner identifiers stay off these slides. Thirty-eight slides. If discussion runs, protect antiseptics, both cases, and recovery.</a:t>
+              <a:t>Welcome. This hour is preoperative evaluation, patient and surgeon preparation, and postoperative care. Two real patients from the same hospital. Willie, a 6-year 11-month MN Cavalier, 13.7 kg, acute vestibular crisis plus left otitis. We sedated him. MoMo, a 6-year SF DSH, 4.25 kg, vomiting that looked like a foreign-body surgery. Imaging cancelled the exploratory. Assign both ASA statuses. Owner identifiers stay off these slides. We use the 2026 CPE Manual of Administration anesthesia and surgery chapters as the competency list for this hour, not as an exam-prep course. Thirty-eight slides. If discussion runs, protect antiseptics, both cases, and recovery.</a:t>
             </a:r>
           </a:p>
         </p:txBody>
@@ -1029,7 +1029,7 @@
           <a:lstStyle/>
           <a:p>
             <a:r>
-              <a:t>Two minutes. Purpose of premed: calm, analgesia, lower induction dose, lower MAC. DKT is dexmedetomidine, ketamine, butorphanol. BAA is butorphanol, acepromazine, atropine. Ace and dexmed are not the default in heart-compromised patients; Willie got alfaxalone. MAC is how we talk about inhalant dose. Timeout includes cefazolin 22 mg/kg IV when prophylaxis is indicated.</a:t>
+              <a:t>Board the two formulas. Dog ETT starting estimate: kilograms divided by 4, plus 3.5. Confirm with Grubb 2020: largest tube that passes the arytenoids without trauma; tip midway from larynx to thoracic inlet. Cuff holds a leak to 20 centimeters of water; that number is in the CPE MOA. Bag: kilograms times 60 milliliters, round up. Willie: 7.0 millimeter tube, 1 liter bag, circle. A 4 kilogram cat: 0.5 liter bag, non-rebreathing, 200 to 400 milliliters per kilogram per minute of oxygen per Grubb 2020. Leak-test, then open the pop-off. Premed still belongs here: exam first, IM or SQ, DKT and BAA for healthy patients, alfaxalone for Willie.</a:t>
             </a:r>
           </a:p>
         </p:txBody>
@@ -1379,7 +1379,7 @@
           <a:lstStyle/>
           <a:p>
             <a:r>
-              <a:t>Airway and plane before clippers. Veterinary Betadine labels: 7.5% scrub, lather about 5 minutes, rinse, paint 5% Solution Veterinary, allow to dry. Eye: Roberts 1986, 1:50 of 10% PVP-I stock, 2-minute scrub plus 2-minute soak. Do not paint 10% from the veterinary bottle; that bottle is 5%.</a:t>
+              <a:t>Do not clip until the patient is ready for prep: tube in, cuff holds to 20 centimeters of water, correct bag, IV running, surgical plane. CPE MOA 2026 Surgery scores hair, skin, position, and drape, then wants you to announce the incision. Veterinary Betadine labels: 7.5% scrub about 5 minutes, rinse, paint 5% Solution Veterinary, dry. Eye: Roberts 1986, 1:50 of 10% stock, 2 plus 2 minutes.</a:t>
             </a:r>
           </a:p>
         </p:txBody>
@@ -1659,7 +1659,7 @@
           <a:lstStyle/>
           <a:p>
             <a:r>
-              <a:t>Airway and monitoring are on before the clip. Keep hips in a neutral spread.</a:t>
+              <a:t>Name the bag size and the tube size on this photograph. Confirm placement with ETCO2. Keep hips in a neutral spread.</a:t>
             </a:r>
           </a:p>
         </p:txBody>
@@ -1869,7 +1869,7 @@
           <a:lstStyle/>
           <a:p>
             <a:r>
-              <a:t>Praise the person who says I just contaminated my sleeve. Then re-glove. Ureter injury is a calm, well-exposed patient problem.</a:t>
+              <a:t>Praise the person who says I just contaminated my sleeve. Then re-glove. Before incision, one unrecognized break is a warning. After incision, there is no warning. Ureter injury is a calm, well-exposed patient problem. The 24-hour window is why recovery is in this lecture.</a:t>
             </a:r>
           </a:p>
         </p:txBody>
@@ -1939,7 +1939,7 @@
           <a:lstStyle/>
           <a:p>
             <a:r>
-              <a:t>Two minutes. B is Roberts 1986 bottle math. D is CHG off the cornea. C is the stabilize-first cat.</a:t>
+              <a:t>Two minutes. C is the board math: Willie 7.0 millimeter tube, 1 liter bag. B is Roberts 1986 bottle math. D is CHG off the cornea. If a student asks about the blocked cat: stabilize potassium first.</a:t>
             </a:r>
           </a:p>
         </p:txBody>
@@ -2709,7 +2709,7 @@
           <a:lstStyle/>
           <a:p>
             <a:r>
-              <a:t>Take questions. If none: Willie versus MoMo ASA from the 2020 AAHA table, then iodine: Roberts 1 to 50 of 10 percent stock, 2 minutes plus 2 minutes on the eye; intact skin is the 7.5 percent scrub for about 5 minutes then 5 percent veterinary paint. Dismiss on time.</a:t>
+              <a:t>Take questions. If none: Willie versus MoMo ASA from the 2020 AAHA table, then Willie 13.7 kg: start 7.0 mm ETT, 1 L bag. Iodine if asked: Roberts 1 to 50 of 10 percent stock. Dismiss on time.</a:t>
             </a:r>
           </a:p>
         </p:txBody>
@@ -2849,7 +2849,7 @@
           <a:lstStyle/>
           <a:p>
             <a:r>
-              <a:t>Anesthesia prepares the patient for surgical prep. Surgery owns prep through the last skin suture. Both own recovery.</a:t>
+              <a:t>Do not teach this as a CPE station. Teach the clocks. Anesthesia owns exam through a patient who is ready for clippers: tube in, cuff up, machine on, IV running, surgical plane. Surgery owns clip through the last skin suture, then both own the first 24 hours. Cite ECFVG CPE Manual of Administration 2026, Anesthesia and Surgery sections.</a:t>
             </a:r>
           </a:p>
         </p:txBody>
@@ -2919,7 +2919,7 @@
           <a:lstStyle/>
           <a:p>
             <a:r>
-              <a:t>Four jobs. Students often skip #3 and #4. Do your own PE, then use technician vitals as a second set of numbers. Order: examine, then premedicate.</a:t>
+              <a:t>Four jobs. Students often skip number 3 and 4. Do your own PE, then use technician vitals as a second set of numbers. CPE MOA 2026 Anesthesia: premedicating before the examination is a dismissible event. Premed is IM or SQ. If today’s ASA is not Status 1, change the drug plan before you inject.</a:t>
             </a:r>
           </a:p>
         </p:txBody>
@@ -2989,7 +2989,7 @@
           <a:lstStyle/>
           <a:p>
             <a:r>
-              <a:t>Read the 2020 AAHA table: Status 1 healthy neuter, Status 2 compensated mild mitral, Status 3 moderate disease such as IRIS 3 CKD, Status 4 threat to life such as bleeding splenic mass, Status 5 moribund septic cat. Then map Willie to 3-E and MoMo to 4-E. E means emergency.</a:t>
+              <a:t>Read the 2020 AAHA table: Status 1 healthy neuter, Status 2 compensated mild mitral, Status 3 moderate disease such as IRIS 3 CKD, Status 4 threat to life such as bleeding splenic mass, Status 5 moribund septic cat. CPE MOA 2026 Appendix 2 uses the same five statuses. Then map Willie to 3-E and MoMo to 4-E. E means emergency.</a:t>
             </a:r>
           </a:p>
         </p:txBody>
@@ -6493,8 +6493,8 @@
                 </a:solidFill>
                 <a:latin typeface="Calibri"/>
               </a:rPr>
-              <a:t>Required reading: Fossum, Small Animal Surgery, 5th ed. (2018)
-Hendrickson &amp; Baird (2013)</a:t>
+              <a:t>Required: Fossum 2018; Hendrickson &amp; Baird 2013.
+Also used: ECFVG CPE Manual of Administration 2026, Anesthesia and Surgery.</a:t>
             </a:r>
           </a:p>
         </p:txBody>
@@ -12060,7 +12060,7 @@
                 </a:solidFill>
                 <a:latin typeface="Calibri"/>
               </a:rPr>
-              <a:t>BRIEF ANESTHESIA VOCABULARY FOR THIS HOUR. NOT AN ANESTHESIA COURSE.</a:t>
+              <a:t>CPE MOA 2026: SELECT ETT, BREATHING SYSTEM, AND RESERVOIR BAG. THEN LEAK-TEST.</a:t>
             </a:r>
           </a:p>
         </p:txBody>
@@ -12136,7 +12136,7 @@
                 </a:solidFill>
                 <a:latin typeface="Calibri"/>
               </a:rPr>
-              <a:t>Premedication, MAC, and the timeout</a:t>
+              <a:t>Premedication, tube, and bag</a:t>
             </a:r>
           </a:p>
         </p:txBody>
@@ -12257,7 +12257,7 @@
                 </a:solidFill>
                 <a:latin typeface="Calibri"/>
               </a:rPr>
-              <a:t>Why we premedicate</a:t>
+              <a:t>Premed, then MAC</a:t>
             </a:r>
           </a:p>
         </p:txBody>
@@ -12270,8 +12270,8 @@
         </p:nvSpPr>
         <p:spPr>
           <a:xfrm>
-            <a:off x="530352" y="1664208"/>
-            <a:ext cx="3438144" cy="4297680"/>
+            <a:off x="512064" y="1627632"/>
+            <a:ext cx="3474720" cy="4370832"/>
           </a:xfrm>
           <a:prstGeom prst="rect">
             <a:avLst/>
@@ -12284,17 +12284,18 @@
           <a:p>
             <a:pPr algn="l"/>
             <a:r>
-              <a:rPr sz="1500" b="0">
+              <a:rPr sz="1400" b="0">
                 <a:solidFill>
                   <a:srgbClr val="1C1C1C"/>
                 </a:solidFill>
                 <a:latin typeface="Calibri"/>
               </a:rPr>
-              <a:t>Calm the patient. Give preemptive analgesia.
-Lower the induction dose.
-Lower MAC of the vaporizer.
-Smoother intubation and recovery.
-Safer handling before the clip.</a:t>
+              <a:t>Exam first. Then IM or SQ premed.
+Calm, analgesia, lower induction dose, lower MAC, safer clip.
+DKT: dexmedetomidine + ketamine + butorphanol. One IM syringe. Healthy ASA 1–2.
+BAA: butorphanol + acepromazine + atropine. Healthy patients.
+Heart / murmur: skip ace and dexmed as the default. Opioid + alfaxalone. That is Willie.
+MAC = alveolar % that stops movement in 50% of patients. Premed lowers it. Turn the dial down.</a:t>
             </a:r>
           </a:p>
         </p:txBody>
@@ -12415,7 +12416,7 @@
                 </a:solidFill>
                 <a:latin typeface="Calibri"/>
               </a:rPr>
-              <a:t>Injectables you will hear</a:t>
+              <a:t>Endotracheal tube</a:t>
             </a:r>
           </a:p>
         </p:txBody>
@@ -12428,8 +12429,8 @@
         </p:nvSpPr>
         <p:spPr>
           <a:xfrm>
-            <a:off x="4443984" y="1664208"/>
-            <a:ext cx="3438144" cy="4297680"/>
+            <a:off x="4425696" y="1627632"/>
+            <a:ext cx="3474720" cy="4370832"/>
           </a:xfrm>
           <a:prstGeom prst="rect">
             <a:avLst/>
@@ -12442,15 +12443,17 @@
           <a:p>
             <a:pPr algn="l"/>
             <a:r>
-              <a:rPr sz="1500" b="0">
+              <a:rPr sz="1400" b="0">
                 <a:solidFill>
                   <a:srgbClr val="1C1C1C"/>
                 </a:solidFill>
                 <a:latin typeface="Calibri"/>
               </a:rPr>
-              <a:t>DKT: dexmedetomidine + ketamine + butorphanol (torb). One IM syringe: sedation, analgesia, muscle relaxation. Ketamine supports HR. Dexmed is reversible. Healthy ASA 1–2 short procedures.
-BAA: butorphanol (torb) + acepromazine + atropine. Classic MAC-sparing premed in healthy patients.
-Heart-compromised / murmur: skip acepromazine and dexmedetomidine as the default. Opioid + alfaxalone is a common plan. That is why Willie received alfaxalone.</a:t>
+              <a:t>CPE MOA: choose a tube that fits. Cuff holds to 20 cm H2O. Grossly too large or too small is unsafe.
+Grubb 2020: largest ID that passes the arytenoids without trauma. Tip midway from larynx to thoracic inlet. Proximal end at or just past the incisors.
+Dog starting estimate: ID mm = (kg / 4) + 3.5. Have 0.5 mm larger and smaller.
+Willie 13.7 kg: (13.7 / 4) + 3.5 = 6.9. Start 7.0 mm. Have 6.5 and 7.5.
+Cat: typically 3.0–4.5 mm. Confirm on the larynx.</a:t>
             </a:r>
           </a:p>
         </p:txBody>
@@ -12571,7 +12574,7 @@
                 </a:solidFill>
                 <a:latin typeface="Calibri"/>
               </a:rPr>
-              <a:t>Gas and MAC</a:t>
+              <a:t>Reservoir bag and circuit</a:t>
             </a:r>
           </a:p>
         </p:txBody>
@@ -12584,8 +12587,8 @@
         </p:nvSpPr>
         <p:spPr>
           <a:xfrm>
-            <a:off x="8357616" y="1664208"/>
-            <a:ext cx="3438144" cy="4297680"/>
+            <a:off x="8339328" y="1627632"/>
+            <a:ext cx="3474720" cy="4370832"/>
           </a:xfrm>
           <a:prstGeom prst="rect">
             <a:avLst/>
@@ -12598,16 +12601,19 @@
           <a:p>
             <a:pPr algn="l"/>
             <a:r>
-              <a:rPr sz="1500" b="0">
+              <a:rPr sz="1400" b="0">
                 <a:solidFill>
                   <a:srgbClr val="1C1C1C"/>
                 </a:solidFill>
                 <a:latin typeface="Calibri"/>
               </a:rPr>
-              <a:t>MAC = minimum alveolar concentration: the alveolar % of inhalant that stops movement in 50% of patients to a surgical stimulus.
-Isoflurane or sevoflurane maintain anesthesia after injectable induction.
-Premeds, local blocks, and hypothermia lower MAC. Turn the vaporizer down.
-Timeout before incision: identity, site, ASA, last meal, monitors on, cefazolin 22 mg/kg IV if indicated.</a:t>
+              <a:t>CPE MOA: select the circuit and the bag. Calculate fresh-gas flow.
+Tidal volume about 10–15 mL/kg (Grubb 2020: dead space ≤2–3 mL/kg is ≤20% of TV).
+Bag = 5–6 × TV. Shortcut: kg × 60 mL. Round UP to 0.5, 1, 2, or 3 L.
+Willie 13.7 kg: 822 mL → 1 L bag. Circle.
+MoMo 4.25 kg, if ever anesthetized: 255 mL → 0.5 L. NRC (Grubb: cats and dogs &lt;3–5 kg).
+NRC O2: 200–400 mL/kg/min.
+Leak-test to 20–30 cm H2O. Then OPEN the pop-off.</a:t>
             </a:r>
           </a:p>
         </p:txBody>
@@ -14420,7 +14426,7 @@
                 </a:solidFill>
                 <a:latin typeface="Calibri"/>
               </a:rPr>
-              <a:t>▸  Assign ASA after today’s PE and labs. Proceed, delay, or stabilize.</a:t>
+              <a:t>▸  Assign ASA after today’s PE and labs. Proceed, delay, or stabilize. Premedicate only after that exam.</a:t>
             </a:r>
           </a:p>
           <a:p>
@@ -14436,7 +14442,7 @@
                 </a:solidFill>
                 <a:latin typeface="Calibri"/>
               </a:rPr>
-              <a:t>▸  Write the peri-op plan: fasting, analgesia, antibiotics, consent, checklist.</a:t>
+              <a:t>▸  Write the peri-op plan: fasting, analgesia, antibiotics, consent, ETT, reservoir bag, breathing system.</a:t>
             </a:r>
           </a:p>
           <a:p>
@@ -14851,7 +14857,7 @@
                 </a:solidFill>
                 <a:latin typeface="Calibri"/>
               </a:rPr>
-              <a:t>PREP ROOM, THEN OPERATING ROOM</a:t>
+              <a:t>CPE MOA 2026 SURGERY: HAIR, SKIN, POSITION, DRAPE. THEN ANNOUNCE INCISION.</a:t>
             </a:r>
           </a:p>
         </p:txBody>
@@ -15081,7 +15087,7 @@
                 </a:solidFill>
                 <a:latin typeface="Calibri"/>
               </a:rPr>
-              <a:t>Anesthetized, airway in, IV in, depth adequate</a:t>
+              <a:t>Ready for prep: ETT in, cuff to 20 cm H2O, bag on, IV running, surgical plane</a:t>
             </a:r>
           </a:p>
         </p:txBody>
@@ -16159,7 +16165,7 @@
                 </a:solidFill>
                 <a:latin typeface="Calibri"/>
               </a:rPr>
-              <a:t>Timeout / checklist → announce incision</a:t>
+              <a:t>Timeout. Announce incision. Clock runs to the last skin suture.</a:t>
             </a:r>
           </a:p>
         </p:txBody>
@@ -18893,12 +18899,12 @@
               </a:rPr>
               <a:t>• ET tube + pulse ox
 • IV catheter + fluids
-• Anesthesia machine
+• Circle + reservoir bag
 • V-trough / padding
-• Ties snug, then check the pulse distal to each tie
-• Clip after a surgical plane of anesthesia
-Keep the hips in a neutral spread.
-Lubricate the eyes. Confirm the tube is patent.
+• Ties snug; pulse distal to each tie
+• Clip after a surgical plane
+Tube tip: midway larynx to thoracic inlet (Grubb 2020).
+Confirm: ETCO2, bag move, no esophageal tube.
 Photo: Anja, CC BY-SA 4.0.</a:t>
             </a:r>
           </a:p>
@@ -20328,7 +20334,7 @@
                 </a:solidFill>
                 <a:latin typeface="Calibri"/>
               </a:rPr>
-              <a:t>RECOGNIZE, ANNOUNCE, CORRECT. THEN PROTECT THE PATIENT.</a:t>
+              <a:t>CPE MOA 2026 SURGERY: ONE UNRECOGNIZED BREAK BEFORE INCISION. NONE AFTER.</a:t>
             </a:r>
           </a:p>
         </p:txBody>
@@ -20509,14 +20515,14 @@
           <a:p>
             <a:pPr algn="l"/>
             <a:r>
-              <a:rPr sz="1800" b="0">
+              <a:rPr sz="1600" b="0">
                 <a:solidFill>
                   <a:srgbClr val="1C1C1C"/>
                 </a:solidFill>
                 <a:latin typeface="Calibri"/>
               </a:rPr>
-              <a:t>Say it immediately. Re-glove, re-gown, or re-drape. Name the break once. Fix it completely.
-After the incision is made, the same rule: notice, announce, correct. Sleeve in the abdomen, instrument off the table, hole in a glove: stop and fix it.</a:t>
+              <a:t>Prep, gown, glove, drape: say it immediately. Re-glove, re-gown, or re-drape. One unrecognized break gets a warning. A second unrecognized break stops the case.
+After the incision: notice, announce, and fully correct. There is no warning. Sleeve in the abdomen, instrument off the table, hole in a glove: stop and fix it.</a:t>
             </a:r>
           </a:p>
         </p:txBody>
@@ -20621,7 +20627,7 @@
           <a:p>
             <a:pPr algn="l"/>
             <a:r>
-              <a:rPr sz="1800" b="0">
+              <a:rPr sz="1600" b="0">
                 <a:solidFill>
                   <a:srgbClr val="1C1C1C"/>
                 </a:solidFill>
@@ -20703,13 +20709,13 @@
           <a:p>
             <a:pPr algn="l"/>
             <a:r>
-              <a:rPr sz="1800" b="0">
+              <a:rPr sz="1600" b="0">
                 <a:solidFill>
                   <a:srgbClr val="0B2C4A"/>
                 </a:solidFill>
                 <a:latin typeface="Calibri"/>
               </a:rPr>
-              <a:t>The operation is not over when the last skin suture is placed. Intra-abdominal hemorrhage from poor ligation, or herniation from a weak linea, can kill the patient after you have left the OR. That is why postoperative care is part of this lecture.</a:t>
+              <a:t>The operation is not over at the last skin suture. CPE MOA 2026 Surgery still scores the first 24 hours: intra-abdominal hemorrhage from a weak ligature, or herniation from a weak linea, is still the operation.</a:t>
             </a:r>
           </a:p>
         </p:txBody>
@@ -21261,7 +21267,7 @@
                 </a:solidFill>
                 <a:latin typeface="Calibri"/>
               </a:rPr>
-              <a:t>After induction, immediately before the scrub.</a:t>
+              <a:t>After the patient is ready for prep: tube in, IV running, surgical plane.</a:t>
             </a:r>
           </a:p>
         </p:txBody>
@@ -21602,7 +21608,7 @@
                 </a:solidFill>
                 <a:latin typeface="Calibri"/>
               </a:rPr>
-              <a:t>Blocked cat, K+ 8.2, booked for PU. First move?</a:t>
+              <a:t>Willie is 13.7 kg. Tube and bag?</a:t>
             </a:r>
           </a:p>
         </p:txBody>
@@ -21635,7 +21641,7 @@
                 </a:solidFill>
                 <a:latin typeface="Calibri"/>
               </a:rPr>
-              <a:t>Stabilize K+. Decompress. Recheck. Then decide on anesthesia.</a:t>
+              <a:t>Start 7.0 mm ID. 13.7 × 60 mL = 822 mL → 1 L bag. Circle. Confirm on the larynx.</a:t>
             </a:r>
           </a:p>
         </p:txBody>
@@ -22344,7 +22350,7 @@
                 </a:solidFill>
                 <a:latin typeface="Calibri"/>
               </a:rPr>
-              <a:t>▸  Pale + tachycardic after celiotomy: return to OR.</a:t>
+              <a:t>▸  Most anesthetic deaths are in recovery, often in the first 3 hours (Grubb 2020).</a:t>
             </a:r>
           </a:p>
           <a:p>
@@ -22360,7 +22366,7 @@
                 </a:solidFill>
                 <a:latin typeface="Calibri"/>
               </a:rPr>
-              <a:t>▸  NSAID injection if kidneys and GI allow. Willie: skip after DexSP.</a:t>
+              <a:t>▸  Pale + tachycardic after celiotomy: return to OR.</a:t>
             </a:r>
           </a:p>
           <a:p>
@@ -22376,7 +22382,7 @@
                 </a:solidFill>
                 <a:latin typeface="Calibri"/>
               </a:rPr>
-              <a:t>▸  E-collar on before they can lick.</a:t>
+              <a:t>▸  NSAID injection if kidneys and GI allow. Willie: skip after DexSP.</a:t>
             </a:r>
           </a:p>
           <a:p>
@@ -22392,7 +22398,7 @@
                 </a:solidFill>
                 <a:latin typeface="Calibri"/>
               </a:rPr>
-              <a:t>▸  Antibiotic injection only if you are treating.</a:t>
+              <a:t>▸  E-collar on before they can lick.</a:t>
             </a:r>
           </a:p>
         </p:txBody>
@@ -22681,7 +22687,7 @@
                 </a:solidFill>
                 <a:latin typeface="Calibri"/>
               </a:rPr>
-              <a:t>WHY THIS HOUR EXISTS</a:t>
+              <a:t>WHY THIS HOUR EXISTS. CPE MOA 2026 SURGERY: PREPARE THE PATIENT, PREPARE YOURSELF, PERFORM THE PROCEDURE.</a:t>
             </a:r>
           </a:p>
         </p:txBody>
@@ -23368,7 +23374,7 @@
                 </a:solidFill>
                 <a:latin typeface="Calibri"/>
               </a:rPr>
-              <a:t>▸  Perform the procedure. Then own the first 24 hours: hemorrhage or herniation in recovery is still the operation.</a:t>
+              <a:t>▸  Perform the procedure. Then own the first 24 hours: hemorrhage from a weak ligature, or herniation from a weak linea, is still the operation (CPE MOA 2026 Surgery).</a:t>
             </a:r>
           </a:p>
         </p:txBody>
@@ -24805,7 +24811,7 @@
                 </a:solidFill>
                 <a:latin typeface="Calibri"/>
               </a:rPr>
-              <a:t>HEMORRHAGE, AIRWAY, HERNIA, DEHISCENCE, SSI, SEROMA</a:t>
+              <a:t>CPE MOA 2026 SURGERY STILL SCORES THIS WINDOW. HEMORRHAGE, HERNIA, DEHISCENCE.</a:t>
             </a:r>
           </a:p>
         </p:txBody>
@@ -27988,7 +27994,7 @@
                 </a:solidFill>
                 <a:latin typeface="Calibri"/>
               </a:rPr>
-              <a:t>Neuro exam. Culture the ear. Radiographs are not MRI. Central until proven otherwise.</a:t>
+              <a:t>Neuro exam. Culture the ear. Radiographs are not MRI. Central until proven otherwise. Exam before any drug.</a:t>
             </a:r>
           </a:p>
         </p:txBody>
@@ -28142,7 +28148,7 @@
                 </a:solidFill>
                 <a:latin typeface="Calibri"/>
               </a:rPr>
-              <a:t>Monitors on. Then alfaxalone. Canal and eye: dilute PVP-I, 1:50 of 10%. Pad him.</a:t>
+              <a:t>If intubated: start 7.0 mm ETT, 1 L bag, circle. Canal and eye: dilute PVP-I, 1:50 of 10%. Then alfaxalone.</a:t>
             </a:r>
           </a:p>
         </p:txBody>
@@ -29763,7 +29769,7 @@
                 </a:solidFill>
                 <a:latin typeface="Calibri"/>
               </a:rPr>
-              <a:t>Serial creatinine can cancel a surgery. That is a successful preoperative evaluation.</a:t>
+              <a:t>Examine, request labs, assign ASA, then premedicate. Never the other way around.</a:t>
             </a:r>
           </a:p>
         </p:txBody>
@@ -29917,7 +29923,7 @@
                 </a:solidFill>
                 <a:latin typeface="Calibri"/>
               </a:rPr>
-              <a:t>When prophylaxis is indicated: cefazolin 22 mg/kg IV 30–60 min before incision. Clean OHE: skip.</a:t>
+              <a:t>Dog ETT start: (kg / 4) + 3.5 mm. Bag: kg × 60 mL, round up. Willie: 7.0 mm and 1 L.</a:t>
             </a:r>
           </a:p>
         </p:txBody>
@@ -30071,7 +30077,7 @@
                 </a:solidFill>
                 <a:latin typeface="Calibri"/>
               </a:rPr>
-              <a:t>Clock minimum contact time. Skin: 7.5% ~5 min, then 5% paint. Eye: 10% 1:50, 2 min + 2 min.</a:t>
+              <a:t>When prophylaxis is indicated: cefazolin 22 mg/kg IV 30–60 min before incision. Clean OHE: skip.</a:t>
             </a:r>
           </a:p>
         </p:txBody>
@@ -30225,7 +30231,7 @@
                 </a:solidFill>
                 <a:latin typeface="Calibri"/>
               </a:rPr>
-              <a:t>Premed lowers MAC. Heart-compromised: opioid + alfaxalone. DKT and BAA are healthy-patient combinations.</a:t>
+              <a:t>Clock minimum contact time. Skin: 7.5% ~5 min, then 5% paint. Eye: 10% 1:50, 2 min + 2 min.</a:t>
             </a:r>
           </a:p>
         </p:txBody>
@@ -30735,7 +30741,7 @@
                 <a:latin typeface="Calibri"/>
               </a:rPr>
               <a:t>Why was Willie ASA Status 3-E and MoMo ASA Status 4-E?
-How do you dilute 10% povidone-iodine for the eye?</a:t>
+Willie is 13.7 kg. What ETT and reservoir bag do you start with?</a:t>
             </a:r>
           </a:p>
         </p:txBody>
@@ -30843,7 +30849,8 @@
 8. Gonzalez OJ, Renberg WC, Roush JK, KuKanich B, Warner M. Am J Vet Res. 2017;78(6):695–701.
 9. BETADINE Surgical Scrub Veterinary. 7.5% povidone-iodine. DailyMed NDC 67618-154. Lather about 5 min, rinse, paint Solution Veterinary, dry.
 10. BETADINE Solution Veterinary. 5% povidone-iodine (not 10%). DailyMed NDC 67618-155.
-11. Nolvasan Surgical Scrub. 2% chlorhexidine acetate. DailyMed NDC 54771-8701. Wash 2 to 4 min. Avoid eyes and mucous membranes.</a:t>
+11. Nolvasan Surgical Scrub. 2% chlorhexidine acetate. DailyMed NDC 54771-8701. Wash 2 to 4 min. Avoid eyes and mucous membranes.
+12. ECFVG. Clinical Proficiency Examination Manual of Administration. 2026 ed. AVMA. Anesthesia; Surgery.</a:t>
             </a:r>
           </a:p>
         </p:txBody>
@@ -32532,7 +32539,7 @@
                 </a:solidFill>
                 <a:latin typeface="Calibri"/>
               </a:rPr>
-              <a:t>PREOPERATIVE, PREPARATION, INTRAOPERATIVE, POSTOPERATIVE</a:t>
+              <a:t>TWO TEAM CLOCKS. CPE MOA 2026 ANESTHESIA AND SURGERY.</a:t>
             </a:r>
           </a:p>
         </p:txBody>
@@ -32621,8 +32628,8 @@
         </p:nvSpPr>
         <p:spPr>
           <a:xfrm>
-            <a:off x="411480" y="1234440"/>
-            <a:ext cx="2743200" cy="3977639"/>
+            <a:off x="411480" y="1078992"/>
+            <a:ext cx="2743200" cy="3611880"/>
           </a:xfrm>
           <a:prstGeom prst="roundRect">
             <a:avLst>
@@ -32666,8 +32673,8 @@
         </p:nvSpPr>
         <p:spPr>
           <a:xfrm>
-            <a:off x="411480" y="1234440"/>
-            <a:ext cx="2743200" cy="640080"/>
+            <a:off x="411480" y="1078992"/>
+            <a:ext cx="2743200" cy="566928"/>
           </a:xfrm>
           <a:prstGeom prst="rect">
             <a:avLst/>
@@ -32709,8 +32716,8 @@
         </p:nvSpPr>
         <p:spPr>
           <a:xfrm>
-            <a:off x="411480" y="1234440"/>
-            <a:ext cx="2743200" cy="640080"/>
+            <a:off x="411480" y="1078992"/>
+            <a:ext cx="2743200" cy="566928"/>
           </a:xfrm>
           <a:prstGeom prst="rect">
             <a:avLst/>
@@ -32723,7 +32730,7 @@
           <a:p>
             <a:pPr algn="ctr"/>
             <a:r>
-              <a:rPr sz="2000" b="1">
+              <a:rPr sz="1800" b="1">
                 <a:solidFill>
                   <a:srgbClr val="FFFFFF"/>
                 </a:solidFill>
@@ -32742,8 +32749,8 @@
         </p:nvSpPr>
         <p:spPr>
           <a:xfrm>
-            <a:off x="594360" y="2011680"/>
-            <a:ext cx="2377440" cy="2926080"/>
+            <a:off x="557784" y="1755648"/>
+            <a:ext cx="2450592" cy="2788920"/>
           </a:xfrm>
           <a:prstGeom prst="rect">
             <a:avLst/>
@@ -32756,16 +32763,16 @@
           <a:p>
             <a:pPr algn="ctr"/>
             <a:r>
-              <a:rPr sz="1800" b="0">
+              <a:rPr sz="1600" b="0">
                 <a:solidFill>
                   <a:srgbClr val="1C1C1C"/>
                 </a:solidFill>
                 <a:latin typeface="Calibri"/>
               </a:rPr>
-              <a:t>History, PE, ASA
-Labs, stabilize
-Consent, plan
-Analgesia, Abx</a:t>
+              <a:t>PE, then labs, ASA
+Then IM/SQ premed
+ETT, bag, circuit
+Leak-test the machine</a:t>
             </a:r>
           </a:p>
         </p:txBody>
@@ -32778,7 +32785,7 @@
         </p:nvSpPr>
         <p:spPr>
           <a:xfrm>
-            <a:off x="2880360" y="2926080"/>
+            <a:off x="2880360" y="2606040"/>
             <a:ext cx="502920" cy="365760"/>
           </a:xfrm>
           <a:prstGeom prst="rect">
@@ -32811,8 +32818,8 @@
         </p:nvSpPr>
         <p:spPr>
           <a:xfrm>
-            <a:off x="3337560" y="1234440"/>
-            <a:ext cx="2743200" cy="3977639"/>
+            <a:off x="3337560" y="1078992"/>
+            <a:ext cx="2743200" cy="3611880"/>
           </a:xfrm>
           <a:prstGeom prst="roundRect">
             <a:avLst>
@@ -32856,8 +32863,8 @@
         </p:nvSpPr>
         <p:spPr>
           <a:xfrm>
-            <a:off x="3337560" y="1234440"/>
-            <a:ext cx="2743200" cy="640080"/>
+            <a:off x="3337560" y="1078992"/>
+            <a:ext cx="2743200" cy="566928"/>
           </a:xfrm>
           <a:prstGeom prst="rect">
             <a:avLst/>
@@ -32899,8 +32906,8 @@
         </p:nvSpPr>
         <p:spPr>
           <a:xfrm>
-            <a:off x="3337560" y="1234440"/>
-            <a:ext cx="2743200" cy="640080"/>
+            <a:off x="3337560" y="1078992"/>
+            <a:ext cx="2743200" cy="566928"/>
           </a:xfrm>
           <a:prstGeom prst="rect">
             <a:avLst/>
@@ -32913,7 +32920,7 @@
           <a:p>
             <a:pPr algn="ctr"/>
             <a:r>
-              <a:rPr sz="2000" b="1">
+              <a:rPr sz="1800" b="1">
                 <a:solidFill>
                   <a:srgbClr val="FFFFFF"/>
                 </a:solidFill>
@@ -32932,8 +32939,8 @@
         </p:nvSpPr>
         <p:spPr>
           <a:xfrm>
-            <a:off x="3520440" y="2011680"/>
-            <a:ext cx="2377440" cy="2926080"/>
+            <a:off x="3483864" y="1755648"/>
+            <a:ext cx="2450592" cy="2788920"/>
           </a:xfrm>
           <a:prstGeom prst="rect">
             <a:avLst/>
@@ -32946,16 +32953,16 @@
           <a:p>
             <a:pPr algn="ctr"/>
             <a:r>
-              <a:rPr sz="1800" b="0">
+              <a:rPr sz="1600" b="0">
                 <a:solidFill>
                   <a:srgbClr val="1C1C1C"/>
                 </a:solidFill>
                 <a:latin typeface="Calibri"/>
               </a:rPr>
-              <a:t>Clip after induction
-Dirty then sterile prep
-Position, drape
-Gown, closed glove</a:t>
+              <a:t>Ready for clip:
+airway, IV, plane
+Hair, skin, position
+Drape, gown, glove</a:t>
             </a:r>
           </a:p>
         </p:txBody>
@@ -32968,7 +32975,7 @@
         </p:nvSpPr>
         <p:spPr>
           <a:xfrm>
-            <a:off x="5806440" y="2926080"/>
+            <a:off x="5806440" y="2606040"/>
             <a:ext cx="502920" cy="365760"/>
           </a:xfrm>
           <a:prstGeom prst="rect">
@@ -33001,8 +33008,8 @@
         </p:nvSpPr>
         <p:spPr>
           <a:xfrm>
-            <a:off x="6263640" y="1234440"/>
-            <a:ext cx="2743200" cy="3977639"/>
+            <a:off x="6263640" y="1078992"/>
+            <a:ext cx="2743200" cy="3611880"/>
           </a:xfrm>
           <a:prstGeom prst="roundRect">
             <a:avLst>
@@ -33046,8 +33053,8 @@
         </p:nvSpPr>
         <p:spPr>
           <a:xfrm>
-            <a:off x="6263640" y="1234440"/>
-            <a:ext cx="2743200" cy="640080"/>
+            <a:off x="6263640" y="1078992"/>
+            <a:ext cx="2743200" cy="566928"/>
           </a:xfrm>
           <a:prstGeom prst="rect">
             <a:avLst/>
@@ -33089,8 +33096,8 @@
         </p:nvSpPr>
         <p:spPr>
           <a:xfrm>
-            <a:off x="6263640" y="1234440"/>
-            <a:ext cx="2743200" cy="640080"/>
+            <a:off x="6263640" y="1078992"/>
+            <a:ext cx="2743200" cy="566928"/>
           </a:xfrm>
           <a:prstGeom prst="rect">
             <a:avLst/>
@@ -33103,7 +33110,7 @@
           <a:p>
             <a:pPr algn="ctr"/>
             <a:r>
-              <a:rPr sz="2000" b="1">
+              <a:rPr sz="1800" b="1">
                 <a:solidFill>
                   <a:srgbClr val="FFFFFF"/>
                 </a:solidFill>
@@ -33122,8 +33129,8 @@
         </p:nvSpPr>
         <p:spPr>
           <a:xfrm>
-            <a:off x="6446520" y="2011680"/>
-            <a:ext cx="2377440" cy="2926080"/>
+            <a:off x="6409944" y="1755648"/>
+            <a:ext cx="2450592" cy="2788920"/>
           </a:xfrm>
           <a:prstGeom prst="rect">
             <a:avLst/>
@@ -33136,15 +33143,16 @@
           <a:p>
             <a:pPr algn="ctr"/>
             <a:r>
-              <a:rPr sz="1800" b="0">
+              <a:rPr sz="1600" b="0">
                 <a:solidFill>
                   <a:srgbClr val="1C1C1C"/>
                 </a:solidFill>
                 <a:latin typeface="Calibri"/>
               </a:rPr>
-              <a:t>Asepsis held
-Halsted applied
-Time, temp, pain</a:t>
+              <a:t>Announce incision
+Hold asepsis
+Halsted, temp, pain
+Record every 5–10 min</a:t>
             </a:r>
           </a:p>
         </p:txBody>
@@ -33157,7 +33165,7 @@
         </p:nvSpPr>
         <p:spPr>
           <a:xfrm>
-            <a:off x="8732520" y="2926080"/>
+            <a:off x="8732520" y="2606040"/>
             <a:ext cx="502920" cy="365760"/>
           </a:xfrm>
           <a:prstGeom prst="rect">
@@ -33190,8 +33198,8 @@
         </p:nvSpPr>
         <p:spPr>
           <a:xfrm>
-            <a:off x="9189720" y="1234440"/>
-            <a:ext cx="2743200" cy="3977639"/>
+            <a:off x="9189720" y="1078992"/>
+            <a:ext cx="2743200" cy="3611880"/>
           </a:xfrm>
           <a:prstGeom prst="roundRect">
             <a:avLst>
@@ -33235,8 +33243,8 @@
         </p:nvSpPr>
         <p:spPr>
           <a:xfrm>
-            <a:off x="9189720" y="1234440"/>
-            <a:ext cx="2743200" cy="640080"/>
+            <a:off x="9189720" y="1078992"/>
+            <a:ext cx="2743200" cy="566928"/>
           </a:xfrm>
           <a:prstGeom prst="rect">
             <a:avLst/>
@@ -33278,8 +33286,8 @@
         </p:nvSpPr>
         <p:spPr>
           <a:xfrm>
-            <a:off x="9189720" y="1234440"/>
-            <a:ext cx="2743200" cy="640080"/>
+            <a:off x="9189720" y="1078992"/>
+            <a:ext cx="2743200" cy="566928"/>
           </a:xfrm>
           <a:prstGeom prst="rect">
             <a:avLst/>
@@ -33292,7 +33300,7 @@
           <a:p>
             <a:pPr algn="ctr"/>
             <a:r>
-              <a:rPr sz="2000" b="1">
+              <a:rPr sz="1800" b="1">
                 <a:solidFill>
                   <a:srgbClr val="FFFFFF"/>
                 </a:solidFill>
@@ -33311,8 +33319,8 @@
         </p:nvSpPr>
         <p:spPr>
           <a:xfrm>
-            <a:off x="9372600" y="2011680"/>
-            <a:ext cx="2377440" cy="2926080"/>
+            <a:off x="9336024" y="1755648"/>
+            <a:ext cx="2450592" cy="2788920"/>
           </a:xfrm>
           <a:prstGeom prst="rect">
             <a:avLst/>
@@ -33325,7 +33333,7 @@
           <a:p>
             <a:pPr algn="ctr"/>
             <a:r>
-              <a:rPr sz="1800" b="0">
+              <a:rPr sz="1600" b="0">
                 <a:solidFill>
                   <a:srgbClr val="1C1C1C"/>
                 </a:solidFill>
@@ -33341,20 +33349,22 @@
       </p:sp>
       <p:sp>
         <p:nvSpPr>
-          <p:cNvPr id="27" name="Rectangle 26"/>
+          <p:cNvPr id="27" name="Rounded Rectangle 26"/>
           <p:cNvSpPr/>
           <p:nvPr/>
         </p:nvSpPr>
         <p:spPr>
           <a:xfrm>
-            <a:off x="0" y="6565392"/>
-            <a:ext cx="12191695" cy="292608"/>
-          </a:xfrm>
-          <a:prstGeom prst="rect">
-            <a:avLst/>
-          </a:prstGeom>
-          <a:solidFill>
-            <a:srgbClr val="0B2C4A"/>
+            <a:off x="411480" y="4828032"/>
+            <a:ext cx="5623560" cy="1554480"/>
+          </a:xfrm>
+          <a:prstGeom prst="roundRect">
+            <a:avLst>
+              <a:gd name="adj" fmla="val 8000"/>
+            </a:avLst>
+          </a:prstGeom>
+          <a:solidFill>
+            <a:srgbClr val="E4F1F3"/>
           </a:solidFill>
           <a:ln>
             <a:noFill/>
@@ -33390,6 +33400,226 @@
         </p:nvSpPr>
         <p:spPr>
           <a:xfrm>
+            <a:off x="594360" y="4937760"/>
+            <a:ext cx="5303520" cy="365760"/>
+          </a:xfrm>
+          <a:prstGeom prst="rect">
+            <a:avLst/>
+          </a:prstGeom>
+          <a:noFill/>
+        </p:spPr>
+        <p:txBody>
+          <a:bodyPr wrap="square" anchor="t"/>
+          <a:lstStyle/>
+          <a:p>
+            <a:pPr algn="l"/>
+            <a:r>
+              <a:rPr sz="1600" b="1">
+                <a:solidFill>
+                  <a:srgbClr val="1B6B7A"/>
+                </a:solidFill>
+                <a:latin typeface="Calibri"/>
+              </a:rPr>
+              <a:t>Anesthesia clock  ·  ready for surgical prep</a:t>
+            </a:r>
+          </a:p>
+        </p:txBody>
+      </p:sp>
+      <p:sp>
+        <p:nvSpPr>
+          <p:cNvPr id="29" name="TextBox 28"/>
+          <p:cNvSpPr txBox="1"/>
+          <p:nvPr/>
+        </p:nvSpPr>
+        <p:spPr>
+          <a:xfrm>
+            <a:off x="594360" y="5321808"/>
+            <a:ext cx="5303520" cy="914400"/>
+          </a:xfrm>
+          <a:prstGeom prst="rect">
+            <a:avLst/>
+          </a:prstGeom>
+          <a:noFill/>
+        </p:spPr>
+        <p:txBody>
+          <a:bodyPr wrap="square" anchor="t"/>
+          <a:lstStyle/>
+          <a:p>
+            <a:pPr algn="l"/>
+            <a:r>
+              <a:rPr sz="1500" b="0">
+                <a:solidFill>
+                  <a:srgbClr val="1C1C1C"/>
+                </a:solidFill>
+                <a:latin typeface="Calibri"/>
+              </a:rPr>
+              <a:t>From the preoperative exam: airway in and secured, machine on, patent IV running, surgical plane, monitoring started. Then call for prep (CPE MOA 2026 Anesthesia).</a:t>
+            </a:r>
+          </a:p>
+        </p:txBody>
+      </p:sp>
+      <p:sp>
+        <p:nvSpPr>
+          <p:cNvPr id="30" name="Rounded Rectangle 29"/>
+          <p:cNvSpPr/>
+          <p:nvPr/>
+        </p:nvSpPr>
+        <p:spPr>
+          <a:xfrm>
+            <a:off x="6217920" y="4828032"/>
+            <a:ext cx="5532120" cy="1554480"/>
+          </a:xfrm>
+          <a:prstGeom prst="roundRect">
+            <a:avLst>
+              <a:gd name="adj" fmla="val 8000"/>
+            </a:avLst>
+          </a:prstGeom>
+          <a:solidFill>
+            <a:srgbClr val="F4EBD3"/>
+          </a:solidFill>
+          <a:ln>
+            <a:noFill/>
+          </a:ln>
+        </p:spPr>
+        <p:style>
+          <a:lnRef idx="1">
+            <a:schemeClr val="accent1"/>
+          </a:lnRef>
+          <a:fillRef idx="3">
+            <a:schemeClr val="accent1"/>
+          </a:fillRef>
+          <a:effectRef idx="2">
+            <a:schemeClr val="accent1"/>
+          </a:effectRef>
+          <a:fontRef idx="minor">
+            <a:schemeClr val="lt1"/>
+          </a:fontRef>
+        </p:style>
+        <p:txBody>
+          <a:bodyPr rtlCol="0" anchor="ctr"/>
+          <a:lstStyle/>
+          <a:p>
+            <a:pPr algn="ctr"/>
+          </a:p>
+        </p:txBody>
+      </p:sp>
+      <p:sp>
+        <p:nvSpPr>
+          <p:cNvPr id="31" name="TextBox 30"/>
+          <p:cNvSpPr txBox="1"/>
+          <p:nvPr/>
+        </p:nvSpPr>
+        <p:spPr>
+          <a:xfrm>
+            <a:off x="6400800" y="4937760"/>
+            <a:ext cx="5212080" cy="365760"/>
+          </a:xfrm>
+          <a:prstGeom prst="rect">
+            <a:avLst/>
+          </a:prstGeom>
+          <a:noFill/>
+        </p:spPr>
+        <p:txBody>
+          <a:bodyPr wrap="square" anchor="t"/>
+          <a:lstStyle/>
+          <a:p>
+            <a:pPr algn="l"/>
+            <a:r>
+              <a:rPr sz="1600" b="1">
+                <a:solidFill>
+                  <a:srgbClr val="0B2C4A"/>
+                </a:solidFill>
+                <a:latin typeface="Calibri"/>
+              </a:rPr>
+              <a:t>Surgery clock  ·  last skin suture</a:t>
+            </a:r>
+          </a:p>
+        </p:txBody>
+      </p:sp>
+      <p:sp>
+        <p:nvSpPr>
+          <p:cNvPr id="32" name="TextBox 31"/>
+          <p:cNvSpPr txBox="1"/>
+          <p:nvPr/>
+        </p:nvSpPr>
+        <p:spPr>
+          <a:xfrm>
+            <a:off x="6400800" y="5321808"/>
+            <a:ext cx="5212080" cy="914400"/>
+          </a:xfrm>
+          <a:prstGeom prst="rect">
+            <a:avLst/>
+          </a:prstGeom>
+          <a:noFill/>
+        </p:spPr>
+        <p:txBody>
+          <a:bodyPr wrap="square" anchor="t"/>
+          <a:lstStyle/>
+          <a:p>
+            <a:pPr algn="l"/>
+            <a:r>
+              <a:rPr sz="1500" b="0">
+                <a:solidFill>
+                  <a:srgbClr val="1C1C1C"/>
+                </a:solidFill>
+                <a:latin typeface="Calibri"/>
+              </a:rPr>
+              <a:t>From the start of patient preparation to the last skin suture, including re-gowning. Then own the first 24 hours (CPE MOA 2026 Surgery).</a:t>
+            </a:r>
+          </a:p>
+        </p:txBody>
+      </p:sp>
+      <p:sp>
+        <p:nvSpPr>
+          <p:cNvPr id="33" name="Rectangle 32"/>
+          <p:cNvSpPr/>
+          <p:nvPr/>
+        </p:nvSpPr>
+        <p:spPr>
+          <a:xfrm>
+            <a:off x="0" y="6565392"/>
+            <a:ext cx="12191695" cy="292608"/>
+          </a:xfrm>
+          <a:prstGeom prst="rect">
+            <a:avLst/>
+          </a:prstGeom>
+          <a:solidFill>
+            <a:srgbClr val="0B2C4A"/>
+          </a:solidFill>
+          <a:ln>
+            <a:noFill/>
+          </a:ln>
+        </p:spPr>
+        <p:style>
+          <a:lnRef idx="1">
+            <a:schemeClr val="accent1"/>
+          </a:lnRef>
+          <a:fillRef idx="3">
+            <a:schemeClr val="accent1"/>
+          </a:fillRef>
+          <a:effectRef idx="2">
+            <a:schemeClr val="accent1"/>
+          </a:effectRef>
+          <a:fontRef idx="minor">
+            <a:schemeClr val="lt1"/>
+          </a:fontRef>
+        </p:style>
+        <p:txBody>
+          <a:bodyPr rtlCol="0" anchor="ctr"/>
+          <a:lstStyle/>
+          <a:p>
+            <a:pPr algn="ctr"/>
+          </a:p>
+        </p:txBody>
+      </p:sp>
+      <p:sp>
+        <p:nvSpPr>
+          <p:cNvPr id="34" name="TextBox 33"/>
+          <p:cNvSpPr txBox="1"/>
+          <p:nvPr/>
+        </p:nvSpPr>
+        <p:spPr>
+          <a:xfrm>
             <a:off x="320040" y="6565392"/>
             <a:ext cx="9875520" cy="292608"/>
           </a:xfrm>
@@ -33417,7 +33647,7 @@
       </p:sp>
       <p:sp>
         <p:nvSpPr>
-          <p:cNvPr id="29" name="TextBox 28"/>
+          <p:cNvPr id="35" name="TextBox 34"/>
           <p:cNvSpPr txBox="1"/>
           <p:nvPr/>
         </p:nvSpPr>
@@ -33623,7 +33853,7 @@
                 </a:solidFill>
                 <a:latin typeface="Calibri"/>
               </a:rPr>
-              <a:t>EXAMINE, REQUEST INDICATED LABS, INTERPRET, THEN ASSIGN ASA</a:t>
+              <a:t>CPE MOA 2026 ANESTHESIA: EXAMINE, REQUEST LABS, ASSIGN ASA, THEN PREMEDICATE.</a:t>
             </a:r>
           </a:p>
         </p:txBody>
@@ -34712,7 +34942,7 @@
 3. Interpret the results
 4. Assign ASA status
 5. Adjust the drug plan
-6. Premedicate</a:t>
+6. Premedicate IM or SQ</a:t>
             </a:r>
           </a:p>
         </p:txBody>
@@ -35001,7 +35231,7 @@
                 </a:solidFill>
                 <a:latin typeface="Calibri"/>
               </a:rPr>
-              <a:t>GRUBB ET AL. 2020 AAHA COMPANION TABLE</a:t>
+              <a:t>GRUBB ET AL. 2020 AAHA TABLE. CPE MOA 2026 ANESTHESIA APPENDIX 2 USES THE SAME 1–5 SCALE.</a:t>
             </a:r>
           </a:p>
         </p:txBody>

</xml_diff>

<commit_message>
Make endotracheal tube and reservoir-bag math a board calculation.
Slide 16 now shows ID mm = (kg / 4) + 3.5 and bag mL = kg × 60, round up, with Willie, a 25 kg Lab, and MoMo as worked rows. Premed stays as the footer on that slide.

Co-authored-by: drkimvet <drkimvet@users.noreply.github.com>
</commit_message>
<xml_diff>
--- a/lectures/DVM-612_Week4_Preop_PatientPrep_Postop.pptx
+++ b/lectures/DVM-612_Week4_Preop_PatientPrep_Postop.pptx
@@ -1029,7 +1029,7 @@
           <a:lstStyle/>
           <a:p>
             <a:r>
-              <a:t>Board the two formulas. Dog ETT starting estimate: kilograms divided by 4, plus 3.5. Confirm with Grubb 2020: largest tube that passes the arytenoids without trauma; tip midway from larynx to thoracic inlet. Cuff holds a leak to 20 centimeters of water; that number is in the CPE MOA. Bag: kilograms times 60 milliliters, round up. Willie: 7.0 millimeter tube, 1 liter bag, circle. A 4 kilogram cat: 0.5 liter bag, non-rebreathing, 200 to 400 milliliters per kilogram per minute of oxygen per Grubb 2020. Leak-test, then open the pop-off. Premed still belongs here: exam first, IM or SQ, DKT and BAA for healthy patients, alfaxalone for Willie.</a:t>
+              <a:t>Board both formulas. Dog tube: kilograms divided by 4, plus 3.5. Willie 13.7: 3.425 plus 3.5 is 6.9, so start 7.0 millimeter, with 6.5 and 7.5 in the hand. Confirm on the larynx: largest that passes without trauma. Bag: kilograms times 60 milliliters, round up. Willie 822 milliliters is a 1 liter bag, circle. Healthy 25 kilogram Lab: 9.75 goes to 10 millimeter, 1500 milliliters rounds up to 2 liters. MoMo is cancelled, but if a 4.25 kilogram cat were anesthetized: cat tube 3.5 to 4.0, not the dog formula, 0.5 liter bag, non-rebreathing, oxygen 200 to 400 milliliters per kilogram per minute. Leak-test, then open the pop-off. Premed is the gold bar: DKT or BAA if healthy, alfaxalone for Willie.</a:t>
             </a:r>
           </a:p>
         </p:txBody>
@@ -12060,7 +12060,7 @@
                 </a:solidFill>
                 <a:latin typeface="Calibri"/>
               </a:rPr>
-              <a:t>CPE MOA 2026: SELECT ETT, BREATHING SYSTEM, AND RESERVOIR BAG. THEN LEAK-TEST.</a:t>
+              <a:t>WRITE BOTH NUMBERS BEFORE INDUCTION. CPE MOA 2026: SELECT THE TUBE, THE CIRCUIT, AND THE BAG.</a:t>
             </a:r>
           </a:p>
         </p:txBody>
@@ -12136,7 +12136,7 @@
                 </a:solidFill>
                 <a:latin typeface="Calibri"/>
               </a:rPr>
-              <a:t>Premedication, tube, and bag</a:t>
+              <a:t>Endotracheal tube and reservoir bag</a:t>
             </a:r>
           </a:p>
         </p:txBody>
@@ -12149,8 +12149,8 @@
         </p:nvSpPr>
         <p:spPr>
           <a:xfrm>
-            <a:off x="365760" y="1051560"/>
-            <a:ext cx="3767328" cy="5074920"/>
+            <a:off x="411480" y="1024128"/>
+            <a:ext cx="5623560" cy="2788920"/>
           </a:xfrm>
           <a:prstGeom prst="roundRect">
             <a:avLst>
@@ -12194,14 +12194,14 @@
         </p:nvSpPr>
         <p:spPr>
           <a:xfrm>
-            <a:off x="365760" y="1051560"/>
-            <a:ext cx="3767328" cy="502920"/>
-          </a:xfrm>
-          <a:prstGeom prst="rect">
-            <a:avLst/>
-          </a:prstGeom>
-          <a:solidFill>
-            <a:srgbClr val="1B6B7A"/>
+            <a:off x="411480" y="1024128"/>
+            <a:ext cx="5623560" cy="438912"/>
+          </a:xfrm>
+          <a:prstGeom prst="rect">
+            <a:avLst/>
+          </a:prstGeom>
+          <a:solidFill>
+            <a:srgbClr val="C5A35A"/>
           </a:solidFill>
           <a:ln>
             <a:noFill/>
@@ -12237,8 +12237,8 @@
         </p:nvSpPr>
         <p:spPr>
           <a:xfrm>
-            <a:off x="365760" y="1051560"/>
-            <a:ext cx="3767328" cy="502920"/>
+            <a:off x="411480" y="1024128"/>
+            <a:ext cx="5623560" cy="438912"/>
           </a:xfrm>
           <a:prstGeom prst="rect">
             <a:avLst/>
@@ -12253,11 +12253,11 @@
             <a:r>
               <a:rPr sz="1600" b="1">
                 <a:solidFill>
-                  <a:srgbClr val="FFFFFF"/>
-                </a:solidFill>
-                <a:latin typeface="Calibri"/>
-              </a:rPr>
-              <a:t>Premed, then MAC</a:t>
+                  <a:srgbClr val="0B2C4A"/>
+                </a:solidFill>
+                <a:latin typeface="Calibri"/>
+              </a:rPr>
+              <a:t>Endotracheal tube  ·  dog starting estimate</a:t>
             </a:r>
           </a:p>
         </p:txBody>
@@ -12270,8 +12270,8 @@
         </p:nvSpPr>
         <p:spPr>
           <a:xfrm>
-            <a:off x="512064" y="1627632"/>
-            <a:ext cx="3474720" cy="4370832"/>
+            <a:off x="594360" y="1536192"/>
+            <a:ext cx="5257800" cy="502920"/>
           </a:xfrm>
           <a:prstGeom prst="rect">
             <a:avLst/>
@@ -12282,34 +12282,64 @@
           <a:bodyPr wrap="square" anchor="t"/>
           <a:lstStyle/>
           <a:p>
+            <a:pPr algn="ctr"/>
+            <a:r>
+              <a:rPr sz="2400" b="1">
+                <a:solidFill>
+                  <a:srgbClr val="0B2C4A"/>
+                </a:solidFill>
+                <a:latin typeface="Calibri"/>
+              </a:rPr>
+              <a:t>ID mm  =  (kg / 4)  +  3.5</a:t>
+            </a:r>
+          </a:p>
+        </p:txBody>
+      </p:sp>
+      <p:sp>
+        <p:nvSpPr>
+          <p:cNvPr id="12" name="TextBox 11"/>
+          <p:cNvSpPr txBox="1"/>
+          <p:nvPr/>
+        </p:nvSpPr>
+        <p:spPr>
+          <a:xfrm>
+            <a:off x="594360" y="2084831"/>
+            <a:ext cx="5257800" cy="1572768"/>
+          </a:xfrm>
+          <a:prstGeom prst="rect">
+            <a:avLst/>
+          </a:prstGeom>
+          <a:noFill/>
+        </p:spPr>
+        <p:txBody>
+          <a:bodyPr wrap="square" anchor="t"/>
+          <a:lstStyle/>
+          <a:p>
             <a:pPr algn="l"/>
             <a:r>
-              <a:rPr sz="1400" b="0">
+              <a:rPr sz="1500" b="0">
                 <a:solidFill>
                   <a:srgbClr val="1C1C1C"/>
                 </a:solidFill>
                 <a:latin typeface="Calibri"/>
               </a:rPr>
-              <a:t>Exam first. Then IM or SQ premed.
-Calm, analgesia, lower induction dose, lower MAC, safer clip.
-DKT: dexmedetomidine + ketamine + butorphanol. One IM syringe. Healthy ASA 1–2.
-BAA: butorphanol + acepromazine + atropine. Healthy patients.
-Heart / murmur: skip ace and dexmed as the default. Opioid + alfaxalone. That is Willie.
-MAC = alveolar % that stops movement in 50% of patients. Premed lowers it. Turn the dial down.</a:t>
-            </a:r>
-          </a:p>
-        </p:txBody>
-      </p:sp>
-      <p:sp>
-        <p:nvSpPr>
-          <p:cNvPr id="12" name="Rounded Rectangle 11"/>
+              <a:t>Have 0.5 mm larger and 0.5 mm smaller ready.
+Confirm: largest ID that passes the arytenoids without trauma (Grubb 2020). Tip midway from larynx to thoracic inlet. Cuff holds to 20 cm H2O (CPE MOA).
+Cat: typically 3.0–4.5 mm. Do not use the dog formula.</a:t>
+            </a:r>
+          </a:p>
+        </p:txBody>
+      </p:sp>
+      <p:sp>
+        <p:nvSpPr>
+          <p:cNvPr id="13" name="Rounded Rectangle 12"/>
           <p:cNvSpPr/>
           <p:nvPr/>
         </p:nvSpPr>
         <p:spPr>
           <a:xfrm>
-            <a:off x="4279392" y="1051560"/>
-            <a:ext cx="3767328" cy="5074920"/>
+            <a:off x="6172200" y="1024128"/>
+            <a:ext cx="5577840" cy="2788920"/>
           </a:xfrm>
           <a:prstGeom prst="roundRect">
             <a:avLst>
@@ -12347,20 +12377,20 @@
       </p:sp>
       <p:sp>
         <p:nvSpPr>
-          <p:cNvPr id="13" name="Rectangle 12"/>
+          <p:cNvPr id="14" name="Rectangle 13"/>
           <p:cNvSpPr/>
           <p:nvPr/>
         </p:nvSpPr>
         <p:spPr>
           <a:xfrm>
-            <a:off x="4279392" y="1051560"/>
-            <a:ext cx="3767328" cy="502920"/>
-          </a:xfrm>
-          <a:prstGeom prst="rect">
-            <a:avLst/>
-          </a:prstGeom>
-          <a:solidFill>
-            <a:srgbClr val="C5A35A"/>
+            <a:off x="6172200" y="1024128"/>
+            <a:ext cx="5577840" cy="438912"/>
+          </a:xfrm>
+          <a:prstGeom prst="rect">
+            <a:avLst/>
+          </a:prstGeom>
+          <a:solidFill>
+            <a:srgbClr val="0B2C4A"/>
           </a:solidFill>
           <a:ln>
             <a:noFill/>
@@ -12390,14 +12420,14 @@
       </p:sp>
       <p:sp>
         <p:nvSpPr>
-          <p:cNvPr id="14" name="TextBox 13"/>
-          <p:cNvSpPr txBox="1"/>
-          <p:nvPr/>
-        </p:nvSpPr>
-        <p:spPr>
-          <a:xfrm>
-            <a:off x="4279392" y="1051560"/>
-            <a:ext cx="3767328" cy="502920"/>
+          <p:cNvPr id="15" name="TextBox 14"/>
+          <p:cNvSpPr txBox="1"/>
+          <p:nvPr/>
+        </p:nvSpPr>
+        <p:spPr>
+          <a:xfrm>
+            <a:off x="6172200" y="1024128"/>
+            <a:ext cx="5577840" cy="438912"/>
           </a:xfrm>
           <a:prstGeom prst="rect">
             <a:avLst/>
@@ -12412,25 +12442,25 @@
             <a:r>
               <a:rPr sz="1600" b="1">
                 <a:solidFill>
-                  <a:srgbClr val="FFFFFF"/>
-                </a:solidFill>
-                <a:latin typeface="Calibri"/>
-              </a:rPr>
-              <a:t>Endotracheal tube</a:t>
-            </a:r>
-          </a:p>
-        </p:txBody>
-      </p:sp>
-      <p:sp>
-        <p:nvSpPr>
-          <p:cNvPr id="15" name="TextBox 14"/>
-          <p:cNvSpPr txBox="1"/>
-          <p:nvPr/>
-        </p:nvSpPr>
-        <p:spPr>
-          <a:xfrm>
-            <a:off x="4425696" y="1627632"/>
-            <a:ext cx="3474720" cy="4370832"/>
+                  <a:srgbClr val="C5A35A"/>
+                </a:solidFill>
+                <a:latin typeface="Calibri"/>
+              </a:rPr>
+              <a:t>Reservoir bag  ·  shortcut</a:t>
+            </a:r>
+          </a:p>
+        </p:txBody>
+      </p:sp>
+      <p:sp>
+        <p:nvSpPr>
+          <p:cNvPr id="16" name="TextBox 15"/>
+          <p:cNvSpPr txBox="1"/>
+          <p:nvPr/>
+        </p:nvSpPr>
+        <p:spPr>
+          <a:xfrm>
+            <a:off x="6355080" y="1536192"/>
+            <a:ext cx="5212080" cy="502920"/>
           </a:xfrm>
           <a:prstGeom prst="rect">
             <a:avLst/>
@@ -12441,41 +12471,69 @@
           <a:bodyPr wrap="square" anchor="t"/>
           <a:lstStyle/>
           <a:p>
+            <a:pPr algn="ctr"/>
+            <a:r>
+              <a:rPr sz="2200" b="1">
+                <a:solidFill>
+                  <a:srgbClr val="0B2C4A"/>
+                </a:solidFill>
+                <a:latin typeface="Calibri"/>
+              </a:rPr>
+              <a:t>mL  =  kg  ×  60     then round UP</a:t>
+            </a:r>
+          </a:p>
+        </p:txBody>
+      </p:sp>
+      <p:sp>
+        <p:nvSpPr>
+          <p:cNvPr id="17" name="TextBox 16"/>
+          <p:cNvSpPr txBox="1"/>
+          <p:nvPr/>
+        </p:nvSpPr>
+        <p:spPr>
+          <a:xfrm>
+            <a:off x="6355080" y="2084831"/>
+            <a:ext cx="5212080" cy="1572768"/>
+          </a:xfrm>
+          <a:prstGeom prst="rect">
+            <a:avLst/>
+          </a:prstGeom>
+          <a:noFill/>
+        </p:spPr>
+        <p:txBody>
+          <a:bodyPr wrap="square" anchor="t"/>
+          <a:lstStyle/>
+          <a:p>
             <a:pPr algn="l"/>
             <a:r>
-              <a:rPr sz="1400" b="0">
+              <a:rPr sz="1500" b="0">
                 <a:solidFill>
                   <a:srgbClr val="1C1C1C"/>
                 </a:solidFill>
                 <a:latin typeface="Calibri"/>
               </a:rPr>
-              <a:t>CPE MOA: choose a tube that fits. Cuff holds to 20 cm H2O. Grossly too large or too small is unsafe.
-Grubb 2020: largest ID that passes the arytenoids without trauma. Tip midway from larynx to thoracic inlet. Proximal end at or just past the incisors.
-Dog starting estimate: ID mm = (kg / 4) + 3.5. Have 0.5 mm larger and smaller.
-Willie 13.7 kg: (13.7 / 4) + 3.5 = 6.9. Start 7.0 mm. Have 6.5 and 7.5.
-Cat: typically 3.0–4.5 mm. Confirm on the larynx.</a:t>
-            </a:r>
-          </a:p>
-        </p:txBody>
-      </p:sp>
-      <p:sp>
-        <p:nvSpPr>
-          <p:cNvPr id="16" name="Rounded Rectangle 15"/>
+              <a:t>Tidal volume about 10–15 mL/kg. Bag = 5–6 × TV, so 60 mL/kg is the low end. Round up to 0.5, 1, 2, or 3 L.
+NRC: cats and dogs &lt;3–5 kg. O2 200–400 mL/kg/min (Grubb 2020). Circle for larger patients. Leak-test, then OPEN the pop-off.</a:t>
+            </a:r>
+          </a:p>
+        </p:txBody>
+      </p:sp>
+      <p:sp>
+        <p:nvSpPr>
+          <p:cNvPr id="18" name="Rectangle 17"/>
           <p:cNvSpPr/>
           <p:nvPr/>
         </p:nvSpPr>
         <p:spPr>
           <a:xfrm>
-            <a:off x="8193024" y="1051560"/>
-            <a:ext cx="3767328" cy="5074920"/>
-          </a:xfrm>
-          <a:prstGeom prst="roundRect">
-            <a:avLst>
-              <a:gd name="adj" fmla="val 8000"/>
-            </a:avLst>
-          </a:prstGeom>
-          <a:solidFill>
-            <a:srgbClr val="FFFFFF"/>
+            <a:off x="411480" y="3931920"/>
+            <a:ext cx="11338560" cy="384048"/>
+          </a:xfrm>
+          <a:prstGeom prst="rect">
+            <a:avLst/>
+          </a:prstGeom>
+          <a:solidFill>
+            <a:srgbClr val="0B2C4A"/>
           </a:solidFill>
           <a:ln>
             <a:noFill/>
@@ -12505,20 +12563,187 @@
       </p:sp>
       <p:sp>
         <p:nvSpPr>
-          <p:cNvPr id="17" name="Rectangle 16"/>
+          <p:cNvPr id="19" name="TextBox 18"/>
+          <p:cNvSpPr txBox="1"/>
+          <p:nvPr/>
+        </p:nvSpPr>
+        <p:spPr>
+          <a:xfrm>
+            <a:off x="457200" y="3931920"/>
+            <a:ext cx="2743200" cy="384048"/>
+          </a:xfrm>
+          <a:prstGeom prst="rect">
+            <a:avLst/>
+          </a:prstGeom>
+          <a:noFill/>
+        </p:spPr>
+        <p:txBody>
+          <a:bodyPr wrap="square" anchor="ctr"/>
+          <a:lstStyle/>
+          <a:p>
+            <a:pPr algn="l"/>
+            <a:r>
+              <a:rPr sz="1500" b="1">
+                <a:solidFill>
+                  <a:srgbClr val="C5A35A"/>
+                </a:solidFill>
+                <a:latin typeface="Calibri"/>
+              </a:rPr>
+              <a:t>Patient</a:t>
+            </a:r>
+          </a:p>
+        </p:txBody>
+      </p:sp>
+      <p:sp>
+        <p:nvSpPr>
+          <p:cNvPr id="20" name="TextBox 19"/>
+          <p:cNvSpPr txBox="1"/>
+          <p:nvPr/>
+        </p:nvSpPr>
+        <p:spPr>
+          <a:xfrm>
+            <a:off x="3246120" y="3931920"/>
+            <a:ext cx="1097280" cy="384048"/>
+          </a:xfrm>
+          <a:prstGeom prst="rect">
+            <a:avLst/>
+          </a:prstGeom>
+          <a:noFill/>
+        </p:spPr>
+        <p:txBody>
+          <a:bodyPr wrap="square" anchor="ctr"/>
+          <a:lstStyle/>
+          <a:p>
+            <a:pPr algn="l"/>
+            <a:r>
+              <a:rPr sz="1500" b="1">
+                <a:solidFill>
+                  <a:srgbClr val="C5A35A"/>
+                </a:solidFill>
+                <a:latin typeface="Calibri"/>
+              </a:rPr>
+              <a:t>kg</a:t>
+            </a:r>
+          </a:p>
+        </p:txBody>
+      </p:sp>
+      <p:sp>
+        <p:nvSpPr>
+          <p:cNvPr id="21" name="TextBox 20"/>
+          <p:cNvSpPr txBox="1"/>
+          <p:nvPr/>
+        </p:nvSpPr>
+        <p:spPr>
+          <a:xfrm>
+            <a:off x="4434840" y="3931920"/>
+            <a:ext cx="2926080" cy="384048"/>
+          </a:xfrm>
+          <a:prstGeom prst="rect">
+            <a:avLst/>
+          </a:prstGeom>
+          <a:noFill/>
+        </p:spPr>
+        <p:txBody>
+          <a:bodyPr wrap="square" anchor="ctr"/>
+          <a:lstStyle/>
+          <a:p>
+            <a:pPr algn="l"/>
+            <a:r>
+              <a:rPr sz="1500" b="1">
+                <a:solidFill>
+                  <a:srgbClr val="C5A35A"/>
+                </a:solidFill>
+                <a:latin typeface="Calibri"/>
+              </a:rPr>
+              <a:t>ETT start</a:t>
+            </a:r>
+          </a:p>
+        </p:txBody>
+      </p:sp>
+      <p:sp>
+        <p:nvSpPr>
+          <p:cNvPr id="22" name="TextBox 21"/>
+          <p:cNvSpPr txBox="1"/>
+          <p:nvPr/>
+        </p:nvSpPr>
+        <p:spPr>
+          <a:xfrm>
+            <a:off x="7452360" y="3931920"/>
+            <a:ext cx="2560320" cy="384048"/>
+          </a:xfrm>
+          <a:prstGeom prst="rect">
+            <a:avLst/>
+          </a:prstGeom>
+          <a:noFill/>
+        </p:spPr>
+        <p:txBody>
+          <a:bodyPr wrap="square" anchor="ctr"/>
+          <a:lstStyle/>
+          <a:p>
+            <a:pPr algn="l"/>
+            <a:r>
+              <a:rPr sz="1500" b="1">
+                <a:solidFill>
+                  <a:srgbClr val="C5A35A"/>
+                </a:solidFill>
+                <a:latin typeface="Calibri"/>
+              </a:rPr>
+              <a:t>Bag</a:t>
+            </a:r>
+          </a:p>
+        </p:txBody>
+      </p:sp>
+      <p:sp>
+        <p:nvSpPr>
+          <p:cNvPr id="23" name="TextBox 22"/>
+          <p:cNvSpPr txBox="1"/>
+          <p:nvPr/>
+        </p:nvSpPr>
+        <p:spPr>
+          <a:xfrm>
+            <a:off x="10104120" y="3931920"/>
+            <a:ext cx="1554480" cy="384048"/>
+          </a:xfrm>
+          <a:prstGeom prst="rect">
+            <a:avLst/>
+          </a:prstGeom>
+          <a:noFill/>
+        </p:spPr>
+        <p:txBody>
+          <a:bodyPr wrap="square" anchor="ctr"/>
+          <a:lstStyle/>
+          <a:p>
+            <a:pPr algn="l"/>
+            <a:r>
+              <a:rPr sz="1500" b="1">
+                <a:solidFill>
+                  <a:srgbClr val="C5A35A"/>
+                </a:solidFill>
+                <a:latin typeface="Calibri"/>
+              </a:rPr>
+              <a:t>Circuit</a:t>
+            </a:r>
+          </a:p>
+        </p:txBody>
+      </p:sp>
+      <p:sp>
+        <p:nvSpPr>
+          <p:cNvPr id="24" name="Rounded Rectangle 23"/>
           <p:cNvSpPr/>
           <p:nvPr/>
         </p:nvSpPr>
         <p:spPr>
           <a:xfrm>
-            <a:off x="8193024" y="1051560"/>
-            <a:ext cx="3767328" cy="502920"/>
-          </a:xfrm>
-          <a:prstGeom prst="rect">
-            <a:avLst/>
-          </a:prstGeom>
-          <a:solidFill>
-            <a:srgbClr val="0B2C4A"/>
+            <a:off x="411480" y="4352544"/>
+            <a:ext cx="11338560" cy="438912"/>
+          </a:xfrm>
+          <a:prstGeom prst="roundRect">
+            <a:avLst>
+              <a:gd name="adj" fmla="val 8000"/>
+            </a:avLst>
+          </a:prstGeom>
+          <a:solidFill>
+            <a:srgbClr val="FFFFFF"/>
           </a:solidFill>
           <a:ln>
             <a:noFill/>
@@ -12548,14 +12773,14 @@
       </p:sp>
       <p:sp>
         <p:nvSpPr>
-          <p:cNvPr id="18" name="TextBox 17"/>
-          <p:cNvSpPr txBox="1"/>
-          <p:nvPr/>
-        </p:nvSpPr>
-        <p:spPr>
-          <a:xfrm>
-            <a:off x="8193024" y="1051560"/>
-            <a:ext cx="3767328" cy="502920"/>
+          <p:cNvPr id="25" name="TextBox 24"/>
+          <p:cNvSpPr txBox="1"/>
+          <p:nvPr/>
+        </p:nvSpPr>
+        <p:spPr>
+          <a:xfrm>
+            <a:off x="457200" y="4352544"/>
+            <a:ext cx="2743200" cy="438912"/>
           </a:xfrm>
           <a:prstGeom prst="rect">
             <a:avLst/>
@@ -12566,74 +12791,169 @@
           <a:bodyPr wrap="square" anchor="ctr"/>
           <a:lstStyle/>
           <a:p>
-            <a:pPr algn="ctr"/>
-            <a:r>
-              <a:rPr sz="1600" b="1">
-                <a:solidFill>
-                  <a:srgbClr val="FFFFFF"/>
-                </a:solidFill>
-                <a:latin typeface="Calibri"/>
-              </a:rPr>
-              <a:t>Reservoir bag and circuit</a:t>
-            </a:r>
-          </a:p>
-        </p:txBody>
-      </p:sp>
-      <p:sp>
-        <p:nvSpPr>
-          <p:cNvPr id="19" name="TextBox 18"/>
-          <p:cNvSpPr txBox="1"/>
-          <p:nvPr/>
-        </p:nvSpPr>
-        <p:spPr>
-          <a:xfrm>
-            <a:off x="8339328" y="1627632"/>
-            <a:ext cx="3474720" cy="4370832"/>
-          </a:xfrm>
-          <a:prstGeom prst="rect">
-            <a:avLst/>
-          </a:prstGeom>
-          <a:noFill/>
-        </p:spPr>
-        <p:txBody>
-          <a:bodyPr wrap="square" anchor="t"/>
-          <a:lstStyle/>
-          <a:p>
             <a:pPr algn="l"/>
             <a:r>
-              <a:rPr sz="1400" b="0">
+              <a:rPr sz="1500" b="1">
+                <a:solidFill>
+                  <a:srgbClr val="0B2C4A"/>
+                </a:solidFill>
+                <a:latin typeface="Calibri"/>
+              </a:rPr>
+              <a:t>Willie (if intubated)</a:t>
+            </a:r>
+          </a:p>
+        </p:txBody>
+      </p:sp>
+      <p:sp>
+        <p:nvSpPr>
+          <p:cNvPr id="26" name="TextBox 25"/>
+          <p:cNvSpPr txBox="1"/>
+          <p:nvPr/>
+        </p:nvSpPr>
+        <p:spPr>
+          <a:xfrm>
+            <a:off x="3246120" y="4352544"/>
+            <a:ext cx="1097280" cy="438912"/>
+          </a:xfrm>
+          <a:prstGeom prst="rect">
+            <a:avLst/>
+          </a:prstGeom>
+          <a:noFill/>
+        </p:spPr>
+        <p:txBody>
+          <a:bodyPr wrap="square" anchor="ctr"/>
+          <a:lstStyle/>
+          <a:p>
+            <a:pPr algn="l"/>
+            <a:r>
+              <a:rPr sz="1500" b="0">
                 <a:solidFill>
                   <a:srgbClr val="1C1C1C"/>
                 </a:solidFill>
                 <a:latin typeface="Calibri"/>
               </a:rPr>
-              <a:t>CPE MOA: select the circuit and the bag. Calculate fresh-gas flow.
-Tidal volume about 10–15 mL/kg (Grubb 2020: dead space ≤2–3 mL/kg is ≤20% of TV).
-Bag = 5–6 × TV. Shortcut: kg × 60 mL. Round UP to 0.5, 1, 2, or 3 L.
-Willie 13.7 kg: 822 mL → 1 L bag. Circle.
-MoMo 4.25 kg, if ever anesthetized: 255 mL → 0.5 L. NRC (Grubb: cats and dogs &lt;3–5 kg).
-NRC O2: 200–400 mL/kg/min.
-Leak-test to 20–30 cm H2O. Then OPEN the pop-off.</a:t>
-            </a:r>
-          </a:p>
-        </p:txBody>
-      </p:sp>
-      <p:sp>
-        <p:nvSpPr>
-          <p:cNvPr id="20" name="Rectangle 19"/>
+              <a:t>13.7</a:t>
+            </a:r>
+          </a:p>
+        </p:txBody>
+      </p:sp>
+      <p:sp>
+        <p:nvSpPr>
+          <p:cNvPr id="27" name="TextBox 26"/>
+          <p:cNvSpPr txBox="1"/>
+          <p:nvPr/>
+        </p:nvSpPr>
+        <p:spPr>
+          <a:xfrm>
+            <a:off x="4434840" y="4352544"/>
+            <a:ext cx="2926080" cy="438912"/>
+          </a:xfrm>
+          <a:prstGeom prst="rect">
+            <a:avLst/>
+          </a:prstGeom>
+          <a:noFill/>
+        </p:spPr>
+        <p:txBody>
+          <a:bodyPr wrap="square" anchor="ctr"/>
+          <a:lstStyle/>
+          <a:p>
+            <a:pPr algn="l"/>
+            <a:r>
+              <a:rPr sz="1500" b="1">
+                <a:solidFill>
+                  <a:srgbClr val="1B6B7A"/>
+                </a:solidFill>
+                <a:latin typeface="Calibri"/>
+              </a:rPr>
+              <a:t>7.0 mm  (6.5 / 7.5)</a:t>
+            </a:r>
+          </a:p>
+        </p:txBody>
+      </p:sp>
+      <p:sp>
+        <p:nvSpPr>
+          <p:cNvPr id="28" name="TextBox 27"/>
+          <p:cNvSpPr txBox="1"/>
+          <p:nvPr/>
+        </p:nvSpPr>
+        <p:spPr>
+          <a:xfrm>
+            <a:off x="7452360" y="4352544"/>
+            <a:ext cx="2560320" cy="438912"/>
+          </a:xfrm>
+          <a:prstGeom prst="rect">
+            <a:avLst/>
+          </a:prstGeom>
+          <a:noFill/>
+        </p:spPr>
+        <p:txBody>
+          <a:bodyPr wrap="square" anchor="ctr"/>
+          <a:lstStyle/>
+          <a:p>
+            <a:pPr algn="l"/>
+            <a:r>
+              <a:rPr sz="1500" b="1">
+                <a:solidFill>
+                  <a:srgbClr val="1B6B7A"/>
+                </a:solidFill>
+                <a:latin typeface="Calibri"/>
+              </a:rPr>
+              <a:t>822 mL → 1 L</a:t>
+            </a:r>
+          </a:p>
+        </p:txBody>
+      </p:sp>
+      <p:sp>
+        <p:nvSpPr>
+          <p:cNvPr id="29" name="TextBox 28"/>
+          <p:cNvSpPr txBox="1"/>
+          <p:nvPr/>
+        </p:nvSpPr>
+        <p:spPr>
+          <a:xfrm>
+            <a:off x="10104120" y="4352544"/>
+            <a:ext cx="1554480" cy="438912"/>
+          </a:xfrm>
+          <a:prstGeom prst="rect">
+            <a:avLst/>
+          </a:prstGeom>
+          <a:noFill/>
+        </p:spPr>
+        <p:txBody>
+          <a:bodyPr wrap="square" anchor="ctr"/>
+          <a:lstStyle/>
+          <a:p>
+            <a:pPr algn="l"/>
+            <a:r>
+              <a:rPr sz="1500" b="0">
+                <a:solidFill>
+                  <a:srgbClr val="1C1C1C"/>
+                </a:solidFill>
+                <a:latin typeface="Calibri"/>
+              </a:rPr>
+              <a:t>Circle</a:t>
+            </a:r>
+          </a:p>
+        </p:txBody>
+      </p:sp>
+      <p:sp>
+        <p:nvSpPr>
+          <p:cNvPr id="30" name="Rounded Rectangle 29"/>
           <p:cNvSpPr/>
           <p:nvPr/>
         </p:nvSpPr>
         <p:spPr>
           <a:xfrm>
-            <a:off x="0" y="6565392"/>
-            <a:ext cx="12191695" cy="292608"/>
-          </a:xfrm>
-          <a:prstGeom prst="rect">
-            <a:avLst/>
-          </a:prstGeom>
-          <a:solidFill>
-            <a:srgbClr val="0B2C4A"/>
+            <a:off x="411480" y="4828032"/>
+            <a:ext cx="11338560" cy="438912"/>
+          </a:xfrm>
+          <a:prstGeom prst="roundRect">
+            <a:avLst>
+              <a:gd name="adj" fmla="val 8000"/>
+            </a:avLst>
+          </a:prstGeom>
+          <a:solidFill>
+            <a:srgbClr val="FFFFFF"/>
           </a:solidFill>
           <a:ln>
             <a:noFill/>
@@ -12663,7 +12983,503 @@
       </p:sp>
       <p:sp>
         <p:nvSpPr>
-          <p:cNvPr id="21" name="TextBox 20"/>
+          <p:cNvPr id="31" name="TextBox 30"/>
+          <p:cNvSpPr txBox="1"/>
+          <p:nvPr/>
+        </p:nvSpPr>
+        <p:spPr>
+          <a:xfrm>
+            <a:off x="457200" y="4828032"/>
+            <a:ext cx="2743200" cy="438912"/>
+          </a:xfrm>
+          <a:prstGeom prst="rect">
+            <a:avLst/>
+          </a:prstGeom>
+          <a:noFill/>
+        </p:spPr>
+        <p:txBody>
+          <a:bodyPr wrap="square" anchor="ctr"/>
+          <a:lstStyle/>
+          <a:p>
+            <a:pPr algn="l"/>
+            <a:r>
+              <a:rPr sz="1500" b="1">
+                <a:solidFill>
+                  <a:srgbClr val="0B2C4A"/>
+                </a:solidFill>
+                <a:latin typeface="Calibri"/>
+              </a:rPr>
+              <a:t>Healthy Lab, elective OHE</a:t>
+            </a:r>
+          </a:p>
+        </p:txBody>
+      </p:sp>
+      <p:sp>
+        <p:nvSpPr>
+          <p:cNvPr id="32" name="TextBox 31"/>
+          <p:cNvSpPr txBox="1"/>
+          <p:nvPr/>
+        </p:nvSpPr>
+        <p:spPr>
+          <a:xfrm>
+            <a:off x="3246120" y="4828032"/>
+            <a:ext cx="1097280" cy="438912"/>
+          </a:xfrm>
+          <a:prstGeom prst="rect">
+            <a:avLst/>
+          </a:prstGeom>
+          <a:noFill/>
+        </p:spPr>
+        <p:txBody>
+          <a:bodyPr wrap="square" anchor="ctr"/>
+          <a:lstStyle/>
+          <a:p>
+            <a:pPr algn="l"/>
+            <a:r>
+              <a:rPr sz="1500" b="0">
+                <a:solidFill>
+                  <a:srgbClr val="1C1C1C"/>
+                </a:solidFill>
+                <a:latin typeface="Calibri"/>
+              </a:rPr>
+              <a:t>25</a:t>
+            </a:r>
+          </a:p>
+        </p:txBody>
+      </p:sp>
+      <p:sp>
+        <p:nvSpPr>
+          <p:cNvPr id="33" name="TextBox 32"/>
+          <p:cNvSpPr txBox="1"/>
+          <p:nvPr/>
+        </p:nvSpPr>
+        <p:spPr>
+          <a:xfrm>
+            <a:off x="4434840" y="4828032"/>
+            <a:ext cx="2926080" cy="438912"/>
+          </a:xfrm>
+          <a:prstGeom prst="rect">
+            <a:avLst/>
+          </a:prstGeom>
+          <a:noFill/>
+        </p:spPr>
+        <p:txBody>
+          <a:bodyPr wrap="square" anchor="ctr"/>
+          <a:lstStyle/>
+          <a:p>
+            <a:pPr algn="l"/>
+            <a:r>
+              <a:rPr sz="1500" b="1">
+                <a:solidFill>
+                  <a:srgbClr val="1B6B7A"/>
+                </a:solidFill>
+                <a:latin typeface="Calibri"/>
+              </a:rPr>
+              <a:t>9.75 → 10 mm</a:t>
+            </a:r>
+          </a:p>
+        </p:txBody>
+      </p:sp>
+      <p:sp>
+        <p:nvSpPr>
+          <p:cNvPr id="34" name="TextBox 33"/>
+          <p:cNvSpPr txBox="1"/>
+          <p:nvPr/>
+        </p:nvSpPr>
+        <p:spPr>
+          <a:xfrm>
+            <a:off x="7452360" y="4828032"/>
+            <a:ext cx="2560320" cy="438912"/>
+          </a:xfrm>
+          <a:prstGeom prst="rect">
+            <a:avLst/>
+          </a:prstGeom>
+          <a:noFill/>
+        </p:spPr>
+        <p:txBody>
+          <a:bodyPr wrap="square" anchor="ctr"/>
+          <a:lstStyle/>
+          <a:p>
+            <a:pPr algn="l"/>
+            <a:r>
+              <a:rPr sz="1500" b="1">
+                <a:solidFill>
+                  <a:srgbClr val="1B6B7A"/>
+                </a:solidFill>
+                <a:latin typeface="Calibri"/>
+              </a:rPr>
+              <a:t>1.5 L → 2 L</a:t>
+            </a:r>
+          </a:p>
+        </p:txBody>
+      </p:sp>
+      <p:sp>
+        <p:nvSpPr>
+          <p:cNvPr id="35" name="TextBox 34"/>
+          <p:cNvSpPr txBox="1"/>
+          <p:nvPr/>
+        </p:nvSpPr>
+        <p:spPr>
+          <a:xfrm>
+            <a:off x="10104120" y="4828032"/>
+            <a:ext cx="1554480" cy="438912"/>
+          </a:xfrm>
+          <a:prstGeom prst="rect">
+            <a:avLst/>
+          </a:prstGeom>
+          <a:noFill/>
+        </p:spPr>
+        <p:txBody>
+          <a:bodyPr wrap="square" anchor="ctr"/>
+          <a:lstStyle/>
+          <a:p>
+            <a:pPr algn="l"/>
+            <a:r>
+              <a:rPr sz="1500" b="0">
+                <a:solidFill>
+                  <a:srgbClr val="1C1C1C"/>
+                </a:solidFill>
+                <a:latin typeface="Calibri"/>
+              </a:rPr>
+              <a:t>Circle</a:t>
+            </a:r>
+          </a:p>
+        </p:txBody>
+      </p:sp>
+      <p:sp>
+        <p:nvSpPr>
+          <p:cNvPr id="36" name="Rounded Rectangle 35"/>
+          <p:cNvSpPr/>
+          <p:nvPr/>
+        </p:nvSpPr>
+        <p:spPr>
+          <a:xfrm>
+            <a:off x="411480" y="5303520"/>
+            <a:ext cx="11338560" cy="438912"/>
+          </a:xfrm>
+          <a:prstGeom prst="roundRect">
+            <a:avLst>
+              <a:gd name="adj" fmla="val 8000"/>
+            </a:avLst>
+          </a:prstGeom>
+          <a:solidFill>
+            <a:srgbClr val="FFFFFF"/>
+          </a:solidFill>
+          <a:ln>
+            <a:noFill/>
+          </a:ln>
+        </p:spPr>
+        <p:style>
+          <a:lnRef idx="1">
+            <a:schemeClr val="accent1"/>
+          </a:lnRef>
+          <a:fillRef idx="3">
+            <a:schemeClr val="accent1"/>
+          </a:fillRef>
+          <a:effectRef idx="2">
+            <a:schemeClr val="accent1"/>
+          </a:effectRef>
+          <a:fontRef idx="minor">
+            <a:schemeClr val="lt1"/>
+          </a:fontRef>
+        </p:style>
+        <p:txBody>
+          <a:bodyPr rtlCol="0" anchor="ctr"/>
+          <a:lstStyle/>
+          <a:p>
+            <a:pPr algn="ctr"/>
+          </a:p>
+        </p:txBody>
+      </p:sp>
+      <p:sp>
+        <p:nvSpPr>
+          <p:cNvPr id="37" name="TextBox 36"/>
+          <p:cNvSpPr txBox="1"/>
+          <p:nvPr/>
+        </p:nvSpPr>
+        <p:spPr>
+          <a:xfrm>
+            <a:off x="457200" y="5303520"/>
+            <a:ext cx="2743200" cy="438912"/>
+          </a:xfrm>
+          <a:prstGeom prst="rect">
+            <a:avLst/>
+          </a:prstGeom>
+          <a:noFill/>
+        </p:spPr>
+        <p:txBody>
+          <a:bodyPr wrap="square" anchor="ctr"/>
+          <a:lstStyle/>
+          <a:p>
+            <a:pPr algn="l"/>
+            <a:r>
+              <a:rPr sz="1500" b="1">
+                <a:solidFill>
+                  <a:srgbClr val="0B2C4A"/>
+                </a:solidFill>
+                <a:latin typeface="Calibri"/>
+              </a:rPr>
+              <a:t>MoMo, teaching only</a:t>
+            </a:r>
+          </a:p>
+        </p:txBody>
+      </p:sp>
+      <p:sp>
+        <p:nvSpPr>
+          <p:cNvPr id="38" name="TextBox 37"/>
+          <p:cNvSpPr txBox="1"/>
+          <p:nvPr/>
+        </p:nvSpPr>
+        <p:spPr>
+          <a:xfrm>
+            <a:off x="3246120" y="5303520"/>
+            <a:ext cx="1097280" cy="438912"/>
+          </a:xfrm>
+          <a:prstGeom prst="rect">
+            <a:avLst/>
+          </a:prstGeom>
+          <a:noFill/>
+        </p:spPr>
+        <p:txBody>
+          <a:bodyPr wrap="square" anchor="ctr"/>
+          <a:lstStyle/>
+          <a:p>
+            <a:pPr algn="l"/>
+            <a:r>
+              <a:rPr sz="1500" b="0">
+                <a:solidFill>
+                  <a:srgbClr val="1C1C1C"/>
+                </a:solidFill>
+                <a:latin typeface="Calibri"/>
+              </a:rPr>
+              <a:t>4.25</a:t>
+            </a:r>
+          </a:p>
+        </p:txBody>
+      </p:sp>
+      <p:sp>
+        <p:nvSpPr>
+          <p:cNvPr id="39" name="TextBox 38"/>
+          <p:cNvSpPr txBox="1"/>
+          <p:nvPr/>
+        </p:nvSpPr>
+        <p:spPr>
+          <a:xfrm>
+            <a:off x="4434840" y="5303520"/>
+            <a:ext cx="2926080" cy="438912"/>
+          </a:xfrm>
+          <a:prstGeom prst="rect">
+            <a:avLst/>
+          </a:prstGeom>
+          <a:noFill/>
+        </p:spPr>
+        <p:txBody>
+          <a:bodyPr wrap="square" anchor="ctr"/>
+          <a:lstStyle/>
+          <a:p>
+            <a:pPr algn="l"/>
+            <a:r>
+              <a:rPr sz="1500" b="1">
+                <a:solidFill>
+                  <a:srgbClr val="1B6B7A"/>
+                </a:solidFill>
+                <a:latin typeface="Calibri"/>
+              </a:rPr>
+              <a:t>3.5–4.0 mm (cat)</a:t>
+            </a:r>
+          </a:p>
+        </p:txBody>
+      </p:sp>
+      <p:sp>
+        <p:nvSpPr>
+          <p:cNvPr id="40" name="TextBox 39"/>
+          <p:cNvSpPr txBox="1"/>
+          <p:nvPr/>
+        </p:nvSpPr>
+        <p:spPr>
+          <a:xfrm>
+            <a:off x="7452360" y="5303520"/>
+            <a:ext cx="2560320" cy="438912"/>
+          </a:xfrm>
+          <a:prstGeom prst="rect">
+            <a:avLst/>
+          </a:prstGeom>
+          <a:noFill/>
+        </p:spPr>
+        <p:txBody>
+          <a:bodyPr wrap="square" anchor="ctr"/>
+          <a:lstStyle/>
+          <a:p>
+            <a:pPr algn="l"/>
+            <a:r>
+              <a:rPr sz="1500" b="1">
+                <a:solidFill>
+                  <a:srgbClr val="1B6B7A"/>
+                </a:solidFill>
+                <a:latin typeface="Calibri"/>
+              </a:rPr>
+              <a:t>255 mL → 0.5 L</a:t>
+            </a:r>
+          </a:p>
+        </p:txBody>
+      </p:sp>
+      <p:sp>
+        <p:nvSpPr>
+          <p:cNvPr id="41" name="TextBox 40"/>
+          <p:cNvSpPr txBox="1"/>
+          <p:nvPr/>
+        </p:nvSpPr>
+        <p:spPr>
+          <a:xfrm>
+            <a:off x="10104120" y="5303520"/>
+            <a:ext cx="1554480" cy="438912"/>
+          </a:xfrm>
+          <a:prstGeom prst="rect">
+            <a:avLst/>
+          </a:prstGeom>
+          <a:noFill/>
+        </p:spPr>
+        <p:txBody>
+          <a:bodyPr wrap="square" anchor="ctr"/>
+          <a:lstStyle/>
+          <a:p>
+            <a:pPr algn="l"/>
+            <a:r>
+              <a:rPr sz="1500" b="0">
+                <a:solidFill>
+                  <a:srgbClr val="1C1C1C"/>
+                </a:solidFill>
+                <a:latin typeface="Calibri"/>
+              </a:rPr>
+              <a:t>NRC</a:t>
+            </a:r>
+          </a:p>
+        </p:txBody>
+      </p:sp>
+      <p:sp>
+        <p:nvSpPr>
+          <p:cNvPr id="42" name="Rounded Rectangle 41"/>
+          <p:cNvSpPr/>
+          <p:nvPr/>
+        </p:nvSpPr>
+        <p:spPr>
+          <a:xfrm>
+            <a:off x="411480" y="5833872"/>
+            <a:ext cx="11338560" cy="621792"/>
+          </a:xfrm>
+          <a:prstGeom prst="roundRect">
+            <a:avLst>
+              <a:gd name="adj" fmla="val 8000"/>
+            </a:avLst>
+          </a:prstGeom>
+          <a:solidFill>
+            <a:srgbClr val="F4EBD3"/>
+          </a:solidFill>
+          <a:ln>
+            <a:noFill/>
+          </a:ln>
+        </p:spPr>
+        <p:style>
+          <a:lnRef idx="1">
+            <a:schemeClr val="accent1"/>
+          </a:lnRef>
+          <a:fillRef idx="3">
+            <a:schemeClr val="accent1"/>
+          </a:fillRef>
+          <a:effectRef idx="2">
+            <a:schemeClr val="accent1"/>
+          </a:effectRef>
+          <a:fontRef idx="minor">
+            <a:schemeClr val="lt1"/>
+          </a:fontRef>
+        </p:style>
+        <p:txBody>
+          <a:bodyPr rtlCol="0" anchor="ctr"/>
+          <a:lstStyle/>
+          <a:p>
+            <a:pPr algn="ctr"/>
+          </a:p>
+        </p:txBody>
+      </p:sp>
+      <p:sp>
+        <p:nvSpPr>
+          <p:cNvPr id="43" name="TextBox 42"/>
+          <p:cNvSpPr txBox="1"/>
+          <p:nvPr/>
+        </p:nvSpPr>
+        <p:spPr>
+          <a:xfrm>
+            <a:off x="594360" y="5833872"/>
+            <a:ext cx="11018520" cy="621792"/>
+          </a:xfrm>
+          <a:prstGeom prst="rect">
+            <a:avLst/>
+          </a:prstGeom>
+          <a:noFill/>
+        </p:spPr>
+        <p:txBody>
+          <a:bodyPr wrap="square" anchor="ctr"/>
+          <a:lstStyle/>
+          <a:p>
+            <a:pPr algn="l"/>
+            <a:r>
+              <a:rPr sz="1500" b="0">
+                <a:solidFill>
+                  <a:srgbClr val="0B2C4A"/>
+                </a:solidFill>
+                <a:latin typeface="Calibri"/>
+              </a:rPr>
+              <a:t>Premed stays in this hour: exam first, then IM/SQ. DKT or BAA if healthy ASA 1–2. Heart / murmur: opioid + alfaxalone (Willie). Premed lowers MAC.</a:t>
+            </a:r>
+          </a:p>
+        </p:txBody>
+      </p:sp>
+      <p:sp>
+        <p:nvSpPr>
+          <p:cNvPr id="44" name="Rectangle 43"/>
+          <p:cNvSpPr/>
+          <p:nvPr/>
+        </p:nvSpPr>
+        <p:spPr>
+          <a:xfrm>
+            <a:off x="0" y="6565392"/>
+            <a:ext cx="12191695" cy="292608"/>
+          </a:xfrm>
+          <a:prstGeom prst="rect">
+            <a:avLst/>
+          </a:prstGeom>
+          <a:solidFill>
+            <a:srgbClr val="0B2C4A"/>
+          </a:solidFill>
+          <a:ln>
+            <a:noFill/>
+          </a:ln>
+        </p:spPr>
+        <p:style>
+          <a:lnRef idx="1">
+            <a:schemeClr val="accent1"/>
+          </a:lnRef>
+          <a:fillRef idx="3">
+            <a:schemeClr val="accent1"/>
+          </a:fillRef>
+          <a:effectRef idx="2">
+            <a:schemeClr val="accent1"/>
+          </a:effectRef>
+          <a:fontRef idx="minor">
+            <a:schemeClr val="lt1"/>
+          </a:fontRef>
+        </p:style>
+        <p:txBody>
+          <a:bodyPr rtlCol="0" anchor="ctr"/>
+          <a:lstStyle/>
+          <a:p>
+            <a:pPr algn="ctr"/>
+          </a:p>
+        </p:txBody>
+      </p:sp>
+      <p:sp>
+        <p:nvSpPr>
+          <p:cNvPr id="45" name="TextBox 44"/>
           <p:cNvSpPr txBox="1"/>
           <p:nvPr/>
         </p:nvSpPr>
@@ -12696,7 +13512,7 @@
       </p:sp>
       <p:sp>
         <p:nvSpPr>
-          <p:cNvPr id="22" name="TextBox 21"/>
+          <p:cNvPr id="46" name="TextBox 45"/>
           <p:cNvSpPr txBox="1"/>
           <p:nvPr/>
         </p:nvSpPr>

</xml_diff>